<commit_message>
Reconstruct Figure 6 and extend the comparison deck
- apply the 2025 saving-rate method to the 2021 authors-kit data
- add matched wealth-level and five-year evolution diagnostics
- integrate Figures 5 and 6 into the verified comparison presentation
</commit_message>
<xml_diff>
--- a/Presentation/4_figure_comparison/presentation.pptx
+++ b/Presentation/4_figure_comparison/presentation.pptx
@@ -2,24 +2,28 @@
 <file path=ppt/presentation.xml><?xml version="1.0" encoding="utf-8"?>
 <p:presentation xmlns:p="http://schemas.openxmlformats.org/presentationml/2006/main">
   <p:sldMasterIdLst>
-    <p:sldMasterId xmlns:r="http://schemas.openxmlformats.org/officeDocument/2006/relationships" id="2147483648" r:id="Rd21de8492d114f63"/>
+    <p:sldMasterId xmlns:r="http://schemas.openxmlformats.org/officeDocument/2006/relationships" id="2147483648" r:id="R1838919981e348df"/>
   </p:sldMasterIdLst>
   <p:notesMasterIdLst>
-    <p:notesMasterId xmlns:r="http://schemas.openxmlformats.org/officeDocument/2006/relationships" r:id="R0aefdf69b6bf4701"/>
+    <p:notesMasterId xmlns:r="http://schemas.openxmlformats.org/officeDocument/2006/relationships" r:id="R605570555d5b462e"/>
   </p:notesMasterIdLst>
   <p:sldIdLst>
-    <p:sldId xmlns:r="http://schemas.openxmlformats.org/officeDocument/2006/relationships" id="256" r:id="R33dc2225ac474c98"/>
-    <p:sldId xmlns:r="http://schemas.openxmlformats.org/officeDocument/2006/relationships" id="257" r:id="R3821e938aac84ccc"/>
-    <p:sldId xmlns:r="http://schemas.openxmlformats.org/officeDocument/2006/relationships" id="258" r:id="R23a67f263b764eb3"/>
-    <p:sldId xmlns:r="http://schemas.openxmlformats.org/officeDocument/2006/relationships" id="259" r:id="R63ae371d3d7144ad"/>
-    <p:sldId xmlns:r="http://schemas.openxmlformats.org/officeDocument/2006/relationships" id="260" r:id="R198399ee6b6b4805"/>
-    <p:sldId xmlns:r="http://schemas.openxmlformats.org/officeDocument/2006/relationships" id="261" r:id="R37471f95254443e8"/>
-    <p:sldId xmlns:r="http://schemas.openxmlformats.org/officeDocument/2006/relationships" id="262" r:id="Re2757cfa3a824e88"/>
-    <p:sldId xmlns:r="http://schemas.openxmlformats.org/officeDocument/2006/relationships" id="263" r:id="R3f8f857983b2448e"/>
-    <p:sldId xmlns:r="http://schemas.openxmlformats.org/officeDocument/2006/relationships" id="264" r:id="R968d13bf997846ad"/>
-    <p:sldId xmlns:r="http://schemas.openxmlformats.org/officeDocument/2006/relationships" id="265" r:id="R13c1acd4f6df4c43"/>
-    <p:sldId xmlns:r="http://schemas.openxmlformats.org/officeDocument/2006/relationships" id="266" r:id="Rdec24148038c4bf2"/>
-    <p:sldId xmlns:r="http://schemas.openxmlformats.org/officeDocument/2006/relationships" id="267" r:id="Rcc51188f998548aa"/>
+    <p:sldId xmlns:r="http://schemas.openxmlformats.org/officeDocument/2006/relationships" id="256" r:id="R84da1362116a4b82"/>
+    <p:sldId xmlns:r="http://schemas.openxmlformats.org/officeDocument/2006/relationships" id="257" r:id="Rcadedfa889564248"/>
+    <p:sldId xmlns:r="http://schemas.openxmlformats.org/officeDocument/2006/relationships" id="258" r:id="R9eb3ad82648f4ae4"/>
+    <p:sldId xmlns:r="http://schemas.openxmlformats.org/officeDocument/2006/relationships" id="259" r:id="R62dfc5cca4974225"/>
+    <p:sldId xmlns:r="http://schemas.openxmlformats.org/officeDocument/2006/relationships" id="260" r:id="R28ee73c8ddf34195"/>
+    <p:sldId xmlns:r="http://schemas.openxmlformats.org/officeDocument/2006/relationships" id="261" r:id="R23235f2fdf5944d3"/>
+    <p:sldId xmlns:r="http://schemas.openxmlformats.org/officeDocument/2006/relationships" id="262" r:id="R4264838c9bf541fd"/>
+    <p:sldId xmlns:r="http://schemas.openxmlformats.org/officeDocument/2006/relationships" id="263" r:id="Rec05dabc391c41e5"/>
+    <p:sldId xmlns:r="http://schemas.openxmlformats.org/officeDocument/2006/relationships" id="264" r:id="Rc0191ebf4b0d4776"/>
+    <p:sldId xmlns:r="http://schemas.openxmlformats.org/officeDocument/2006/relationships" id="265" r:id="R057506c52c764860"/>
+    <p:sldId xmlns:r="http://schemas.openxmlformats.org/officeDocument/2006/relationships" id="266" r:id="Rfb9f3df32da049c9"/>
+    <p:sldId xmlns:r="http://schemas.openxmlformats.org/officeDocument/2006/relationships" id="267" r:id="Raf2da36407f04012"/>
+    <p:sldId xmlns:r="http://schemas.openxmlformats.org/officeDocument/2006/relationships" id="268" r:id="Rab1f9779c11e4a04"/>
+    <p:sldId xmlns:r="http://schemas.openxmlformats.org/officeDocument/2006/relationships" id="269" r:id="R8e5cc8f4e278455b"/>
+    <p:sldId xmlns:r="http://schemas.openxmlformats.org/officeDocument/2006/relationships" id="270" r:id="R3c67d6e8237a4c28"/>
+    <p:sldId xmlns:r="http://schemas.openxmlformats.org/officeDocument/2006/relationships" id="271" r:id="Rc78f4ef058d54d18"/>
   </p:sldIdLst>
   <p:sldSz cx="12192000" cy="6858000"/>
   <p:notesSz cx="6858000" cy="9144000"/>
@@ -468,6 +472,11 @@
           </a:p>
           <a:p xmlns:a="http://schemas.openxmlformats.org/drawingml/2006/main">
             <a:r>
+              <a:t>- docs/project/tasks/figure6-replication.md</a:t>
+            </a:r>
+          </a:p>
+          <a:p xmlns:a="http://schemas.openxmlformats.org/drawingml/2006/main">
+            <a:r>
               <a:t>- docs/project/tasks/figure8-replication.md</a:t>
             </a:r>
           </a:p>
@@ -548,22 +557,22 @@
           </a:p>
           <a:p xmlns:a="http://schemas.openxmlformats.org/drawingml/2006/main">
             <a:r>
-              <a:t>- MSS_SGR_July242025.pdf, Sections 4.1-4.2 and Figure 8, physical PDF page 29</a:t>
-            </a:r>
-          </a:p>
-          <a:p xmlns:a="http://schemas.openxmlformats.org/drawingml/2006/main">
-            <a:r>
-              <a:t>- MSS2021Febreplicationkit/code/build_fa_unveiling_data.do</a:t>
-            </a:r>
-          </a:p>
-          <a:p xmlns:a="http://schemas.openxmlformats.org/drawingml/2006/main">
-            <a:r>
-              <a:t>- docs/data/figure8-data.md</a:t>
-            </a:r>
-          </a:p>
-          <a:p xmlns:a="http://schemas.openxmlformats.org/drawingml/2006/main">
-            <a:r>
-              <a:t>- Code/unveiling/figure8_authors.py</a:t>
+              <a:t>- MSS_SGR_July242025.pdf, Section 3.4 and Figure 6, physical PDF page 24</a:t>
+            </a:r>
+          </a:p>
+          <a:p xmlns:a="http://schemas.openxmlformats.org/drawingml/2006/main">
+            <a:r>
+              <a:t>- docs/data/figure6-data.md</a:t>
+            </a:r>
+          </a:p>
+          <a:p xmlns:a="http://schemas.openxmlformats.org/drawingml/2006/main">
+            <a:r>
+              <a:t>- docs/project/tasks/figure6-replication.md</a:t>
+            </a:r>
+          </a:p>
+          <a:p xmlns:a="http://schemas.openxmlformats.org/drawingml/2006/main">
+            <a:r>
+              <a:t>- Code/unveiling/figure6_authors.py</a:t>
             </a:r>
           </a:p>
         </p:txBody>
@@ -638,22 +647,22 @@
           </a:p>
           <a:p xmlns:a="http://schemas.openxmlformats.org/drawingml/2006/main">
             <a:r>
-              <a:t>- MSS_SGR_July242025.pdf, Figure 8, physical PDF page 29; embedded chart extracted without caption</a:t>
-            </a:r>
-          </a:p>
-          <a:p xmlns:a="http://schemas.openxmlformats.org/drawingml/2006/main">
-            <a:r>
-              <a:t>- Results_Proposal/figures/figure8_authors_proxy.png</a:t>
-            </a:r>
-          </a:p>
-          <a:p xmlns:a="http://schemas.openxmlformats.org/drawingml/2006/main">
-            <a:r>
-              <a:t>- Data/processed/figure8_authors_proxy_comparison.csv</a:t>
-            </a:r>
-          </a:p>
-          <a:p xmlns:a="http://schemas.openxmlformats.org/drawingml/2006/main">
-            <a:r>
-              <a:t>- docs/project/tasks/figure8-replication.md, Verification and result</a:t>
+              <a:t>- MSS_SGR_July242025.pdf, Figure 6, physical PDF page 24; embedded chart extracted without caption</a:t>
+            </a:r>
+          </a:p>
+          <a:p xmlns:a="http://schemas.openxmlformats.org/drawingml/2006/main">
+            <a:r>
+              <a:t>- Results_Proposal/figures/figure6_authors_data_percentiles.png</a:t>
+            </a:r>
+          </a:p>
+          <a:p xmlns:a="http://schemas.openxmlformats.org/drawingml/2006/main">
+            <a:r>
+              <a:t>- Data/processed/figure6_authors_comparison.csv</a:t>
+            </a:r>
+          </a:p>
+          <a:p xmlns:a="http://schemas.openxmlformats.org/drawingml/2006/main">
+            <a:r>
+              <a:t>- docs/project/tasks/figure6-replication.md</a:t>
             </a:r>
           </a:p>
         </p:txBody>
@@ -728,6 +737,376 @@
           </a:p>
           <a:p xmlns:a="http://schemas.openxmlformats.org/drawingml/2006/main">
             <a:r>
+              <a:t>- Results_Proposal/figures/figure6_authors_data_percentiles.png</a:t>
+            </a:r>
+          </a:p>
+          <a:p xmlns:a="http://schemas.openxmlformats.org/drawingml/2006/main">
+            <a:r>
+              <a:t>- Results_Proposal/figures/figure6_authors_data_wealth_levels.png</a:t>
+            </a:r>
+          </a:p>
+          <a:p xmlns:a="http://schemas.openxmlformats.org/drawingml/2006/main">
+            <a:r>
+              <a:t>- Data/processed/figure6_authors_data.csv</a:t>
+            </a:r>
+          </a:p>
+          <a:p xmlns:a="http://schemas.openxmlformats.org/drawingml/2006/main">
+            <a:r>
+              <a:t>- docs/project/personal-considerations-saving-inequality.md</a:t>
+            </a:r>
+          </a:p>
+          <a:p xmlns:a="http://schemas.openxmlformats.org/drawingml/2006/main">
+            <a:r>
+              <a:t>- docs/data/figure6-data.md</a:t>
+            </a:r>
+          </a:p>
+        </p:txBody>
+      </p:sp>
+      <p:sp>
+        <p:nvSpPr>
+          <p:cNvPr id="4" name="Slide Number Placeholder 3"/>
+          <p:cNvSpPr>
+            <a:spLocks xmlns:a="http://schemas.openxmlformats.org/drawingml/2006/main" noGrp="1"/>
+          </p:cNvSpPr>
+          <p:nvPr>
+            <p:ph type="sldNum" idx="5"/>
+          </p:nvPr>
+        </p:nvSpPr>
+        <p:spPr/>
+        <p:txBody>
+          <a:bodyPr xmlns:a="http://schemas.openxmlformats.org/drawingml/2006/main"/>
+          <a:lstStyle xmlns:a="http://schemas.openxmlformats.org/drawingml/2006/main"/>
+          <a:p xmlns:a="http://schemas.openxmlformats.org/drawingml/2006/main"/>
+        </p:txBody>
+      </p:sp>
+    </p:spTree>
+  </p:cSld>
+  <p:clrMapOvr>
+    <a:masterClrMapping xmlns:a="http://schemas.openxmlformats.org/drawingml/2006/main"/>
+  </p:clrMapOvr>
+</p:notes>
+</file>
+
+<file path=ppt/notesSlides/notesSlide13.xml><?xml version="1.0" encoding="utf-8"?>
+<p:notes xmlns:p="http://schemas.openxmlformats.org/presentationml/2006/main">
+  <p:cSld>
+    <p:spTree>
+      <p:nvGrpSpPr>
+        <p:cNvPr id="1" name=""/>
+        <p:cNvGrpSpPr/>
+        <p:nvPr/>
+      </p:nvGrpSpPr>
+      <p:grpSpPr>
+        <a:xfrm xmlns:a="http://schemas.openxmlformats.org/drawingml/2006/main"/>
+      </p:grpSpPr>
+      <p:sp>
+        <p:nvSpPr>
+          <p:cNvPr id="2" name="Slide Image Placeholder 1"/>
+          <p:cNvSpPr>
+            <a:spLocks xmlns:a="http://schemas.openxmlformats.org/drawingml/2006/main" noGrp="1"/>
+          </p:cNvSpPr>
+          <p:nvPr>
+            <p:ph type="sldImg" idx="0"/>
+          </p:nvPr>
+        </p:nvSpPr>
+        <p:spPr/>
+      </p:sp>
+      <p:sp>
+        <p:nvSpPr>
+          <p:cNvPr id="3" name="Notes Placeholder 2"/>
+          <p:cNvSpPr>
+            <a:spLocks xmlns:a="http://schemas.openxmlformats.org/drawingml/2006/main" noGrp="1"/>
+          </p:cNvSpPr>
+          <p:nvPr>
+            <p:ph type="body" idx="1"/>
+          </p:nvPr>
+        </p:nvSpPr>
+        <p:spPr/>
+        <p:txBody>
+          <a:bodyPr xmlns:a="http://schemas.openxmlformats.org/drawingml/2006/main"/>
+          <a:lstStyle xmlns:a="http://schemas.openxmlformats.org/drawingml/2006/main"/>
+          <a:p xmlns:a="http://schemas.openxmlformats.org/drawingml/2006/main">
+            <a:r>
+              <a:t>[Sources]</a:t>
+            </a:r>
+          </a:p>
+          <a:p xmlns:a="http://schemas.openxmlformats.org/drawingml/2006/main">
+            <a:r>
+              <a:t>- Data/processed/figure6_authors_rolling5.csv</a:t>
+            </a:r>
+          </a:p>
+          <a:p xmlns:a="http://schemas.openxmlformats.org/drawingml/2006/main">
+            <a:r>
+              <a:t>- Results_Proposal/figures/figure6_rolling5_heatmap.png</a:t>
+            </a:r>
+          </a:p>
+          <a:p xmlns:a="http://schemas.openxmlformats.org/drawingml/2006/main">
+            <a:r>
+              <a:t>- Results_Proposal/figures/figure6_rolling5_selected_percentiles.png</a:t>
+            </a:r>
+          </a:p>
+          <a:p xmlns:a="http://schemas.openxmlformats.org/drawingml/2006/main">
+            <a:r>
+              <a:t>- Code/scripts/build_figure6_authors_data.py</a:t>
+            </a:r>
+          </a:p>
+          <a:p xmlns:a="http://schemas.openxmlformats.org/drawingml/2006/main">
+            <a:r>
+              <a:t>- docs/data/figure6-data.md</a:t>
+            </a:r>
+          </a:p>
+        </p:txBody>
+      </p:sp>
+      <p:sp>
+        <p:nvSpPr>
+          <p:cNvPr id="4" name="Slide Number Placeholder 3"/>
+          <p:cNvSpPr>
+            <a:spLocks xmlns:a="http://schemas.openxmlformats.org/drawingml/2006/main" noGrp="1"/>
+          </p:cNvSpPr>
+          <p:nvPr>
+            <p:ph type="sldNum" idx="5"/>
+          </p:nvPr>
+        </p:nvSpPr>
+        <p:spPr/>
+        <p:txBody>
+          <a:bodyPr xmlns:a="http://schemas.openxmlformats.org/drawingml/2006/main"/>
+          <a:lstStyle xmlns:a="http://schemas.openxmlformats.org/drawingml/2006/main"/>
+          <a:p xmlns:a="http://schemas.openxmlformats.org/drawingml/2006/main"/>
+        </p:txBody>
+      </p:sp>
+    </p:spTree>
+  </p:cSld>
+  <p:clrMapOvr>
+    <a:masterClrMapping xmlns:a="http://schemas.openxmlformats.org/drawingml/2006/main"/>
+  </p:clrMapOvr>
+</p:notes>
+</file>
+
+<file path=ppt/notesSlides/notesSlide14.xml><?xml version="1.0" encoding="utf-8"?>
+<p:notes xmlns:p="http://schemas.openxmlformats.org/presentationml/2006/main">
+  <p:cSld>
+    <p:spTree>
+      <p:nvGrpSpPr>
+        <p:cNvPr id="1" name=""/>
+        <p:cNvGrpSpPr/>
+        <p:nvPr/>
+      </p:nvGrpSpPr>
+      <p:grpSpPr>
+        <a:xfrm xmlns:a="http://schemas.openxmlformats.org/drawingml/2006/main"/>
+      </p:grpSpPr>
+      <p:sp>
+        <p:nvSpPr>
+          <p:cNvPr id="2" name="Slide Image Placeholder 1"/>
+          <p:cNvSpPr>
+            <a:spLocks xmlns:a="http://schemas.openxmlformats.org/drawingml/2006/main" noGrp="1"/>
+          </p:cNvSpPr>
+          <p:nvPr>
+            <p:ph type="sldImg" idx="0"/>
+          </p:nvPr>
+        </p:nvSpPr>
+        <p:spPr/>
+      </p:sp>
+      <p:sp>
+        <p:nvSpPr>
+          <p:cNvPr id="3" name="Notes Placeholder 2"/>
+          <p:cNvSpPr>
+            <a:spLocks xmlns:a="http://schemas.openxmlformats.org/drawingml/2006/main" noGrp="1"/>
+          </p:cNvSpPr>
+          <p:nvPr>
+            <p:ph type="body" idx="1"/>
+          </p:nvPr>
+        </p:nvSpPr>
+        <p:spPr/>
+        <p:txBody>
+          <a:bodyPr xmlns:a="http://schemas.openxmlformats.org/drawingml/2006/main"/>
+          <a:lstStyle xmlns:a="http://schemas.openxmlformats.org/drawingml/2006/main"/>
+          <a:p xmlns:a="http://schemas.openxmlformats.org/drawingml/2006/main">
+            <a:r>
+              <a:t>[Sources]</a:t>
+            </a:r>
+          </a:p>
+          <a:p xmlns:a="http://schemas.openxmlformats.org/drawingml/2006/main">
+            <a:r>
+              <a:t>- MSS_SGR_July242025.pdf, Sections 4.1-4.2 and Figure 8, physical PDF page 29</a:t>
+            </a:r>
+          </a:p>
+          <a:p xmlns:a="http://schemas.openxmlformats.org/drawingml/2006/main">
+            <a:r>
+              <a:t>- MSS2021Febreplicationkit/code/build_fa_unveiling_data.do</a:t>
+            </a:r>
+          </a:p>
+          <a:p xmlns:a="http://schemas.openxmlformats.org/drawingml/2006/main">
+            <a:r>
+              <a:t>- docs/data/figure8-data.md</a:t>
+            </a:r>
+          </a:p>
+          <a:p xmlns:a="http://schemas.openxmlformats.org/drawingml/2006/main">
+            <a:r>
+              <a:t>- Code/unveiling/figure8_authors.py</a:t>
+            </a:r>
+          </a:p>
+        </p:txBody>
+      </p:sp>
+      <p:sp>
+        <p:nvSpPr>
+          <p:cNvPr id="4" name="Slide Number Placeholder 3"/>
+          <p:cNvSpPr>
+            <a:spLocks xmlns:a="http://schemas.openxmlformats.org/drawingml/2006/main" noGrp="1"/>
+          </p:cNvSpPr>
+          <p:nvPr>
+            <p:ph type="sldNum" idx="5"/>
+          </p:nvPr>
+        </p:nvSpPr>
+        <p:spPr/>
+        <p:txBody>
+          <a:bodyPr xmlns:a="http://schemas.openxmlformats.org/drawingml/2006/main"/>
+          <a:lstStyle xmlns:a="http://schemas.openxmlformats.org/drawingml/2006/main"/>
+          <a:p xmlns:a="http://schemas.openxmlformats.org/drawingml/2006/main"/>
+        </p:txBody>
+      </p:sp>
+    </p:spTree>
+  </p:cSld>
+  <p:clrMapOvr>
+    <a:masterClrMapping xmlns:a="http://schemas.openxmlformats.org/drawingml/2006/main"/>
+  </p:clrMapOvr>
+</p:notes>
+</file>
+
+<file path=ppt/notesSlides/notesSlide15.xml><?xml version="1.0" encoding="utf-8"?>
+<p:notes xmlns:p="http://schemas.openxmlformats.org/presentationml/2006/main">
+  <p:cSld>
+    <p:spTree>
+      <p:nvGrpSpPr>
+        <p:cNvPr id="1" name=""/>
+        <p:cNvGrpSpPr/>
+        <p:nvPr/>
+      </p:nvGrpSpPr>
+      <p:grpSpPr>
+        <a:xfrm xmlns:a="http://schemas.openxmlformats.org/drawingml/2006/main"/>
+      </p:grpSpPr>
+      <p:sp>
+        <p:nvSpPr>
+          <p:cNvPr id="2" name="Slide Image Placeholder 1"/>
+          <p:cNvSpPr>
+            <a:spLocks xmlns:a="http://schemas.openxmlformats.org/drawingml/2006/main" noGrp="1"/>
+          </p:cNvSpPr>
+          <p:nvPr>
+            <p:ph type="sldImg" idx="0"/>
+          </p:nvPr>
+        </p:nvSpPr>
+        <p:spPr/>
+      </p:sp>
+      <p:sp>
+        <p:nvSpPr>
+          <p:cNvPr id="3" name="Notes Placeholder 2"/>
+          <p:cNvSpPr>
+            <a:spLocks xmlns:a="http://schemas.openxmlformats.org/drawingml/2006/main" noGrp="1"/>
+          </p:cNvSpPr>
+          <p:nvPr>
+            <p:ph type="body" idx="1"/>
+          </p:nvPr>
+        </p:nvSpPr>
+        <p:spPr/>
+        <p:txBody>
+          <a:bodyPr xmlns:a="http://schemas.openxmlformats.org/drawingml/2006/main"/>
+          <a:lstStyle xmlns:a="http://schemas.openxmlformats.org/drawingml/2006/main"/>
+          <a:p xmlns:a="http://schemas.openxmlformats.org/drawingml/2006/main">
+            <a:r>
+              <a:t>[Sources]</a:t>
+            </a:r>
+          </a:p>
+          <a:p xmlns:a="http://schemas.openxmlformats.org/drawingml/2006/main">
+            <a:r>
+              <a:t>- MSS_SGR_July242025.pdf, Figure 8, physical PDF page 29; embedded chart extracted without caption</a:t>
+            </a:r>
+          </a:p>
+          <a:p xmlns:a="http://schemas.openxmlformats.org/drawingml/2006/main">
+            <a:r>
+              <a:t>- Results_Proposal/figures/figure8_authors_proxy.png</a:t>
+            </a:r>
+          </a:p>
+          <a:p xmlns:a="http://schemas.openxmlformats.org/drawingml/2006/main">
+            <a:r>
+              <a:t>- Data/processed/figure8_authors_proxy_comparison.csv</a:t>
+            </a:r>
+          </a:p>
+          <a:p xmlns:a="http://schemas.openxmlformats.org/drawingml/2006/main">
+            <a:r>
+              <a:t>- docs/project/tasks/figure8-replication.md, Verification and result</a:t>
+            </a:r>
+          </a:p>
+        </p:txBody>
+      </p:sp>
+      <p:sp>
+        <p:nvSpPr>
+          <p:cNvPr id="4" name="Slide Number Placeholder 3"/>
+          <p:cNvSpPr>
+            <a:spLocks xmlns:a="http://schemas.openxmlformats.org/drawingml/2006/main" noGrp="1"/>
+          </p:cNvSpPr>
+          <p:nvPr>
+            <p:ph type="sldNum" idx="5"/>
+          </p:nvPr>
+        </p:nvSpPr>
+        <p:spPr/>
+        <p:txBody>
+          <a:bodyPr xmlns:a="http://schemas.openxmlformats.org/drawingml/2006/main"/>
+          <a:lstStyle xmlns:a="http://schemas.openxmlformats.org/drawingml/2006/main"/>
+          <a:p xmlns:a="http://schemas.openxmlformats.org/drawingml/2006/main"/>
+        </p:txBody>
+      </p:sp>
+    </p:spTree>
+  </p:cSld>
+  <p:clrMapOvr>
+    <a:masterClrMapping xmlns:a="http://schemas.openxmlformats.org/drawingml/2006/main"/>
+  </p:clrMapOvr>
+</p:notes>
+</file>
+
+<file path=ppt/notesSlides/notesSlide16.xml><?xml version="1.0" encoding="utf-8"?>
+<p:notes xmlns:p="http://schemas.openxmlformats.org/presentationml/2006/main">
+  <p:cSld>
+    <p:spTree>
+      <p:nvGrpSpPr>
+        <p:cNvPr id="1" name=""/>
+        <p:cNvGrpSpPr/>
+        <p:nvPr/>
+      </p:nvGrpSpPr>
+      <p:grpSpPr>
+        <a:xfrm xmlns:a="http://schemas.openxmlformats.org/drawingml/2006/main"/>
+      </p:grpSpPr>
+      <p:sp>
+        <p:nvSpPr>
+          <p:cNvPr id="2" name="Slide Image Placeholder 1"/>
+          <p:cNvSpPr>
+            <a:spLocks xmlns:a="http://schemas.openxmlformats.org/drawingml/2006/main" noGrp="1"/>
+          </p:cNvSpPr>
+          <p:nvPr>
+            <p:ph type="sldImg" idx="0"/>
+          </p:nvPr>
+        </p:nvSpPr>
+        <p:spPr/>
+      </p:sp>
+      <p:sp>
+        <p:nvSpPr>
+          <p:cNvPr id="3" name="Notes Placeholder 2"/>
+          <p:cNvSpPr>
+            <a:spLocks xmlns:a="http://schemas.openxmlformats.org/drawingml/2006/main" noGrp="1"/>
+          </p:cNvSpPr>
+          <p:nvPr>
+            <p:ph type="body" idx="1"/>
+          </p:nvPr>
+        </p:nvSpPr>
+        <p:spPr/>
+        <p:txBody>
+          <a:bodyPr xmlns:a="http://schemas.openxmlformats.org/drawingml/2006/main"/>
+          <a:lstStyle xmlns:a="http://schemas.openxmlformats.org/drawingml/2006/main"/>
+          <a:p xmlns:a="http://schemas.openxmlformats.org/drawingml/2006/main">
+            <a:r>
+              <a:t>[Sources]</a:t>
+            </a:r>
+          </a:p>
+          <a:p xmlns:a="http://schemas.openxmlformats.org/drawingml/2006/main">
+            <a:r>
               <a:t>- Results_Proposal/major_results.md, R-001 to R-003</a:t>
             </a:r>
           </a:p>
@@ -739,6 +1118,11 @@
           <a:p xmlns:a="http://schemas.openxmlformats.org/drawingml/2006/main">
             <a:r>
               <a:t>- docs/project/tasks/figure5-replication.md</a:t>
+            </a:r>
+          </a:p>
+          <a:p xmlns:a="http://schemas.openxmlformats.org/drawingml/2006/main">
+            <a:r>
+              <a:t>- docs/project/tasks/figure6-replication.md</a:t>
             </a:r>
           </a:p>
           <a:p xmlns:a="http://schemas.openxmlformats.org/drawingml/2006/main">
@@ -818,7 +1202,7 @@
           </a:p>
           <a:p xmlns:a="http://schemas.openxmlformats.org/drawingml/2006/main">
             <a:r>
-              <a:t>- MSS_SGR_July242025.pdf, Figures 1, 5, and 8</a:t>
+              <a:t>- MSS_SGR_July242025.pdf, Figures 1, 5, 6, and 8</a:t>
             </a:r>
           </a:p>
           <a:p xmlns:a="http://schemas.openxmlformats.org/drawingml/2006/main">
@@ -829,6 +1213,11 @@
           <a:p xmlns:a="http://schemas.openxmlformats.org/drawingml/2006/main">
             <a:r>
               <a:t>- Results_Proposal/major_results.md, R-001 to R-003</a:t>
+            </a:r>
+          </a:p>
+          <a:p xmlns:a="http://schemas.openxmlformats.org/drawingml/2006/main">
+            <a:r>
+              <a:t>- docs/project/tasks/figure6-replication.md</a:t>
             </a:r>
           </a:p>
         </p:txBody>
@@ -1526,7 +1915,7 @@
   </p:cSld>
   <p:clrMap bg1="lt1" tx1="dk1" bg2="lt2" tx2="dk2" accent1="accent1" accent2="accent2" accent3="accent3" accent4="accent4" accent5="accent5" accent6="accent6" hlink="hlink" folHlink="folHlink"/>
   <p:sldLayoutIdLst>
-    <p:sldLayoutId xmlns:r="http://schemas.openxmlformats.org/officeDocument/2006/relationships" id="2147483649" r:id="Rb9d2842a0adc4f13"/>
+    <p:sldLayoutId xmlns:r="http://schemas.openxmlformats.org/officeDocument/2006/relationships" id="2147483649" r:id="R9cabc6dfa9f443f0"/>
   </p:sldLayoutIdLst>
   <p:txStyles>
     <p:titleStyle>
@@ -2200,7 +2589,7 @@
                   <a:srgbClr val="102A43"/>
                 </a:solidFill>
               </a:rPr>
-              <a:t>Three figures, one evidence hierarchy</a:t>
+              <a:t>Four figures, one evidence hierarchy</a:t>
             </a:r>
           </a:p>
         </p:txBody>
@@ -2466,7 +2855,7 @@
                   <a:srgbClr val="627D98"/>
                 </a:solidFill>
               </a:rPr>
-              <a:t>10 August 2026</a:t>
+              <a:t>11 August 2026</a:t>
             </a:r>
           </a:p>
         </p:txBody>
@@ -2546,7 +2935,7 @@
                   <a:srgbClr val="C65D16"/>
                 </a:solidFill>
               </a:rPr>
-              <a:t>FIGURE 8 FEASIBILITY</a:t>
+              <a:t>FIGURE 6 IDENTIFICATION</a:t>
             </a:r>
           </a:p>
         </p:txBody>
@@ -2597,7 +2986,7 @@
                   <a:srgbClr val="102A43"/>
                 </a:solidFill>
               </a:rPr>
-              <a:t>Figure 8 stops one step before the revised matrix solve</a:t>
+              <a:t>The same saving rate supports rank and wealth-level views</a:t>
             </a:r>
           </a:p>
         </p:txBody>
@@ -2781,7 +3170,7 @@
                   <a:srgbClr val="243B53"/>
                 </a:solidFill>
               </a:rPr>
-              <a:t>2025 Figure 8</a:t>
+              <a:t>2025 Figure 6</a:t>
             </a:r>
           </a:p>
           <a:p xmlns:a="http://schemas.openxmlformats.org/drawingml/2006/main">
@@ -2799,7 +3188,7 @@
                   <a:srgbClr val="243B53"/>
                 </a:solidFill>
               </a:rPr>
-              <a:t>Net household debt by wealth group</a:t>
+              <a:t>Net saving rate by wealth percentile</a:t>
             </a:r>
           </a:p>
         </p:txBody>
@@ -2912,7 +3301,7 @@
                   <a:srgbClr val="627D98"/>
                 </a:solidFill>
               </a:rPr>
-              <a:t>1 · Missing upstream</a:t>
+              <a:t>1 · Rebuild bins</a:t>
             </a:r>
           </a:p>
         </p:txBody>
@@ -2963,7 +3352,7 @@
                   <a:srgbClr val="243B53"/>
                 </a:solidFill>
               </a:rPr>
-              <a:t>Completed 2025 instrument × sector matrices and augmented household columns.</a:t>
+              <a:t>Raw DINA: bottom 40%, then one-percentile bins through the top 1%.</a:t>
             </a:r>
           </a:p>
         </p:txBody>
@@ -3045,7 +3434,7 @@
                   <a:srgbClr val="2E5B88"/>
                 </a:solidFill>
               </a:rPr>
-              <a:t>2 · Old-kit output</a:t>
+              <a:t>2 · Match income</a:t>
             </a:r>
           </a:p>
         </p:txBody>
@@ -3096,7 +3485,7 @@
                   <a:srgbClr val="243B53"/>
                 </a:solidFill>
               </a:rPr>
-              <a:t>Fine debt assets after seven rounds + fine liabilities.</a:t>
+              <a:t>Personal plus attributable corporate disposable income, allocated by income and equity shares.</a:t>
             </a:r>
           </a:p>
         </p:txBody>
@@ -3178,7 +3567,7 @@
                   <a:srgbClr val="C65D16"/>
                 </a:solidFill>
               </a:rPr>
-              <a:t>3 · Applied faithfully</a:t>
+              <a:t>3 · Hold rate fixed</a:t>
             </a:r>
           </a:p>
         </p:txBody>
@@ -3229,7 +3618,7 @@
                   <a:srgbClr val="243B53"/>
                 </a:solidFill>
               </a:rPr>
-              <a:t>Net debt = debt assets − liabilities; divide by NI; subtract 1982.</a:t>
+              <a:t>Active saving divided by disposable income; only the horizontal coordinate changes.</a:t>
             </a:r>
           </a:p>
         </p:txBody>
@@ -3364,7 +3753,7 @@
                   <a:srgbClr val="243B53"/>
                 </a:solidFill>
               </a:rPr>
-              <a:t>Proxy: group, sign, scale, and base are revised; unveiled asset stocks still come from the older method.</a:t>
+              <a:t>Exact-method reconstruction through 2016; the paper's later window ends in 2019.</a:t>
             </a:r>
           </a:p>
         </p:txBody>
@@ -3444,7 +3833,7 @@
                   <a:srgbClr val="C65D16"/>
                 </a:solidFill>
               </a:rPr>
-              <a:t>FIGURE 8 PRIMARY COMPARISON</a:t>
+              <a:t>FIGURE 6 PRIMARY COMPARISON</a:t>
             </a:r>
           </a:p>
         </p:txBody>
@@ -3495,7 +3884,7 @@
                   <a:srgbClr val="102A43"/>
                 </a:solidFill>
               </a:rPr>
-              <a:t>The proxy reproduces borrowing, but understates top-1 lending</a:t>
+              <a:t>The older inputs reproduce the cross-sectional saving pattern</a:t>
             </a:r>
           </a:p>
         </p:txBody>
@@ -3628,7 +4017,7 @@
                   <a:srgbClr val="2E5B88"/>
                 </a:solidFill>
               </a:rPr>
-              <a:t>2025 paper · ratio axis (0.10 = 10 pp)</a:t>
+              <a:t>2025 paper · 1963–82 and 1983–2019</a:t>
             </a:r>
           </a:p>
         </p:txBody>
@@ -3679,7 +4068,7 @@
                   <a:srgbClr val="C65D16"/>
                 </a:solidFill>
               </a:rPr>
-              <a:t>Our proxy · percentage-point axis</a:t>
+              <a:t>Our reconstruction · second period ends in 2016</a:t>
             </a:r>
           </a:p>
         </p:txBody>
@@ -3864,7 +4253,7 @@
                   <a:srgbClr val="2F855A"/>
                 </a:solidFill>
               </a:rPr>
-              <a:t>CLOSE PROXY</a:t>
+              <a:t>CLOSE SHAPE MATCH</a:t>
             </a:r>
           </a:p>
         </p:txBody>
@@ -3915,7 +4304,7 @@
                   <a:srgbClr val="243B53"/>
                 </a:solidFill>
               </a:rPr>
-              <a:t>2007: bottom 99% -38.88 pp proxy vs -38.76 paper; top 1% +12.03 vs +18.02.</a:t>
+              <a:t>Correlations: 0.991 / 0.972; MAE: 1.46 / 1.20 pp.</a:t>
             </a:r>
           </a:p>
         </p:txBody>
@@ -3966,7 +4355,7 @@
                   <a:srgbClr val="627D98"/>
                 </a:solidFill>
               </a:rPr>
-              <a:t>Correlations: 0.993 / 0.995 (top 1% / bottom 99%). Missing matrices prevent a code-only interpretation.</a:t>
+              <a:t>Top 1%: ours 28.8%→36.2%; paper ≈43%→54%. The old inputs end in 2016, not 2019.</a:t>
             </a:r>
           </a:p>
         </p:txBody>
@@ -3980,11 +4369,11 @@
           <p:nvPr/>
         </p:nvPicPr>
         <p:blipFill>
-          <a:blip xmlns:r="http://schemas.openxmlformats.org/officeDocument/2006/relationships" xmlns:a="http://schemas.openxmlformats.org/drawingml/2006/main" r:embed="R676d9f0694e74898"/>
+          <a:blip xmlns:r="http://schemas.openxmlformats.org/officeDocument/2006/relationships" xmlns:a="http://schemas.openxmlformats.org/drawingml/2006/main" r:embed="R0f0005083477437e"/>
           <a:stretch xmlns:a="http://schemas.openxmlformats.org/drawingml/2006/main"/>
         </p:blipFill>
         <p:spPr>
-          <a:xfrm xmlns:a="http://schemas.openxmlformats.org/drawingml/2006/main">
+          <a:xfrm xmlns:a="http://schemas.openxmlformats.org/drawingml/2006/main" flipH="0" flipV="0">
             <a:off x="632746" y="1552099"/>
             <a:ext cx="5059204" cy="3372802"/>
           </a:xfrm>
@@ -4002,11 +4391,11 @@
           <p:nvPr/>
         </p:nvPicPr>
         <p:blipFill>
-          <a:blip xmlns:r="http://schemas.openxmlformats.org/officeDocument/2006/relationships" xmlns:a="http://schemas.openxmlformats.org/drawingml/2006/main" r:embed="R59f648144b03498b"/>
+          <a:blip xmlns:r="http://schemas.openxmlformats.org/officeDocument/2006/relationships" xmlns:a="http://schemas.openxmlformats.org/drawingml/2006/main" r:embed="R1e207e051435401b"/>
           <a:stretch xmlns:a="http://schemas.openxmlformats.org/drawingml/2006/main"/>
         </p:blipFill>
         <p:spPr>
-          <a:xfrm xmlns:a="http://schemas.openxmlformats.org/drawingml/2006/main">
+          <a:xfrm xmlns:a="http://schemas.openxmlformats.org/drawingml/2006/main" flipH="0" flipV="0">
             <a:off x="6450393" y="1776603"/>
             <a:ext cx="5158614" cy="2923699"/>
           </a:xfrm>
@@ -4046,10 +4435,10 @@
       </p:grpSpPr>
       <p:sp>
         <p:nvSpPr>
-          <p:cNvPr id="20" name="kicker">
-            <a:extLst xmlns:a="http://schemas.openxmlformats.org/drawingml/2006/main">
-              <a:ext uri="{FF2B5EF4-FFF2-40B4-BE49-F238E27FC236}">
-                <a16:creationId xmlns:a16="http://schemas.microsoft.com/office/drawing/2014/main" id="{4DBD74DF-ED28-4EE9-8535-9E366A67537D}"/>
+          <p:cNvPr id="16" name="kicker">
+            <a:extLst xmlns:a="http://schemas.openxmlformats.org/drawingml/2006/main">
+              <a:ext uri="{FF2B5EF4-FFF2-40B4-BE49-F238E27FC236}">
+                <a16:creationId xmlns:a16="http://schemas.microsoft.com/office/drawing/2014/main" id="{AA955CD9-B4EF-4E20-A3FC-1D7B4F59A354}"/>
               </a:ext>
             </a:extLst>
           </p:cNvPr>
@@ -4090,7 +4479,7 @@
                   <a:srgbClr val="C65D16"/>
                 </a:solidFill>
               </a:rPr>
-              <a:t>REPLICATION SYNTHESIS</a:t>
+              <a:t>FIGURE 6 MECHANISM VIEW</a:t>
             </a:r>
           </a:p>
         </p:txBody>
@@ -4100,7 +4489,7 @@
           <p:cNvPr id="2" name="title">
             <a:extLst xmlns:a="http://schemas.openxmlformats.org/drawingml/2006/main">
               <a:ext uri="{FF2B5EF4-FFF2-40B4-BE49-F238E27FC236}">
-                <a16:creationId xmlns:a16="http://schemas.microsoft.com/office/drawing/2014/main" id="{25994307-319F-4EAA-8D7C-9E832F74B960}"/>
+                <a16:creationId xmlns:a16="http://schemas.microsoft.com/office/drawing/2014/main" id="{BE8A36E9-77A3-4197-AAEB-944D96A22E35}"/>
               </a:ext>
             </a:extLst>
           </p:cNvPr>
@@ -4141,7 +4530,7 @@
                   <a:srgbClr val="102A43"/>
                 </a:solidFill>
               </a:rPr>
-              <a:t>Figures 1 and 5 reconstruct closely; Figure 8 remains a proxy</a:t>
+              <a:t>Rising wealth alone does not explain the saving-rate shift</a:t>
             </a:r>
           </a:p>
         </p:txBody>
@@ -4151,7 +4540,7 @@
           <p:cNvPr id="3" name="header-rule">
             <a:extLst xmlns:a="http://schemas.openxmlformats.org/drawingml/2006/main">
               <a:ext uri="{FF2B5EF4-FFF2-40B4-BE49-F238E27FC236}">
-                <a16:creationId xmlns:a16="http://schemas.microsoft.com/office/drawing/2014/main" id="{9304C898-8A92-4A39-A7EB-64A100354E4A}"/>
+                <a16:creationId xmlns:a16="http://schemas.microsoft.com/office/drawing/2014/main" id="{514C6BB1-D2D7-4502-B63E-CB46F5220FD9}"/>
               </a:ext>
             </a:extLst>
           </p:cNvPr>
@@ -4182,7 +4571,7 @@
           <p:cNvPr id="4" name="slide-number">
             <a:extLst xmlns:a="http://schemas.openxmlformats.org/drawingml/2006/main">
               <a:ext uri="{FF2B5EF4-FFF2-40B4-BE49-F238E27FC236}">
-                <a16:creationId xmlns:a16="http://schemas.microsoft.com/office/drawing/2014/main" id="{E4772364-3993-46C7-BB6A-7696849F37B9}"/>
+                <a16:creationId xmlns:a16="http://schemas.microsoft.com/office/drawing/2014/main" id="{1846DD66-DAE1-4F4D-9638-E1108AC93C86}"/>
               </a:ext>
             </a:extLst>
           </p:cNvPr>
@@ -4230,6 +4619,1298 @@
       </p:sp>
       <p:sp>
         <p:nvSpPr>
+          <p:cNvPr id="5" name="left-label">
+            <a:extLst xmlns:a="http://schemas.openxmlformats.org/drawingml/2006/main">
+              <a:ext uri="{FF2B5EF4-FFF2-40B4-BE49-F238E27FC236}">
+                <a16:creationId xmlns:a16="http://schemas.microsoft.com/office/drawing/2014/main" id="{AC7EBFD9-49FB-40B3-B7BA-0564A41A3ADA}"/>
+              </a:ext>
+            </a:extLst>
+          </p:cNvPr>
+          <p:cNvSpPr>
+            <a:spLocks xmlns:a="http://schemas.openxmlformats.org/drawingml/2006/main" noGrp="1"/>
+          </p:cNvSpPr>
+          <p:nvPr/>
+        </p:nvSpPr>
+        <p:spPr>
+          <a:xfrm xmlns:a="http://schemas.openxmlformats.org/drawingml/2006/main">
+            <a:off x="457200" y="1123950"/>
+            <a:ext cx="5334000" cy="266700"/>
+          </a:xfrm>
+          <a:prstGeom xmlns:a="http://schemas.openxmlformats.org/drawingml/2006/main" prst="rect">
+            <a:avLst/>
+          </a:prstGeom>
+          <a:noFill xmlns:a="http://schemas.openxmlformats.org/drawingml/2006/main"/>
+          <a:ln xmlns:a="http://schemas.openxmlformats.org/drawingml/2006/main" w="0">
+            <a:noFill/>
+            <a:prstDash val="solid"/>
+          </a:ln>
+        </p:spPr>
+        <p:txBody>
+          <a:bodyPr xmlns:a="http://schemas.openxmlformats.org/drawingml/2006/main" anchor="t"/>
+          <a:lstStyle xmlns:a="http://schemas.openxmlformats.org/drawingml/2006/main"/>
+          <a:p xmlns:a="http://schemas.openxmlformats.org/drawingml/2006/main">
+            <a:pPr algn="l">
+              <a:buNone/>
+              <a:defRPr sz="1350" b="1">
+                <a:solidFill>
+                  <a:srgbClr val="2E5B88"/>
+                </a:solidFill>
+              </a:defRPr>
+            </a:pPr>
+            <a:r>
+              <a:rPr sz="1350" b="1">
+                <a:solidFill>
+                  <a:srgbClr val="2E5B88"/>
+                </a:solidFill>
+              </a:rPr>
+              <a:t>Same rates · wealth percentile</a:t>
+            </a:r>
+          </a:p>
+        </p:txBody>
+      </p:sp>
+      <p:sp>
+        <p:nvSpPr>
+          <p:cNvPr id="6" name="right-label">
+            <a:extLst xmlns:a="http://schemas.openxmlformats.org/drawingml/2006/main">
+              <a:ext uri="{FF2B5EF4-FFF2-40B4-BE49-F238E27FC236}">
+                <a16:creationId xmlns:a16="http://schemas.microsoft.com/office/drawing/2014/main" id="{D7EBD11C-5C33-487B-AFE7-65F7CD7D2108}"/>
+              </a:ext>
+            </a:extLst>
+          </p:cNvPr>
+          <p:cNvSpPr>
+            <a:spLocks xmlns:a="http://schemas.openxmlformats.org/drawingml/2006/main" noGrp="1"/>
+          </p:cNvSpPr>
+          <p:nvPr/>
+        </p:nvSpPr>
+        <p:spPr>
+          <a:xfrm xmlns:a="http://schemas.openxmlformats.org/drawingml/2006/main">
+            <a:off x="6324600" y="1123950"/>
+            <a:ext cx="5410200" cy="266700"/>
+          </a:xfrm>
+          <a:prstGeom xmlns:a="http://schemas.openxmlformats.org/drawingml/2006/main" prst="rect">
+            <a:avLst/>
+          </a:prstGeom>
+          <a:noFill xmlns:a="http://schemas.openxmlformats.org/drawingml/2006/main"/>
+          <a:ln xmlns:a="http://schemas.openxmlformats.org/drawingml/2006/main" w="0">
+            <a:noFill/>
+            <a:prstDash val="solid"/>
+          </a:ln>
+        </p:spPr>
+        <p:txBody>
+          <a:bodyPr xmlns:a="http://schemas.openxmlformats.org/drawingml/2006/main" anchor="t"/>
+          <a:lstStyle xmlns:a="http://schemas.openxmlformats.org/drawingml/2006/main"/>
+          <a:p xmlns:a="http://schemas.openxmlformats.org/drawingml/2006/main">
+            <a:pPr algn="l">
+              <a:buNone/>
+              <a:defRPr sz="1350" b="1">
+                <a:solidFill>
+                  <a:srgbClr val="C65D16"/>
+                </a:solidFill>
+              </a:defRPr>
+            </a:pPr>
+            <a:r>
+              <a:rPr sz="1350" b="1">
+                <a:solidFill>
+                  <a:srgbClr val="C65D16"/>
+                </a:solidFill>
+              </a:rPr>
+              <a:t>Same rates · mean real wealth per adult</a:t>
+            </a:r>
+          </a:p>
+        </p:txBody>
+      </p:sp>
+      <p:sp>
+        <p:nvSpPr>
+          <p:cNvPr id="7" name="Regenerated 2021 safe-asset demand figure-frame">
+            <a:extLst xmlns:a="http://schemas.openxmlformats.org/drawingml/2006/main">
+              <a:ext uri="{FF2B5EF4-FFF2-40B4-BE49-F238E27FC236}">
+                <a16:creationId xmlns:a16="http://schemas.microsoft.com/office/drawing/2014/main" id="{1442A94D-98B9-4DC6-8E97-11AE6BD7202F}"/>
+              </a:ext>
+            </a:extLst>
+          </p:cNvPr>
+          <p:cNvSpPr>
+            <a:spLocks xmlns:a="http://schemas.openxmlformats.org/drawingml/2006/main" noGrp="1"/>
+          </p:cNvSpPr>
+          <p:nvPr/>
+        </p:nvSpPr>
+        <p:spPr>
+          <a:xfrm xmlns:a="http://schemas.openxmlformats.org/drawingml/2006/main">
+            <a:off x="457200" y="1428750"/>
+            <a:ext cx="5410200" cy="3638550"/>
+          </a:xfrm>
+          <a:prstGeom xmlns:a="http://schemas.openxmlformats.org/drawingml/2006/main" prst="roundRect">
+            <a:avLst>
+              <a:gd name="adj" fmla="val 1047"/>
+            </a:avLst>
+          </a:prstGeom>
+          <a:solidFill xmlns:a="http://schemas.openxmlformats.org/drawingml/2006/main">
+            <a:srgbClr val="FFFFFF"/>
+          </a:solidFill>
+          <a:ln xmlns:a="http://schemas.openxmlformats.org/drawingml/2006/main" w="9525">
+            <a:solidFill>
+              <a:srgbClr val="D8E1E8"/>
+            </a:solidFill>
+            <a:prstDash val="solid"/>
+          </a:ln>
+        </p:spPr>
+      </p:sp>
+      <p:sp>
+        <p:nvSpPr>
+          <p:cNvPr id="9" name="2025 Figure 10 safe-asset demand-frame">
+            <a:extLst xmlns:a="http://schemas.openxmlformats.org/drawingml/2006/main">
+              <a:ext uri="{FF2B5EF4-FFF2-40B4-BE49-F238E27FC236}">
+                <a16:creationId xmlns:a16="http://schemas.microsoft.com/office/drawing/2014/main" id="{98F7C92D-66A0-4F20-83BF-E349E5E80E9E}"/>
+              </a:ext>
+            </a:extLst>
+          </p:cNvPr>
+          <p:cNvSpPr>
+            <a:spLocks xmlns:a="http://schemas.openxmlformats.org/drawingml/2006/main" noGrp="1"/>
+          </p:cNvSpPr>
+          <p:nvPr/>
+        </p:nvSpPr>
+        <p:spPr>
+          <a:xfrm xmlns:a="http://schemas.openxmlformats.org/drawingml/2006/main">
+            <a:off x="6324600" y="1428750"/>
+            <a:ext cx="5410200" cy="3638550"/>
+          </a:xfrm>
+          <a:prstGeom xmlns:a="http://schemas.openxmlformats.org/drawingml/2006/main" prst="roundRect">
+            <a:avLst>
+              <a:gd name="adj" fmla="val 1047"/>
+            </a:avLst>
+          </a:prstGeom>
+          <a:solidFill xmlns:a="http://schemas.openxmlformats.org/drawingml/2006/main">
+            <a:srgbClr val="FFFFFF"/>
+          </a:solidFill>
+          <a:ln xmlns:a="http://schemas.openxmlformats.org/drawingml/2006/main" w="9525">
+            <a:solidFill>
+              <a:srgbClr val="D8E1E8"/>
+            </a:solidFill>
+            <a:prstDash val="solid"/>
+          </a:ln>
+        </p:spPr>
+      </p:sp>
+      <p:sp>
+        <p:nvSpPr>
+          <p:cNvPr id="11" name="assessment-band">
+            <a:extLst xmlns:a="http://schemas.openxmlformats.org/drawingml/2006/main">
+              <a:ext uri="{FF2B5EF4-FFF2-40B4-BE49-F238E27FC236}">
+                <a16:creationId xmlns:a16="http://schemas.microsoft.com/office/drawing/2014/main" id="{8E0201B9-6249-4F69-8DD3-3C91F0AFAC32}"/>
+              </a:ext>
+            </a:extLst>
+          </p:cNvPr>
+          <p:cNvSpPr>
+            <a:spLocks xmlns:a="http://schemas.openxmlformats.org/drawingml/2006/main" noGrp="1"/>
+          </p:cNvSpPr>
+          <p:nvPr/>
+        </p:nvSpPr>
+        <p:spPr>
+          <a:xfrm xmlns:a="http://schemas.openxmlformats.org/drawingml/2006/main">
+            <a:off x="457200" y="5219700"/>
+            <a:ext cx="11277600" cy="1219200"/>
+          </a:xfrm>
+          <a:prstGeom xmlns:a="http://schemas.openxmlformats.org/drawingml/2006/main" prst="roundRect">
+            <a:avLst>
+              <a:gd name="adj" fmla="val 3125"/>
+            </a:avLst>
+          </a:prstGeom>
+          <a:solidFill xmlns:a="http://schemas.openxmlformats.org/drawingml/2006/main">
+            <a:srgbClr val="F4F7FA"/>
+          </a:solidFill>
+          <a:ln xmlns:a="http://schemas.openxmlformats.org/drawingml/2006/main" w="0">
+            <a:noFill/>
+            <a:prstDash val="solid"/>
+          </a:ln>
+        </p:spPr>
+      </p:sp>
+      <p:sp>
+        <p:nvSpPr>
+          <p:cNvPr id="12" name="assessment-accent">
+            <a:extLst xmlns:a="http://schemas.openxmlformats.org/drawingml/2006/main">
+              <a:ext uri="{FF2B5EF4-FFF2-40B4-BE49-F238E27FC236}">
+                <a16:creationId xmlns:a16="http://schemas.microsoft.com/office/drawing/2014/main" id="{E6607933-8AC4-4796-94EB-F2FB6C0865F1}"/>
+              </a:ext>
+            </a:extLst>
+          </p:cNvPr>
+          <p:cNvSpPr>
+            <a:spLocks xmlns:a="http://schemas.openxmlformats.org/drawingml/2006/main" noGrp="1"/>
+          </p:cNvSpPr>
+          <p:nvPr/>
+        </p:nvSpPr>
+        <p:spPr>
+          <a:xfrm xmlns:a="http://schemas.openxmlformats.org/drawingml/2006/main">
+            <a:off x="457200" y="5219700"/>
+            <a:ext cx="76200" cy="1219200"/>
+          </a:xfrm>
+          <a:prstGeom xmlns:a="http://schemas.openxmlformats.org/drawingml/2006/main" prst="rect">
+            <a:avLst/>
+          </a:prstGeom>
+          <a:solidFill xmlns:a="http://schemas.openxmlformats.org/drawingml/2006/main">
+            <a:srgbClr val="2F855A"/>
+          </a:solidFill>
+          <a:ln xmlns:a="http://schemas.openxmlformats.org/drawingml/2006/main" w="0">
+            <a:noFill/>
+            <a:prstDash val="solid"/>
+          </a:ln>
+        </p:spPr>
+      </p:sp>
+      <p:sp>
+        <p:nvSpPr>
+          <p:cNvPr id="13" name="verdict">
+            <a:extLst xmlns:a="http://schemas.openxmlformats.org/drawingml/2006/main">
+              <a:ext uri="{FF2B5EF4-FFF2-40B4-BE49-F238E27FC236}">
+                <a16:creationId xmlns:a16="http://schemas.microsoft.com/office/drawing/2014/main" id="{DAEE4CAF-C158-4F1E-AF88-9B2A72776725}"/>
+              </a:ext>
+            </a:extLst>
+          </p:cNvPr>
+          <p:cNvSpPr>
+            <a:spLocks xmlns:a="http://schemas.openxmlformats.org/drawingml/2006/main" noGrp="1"/>
+          </p:cNvSpPr>
+          <p:nvPr/>
+        </p:nvSpPr>
+        <p:spPr>
+          <a:xfrm xmlns:a="http://schemas.openxmlformats.org/drawingml/2006/main">
+            <a:off x="685800" y="5362575"/>
+            <a:ext cx="3143250" cy="314325"/>
+          </a:xfrm>
+          <a:prstGeom xmlns:a="http://schemas.openxmlformats.org/drawingml/2006/main" prst="rect">
+            <a:avLst/>
+          </a:prstGeom>
+          <a:noFill xmlns:a="http://schemas.openxmlformats.org/drawingml/2006/main"/>
+          <a:ln xmlns:a="http://schemas.openxmlformats.org/drawingml/2006/main" w="0">
+            <a:noFill/>
+            <a:prstDash val="solid"/>
+          </a:ln>
+        </p:spPr>
+        <p:txBody>
+          <a:bodyPr xmlns:a="http://schemas.openxmlformats.org/drawingml/2006/main" anchor="t"/>
+          <a:lstStyle xmlns:a="http://schemas.openxmlformats.org/drawingml/2006/main"/>
+          <a:p xmlns:a="http://schemas.openxmlformats.org/drawingml/2006/main">
+            <a:pPr algn="l">
+              <a:buNone/>
+              <a:defRPr sz="1725" b="1">
+                <a:solidFill>
+                  <a:srgbClr val="2F855A"/>
+                </a:solidFill>
+              </a:defRPr>
+            </a:pPr>
+            <a:r>
+              <a:rPr sz="1725" b="1">
+                <a:solidFill>
+                  <a:srgbClr val="2F855A"/>
+                </a:solidFill>
+              </a:rPr>
+              <a:t>NOT PURE COMPOSITION</a:t>
+            </a:r>
+          </a:p>
+        </p:txBody>
+      </p:sp>
+      <p:sp>
+        <p:nvSpPr>
+          <p:cNvPr id="14" name="assessment">
+            <a:extLst xmlns:a="http://schemas.openxmlformats.org/drawingml/2006/main">
+              <a:ext uri="{FF2B5EF4-FFF2-40B4-BE49-F238E27FC236}">
+                <a16:creationId xmlns:a16="http://schemas.microsoft.com/office/drawing/2014/main" id="{F5E1C807-0687-4A75-8864-05548460D9A0}"/>
+              </a:ext>
+            </a:extLst>
+          </p:cNvPr>
+          <p:cNvSpPr>
+            <a:spLocks xmlns:a="http://schemas.openxmlformats.org/drawingml/2006/main" noGrp="1"/>
+          </p:cNvSpPr>
+          <p:nvPr/>
+        </p:nvSpPr>
+        <p:spPr>
+          <a:xfrm xmlns:a="http://schemas.openxmlformats.org/drawingml/2006/main">
+            <a:off x="3857625" y="5334000"/>
+            <a:ext cx="7620000" cy="457200"/>
+          </a:xfrm>
+          <a:prstGeom xmlns:a="http://schemas.openxmlformats.org/drawingml/2006/main" prst="rect">
+            <a:avLst/>
+          </a:prstGeom>
+          <a:noFill xmlns:a="http://schemas.openxmlformats.org/drawingml/2006/main"/>
+          <a:ln xmlns:a="http://schemas.openxmlformats.org/drawingml/2006/main" w="0">
+            <a:noFill/>
+            <a:prstDash val="solid"/>
+          </a:ln>
+        </p:spPr>
+        <p:txBody>
+          <a:bodyPr xmlns:a="http://schemas.openxmlformats.org/drawingml/2006/main" anchor="t"/>
+          <a:lstStyle xmlns:a="http://schemas.openxmlformats.org/drawingml/2006/main"/>
+          <a:p xmlns:a="http://schemas.openxmlformats.org/drawingml/2006/main">
+            <a:pPr algn="l">
+              <a:buNone/>
+              <a:defRPr sz="1350" b="0">
+                <a:solidFill>
+                  <a:srgbClr val="243B53"/>
+                </a:solidFill>
+              </a:defRPr>
+            </a:pPr>
+            <a:r>
+              <a:rPr sz="1350" b="0">
+                <a:solidFill>
+                  <a:srgbClr val="243B53"/>
+                </a:solidFill>
+              </a:rPr>
+              <a:t>At similar mean wealth, post-1982 cohorts often save less.</a:t>
+            </a:r>
+          </a:p>
+        </p:txBody>
+      </p:sp>
+      <p:sp>
+        <p:nvSpPr>
+          <p:cNvPr id="15" name="difference">
+            <a:extLst xmlns:a="http://schemas.openxmlformats.org/drawingml/2006/main">
+              <a:ext uri="{FF2B5EF4-FFF2-40B4-BE49-F238E27FC236}">
+                <a16:creationId xmlns:a16="http://schemas.microsoft.com/office/drawing/2014/main" id="{9E94ECB7-8637-4F89-9ABB-1A8B2FEF54E1}"/>
+              </a:ext>
+            </a:extLst>
+          </p:cNvPr>
+          <p:cNvSpPr>
+            <a:spLocks xmlns:a="http://schemas.openxmlformats.org/drawingml/2006/main" noGrp="1"/>
+          </p:cNvSpPr>
+          <p:nvPr/>
+        </p:nvSpPr>
+        <p:spPr>
+          <a:xfrm xmlns:a="http://schemas.openxmlformats.org/drawingml/2006/main">
+            <a:off x="685800" y="5848350"/>
+            <a:ext cx="10763250" cy="400050"/>
+          </a:xfrm>
+          <a:prstGeom xmlns:a="http://schemas.openxmlformats.org/drawingml/2006/main" prst="rect">
+            <a:avLst/>
+          </a:prstGeom>
+          <a:noFill xmlns:a="http://schemas.openxmlformats.org/drawingml/2006/main"/>
+          <a:ln xmlns:a="http://schemas.openxmlformats.org/drawingml/2006/main" w="0">
+            <a:noFill/>
+            <a:prstDash val="solid"/>
+          </a:ln>
+        </p:spPr>
+        <p:txBody>
+          <a:bodyPr xmlns:a="http://schemas.openxmlformats.org/drawingml/2006/main" anchor="t"/>
+          <a:lstStyle xmlns:a="http://schemas.openxmlformats.org/drawingml/2006/main"/>
+          <a:p xmlns:a="http://schemas.openxmlformats.org/drawingml/2006/main">
+            <a:pPr algn="l">
+              <a:buNone/>
+              <a:defRPr sz="1200" b="0">
+                <a:solidFill>
+                  <a:srgbClr val="627D98"/>
+                </a:solidFill>
+              </a:defRPr>
+            </a:pPr>
+            <a:r>
+              <a:rPr sz="1200" b="0">
+                <a:solidFill>
+                  <a:srgbClr val="627D98"/>
+                </a:solidFill>
+              </a:rPr>
+              <a:t>Near $300k mean wealth: pre p90 saves 31.5%; post p80 saves 7.4%. Cohort means are not fixed-dollar bins.</a:t>
+            </a:r>
+          </a:p>
+        </p:txBody>
+      </p:sp>
+      <p:pic>
+        <p:nvPicPr>
+          <p:cNvPr id="32" name=""/>
+          <p:cNvPicPr>
+            <a:picLocks xmlns:a="http://schemas.openxmlformats.org/drawingml/2006/main" noChangeAspect="1"/>
+          </p:cNvPicPr>
+          <p:nvPr/>
+        </p:nvPicPr>
+        <p:blipFill>
+          <a:blip xmlns:r="http://schemas.openxmlformats.org/officeDocument/2006/relationships" xmlns:a="http://schemas.openxmlformats.org/drawingml/2006/main" r:embed="R5e0396f78d1a4d55"/>
+          <a:stretch xmlns:a="http://schemas.openxmlformats.org/drawingml/2006/main"/>
+        </p:blipFill>
+        <p:spPr>
+          <a:xfrm xmlns:a="http://schemas.openxmlformats.org/drawingml/2006/main" flipH="0" flipV="0">
+            <a:off x="632746" y="1552099"/>
+            <a:ext cx="5059204" cy="3372802"/>
+          </a:xfrm>
+          <a:prstGeom xmlns:a="http://schemas.openxmlformats.org/drawingml/2006/main" prst="rect">
+            <a:avLst/>
+          </a:prstGeom>
+        </p:spPr>
+      </p:pic>
+      <p:pic>
+        <p:nvPicPr>
+          <p:cNvPr id="33" name=""/>
+          <p:cNvPicPr>
+            <a:picLocks xmlns:a="http://schemas.openxmlformats.org/drawingml/2006/main" noChangeAspect="1"/>
+          </p:cNvPicPr>
+          <p:nvPr/>
+        </p:nvPicPr>
+        <p:blipFill>
+          <a:blip xmlns:r="http://schemas.openxmlformats.org/officeDocument/2006/relationships" xmlns:a="http://schemas.openxmlformats.org/drawingml/2006/main" r:embed="R0e563d3933f64e0c"/>
+          <a:stretch xmlns:a="http://schemas.openxmlformats.org/drawingml/2006/main"/>
+        </p:blipFill>
+        <p:spPr>
+          <a:xfrm xmlns:a="http://schemas.openxmlformats.org/drawingml/2006/main" flipH="0" flipV="0">
+            <a:off x="6450393" y="1776603"/>
+            <a:ext cx="5158614" cy="2923699"/>
+          </a:xfrm>
+          <a:prstGeom xmlns:a="http://schemas.openxmlformats.org/drawingml/2006/main" prst="rect">
+            <a:avLst/>
+          </a:prstGeom>
+        </p:spPr>
+      </p:pic>
+    </p:spTree>
+    <p:extLst>
+      <p:ext uri="{BB962C8B-B14F-4D97-AF65-F5344CB8AC3E}">
+        <p14:creationId xmlns:p14="http://schemas.microsoft.com/office/powerpoint/2010/main" val="1065330000"/>
+      </p:ext>
+    </p:extLst>
+  </p:cSld>
+</p:sld>
+</file>
+
+<file path=ppt/slides/slide13.xml><?xml version="1.0" encoding="utf-8"?>
+<p:sld xmlns:p="http://schemas.openxmlformats.org/presentationml/2006/main">
+  <p:cSld>
+    <p:bg>
+      <p:bgPr>
+        <a:solidFill xmlns:a="http://schemas.openxmlformats.org/drawingml/2006/main">
+          <a:srgbClr val="FFFFFF"/>
+        </a:solidFill>
+      </p:bgPr>
+    </p:bg>
+    <p:spTree>
+      <p:nvGrpSpPr>
+        <p:cNvPr id="1" name=""/>
+        <p:cNvGrpSpPr/>
+        <p:nvPr/>
+      </p:nvGrpSpPr>
+      <p:grpSpPr>
+        <a:xfrm xmlns:a="http://schemas.openxmlformats.org/drawingml/2006/main"/>
+      </p:grpSpPr>
+      <p:sp>
+        <p:nvSpPr>
+          <p:cNvPr id="16" name="kicker">
+            <a:extLst xmlns:a="http://schemas.openxmlformats.org/drawingml/2006/main">
+              <a:ext uri="{FF2B5EF4-FFF2-40B4-BE49-F238E27FC236}">
+                <a16:creationId xmlns:a16="http://schemas.microsoft.com/office/drawing/2014/main" id="{AA955CD9-B4EF-4E20-A3FC-1D7B4F59A354}"/>
+              </a:ext>
+            </a:extLst>
+          </p:cNvPr>
+          <p:cNvSpPr>
+            <a:spLocks xmlns:a="http://schemas.openxmlformats.org/drawingml/2006/main" noGrp="1"/>
+          </p:cNvSpPr>
+          <p:nvPr/>
+        </p:nvSpPr>
+        <p:spPr>
+          <a:xfrm xmlns:a="http://schemas.openxmlformats.org/drawingml/2006/main">
+            <a:off x="457200" y="228600"/>
+            <a:ext cx="8572500" cy="209550"/>
+          </a:xfrm>
+          <a:prstGeom xmlns:a="http://schemas.openxmlformats.org/drawingml/2006/main" prst="rect">
+            <a:avLst/>
+          </a:prstGeom>
+          <a:noFill xmlns:a="http://schemas.openxmlformats.org/drawingml/2006/main"/>
+          <a:ln xmlns:a="http://schemas.openxmlformats.org/drawingml/2006/main" w="0">
+            <a:noFill/>
+            <a:prstDash val="solid"/>
+          </a:ln>
+        </p:spPr>
+        <p:txBody>
+          <a:bodyPr xmlns:a="http://schemas.openxmlformats.org/drawingml/2006/main" anchor="t"/>
+          <a:lstStyle xmlns:a="http://schemas.openxmlformats.org/drawingml/2006/main"/>
+          <a:p xmlns:a="http://schemas.openxmlformats.org/drawingml/2006/main">
+            <a:pPr algn="l">
+              <a:buNone/>
+              <a:defRPr sz="1050" b="1">
+                <a:solidFill>
+                  <a:srgbClr val="C65D16"/>
+                </a:solidFill>
+              </a:defRPr>
+            </a:pPr>
+            <a:r>
+              <a:rPr sz="1050" b="1">
+                <a:solidFill>
+                  <a:srgbClr val="C65D16"/>
+                </a:solidFill>
+              </a:rPr>
+              <a:t>FIGURE 6 TIME EVOLUTION</a:t>
+            </a:r>
+          </a:p>
+        </p:txBody>
+      </p:sp>
+      <p:sp>
+        <p:nvSpPr>
+          <p:cNvPr id="2" name="title">
+            <a:extLst xmlns:a="http://schemas.openxmlformats.org/drawingml/2006/main">
+              <a:ext uri="{FF2B5EF4-FFF2-40B4-BE49-F238E27FC236}">
+                <a16:creationId xmlns:a16="http://schemas.microsoft.com/office/drawing/2014/main" id="{BE8A36E9-77A3-4197-AAEB-944D96A22E35}"/>
+              </a:ext>
+            </a:extLst>
+          </p:cNvPr>
+          <p:cNvSpPr>
+            <a:spLocks xmlns:a="http://schemas.openxmlformats.org/drawingml/2006/main" noGrp="1"/>
+          </p:cNvSpPr>
+          <p:nvPr/>
+        </p:nvSpPr>
+        <p:spPr>
+          <a:xfrm xmlns:a="http://schemas.openxmlformats.org/drawingml/2006/main">
+            <a:off x="457200" y="457200"/>
+            <a:ext cx="10858500" cy="495300"/>
+          </a:xfrm>
+          <a:prstGeom xmlns:a="http://schemas.openxmlformats.org/drawingml/2006/main" prst="rect">
+            <a:avLst/>
+          </a:prstGeom>
+          <a:noFill xmlns:a="http://schemas.openxmlformats.org/drawingml/2006/main"/>
+          <a:ln xmlns:a="http://schemas.openxmlformats.org/drawingml/2006/main" w="0">
+            <a:noFill/>
+            <a:prstDash val="solid"/>
+          </a:ln>
+        </p:spPr>
+        <p:txBody>
+          <a:bodyPr xmlns:a="http://schemas.openxmlformats.org/drawingml/2006/main" anchor="t"/>
+          <a:lstStyle xmlns:a="http://schemas.openxmlformats.org/drawingml/2006/main"/>
+          <a:p xmlns:a="http://schemas.openxmlformats.org/drawingml/2006/main">
+            <a:pPr algn="l">
+              <a:buNone/>
+              <a:defRPr sz="2700" b="1">
+                <a:solidFill>
+                  <a:srgbClr val="102A43"/>
+                </a:solidFill>
+              </a:defRPr>
+            </a:pPr>
+            <a:r>
+              <a:rPr sz="2700" b="1">
+                <a:solidFill>
+                  <a:srgbClr val="102A43"/>
+                </a:solidFill>
+              </a:rPr>
+              <a:t>Upper-middle rates trend down; the top 1% remains volatile</a:t>
+            </a:r>
+          </a:p>
+        </p:txBody>
+      </p:sp>
+      <p:sp>
+        <p:nvSpPr>
+          <p:cNvPr id="3" name="header-rule">
+            <a:extLst xmlns:a="http://schemas.openxmlformats.org/drawingml/2006/main">
+              <a:ext uri="{FF2B5EF4-FFF2-40B4-BE49-F238E27FC236}">
+                <a16:creationId xmlns:a16="http://schemas.microsoft.com/office/drawing/2014/main" id="{514C6BB1-D2D7-4502-B63E-CB46F5220FD9}"/>
+              </a:ext>
+            </a:extLst>
+          </p:cNvPr>
+          <p:cNvSpPr>
+            <a:spLocks xmlns:a="http://schemas.openxmlformats.org/drawingml/2006/main" noGrp="1"/>
+          </p:cNvSpPr>
+          <p:nvPr/>
+        </p:nvSpPr>
+        <p:spPr>
+          <a:xfrm xmlns:a="http://schemas.openxmlformats.org/drawingml/2006/main">
+            <a:off x="457200" y="981075"/>
+            <a:ext cx="11277600" cy="19050"/>
+          </a:xfrm>
+          <a:prstGeom xmlns:a="http://schemas.openxmlformats.org/drawingml/2006/main" prst="rect">
+            <a:avLst/>
+          </a:prstGeom>
+          <a:solidFill xmlns:a="http://schemas.openxmlformats.org/drawingml/2006/main">
+            <a:srgbClr val="102A43"/>
+          </a:solidFill>
+          <a:ln xmlns:a="http://schemas.openxmlformats.org/drawingml/2006/main" w="0">
+            <a:noFill/>
+            <a:prstDash val="solid"/>
+          </a:ln>
+        </p:spPr>
+      </p:sp>
+      <p:sp>
+        <p:nvSpPr>
+          <p:cNvPr id="4" name="slide-number">
+            <a:extLst xmlns:a="http://schemas.openxmlformats.org/drawingml/2006/main">
+              <a:ext uri="{FF2B5EF4-FFF2-40B4-BE49-F238E27FC236}">
+                <a16:creationId xmlns:a16="http://schemas.microsoft.com/office/drawing/2014/main" id="{1846DD66-DAE1-4F4D-9638-E1108AC93C86}"/>
+              </a:ext>
+            </a:extLst>
+          </p:cNvPr>
+          <p:cNvSpPr>
+            <a:spLocks xmlns:a="http://schemas.openxmlformats.org/drawingml/2006/main" noGrp="1"/>
+          </p:cNvSpPr>
+          <p:nvPr/>
+        </p:nvSpPr>
+        <p:spPr>
+          <a:xfrm xmlns:a="http://schemas.openxmlformats.org/drawingml/2006/main">
+            <a:off x="11334750" y="266700"/>
+            <a:ext cx="400050" cy="228600"/>
+          </a:xfrm>
+          <a:prstGeom xmlns:a="http://schemas.openxmlformats.org/drawingml/2006/main" prst="rect">
+            <a:avLst/>
+          </a:prstGeom>
+          <a:noFill xmlns:a="http://schemas.openxmlformats.org/drawingml/2006/main"/>
+          <a:ln xmlns:a="http://schemas.openxmlformats.org/drawingml/2006/main" w="0">
+            <a:noFill/>
+            <a:prstDash val="solid"/>
+          </a:ln>
+        </p:spPr>
+        <p:txBody>
+          <a:bodyPr xmlns:a="http://schemas.openxmlformats.org/drawingml/2006/main" anchor="t"/>
+          <a:lstStyle xmlns:a="http://schemas.openxmlformats.org/drawingml/2006/main"/>
+          <a:p xmlns:a="http://schemas.openxmlformats.org/drawingml/2006/main">
+            <a:pPr algn="r">
+              <a:buNone/>
+              <a:defRPr sz="1050" b="1">
+                <a:solidFill>
+                  <a:srgbClr val="627D98"/>
+                </a:solidFill>
+              </a:defRPr>
+            </a:pPr>
+            <a:r>
+              <a:rPr sz="1050" b="1">
+                <a:solidFill>
+                  <a:srgbClr val="627D98"/>
+                </a:solidFill>
+              </a:rPr>
+              <a:t>13</a:t>
+            </a:r>
+          </a:p>
+        </p:txBody>
+      </p:sp>
+      <p:sp>
+        <p:nvSpPr>
+          <p:cNvPr id="5" name="left-label">
+            <a:extLst xmlns:a="http://schemas.openxmlformats.org/drawingml/2006/main">
+              <a:ext uri="{FF2B5EF4-FFF2-40B4-BE49-F238E27FC236}">
+                <a16:creationId xmlns:a16="http://schemas.microsoft.com/office/drawing/2014/main" id="{AC7EBFD9-49FB-40B3-B7BA-0564A41A3ADA}"/>
+              </a:ext>
+            </a:extLst>
+          </p:cNvPr>
+          <p:cNvSpPr>
+            <a:spLocks xmlns:a="http://schemas.openxmlformats.org/drawingml/2006/main" noGrp="1"/>
+          </p:cNvSpPr>
+          <p:nvPr/>
+        </p:nvSpPr>
+        <p:spPr>
+          <a:xfrm xmlns:a="http://schemas.openxmlformats.org/drawingml/2006/main">
+            <a:off x="457200" y="1123950"/>
+            <a:ext cx="5334000" cy="266700"/>
+          </a:xfrm>
+          <a:prstGeom xmlns:a="http://schemas.openxmlformats.org/drawingml/2006/main" prst="rect">
+            <a:avLst/>
+          </a:prstGeom>
+          <a:noFill xmlns:a="http://schemas.openxmlformats.org/drawingml/2006/main"/>
+          <a:ln xmlns:a="http://schemas.openxmlformats.org/drawingml/2006/main" w="0">
+            <a:noFill/>
+            <a:prstDash val="solid"/>
+          </a:ln>
+        </p:spPr>
+        <p:txBody>
+          <a:bodyPr xmlns:a="http://schemas.openxmlformats.org/drawingml/2006/main" anchor="t"/>
+          <a:lstStyle xmlns:a="http://schemas.openxmlformats.org/drawingml/2006/main"/>
+          <a:p xmlns:a="http://schemas.openxmlformats.org/drawingml/2006/main">
+            <a:pPr algn="l">
+              <a:buNone/>
+              <a:defRPr sz="1350" b="1">
+                <a:solidFill>
+                  <a:srgbClr val="2E5B88"/>
+                </a:solidFill>
+              </a:defRPr>
+            </a:pPr>
+            <a:r>
+              <a:rPr sz="1350" b="1">
+                <a:solidFill>
+                  <a:srgbClr val="2E5B88"/>
+                </a:solidFill>
+              </a:rPr>
+              <a:t>Full distribution · trailing five-year means</a:t>
+            </a:r>
+          </a:p>
+        </p:txBody>
+      </p:sp>
+      <p:sp>
+        <p:nvSpPr>
+          <p:cNvPr id="6" name="right-label">
+            <a:extLst xmlns:a="http://schemas.openxmlformats.org/drawingml/2006/main">
+              <a:ext uri="{FF2B5EF4-FFF2-40B4-BE49-F238E27FC236}">
+                <a16:creationId xmlns:a16="http://schemas.microsoft.com/office/drawing/2014/main" id="{D7EBD11C-5C33-487B-AFE7-65F7CD7D2108}"/>
+              </a:ext>
+            </a:extLst>
+          </p:cNvPr>
+          <p:cNvSpPr>
+            <a:spLocks xmlns:a="http://schemas.openxmlformats.org/drawingml/2006/main" noGrp="1"/>
+          </p:cNvSpPr>
+          <p:nvPr/>
+        </p:nvSpPr>
+        <p:spPr>
+          <a:xfrm xmlns:a="http://schemas.openxmlformats.org/drawingml/2006/main">
+            <a:off x="6324600" y="1123950"/>
+            <a:ext cx="5410200" cy="266700"/>
+          </a:xfrm>
+          <a:prstGeom xmlns:a="http://schemas.openxmlformats.org/drawingml/2006/main" prst="rect">
+            <a:avLst/>
+          </a:prstGeom>
+          <a:noFill xmlns:a="http://schemas.openxmlformats.org/drawingml/2006/main"/>
+          <a:ln xmlns:a="http://schemas.openxmlformats.org/drawingml/2006/main" w="0">
+            <a:noFill/>
+            <a:prstDash val="solid"/>
+          </a:ln>
+        </p:spPr>
+        <p:txBody>
+          <a:bodyPr xmlns:a="http://schemas.openxmlformats.org/drawingml/2006/main" anchor="t"/>
+          <a:lstStyle xmlns:a="http://schemas.openxmlformats.org/drawingml/2006/main"/>
+          <a:p xmlns:a="http://schemas.openxmlformats.org/drawingml/2006/main">
+            <a:pPr algn="l">
+              <a:buNone/>
+              <a:defRPr sz="1350" b="1">
+                <a:solidFill>
+                  <a:srgbClr val="C65D16"/>
+                </a:solidFill>
+              </a:defRPr>
+            </a:pPr>
+            <a:r>
+              <a:rPr sz="1350" b="1">
+                <a:solidFill>
+                  <a:srgbClr val="C65D16"/>
+                </a:solidFill>
+              </a:rPr>
+              <a:t>Selected upper-tail percentiles</a:t>
+            </a:r>
+          </a:p>
+        </p:txBody>
+      </p:sp>
+      <p:sp>
+        <p:nvSpPr>
+          <p:cNvPr id="7" name="Regenerated 2021 safe-asset demand figure-frame">
+            <a:extLst xmlns:a="http://schemas.openxmlformats.org/drawingml/2006/main">
+              <a:ext uri="{FF2B5EF4-FFF2-40B4-BE49-F238E27FC236}">
+                <a16:creationId xmlns:a16="http://schemas.microsoft.com/office/drawing/2014/main" id="{1442A94D-98B9-4DC6-8E97-11AE6BD7202F}"/>
+              </a:ext>
+            </a:extLst>
+          </p:cNvPr>
+          <p:cNvSpPr>
+            <a:spLocks xmlns:a="http://schemas.openxmlformats.org/drawingml/2006/main" noGrp="1"/>
+          </p:cNvSpPr>
+          <p:nvPr/>
+        </p:nvSpPr>
+        <p:spPr>
+          <a:xfrm xmlns:a="http://schemas.openxmlformats.org/drawingml/2006/main">
+            <a:off x="457200" y="1428750"/>
+            <a:ext cx="5410200" cy="3638550"/>
+          </a:xfrm>
+          <a:prstGeom xmlns:a="http://schemas.openxmlformats.org/drawingml/2006/main" prst="roundRect">
+            <a:avLst>
+              <a:gd name="adj" fmla="val 1047"/>
+            </a:avLst>
+          </a:prstGeom>
+          <a:solidFill xmlns:a="http://schemas.openxmlformats.org/drawingml/2006/main">
+            <a:srgbClr val="FFFFFF"/>
+          </a:solidFill>
+          <a:ln xmlns:a="http://schemas.openxmlformats.org/drawingml/2006/main" w="9525">
+            <a:solidFill>
+              <a:srgbClr val="D8E1E8"/>
+            </a:solidFill>
+            <a:prstDash val="solid"/>
+          </a:ln>
+        </p:spPr>
+      </p:sp>
+      <p:sp>
+        <p:nvSpPr>
+          <p:cNvPr id="9" name="2025 Figure 10 safe-asset demand-frame">
+            <a:extLst xmlns:a="http://schemas.openxmlformats.org/drawingml/2006/main">
+              <a:ext uri="{FF2B5EF4-FFF2-40B4-BE49-F238E27FC236}">
+                <a16:creationId xmlns:a16="http://schemas.microsoft.com/office/drawing/2014/main" id="{98F7C92D-66A0-4F20-83BF-E349E5E80E9E}"/>
+              </a:ext>
+            </a:extLst>
+          </p:cNvPr>
+          <p:cNvSpPr>
+            <a:spLocks xmlns:a="http://schemas.openxmlformats.org/drawingml/2006/main" noGrp="1"/>
+          </p:cNvSpPr>
+          <p:nvPr/>
+        </p:nvSpPr>
+        <p:spPr>
+          <a:xfrm xmlns:a="http://schemas.openxmlformats.org/drawingml/2006/main">
+            <a:off x="6324600" y="1428750"/>
+            <a:ext cx="5410200" cy="3638550"/>
+          </a:xfrm>
+          <a:prstGeom xmlns:a="http://schemas.openxmlformats.org/drawingml/2006/main" prst="roundRect">
+            <a:avLst>
+              <a:gd name="adj" fmla="val 1047"/>
+            </a:avLst>
+          </a:prstGeom>
+          <a:solidFill xmlns:a="http://schemas.openxmlformats.org/drawingml/2006/main">
+            <a:srgbClr val="FFFFFF"/>
+          </a:solidFill>
+          <a:ln xmlns:a="http://schemas.openxmlformats.org/drawingml/2006/main" w="9525">
+            <a:solidFill>
+              <a:srgbClr val="D8E1E8"/>
+            </a:solidFill>
+            <a:prstDash val="solid"/>
+          </a:ln>
+        </p:spPr>
+      </p:sp>
+      <p:sp>
+        <p:nvSpPr>
+          <p:cNvPr id="11" name="assessment-band">
+            <a:extLst xmlns:a="http://schemas.openxmlformats.org/drawingml/2006/main">
+              <a:ext uri="{FF2B5EF4-FFF2-40B4-BE49-F238E27FC236}">
+                <a16:creationId xmlns:a16="http://schemas.microsoft.com/office/drawing/2014/main" id="{8E0201B9-6249-4F69-8DD3-3C91F0AFAC32}"/>
+              </a:ext>
+            </a:extLst>
+          </p:cNvPr>
+          <p:cNvSpPr>
+            <a:spLocks xmlns:a="http://schemas.openxmlformats.org/drawingml/2006/main" noGrp="1"/>
+          </p:cNvSpPr>
+          <p:nvPr/>
+        </p:nvSpPr>
+        <p:spPr>
+          <a:xfrm xmlns:a="http://schemas.openxmlformats.org/drawingml/2006/main">
+            <a:off x="457200" y="5219700"/>
+            <a:ext cx="11277600" cy="1219200"/>
+          </a:xfrm>
+          <a:prstGeom xmlns:a="http://schemas.openxmlformats.org/drawingml/2006/main" prst="roundRect">
+            <a:avLst>
+              <a:gd name="adj" fmla="val 3125"/>
+            </a:avLst>
+          </a:prstGeom>
+          <a:solidFill xmlns:a="http://schemas.openxmlformats.org/drawingml/2006/main">
+            <a:srgbClr val="F4F7FA"/>
+          </a:solidFill>
+          <a:ln xmlns:a="http://schemas.openxmlformats.org/drawingml/2006/main" w="0">
+            <a:noFill/>
+            <a:prstDash val="solid"/>
+          </a:ln>
+        </p:spPr>
+      </p:sp>
+      <p:sp>
+        <p:nvSpPr>
+          <p:cNvPr id="12" name="assessment-accent">
+            <a:extLst xmlns:a="http://schemas.openxmlformats.org/drawingml/2006/main">
+              <a:ext uri="{FF2B5EF4-FFF2-40B4-BE49-F238E27FC236}">
+                <a16:creationId xmlns:a16="http://schemas.microsoft.com/office/drawing/2014/main" id="{E6607933-8AC4-4796-94EB-F2FB6C0865F1}"/>
+              </a:ext>
+            </a:extLst>
+          </p:cNvPr>
+          <p:cNvSpPr>
+            <a:spLocks xmlns:a="http://schemas.openxmlformats.org/drawingml/2006/main" noGrp="1"/>
+          </p:cNvSpPr>
+          <p:nvPr/>
+        </p:nvSpPr>
+        <p:spPr>
+          <a:xfrm xmlns:a="http://schemas.openxmlformats.org/drawingml/2006/main">
+            <a:off x="457200" y="5219700"/>
+            <a:ext cx="76200" cy="1219200"/>
+          </a:xfrm>
+          <a:prstGeom xmlns:a="http://schemas.openxmlformats.org/drawingml/2006/main" prst="rect">
+            <a:avLst/>
+          </a:prstGeom>
+          <a:solidFill xmlns:a="http://schemas.openxmlformats.org/drawingml/2006/main">
+            <a:srgbClr val="2F855A"/>
+          </a:solidFill>
+          <a:ln xmlns:a="http://schemas.openxmlformats.org/drawingml/2006/main" w="0">
+            <a:noFill/>
+            <a:prstDash val="solid"/>
+          </a:ln>
+        </p:spPr>
+      </p:sp>
+      <p:sp>
+        <p:nvSpPr>
+          <p:cNvPr id="13" name="verdict">
+            <a:extLst xmlns:a="http://schemas.openxmlformats.org/drawingml/2006/main">
+              <a:ext uri="{FF2B5EF4-FFF2-40B4-BE49-F238E27FC236}">
+                <a16:creationId xmlns:a16="http://schemas.microsoft.com/office/drawing/2014/main" id="{DAEE4CAF-C158-4F1E-AF88-9B2A72776725}"/>
+              </a:ext>
+            </a:extLst>
+          </p:cNvPr>
+          <p:cNvSpPr>
+            <a:spLocks xmlns:a="http://schemas.openxmlformats.org/drawingml/2006/main" noGrp="1"/>
+          </p:cNvSpPr>
+          <p:nvPr/>
+        </p:nvSpPr>
+        <p:spPr>
+          <a:xfrm xmlns:a="http://schemas.openxmlformats.org/drawingml/2006/main">
+            <a:off x="685800" y="5362575"/>
+            <a:ext cx="3143250" cy="314325"/>
+          </a:xfrm>
+          <a:prstGeom xmlns:a="http://schemas.openxmlformats.org/drawingml/2006/main" prst="rect">
+            <a:avLst/>
+          </a:prstGeom>
+          <a:noFill xmlns:a="http://schemas.openxmlformats.org/drawingml/2006/main"/>
+          <a:ln xmlns:a="http://schemas.openxmlformats.org/drawingml/2006/main" w="0">
+            <a:noFill/>
+            <a:prstDash val="solid"/>
+          </a:ln>
+        </p:spPr>
+        <p:txBody>
+          <a:bodyPr xmlns:a="http://schemas.openxmlformats.org/drawingml/2006/main" anchor="t"/>
+          <a:lstStyle xmlns:a="http://schemas.openxmlformats.org/drawingml/2006/main"/>
+          <a:p xmlns:a="http://schemas.openxmlformats.org/drawingml/2006/main">
+            <a:pPr algn="l">
+              <a:buNone/>
+              <a:defRPr sz="1725" b="1">
+                <a:solidFill>
+                  <a:srgbClr val="2F855A"/>
+                </a:solidFill>
+              </a:defRPr>
+            </a:pPr>
+            <a:r>
+              <a:rPr sz="1725" b="1">
+                <a:solidFill>
+                  <a:srgbClr val="2F855A"/>
+                </a:solidFill>
+              </a:rPr>
+              <a:t>NOT A SINGLE BREAK</a:t>
+            </a:r>
+          </a:p>
+        </p:txBody>
+      </p:sp>
+      <p:sp>
+        <p:nvSpPr>
+          <p:cNvPr id="14" name="assessment">
+            <a:extLst xmlns:a="http://schemas.openxmlformats.org/drawingml/2006/main">
+              <a:ext uri="{FF2B5EF4-FFF2-40B4-BE49-F238E27FC236}">
+                <a16:creationId xmlns:a16="http://schemas.microsoft.com/office/drawing/2014/main" id="{F5E1C807-0687-4A75-8864-05548460D9A0}"/>
+              </a:ext>
+            </a:extLst>
+          </p:cNvPr>
+          <p:cNvSpPr>
+            <a:spLocks xmlns:a="http://schemas.openxmlformats.org/drawingml/2006/main" noGrp="1"/>
+          </p:cNvSpPr>
+          <p:nvPr/>
+        </p:nvSpPr>
+        <p:spPr>
+          <a:xfrm xmlns:a="http://schemas.openxmlformats.org/drawingml/2006/main">
+            <a:off x="3857625" y="5334000"/>
+            <a:ext cx="7620000" cy="457200"/>
+          </a:xfrm>
+          <a:prstGeom xmlns:a="http://schemas.openxmlformats.org/drawingml/2006/main" prst="rect">
+            <a:avLst/>
+          </a:prstGeom>
+          <a:noFill xmlns:a="http://schemas.openxmlformats.org/drawingml/2006/main"/>
+          <a:ln xmlns:a="http://schemas.openxmlformats.org/drawingml/2006/main" w="0">
+            <a:noFill/>
+            <a:prstDash val="solid"/>
+          </a:ln>
+        </p:spPr>
+        <p:txBody>
+          <a:bodyPr xmlns:a="http://schemas.openxmlformats.org/drawingml/2006/main" anchor="t"/>
+          <a:lstStyle xmlns:a="http://schemas.openxmlformats.org/drawingml/2006/main"/>
+          <a:p xmlns:a="http://schemas.openxmlformats.org/drawingml/2006/main">
+            <a:pPr algn="l">
+              <a:buNone/>
+              <a:defRPr sz="1350" b="0">
+                <a:solidFill>
+                  <a:srgbClr val="243B53"/>
+                </a:solidFill>
+              </a:defRPr>
+            </a:pPr>
+            <a:r>
+              <a:rPr sz="1350" b="0">
+                <a:solidFill>
+                  <a:srgbClr val="243B53"/>
+                </a:solidFill>
+              </a:rPr>
+              <a:t>The 80th–90th percentiles decline persistently after the late 1980s.</a:t>
+            </a:r>
+          </a:p>
+        </p:txBody>
+      </p:sp>
+      <p:sp>
+        <p:nvSpPr>
+          <p:cNvPr id="15" name="difference">
+            <a:extLst xmlns:a="http://schemas.openxmlformats.org/drawingml/2006/main">
+              <a:ext uri="{FF2B5EF4-FFF2-40B4-BE49-F238E27FC236}">
+                <a16:creationId xmlns:a16="http://schemas.microsoft.com/office/drawing/2014/main" id="{9E94ECB7-8637-4F89-9ABB-1A8B2FEF54E1}"/>
+              </a:ext>
+            </a:extLst>
+          </p:cNvPr>
+          <p:cNvSpPr>
+            <a:spLocks xmlns:a="http://schemas.openxmlformats.org/drawingml/2006/main" noGrp="1"/>
+          </p:cNvSpPr>
+          <p:nvPr/>
+        </p:nvSpPr>
+        <p:spPr>
+          <a:xfrm xmlns:a="http://schemas.openxmlformats.org/drawingml/2006/main">
+            <a:off x="685800" y="5848350"/>
+            <a:ext cx="10763250" cy="400050"/>
+          </a:xfrm>
+          <a:prstGeom xmlns:a="http://schemas.openxmlformats.org/drawingml/2006/main" prst="rect">
+            <a:avLst/>
+          </a:prstGeom>
+          <a:noFill xmlns:a="http://schemas.openxmlformats.org/drawingml/2006/main"/>
+          <a:ln xmlns:a="http://schemas.openxmlformats.org/drawingml/2006/main" w="0">
+            <a:noFill/>
+            <a:prstDash val="solid"/>
+          </a:ln>
+        </p:spPr>
+        <p:txBody>
+          <a:bodyPr xmlns:a="http://schemas.openxmlformats.org/drawingml/2006/main" anchor="t"/>
+          <a:lstStyle xmlns:a="http://schemas.openxmlformats.org/drawingml/2006/main"/>
+          <a:p xmlns:a="http://schemas.openxmlformats.org/drawingml/2006/main">
+            <a:pPr algn="l">
+              <a:buNone/>
+              <a:defRPr sz="1200" b="0">
+                <a:solidFill>
+                  <a:srgbClr val="627D98"/>
+                </a:solidFill>
+              </a:defRPr>
+            </a:pPr>
+            <a:r>
+              <a:rPr sz="1200" b="0">
+                <a:solidFill>
+                  <a:srgbClr val="627D98"/>
+                </a:solidFill>
+              </a:rPr>
+              <a:t>The top 1% oscillates sharply, including a 2008 five-year peak; this is not one smooth monotone trend.</a:t>
+            </a:r>
+          </a:p>
+        </p:txBody>
+      </p:sp>
+      <p:pic>
+        <p:nvPicPr>
+          <p:cNvPr id="32" name=""/>
+          <p:cNvPicPr>
+            <a:picLocks xmlns:a="http://schemas.openxmlformats.org/drawingml/2006/main" noChangeAspect="1"/>
+          </p:cNvPicPr>
+          <p:nvPr/>
+        </p:nvPicPr>
+        <p:blipFill>
+          <a:blip xmlns:r="http://schemas.openxmlformats.org/officeDocument/2006/relationships" xmlns:a="http://schemas.openxmlformats.org/drawingml/2006/main" r:embed="Ree30bd9c5b574034"/>
+          <a:stretch xmlns:a="http://schemas.openxmlformats.org/drawingml/2006/main"/>
+        </p:blipFill>
+        <p:spPr>
+          <a:xfrm xmlns:a="http://schemas.openxmlformats.org/drawingml/2006/main" flipH="0" flipV="0">
+            <a:off x="632746" y="1552099"/>
+            <a:ext cx="5059204" cy="3372802"/>
+          </a:xfrm>
+          <a:prstGeom xmlns:a="http://schemas.openxmlformats.org/drawingml/2006/main" prst="rect">
+            <a:avLst/>
+          </a:prstGeom>
+        </p:spPr>
+      </p:pic>
+      <p:pic>
+        <p:nvPicPr>
+          <p:cNvPr id="33" name=""/>
+          <p:cNvPicPr>
+            <a:picLocks xmlns:a="http://schemas.openxmlformats.org/drawingml/2006/main" noChangeAspect="1"/>
+          </p:cNvPicPr>
+          <p:nvPr/>
+        </p:nvPicPr>
+        <p:blipFill>
+          <a:blip xmlns:r="http://schemas.openxmlformats.org/officeDocument/2006/relationships" xmlns:a="http://schemas.openxmlformats.org/drawingml/2006/main" r:embed="R13be0ab094e54193"/>
+          <a:stretch xmlns:a="http://schemas.openxmlformats.org/drawingml/2006/main"/>
+        </p:blipFill>
+        <p:spPr>
+          <a:xfrm xmlns:a="http://schemas.openxmlformats.org/drawingml/2006/main" flipH="0" flipV="0">
+            <a:off x="6450393" y="1776603"/>
+            <a:ext cx="5158614" cy="2923699"/>
+          </a:xfrm>
+          <a:prstGeom xmlns:a="http://schemas.openxmlformats.org/drawingml/2006/main" prst="rect">
+            <a:avLst/>
+          </a:prstGeom>
+        </p:spPr>
+      </p:pic>
+    </p:spTree>
+    <p:extLst>
+      <p:ext uri="{BB962C8B-B14F-4D97-AF65-F5344CB8AC3E}">
+        <p14:creationId xmlns:p14="http://schemas.microsoft.com/office/powerpoint/2010/main" val="1065330000"/>
+      </p:ext>
+    </p:extLst>
+  </p:cSld>
+</p:sld>
+</file>
+
+<file path=ppt/slides/slide14.xml><?xml version="1.0" encoding="utf-8"?>
+<p:sld xmlns:p="http://schemas.openxmlformats.org/presentationml/2006/main">
+  <p:cSld>
+    <p:bg>
+      <p:bgPr>
+        <a:solidFill xmlns:a="http://schemas.openxmlformats.org/drawingml/2006/main">
+          <a:srgbClr val="FFFFFF"/>
+        </a:solidFill>
+      </p:bgPr>
+    </p:bg>
+    <p:spTree>
+      <p:nvGrpSpPr>
+        <p:cNvPr id="1" name=""/>
+        <p:cNvGrpSpPr/>
+        <p:nvPr/>
+      </p:nvGrpSpPr>
+      <p:grpSpPr>
+        <a:xfrm xmlns:a="http://schemas.openxmlformats.org/drawingml/2006/main"/>
+      </p:grpSpPr>
+      <p:sp>
+        <p:nvSpPr>
+          <p:cNvPr id="20" name="kicker">
+            <a:extLst xmlns:a="http://schemas.openxmlformats.org/drawingml/2006/main">
+              <a:ext uri="{FF2B5EF4-FFF2-40B4-BE49-F238E27FC236}">
+                <a16:creationId xmlns:a16="http://schemas.microsoft.com/office/drawing/2014/main" id="{4DBD74DF-ED28-4EE9-8535-9E366A67537D}"/>
+              </a:ext>
+            </a:extLst>
+          </p:cNvPr>
+          <p:cNvSpPr>
+            <a:spLocks xmlns:a="http://schemas.openxmlformats.org/drawingml/2006/main" noGrp="1"/>
+          </p:cNvSpPr>
+          <p:nvPr/>
+        </p:nvSpPr>
+        <p:spPr>
+          <a:xfrm xmlns:a="http://schemas.openxmlformats.org/drawingml/2006/main">
+            <a:off x="457200" y="228600"/>
+            <a:ext cx="8572500" cy="209550"/>
+          </a:xfrm>
+          <a:prstGeom xmlns:a="http://schemas.openxmlformats.org/drawingml/2006/main" prst="rect">
+            <a:avLst/>
+          </a:prstGeom>
+          <a:noFill xmlns:a="http://schemas.openxmlformats.org/drawingml/2006/main"/>
+          <a:ln xmlns:a="http://schemas.openxmlformats.org/drawingml/2006/main" w="0">
+            <a:noFill/>
+            <a:prstDash val="solid"/>
+          </a:ln>
+        </p:spPr>
+        <p:txBody>
+          <a:bodyPr xmlns:a="http://schemas.openxmlformats.org/drawingml/2006/main" anchor="t"/>
+          <a:lstStyle xmlns:a="http://schemas.openxmlformats.org/drawingml/2006/main"/>
+          <a:p xmlns:a="http://schemas.openxmlformats.org/drawingml/2006/main">
+            <a:pPr algn="l">
+              <a:buNone/>
+              <a:defRPr sz="1050" b="1">
+                <a:solidFill>
+                  <a:srgbClr val="C65D16"/>
+                </a:solidFill>
+              </a:defRPr>
+            </a:pPr>
+            <a:r>
+              <a:rPr sz="1050" b="1">
+                <a:solidFill>
+                  <a:srgbClr val="C65D16"/>
+                </a:solidFill>
+              </a:rPr>
+              <a:t>FIGURE 8 FEASIBILITY</a:t>
+            </a:r>
+          </a:p>
+        </p:txBody>
+      </p:sp>
+      <p:sp>
+        <p:nvSpPr>
+          <p:cNvPr id="2" name="title">
+            <a:extLst xmlns:a="http://schemas.openxmlformats.org/drawingml/2006/main">
+              <a:ext uri="{FF2B5EF4-FFF2-40B4-BE49-F238E27FC236}">
+                <a16:creationId xmlns:a16="http://schemas.microsoft.com/office/drawing/2014/main" id="{25994307-319F-4EAA-8D7C-9E832F74B960}"/>
+              </a:ext>
+            </a:extLst>
+          </p:cNvPr>
+          <p:cNvSpPr>
+            <a:spLocks xmlns:a="http://schemas.openxmlformats.org/drawingml/2006/main" noGrp="1"/>
+          </p:cNvSpPr>
+          <p:nvPr/>
+        </p:nvSpPr>
+        <p:spPr>
+          <a:xfrm xmlns:a="http://schemas.openxmlformats.org/drawingml/2006/main">
+            <a:off x="457200" y="457200"/>
+            <a:ext cx="10858500" cy="495300"/>
+          </a:xfrm>
+          <a:prstGeom xmlns:a="http://schemas.openxmlformats.org/drawingml/2006/main" prst="rect">
+            <a:avLst/>
+          </a:prstGeom>
+          <a:noFill xmlns:a="http://schemas.openxmlformats.org/drawingml/2006/main"/>
+          <a:ln xmlns:a="http://schemas.openxmlformats.org/drawingml/2006/main" w="0">
+            <a:noFill/>
+            <a:prstDash val="solid"/>
+          </a:ln>
+        </p:spPr>
+        <p:txBody>
+          <a:bodyPr xmlns:a="http://schemas.openxmlformats.org/drawingml/2006/main" anchor="t"/>
+          <a:lstStyle xmlns:a="http://schemas.openxmlformats.org/drawingml/2006/main"/>
+          <a:p xmlns:a="http://schemas.openxmlformats.org/drawingml/2006/main">
+            <a:pPr algn="l">
+              <a:buNone/>
+              <a:defRPr sz="2700" b="1">
+                <a:solidFill>
+                  <a:srgbClr val="102A43"/>
+                </a:solidFill>
+              </a:defRPr>
+            </a:pPr>
+            <a:r>
+              <a:rPr sz="2700" b="1">
+                <a:solidFill>
+                  <a:srgbClr val="102A43"/>
+                </a:solidFill>
+              </a:rPr>
+              <a:t>Figure 8 stops one step before the revised matrix solve</a:t>
+            </a:r>
+          </a:p>
+        </p:txBody>
+      </p:sp>
+      <p:sp>
+        <p:nvSpPr>
+          <p:cNvPr id="3" name="header-rule">
+            <a:extLst xmlns:a="http://schemas.openxmlformats.org/drawingml/2006/main">
+              <a:ext uri="{FF2B5EF4-FFF2-40B4-BE49-F238E27FC236}">
+                <a16:creationId xmlns:a16="http://schemas.microsoft.com/office/drawing/2014/main" id="{9304C898-8A92-4A39-A7EB-64A100354E4A}"/>
+              </a:ext>
+            </a:extLst>
+          </p:cNvPr>
+          <p:cNvSpPr>
+            <a:spLocks xmlns:a="http://schemas.openxmlformats.org/drawingml/2006/main" noGrp="1"/>
+          </p:cNvSpPr>
+          <p:nvPr/>
+        </p:nvSpPr>
+        <p:spPr>
+          <a:xfrm xmlns:a="http://schemas.openxmlformats.org/drawingml/2006/main">
+            <a:off x="457200" y="981075"/>
+            <a:ext cx="11277600" cy="19050"/>
+          </a:xfrm>
+          <a:prstGeom xmlns:a="http://schemas.openxmlformats.org/drawingml/2006/main" prst="rect">
+            <a:avLst/>
+          </a:prstGeom>
+          <a:solidFill xmlns:a="http://schemas.openxmlformats.org/drawingml/2006/main">
+            <a:srgbClr val="102A43"/>
+          </a:solidFill>
+          <a:ln xmlns:a="http://schemas.openxmlformats.org/drawingml/2006/main" w="0">
+            <a:noFill/>
+            <a:prstDash val="solid"/>
+          </a:ln>
+        </p:spPr>
+      </p:sp>
+      <p:sp>
+        <p:nvSpPr>
+          <p:cNvPr id="4" name="slide-number">
+            <a:extLst xmlns:a="http://schemas.openxmlformats.org/drawingml/2006/main">
+              <a:ext uri="{FF2B5EF4-FFF2-40B4-BE49-F238E27FC236}">
+                <a16:creationId xmlns:a16="http://schemas.microsoft.com/office/drawing/2014/main" id="{E4772364-3993-46C7-BB6A-7696849F37B9}"/>
+              </a:ext>
+            </a:extLst>
+          </p:cNvPr>
+          <p:cNvSpPr>
+            <a:spLocks xmlns:a="http://schemas.openxmlformats.org/drawingml/2006/main" noGrp="1"/>
+          </p:cNvSpPr>
+          <p:nvPr/>
+        </p:nvSpPr>
+        <p:spPr>
+          <a:xfrm xmlns:a="http://schemas.openxmlformats.org/drawingml/2006/main">
+            <a:off x="11334750" y="266700"/>
+            <a:ext cx="400050" cy="228600"/>
+          </a:xfrm>
+          <a:prstGeom xmlns:a="http://schemas.openxmlformats.org/drawingml/2006/main" prst="rect">
+            <a:avLst/>
+          </a:prstGeom>
+          <a:noFill xmlns:a="http://schemas.openxmlformats.org/drawingml/2006/main"/>
+          <a:ln xmlns:a="http://schemas.openxmlformats.org/drawingml/2006/main" w="0">
+            <a:noFill/>
+            <a:prstDash val="solid"/>
+          </a:ln>
+        </p:spPr>
+        <p:txBody>
+          <a:bodyPr xmlns:a="http://schemas.openxmlformats.org/drawingml/2006/main" anchor="t"/>
+          <a:lstStyle xmlns:a="http://schemas.openxmlformats.org/drawingml/2006/main"/>
+          <a:p xmlns:a="http://schemas.openxmlformats.org/drawingml/2006/main">
+            <a:pPr algn="r">
+              <a:buNone/>
+              <a:defRPr sz="1050" b="1">
+                <a:solidFill>
+                  <a:srgbClr val="627D98"/>
+                </a:solidFill>
+              </a:defRPr>
+            </a:pPr>
+            <a:r>
+              <a:rPr sz="1050" b="1">
+                <a:solidFill>
+                  <a:srgbClr val="627D98"/>
+                </a:solidFill>
+              </a:rPr>
+              <a:t>14</a:t>
+            </a:r>
+          </a:p>
+        </p:txBody>
+      </p:sp>
+      <p:sp>
+        <p:nvSpPr>
           <p:cNvPr id="5" name="question">
             <a:extLst xmlns:a="http://schemas.openxmlformats.org/drawingml/2006/main">
               <a:ext uri="{FF2B5EF4-FFF2-40B4-BE49-F238E27FC236}">
@@ -4274,7 +5955,7 @@
                   <a:srgbClr val="102A43"/>
                 </a:solidFill>
               </a:rPr>
-              <a:t>Conclusion</a:t>
+              <a:t>Target</a:t>
             </a:r>
           </a:p>
         </p:txBody>
@@ -4325,7 +6006,25 @@
                   <a:srgbClr val="243B53"/>
                 </a:solidFill>
               </a:rPr>
-              <a:t>What did the 2021 kit let us test?</a:t>
+              <a:t>2025 Figure 8</a:t>
+            </a:r>
+          </a:p>
+          <a:p xmlns:a="http://schemas.openxmlformats.org/drawingml/2006/main">
+            <a:pPr algn="l">
+              <a:buNone/>
+              <a:defRPr sz="1875" b="0">
+                <a:solidFill>
+                  <a:srgbClr val="243B53"/>
+                </a:solidFill>
+              </a:defRPr>
+            </a:pPr>
+            <a:r>
+              <a:rPr sz="1875" b="0">
+                <a:solidFill>
+                  <a:srgbClr val="243B53"/>
+                </a:solidFill>
+              </a:rPr>
+              <a:t>Net household debt by wealth group</a:t>
             </a:r>
           </a:p>
         </p:txBody>
@@ -4384,7 +6083,7 @@
             <a:avLst/>
           </a:prstGeom>
           <a:solidFill xmlns:a="http://schemas.openxmlformats.org/drawingml/2006/main">
-            <a:srgbClr val="C65D16"/>
+            <a:srgbClr val="8A96A3"/>
           </a:solidFill>
           <a:ln xmlns:a="http://schemas.openxmlformats.org/drawingml/2006/main" w="0">
             <a:noFill/>
@@ -4435,10 +6134,10 @@
             <a:r>
               <a:rPr sz="1725" b="1">
                 <a:solidFill>
-                  <a:srgbClr val="C65D16"/>
-                </a:solidFill>
-              </a:rPr>
-              <a:t>Figure 1</a:t>
+                  <a:srgbClr val="627D98"/>
+                </a:solidFill>
+              </a:rPr>
+              <a:t>1 · Missing upstream</a:t>
             </a:r>
           </a:p>
         </p:txBody>
@@ -4489,7 +6188,7 @@
                   <a:srgbClr val="243B53"/>
                 </a:solidFill>
               </a:rPr>
-              <a:t>Close stock reconstruction; share denominator remains version-specific.</a:t>
+              <a:t>Completed 2025 instrument × sector matrices and augmented household columns.</a:t>
             </a:r>
           </a:p>
         </p:txBody>
@@ -4511,139 +6210,6 @@
         <p:spPr>
           <a:xfrm xmlns:a="http://schemas.openxmlformats.org/drawingml/2006/main">
             <a:off x="5905500" y="2609850"/>
-            <a:ext cx="76200" cy="952500"/>
-          </a:xfrm>
-          <a:prstGeom xmlns:a="http://schemas.openxmlformats.org/drawingml/2006/main" prst="rect">
-            <a:avLst/>
-          </a:prstGeom>
-          <a:solidFill xmlns:a="http://schemas.openxmlformats.org/drawingml/2006/main">
-            <a:srgbClr val="627D98"/>
-          </a:solidFill>
-          <a:ln xmlns:a="http://schemas.openxmlformats.org/drawingml/2006/main" w="0">
-            <a:noFill/>
-            <a:prstDash val="solid"/>
-          </a:ln>
-        </p:spPr>
-      </p:sp>
-      <p:sp>
-        <p:nvSpPr>
-          <p:cNvPr id="12" name="Partial match-label">
-            <a:extLst xmlns:a="http://schemas.openxmlformats.org/drawingml/2006/main">
-              <a:ext uri="{FF2B5EF4-FFF2-40B4-BE49-F238E27FC236}">
-                <a16:creationId xmlns:a16="http://schemas.microsoft.com/office/drawing/2014/main" id="{217D0269-3366-4106-A614-BFB2DD0B2ECF}"/>
-              </a:ext>
-            </a:extLst>
-          </p:cNvPr>
-          <p:cNvSpPr>
-            <a:spLocks xmlns:a="http://schemas.openxmlformats.org/drawingml/2006/main" noGrp="1"/>
-          </p:cNvSpPr>
-          <p:nvPr/>
-        </p:nvSpPr>
-        <p:spPr>
-          <a:xfrm xmlns:a="http://schemas.openxmlformats.org/drawingml/2006/main">
-            <a:off x="6191250" y="2647950"/>
-            <a:ext cx="2476500" cy="285750"/>
-          </a:xfrm>
-          <a:prstGeom xmlns:a="http://schemas.openxmlformats.org/drawingml/2006/main" prst="rect">
-            <a:avLst/>
-          </a:prstGeom>
-          <a:noFill xmlns:a="http://schemas.openxmlformats.org/drawingml/2006/main"/>
-          <a:ln xmlns:a="http://schemas.openxmlformats.org/drawingml/2006/main" w="0">
-            <a:noFill/>
-            <a:prstDash val="solid"/>
-          </a:ln>
-        </p:spPr>
-        <p:txBody>
-          <a:bodyPr xmlns:a="http://schemas.openxmlformats.org/drawingml/2006/main" anchor="t"/>
-          <a:lstStyle xmlns:a="http://schemas.openxmlformats.org/drawingml/2006/main"/>
-          <a:p xmlns:a="http://schemas.openxmlformats.org/drawingml/2006/main">
-            <a:pPr algn="l">
-              <a:buNone/>
-              <a:defRPr sz="1725" b="1">
-                <a:solidFill>
-                  <a:srgbClr val="B7791F"/>
-                </a:solidFill>
-              </a:defRPr>
-            </a:pPr>
-            <a:r>
-              <a:rPr sz="1725" b="1">
-                <a:solidFill>
-                  <a:srgbClr val="627D98"/>
-                </a:solidFill>
-              </a:rPr>
-              <a:t>Figure 5</a:t>
-            </a:r>
-          </a:p>
-        </p:txBody>
-      </p:sp>
-      <p:sp>
-        <p:nvSpPr>
-          <p:cNvPr id="13" name="Partial match-body">
-            <a:extLst xmlns:a="http://schemas.openxmlformats.org/drawingml/2006/main">
-              <a:ext uri="{FF2B5EF4-FFF2-40B4-BE49-F238E27FC236}">
-                <a16:creationId xmlns:a16="http://schemas.microsoft.com/office/drawing/2014/main" id="{00ABC748-B2B5-4893-8CE6-FDE63773F6C0}"/>
-              </a:ext>
-            </a:extLst>
-          </p:cNvPr>
-          <p:cNvSpPr>
-            <a:spLocks xmlns:a="http://schemas.openxmlformats.org/drawingml/2006/main" noGrp="1"/>
-          </p:cNvSpPr>
-          <p:nvPr/>
-        </p:nvSpPr>
-        <p:spPr>
-          <a:xfrm xmlns:a="http://schemas.openxmlformats.org/drawingml/2006/main">
-            <a:off x="6191250" y="2981325"/>
-            <a:ext cx="5048250" cy="552450"/>
-          </a:xfrm>
-          <a:prstGeom xmlns:a="http://schemas.openxmlformats.org/drawingml/2006/main" prst="rect">
-            <a:avLst/>
-          </a:prstGeom>
-          <a:noFill xmlns:a="http://schemas.openxmlformats.org/drawingml/2006/main"/>
-          <a:ln xmlns:a="http://schemas.openxmlformats.org/drawingml/2006/main" w="0">
-            <a:noFill/>
-            <a:prstDash val="solid"/>
-          </a:ln>
-        </p:spPr>
-        <p:txBody>
-          <a:bodyPr xmlns:a="http://schemas.openxmlformats.org/drawingml/2006/main" anchor="t"/>
-          <a:lstStyle xmlns:a="http://schemas.openxmlformats.org/drawingml/2006/main"/>
-          <a:p xmlns:a="http://schemas.openxmlformats.org/drawingml/2006/main">
-            <a:pPr algn="l">
-              <a:buNone/>
-              <a:defRPr sz="1350" b="0">
-                <a:solidFill>
-                  <a:srgbClr val="243B53"/>
-                </a:solidFill>
-              </a:defRPr>
-            </a:pPr>
-            <a:r>
-              <a:rPr sz="1350" b="0">
-                <a:solidFill>
-                  <a:srgbClr val="243B53"/>
-                </a:solidFill>
-              </a:rPr>
-              <a:t>High-fidelity revised saving and display method through 2016.</a:t>
-            </a:r>
-          </a:p>
-        </p:txBody>
-      </p:sp>
-      <p:sp>
-        <p:nvSpPr>
-          <p:cNvPr id="14" name="Context only-bar">
-            <a:extLst xmlns:a="http://schemas.openxmlformats.org/drawingml/2006/main">
-              <a:ext uri="{FF2B5EF4-FFF2-40B4-BE49-F238E27FC236}">
-                <a16:creationId xmlns:a16="http://schemas.microsoft.com/office/drawing/2014/main" id="{A567A865-2022-41CE-BB30-AB58E2C2A04A}"/>
-              </a:ext>
-            </a:extLst>
-          </p:cNvPr>
-          <p:cNvSpPr>
-            <a:spLocks xmlns:a="http://schemas.openxmlformats.org/drawingml/2006/main" noGrp="1"/>
-          </p:cNvSpPr>
-          <p:nvPr/>
-        </p:nvSpPr>
-        <p:spPr>
-          <a:xfrm xmlns:a="http://schemas.openxmlformats.org/drawingml/2006/main">
-            <a:off x="5905500" y="3886200"/>
             <a:ext cx="76200" cy="952500"/>
           </a:xfrm>
           <a:prstGeom xmlns:a="http://schemas.openxmlformats.org/drawingml/2006/main" prst="rect">
@@ -4660,6 +6226,139 @@
       </p:sp>
       <p:sp>
         <p:nvSpPr>
+          <p:cNvPr id="12" name="Partial match-label">
+            <a:extLst xmlns:a="http://schemas.openxmlformats.org/drawingml/2006/main">
+              <a:ext uri="{FF2B5EF4-FFF2-40B4-BE49-F238E27FC236}">
+                <a16:creationId xmlns:a16="http://schemas.microsoft.com/office/drawing/2014/main" id="{217D0269-3366-4106-A614-BFB2DD0B2ECF}"/>
+              </a:ext>
+            </a:extLst>
+          </p:cNvPr>
+          <p:cNvSpPr>
+            <a:spLocks xmlns:a="http://schemas.openxmlformats.org/drawingml/2006/main" noGrp="1"/>
+          </p:cNvSpPr>
+          <p:nvPr/>
+        </p:nvSpPr>
+        <p:spPr>
+          <a:xfrm xmlns:a="http://schemas.openxmlformats.org/drawingml/2006/main">
+            <a:off x="6191250" y="2647950"/>
+            <a:ext cx="2476500" cy="285750"/>
+          </a:xfrm>
+          <a:prstGeom xmlns:a="http://schemas.openxmlformats.org/drawingml/2006/main" prst="rect">
+            <a:avLst/>
+          </a:prstGeom>
+          <a:noFill xmlns:a="http://schemas.openxmlformats.org/drawingml/2006/main"/>
+          <a:ln xmlns:a="http://schemas.openxmlformats.org/drawingml/2006/main" w="0">
+            <a:noFill/>
+            <a:prstDash val="solid"/>
+          </a:ln>
+        </p:spPr>
+        <p:txBody>
+          <a:bodyPr xmlns:a="http://schemas.openxmlformats.org/drawingml/2006/main" anchor="t"/>
+          <a:lstStyle xmlns:a="http://schemas.openxmlformats.org/drawingml/2006/main"/>
+          <a:p xmlns:a="http://schemas.openxmlformats.org/drawingml/2006/main">
+            <a:pPr algn="l">
+              <a:buNone/>
+              <a:defRPr sz="1725" b="1">
+                <a:solidFill>
+                  <a:srgbClr val="B7791F"/>
+                </a:solidFill>
+              </a:defRPr>
+            </a:pPr>
+            <a:r>
+              <a:rPr sz="1725" b="1">
+                <a:solidFill>
+                  <a:srgbClr val="2E5B88"/>
+                </a:solidFill>
+              </a:rPr>
+              <a:t>2 · Old-kit output</a:t>
+            </a:r>
+          </a:p>
+        </p:txBody>
+      </p:sp>
+      <p:sp>
+        <p:nvSpPr>
+          <p:cNvPr id="13" name="Partial match-body">
+            <a:extLst xmlns:a="http://schemas.openxmlformats.org/drawingml/2006/main">
+              <a:ext uri="{FF2B5EF4-FFF2-40B4-BE49-F238E27FC236}">
+                <a16:creationId xmlns:a16="http://schemas.microsoft.com/office/drawing/2014/main" id="{00ABC748-B2B5-4893-8CE6-FDE63773F6C0}"/>
+              </a:ext>
+            </a:extLst>
+          </p:cNvPr>
+          <p:cNvSpPr>
+            <a:spLocks xmlns:a="http://schemas.openxmlformats.org/drawingml/2006/main" noGrp="1"/>
+          </p:cNvSpPr>
+          <p:nvPr/>
+        </p:nvSpPr>
+        <p:spPr>
+          <a:xfrm xmlns:a="http://schemas.openxmlformats.org/drawingml/2006/main">
+            <a:off x="6191250" y="2981325"/>
+            <a:ext cx="5048250" cy="552450"/>
+          </a:xfrm>
+          <a:prstGeom xmlns:a="http://schemas.openxmlformats.org/drawingml/2006/main" prst="rect">
+            <a:avLst/>
+          </a:prstGeom>
+          <a:noFill xmlns:a="http://schemas.openxmlformats.org/drawingml/2006/main"/>
+          <a:ln xmlns:a="http://schemas.openxmlformats.org/drawingml/2006/main" w="0">
+            <a:noFill/>
+            <a:prstDash val="solid"/>
+          </a:ln>
+        </p:spPr>
+        <p:txBody>
+          <a:bodyPr xmlns:a="http://schemas.openxmlformats.org/drawingml/2006/main" anchor="t"/>
+          <a:lstStyle xmlns:a="http://schemas.openxmlformats.org/drawingml/2006/main"/>
+          <a:p xmlns:a="http://schemas.openxmlformats.org/drawingml/2006/main">
+            <a:pPr algn="l">
+              <a:buNone/>
+              <a:defRPr sz="1350" b="0">
+                <a:solidFill>
+                  <a:srgbClr val="243B53"/>
+                </a:solidFill>
+              </a:defRPr>
+            </a:pPr>
+            <a:r>
+              <a:rPr sz="1350" b="0">
+                <a:solidFill>
+                  <a:srgbClr val="243B53"/>
+                </a:solidFill>
+              </a:rPr>
+              <a:t>Fine debt assets after seven rounds + fine liabilities.</a:t>
+            </a:r>
+          </a:p>
+        </p:txBody>
+      </p:sp>
+      <p:sp>
+        <p:nvSpPr>
+          <p:cNvPr id="14" name="Context only-bar">
+            <a:extLst xmlns:a="http://schemas.openxmlformats.org/drawingml/2006/main">
+              <a:ext uri="{FF2B5EF4-FFF2-40B4-BE49-F238E27FC236}">
+                <a16:creationId xmlns:a16="http://schemas.microsoft.com/office/drawing/2014/main" id="{A567A865-2022-41CE-BB30-AB58E2C2A04A}"/>
+              </a:ext>
+            </a:extLst>
+          </p:cNvPr>
+          <p:cNvSpPr>
+            <a:spLocks xmlns:a="http://schemas.openxmlformats.org/drawingml/2006/main" noGrp="1"/>
+          </p:cNvSpPr>
+          <p:nvPr/>
+        </p:nvSpPr>
+        <p:spPr>
+          <a:xfrm xmlns:a="http://schemas.openxmlformats.org/drawingml/2006/main">
+            <a:off x="5905500" y="3886200"/>
+            <a:ext cx="76200" cy="952500"/>
+          </a:xfrm>
+          <a:prstGeom xmlns:a="http://schemas.openxmlformats.org/drawingml/2006/main" prst="rect">
+            <a:avLst/>
+          </a:prstGeom>
+          <a:solidFill xmlns:a="http://schemas.openxmlformats.org/drawingml/2006/main">
+            <a:srgbClr val="C65D16"/>
+          </a:solidFill>
+          <a:ln xmlns:a="http://schemas.openxmlformats.org/drawingml/2006/main" w="0">
+            <a:noFill/>
+            <a:prstDash val="solid"/>
+          </a:ln>
+        </p:spPr>
+      </p:sp>
+      <p:sp>
+        <p:nvSpPr>
           <p:cNvPr id="15" name="Context only-label">
             <a:extLst xmlns:a="http://schemas.openxmlformats.org/drawingml/2006/main">
               <a:ext uri="{FF2B5EF4-FFF2-40B4-BE49-F238E27FC236}">
@@ -4701,10 +6400,10 @@
             <a:r>
               <a:rPr sz="1725" b="1">
                 <a:solidFill>
-                  <a:srgbClr val="2E5B88"/>
-                </a:solidFill>
-              </a:rPr>
-              <a:t>Figure 8</a:t>
+                  <a:srgbClr val="C65D16"/>
+                </a:solidFill>
+              </a:rPr>
+              <a:t>3 · Applied faithfully</a:t>
             </a:r>
           </a:p>
         </p:txBody>
@@ -4755,7 +6454,7 @@
                   <a:srgbClr val="243B53"/>
                 </a:solidFill>
               </a:rPr>
-              <a:t>Direction and bottom-99 level match; revised matrices are unavailable.</a:t>
+              <a:t>Net debt = debt assets − liabilities; divide by NI; subtract 1982.</a:t>
             </a:r>
           </a:p>
         </p:txBody>
@@ -4839,7 +6538,7 @@
                   <a:srgbClr val="B83232"/>
                 </a:solidFill>
               </a:rPr>
-              <a:t>Main lesson</a:t>
+              <a:t>Classification</a:t>
             </a:r>
           </a:p>
         </p:txBody>
@@ -4890,7 +6589,1533 @@
                   <a:srgbClr val="243B53"/>
                 </a:solidFill>
               </a:rPr>
-              <a:t>The data support the paper's core patterns. Only Figure 8 prevents a full method claim, so its filename and slide label say proxy.</a:t>
+              <a:t>Proxy: group, sign, scale, and base are revised; unveiled asset stocks still come from the older method.</a:t>
+            </a:r>
+          </a:p>
+        </p:txBody>
+      </p:sp>
+    </p:spTree>
+    <p:extLst>
+      <p:ext uri="{BB962C8B-B14F-4D97-AF65-F5344CB8AC3E}">
+        <p14:creationId xmlns:p14="http://schemas.microsoft.com/office/powerpoint/2010/main" val="221189521"/>
+      </p:ext>
+    </p:extLst>
+  </p:cSld>
+</p:sld>
+</file>
+
+<file path=ppt/slides/slide15.xml><?xml version="1.0" encoding="utf-8"?>
+<p:sld xmlns:p="http://schemas.openxmlformats.org/presentationml/2006/main">
+  <p:cSld>
+    <p:bg>
+      <p:bgPr>
+        <a:solidFill xmlns:a="http://schemas.openxmlformats.org/drawingml/2006/main">
+          <a:srgbClr val="FFFFFF"/>
+        </a:solidFill>
+      </p:bgPr>
+    </p:bg>
+    <p:spTree>
+      <p:nvGrpSpPr>
+        <p:cNvPr id="1" name=""/>
+        <p:cNvGrpSpPr/>
+        <p:nvPr/>
+      </p:nvGrpSpPr>
+      <p:grpSpPr>
+        <a:xfrm xmlns:a="http://schemas.openxmlformats.org/drawingml/2006/main"/>
+      </p:grpSpPr>
+      <p:sp>
+        <p:nvSpPr>
+          <p:cNvPr id="16" name="kicker">
+            <a:extLst xmlns:a="http://schemas.openxmlformats.org/drawingml/2006/main">
+              <a:ext uri="{FF2B5EF4-FFF2-40B4-BE49-F238E27FC236}">
+                <a16:creationId xmlns:a16="http://schemas.microsoft.com/office/drawing/2014/main" id="{AA955CD9-B4EF-4E20-A3FC-1D7B4F59A354}"/>
+              </a:ext>
+            </a:extLst>
+          </p:cNvPr>
+          <p:cNvSpPr>
+            <a:spLocks xmlns:a="http://schemas.openxmlformats.org/drawingml/2006/main" noGrp="1"/>
+          </p:cNvSpPr>
+          <p:nvPr/>
+        </p:nvSpPr>
+        <p:spPr>
+          <a:xfrm xmlns:a="http://schemas.openxmlformats.org/drawingml/2006/main">
+            <a:off x="457200" y="228600"/>
+            <a:ext cx="8572500" cy="209550"/>
+          </a:xfrm>
+          <a:prstGeom xmlns:a="http://schemas.openxmlformats.org/drawingml/2006/main" prst="rect">
+            <a:avLst/>
+          </a:prstGeom>
+          <a:noFill xmlns:a="http://schemas.openxmlformats.org/drawingml/2006/main"/>
+          <a:ln xmlns:a="http://schemas.openxmlformats.org/drawingml/2006/main" w="0">
+            <a:noFill/>
+            <a:prstDash val="solid"/>
+          </a:ln>
+        </p:spPr>
+        <p:txBody>
+          <a:bodyPr xmlns:a="http://schemas.openxmlformats.org/drawingml/2006/main" anchor="t"/>
+          <a:lstStyle xmlns:a="http://schemas.openxmlformats.org/drawingml/2006/main"/>
+          <a:p xmlns:a="http://schemas.openxmlformats.org/drawingml/2006/main">
+            <a:pPr algn="l">
+              <a:buNone/>
+              <a:defRPr sz="1050" b="1">
+                <a:solidFill>
+                  <a:srgbClr val="C65D16"/>
+                </a:solidFill>
+              </a:defRPr>
+            </a:pPr>
+            <a:r>
+              <a:rPr sz="1050" b="1">
+                <a:solidFill>
+                  <a:srgbClr val="C65D16"/>
+                </a:solidFill>
+              </a:rPr>
+              <a:t>FIGURE 8 PRIMARY COMPARISON</a:t>
+            </a:r>
+          </a:p>
+        </p:txBody>
+      </p:sp>
+      <p:sp>
+        <p:nvSpPr>
+          <p:cNvPr id="2" name="title">
+            <a:extLst xmlns:a="http://schemas.openxmlformats.org/drawingml/2006/main">
+              <a:ext uri="{FF2B5EF4-FFF2-40B4-BE49-F238E27FC236}">
+                <a16:creationId xmlns:a16="http://schemas.microsoft.com/office/drawing/2014/main" id="{BE8A36E9-77A3-4197-AAEB-944D96A22E35}"/>
+              </a:ext>
+            </a:extLst>
+          </p:cNvPr>
+          <p:cNvSpPr>
+            <a:spLocks xmlns:a="http://schemas.openxmlformats.org/drawingml/2006/main" noGrp="1"/>
+          </p:cNvSpPr>
+          <p:nvPr/>
+        </p:nvSpPr>
+        <p:spPr>
+          <a:xfrm xmlns:a="http://schemas.openxmlformats.org/drawingml/2006/main">
+            <a:off x="457200" y="457200"/>
+            <a:ext cx="10858500" cy="495300"/>
+          </a:xfrm>
+          <a:prstGeom xmlns:a="http://schemas.openxmlformats.org/drawingml/2006/main" prst="rect">
+            <a:avLst/>
+          </a:prstGeom>
+          <a:noFill xmlns:a="http://schemas.openxmlformats.org/drawingml/2006/main"/>
+          <a:ln xmlns:a="http://schemas.openxmlformats.org/drawingml/2006/main" w="0">
+            <a:noFill/>
+            <a:prstDash val="solid"/>
+          </a:ln>
+        </p:spPr>
+        <p:txBody>
+          <a:bodyPr xmlns:a="http://schemas.openxmlformats.org/drawingml/2006/main" anchor="t"/>
+          <a:lstStyle xmlns:a="http://schemas.openxmlformats.org/drawingml/2006/main"/>
+          <a:p xmlns:a="http://schemas.openxmlformats.org/drawingml/2006/main">
+            <a:pPr algn="l">
+              <a:buNone/>
+              <a:defRPr sz="2700" b="1">
+                <a:solidFill>
+                  <a:srgbClr val="102A43"/>
+                </a:solidFill>
+              </a:defRPr>
+            </a:pPr>
+            <a:r>
+              <a:rPr sz="2700" b="1">
+                <a:solidFill>
+                  <a:srgbClr val="102A43"/>
+                </a:solidFill>
+              </a:rPr>
+              <a:t>The proxy reproduces borrowing, but understates top-1 lending</a:t>
+            </a:r>
+          </a:p>
+        </p:txBody>
+      </p:sp>
+      <p:sp>
+        <p:nvSpPr>
+          <p:cNvPr id="3" name="header-rule">
+            <a:extLst xmlns:a="http://schemas.openxmlformats.org/drawingml/2006/main">
+              <a:ext uri="{FF2B5EF4-FFF2-40B4-BE49-F238E27FC236}">
+                <a16:creationId xmlns:a16="http://schemas.microsoft.com/office/drawing/2014/main" id="{514C6BB1-D2D7-4502-B63E-CB46F5220FD9}"/>
+              </a:ext>
+            </a:extLst>
+          </p:cNvPr>
+          <p:cNvSpPr>
+            <a:spLocks xmlns:a="http://schemas.openxmlformats.org/drawingml/2006/main" noGrp="1"/>
+          </p:cNvSpPr>
+          <p:nvPr/>
+        </p:nvSpPr>
+        <p:spPr>
+          <a:xfrm xmlns:a="http://schemas.openxmlformats.org/drawingml/2006/main">
+            <a:off x="457200" y="981075"/>
+            <a:ext cx="11277600" cy="19050"/>
+          </a:xfrm>
+          <a:prstGeom xmlns:a="http://schemas.openxmlformats.org/drawingml/2006/main" prst="rect">
+            <a:avLst/>
+          </a:prstGeom>
+          <a:solidFill xmlns:a="http://schemas.openxmlformats.org/drawingml/2006/main">
+            <a:srgbClr val="102A43"/>
+          </a:solidFill>
+          <a:ln xmlns:a="http://schemas.openxmlformats.org/drawingml/2006/main" w="0">
+            <a:noFill/>
+            <a:prstDash val="solid"/>
+          </a:ln>
+        </p:spPr>
+      </p:sp>
+      <p:sp>
+        <p:nvSpPr>
+          <p:cNvPr id="4" name="slide-number">
+            <a:extLst xmlns:a="http://schemas.openxmlformats.org/drawingml/2006/main">
+              <a:ext uri="{FF2B5EF4-FFF2-40B4-BE49-F238E27FC236}">
+                <a16:creationId xmlns:a16="http://schemas.microsoft.com/office/drawing/2014/main" id="{1846DD66-DAE1-4F4D-9638-E1108AC93C86}"/>
+              </a:ext>
+            </a:extLst>
+          </p:cNvPr>
+          <p:cNvSpPr>
+            <a:spLocks xmlns:a="http://schemas.openxmlformats.org/drawingml/2006/main" noGrp="1"/>
+          </p:cNvSpPr>
+          <p:nvPr/>
+        </p:nvSpPr>
+        <p:spPr>
+          <a:xfrm xmlns:a="http://schemas.openxmlformats.org/drawingml/2006/main">
+            <a:off x="11334750" y="266700"/>
+            <a:ext cx="400050" cy="228600"/>
+          </a:xfrm>
+          <a:prstGeom xmlns:a="http://schemas.openxmlformats.org/drawingml/2006/main" prst="rect">
+            <a:avLst/>
+          </a:prstGeom>
+          <a:noFill xmlns:a="http://schemas.openxmlformats.org/drawingml/2006/main"/>
+          <a:ln xmlns:a="http://schemas.openxmlformats.org/drawingml/2006/main" w="0">
+            <a:noFill/>
+            <a:prstDash val="solid"/>
+          </a:ln>
+        </p:spPr>
+        <p:txBody>
+          <a:bodyPr xmlns:a="http://schemas.openxmlformats.org/drawingml/2006/main" anchor="t"/>
+          <a:lstStyle xmlns:a="http://schemas.openxmlformats.org/drawingml/2006/main"/>
+          <a:p xmlns:a="http://schemas.openxmlformats.org/drawingml/2006/main">
+            <a:pPr algn="r">
+              <a:buNone/>
+              <a:defRPr sz="1050" b="1">
+                <a:solidFill>
+                  <a:srgbClr val="627D98"/>
+                </a:solidFill>
+              </a:defRPr>
+            </a:pPr>
+            <a:r>
+              <a:rPr sz="1050" b="1">
+                <a:solidFill>
+                  <a:srgbClr val="627D98"/>
+                </a:solidFill>
+              </a:rPr>
+              <a:t>15</a:t>
+            </a:r>
+          </a:p>
+        </p:txBody>
+      </p:sp>
+      <p:sp>
+        <p:nvSpPr>
+          <p:cNvPr id="5" name="left-label">
+            <a:extLst xmlns:a="http://schemas.openxmlformats.org/drawingml/2006/main">
+              <a:ext uri="{FF2B5EF4-FFF2-40B4-BE49-F238E27FC236}">
+                <a16:creationId xmlns:a16="http://schemas.microsoft.com/office/drawing/2014/main" id="{AC7EBFD9-49FB-40B3-B7BA-0564A41A3ADA}"/>
+              </a:ext>
+            </a:extLst>
+          </p:cNvPr>
+          <p:cNvSpPr>
+            <a:spLocks xmlns:a="http://schemas.openxmlformats.org/drawingml/2006/main" noGrp="1"/>
+          </p:cNvSpPr>
+          <p:nvPr/>
+        </p:nvSpPr>
+        <p:spPr>
+          <a:xfrm xmlns:a="http://schemas.openxmlformats.org/drawingml/2006/main">
+            <a:off x="457200" y="1123950"/>
+            <a:ext cx="5334000" cy="266700"/>
+          </a:xfrm>
+          <a:prstGeom xmlns:a="http://schemas.openxmlformats.org/drawingml/2006/main" prst="rect">
+            <a:avLst/>
+          </a:prstGeom>
+          <a:noFill xmlns:a="http://schemas.openxmlformats.org/drawingml/2006/main"/>
+          <a:ln xmlns:a="http://schemas.openxmlformats.org/drawingml/2006/main" w="0">
+            <a:noFill/>
+            <a:prstDash val="solid"/>
+          </a:ln>
+        </p:spPr>
+        <p:txBody>
+          <a:bodyPr xmlns:a="http://schemas.openxmlformats.org/drawingml/2006/main" anchor="t"/>
+          <a:lstStyle xmlns:a="http://schemas.openxmlformats.org/drawingml/2006/main"/>
+          <a:p xmlns:a="http://schemas.openxmlformats.org/drawingml/2006/main">
+            <a:pPr algn="l">
+              <a:buNone/>
+              <a:defRPr sz="1350" b="1">
+                <a:solidFill>
+                  <a:srgbClr val="2E5B88"/>
+                </a:solidFill>
+              </a:defRPr>
+            </a:pPr>
+            <a:r>
+              <a:rPr sz="1350" b="1">
+                <a:solidFill>
+                  <a:srgbClr val="2E5B88"/>
+                </a:solidFill>
+              </a:rPr>
+              <a:t>2025 paper · ratio axis (0.10 = 10 pp)</a:t>
+            </a:r>
+          </a:p>
+        </p:txBody>
+      </p:sp>
+      <p:sp>
+        <p:nvSpPr>
+          <p:cNvPr id="6" name="right-label">
+            <a:extLst xmlns:a="http://schemas.openxmlformats.org/drawingml/2006/main">
+              <a:ext uri="{FF2B5EF4-FFF2-40B4-BE49-F238E27FC236}">
+                <a16:creationId xmlns:a16="http://schemas.microsoft.com/office/drawing/2014/main" id="{D7EBD11C-5C33-487B-AFE7-65F7CD7D2108}"/>
+              </a:ext>
+            </a:extLst>
+          </p:cNvPr>
+          <p:cNvSpPr>
+            <a:spLocks xmlns:a="http://schemas.openxmlformats.org/drawingml/2006/main" noGrp="1"/>
+          </p:cNvSpPr>
+          <p:nvPr/>
+        </p:nvSpPr>
+        <p:spPr>
+          <a:xfrm xmlns:a="http://schemas.openxmlformats.org/drawingml/2006/main">
+            <a:off x="6324600" y="1123950"/>
+            <a:ext cx="5410200" cy="266700"/>
+          </a:xfrm>
+          <a:prstGeom xmlns:a="http://schemas.openxmlformats.org/drawingml/2006/main" prst="rect">
+            <a:avLst/>
+          </a:prstGeom>
+          <a:noFill xmlns:a="http://schemas.openxmlformats.org/drawingml/2006/main"/>
+          <a:ln xmlns:a="http://schemas.openxmlformats.org/drawingml/2006/main" w="0">
+            <a:noFill/>
+            <a:prstDash val="solid"/>
+          </a:ln>
+        </p:spPr>
+        <p:txBody>
+          <a:bodyPr xmlns:a="http://schemas.openxmlformats.org/drawingml/2006/main" anchor="t"/>
+          <a:lstStyle xmlns:a="http://schemas.openxmlformats.org/drawingml/2006/main"/>
+          <a:p xmlns:a="http://schemas.openxmlformats.org/drawingml/2006/main">
+            <a:pPr algn="l">
+              <a:buNone/>
+              <a:defRPr sz="1350" b="1">
+                <a:solidFill>
+                  <a:srgbClr val="C65D16"/>
+                </a:solidFill>
+              </a:defRPr>
+            </a:pPr>
+            <a:r>
+              <a:rPr sz="1350" b="1">
+                <a:solidFill>
+                  <a:srgbClr val="C65D16"/>
+                </a:solidFill>
+              </a:rPr>
+              <a:t>Our proxy · percentage-point axis</a:t>
+            </a:r>
+          </a:p>
+        </p:txBody>
+      </p:sp>
+      <p:sp>
+        <p:nvSpPr>
+          <p:cNvPr id="7" name="Regenerated 2021 safe-asset demand figure-frame">
+            <a:extLst xmlns:a="http://schemas.openxmlformats.org/drawingml/2006/main">
+              <a:ext uri="{FF2B5EF4-FFF2-40B4-BE49-F238E27FC236}">
+                <a16:creationId xmlns:a16="http://schemas.microsoft.com/office/drawing/2014/main" id="{1442A94D-98B9-4DC6-8E97-11AE6BD7202F}"/>
+              </a:ext>
+            </a:extLst>
+          </p:cNvPr>
+          <p:cNvSpPr>
+            <a:spLocks xmlns:a="http://schemas.openxmlformats.org/drawingml/2006/main" noGrp="1"/>
+          </p:cNvSpPr>
+          <p:nvPr/>
+        </p:nvSpPr>
+        <p:spPr>
+          <a:xfrm xmlns:a="http://schemas.openxmlformats.org/drawingml/2006/main">
+            <a:off x="457200" y="1428750"/>
+            <a:ext cx="5410200" cy="3638550"/>
+          </a:xfrm>
+          <a:prstGeom xmlns:a="http://schemas.openxmlformats.org/drawingml/2006/main" prst="roundRect">
+            <a:avLst>
+              <a:gd name="adj" fmla="val 1047"/>
+            </a:avLst>
+          </a:prstGeom>
+          <a:solidFill xmlns:a="http://schemas.openxmlformats.org/drawingml/2006/main">
+            <a:srgbClr val="FFFFFF"/>
+          </a:solidFill>
+          <a:ln xmlns:a="http://schemas.openxmlformats.org/drawingml/2006/main" w="9525">
+            <a:solidFill>
+              <a:srgbClr val="D8E1E8"/>
+            </a:solidFill>
+            <a:prstDash val="solid"/>
+          </a:ln>
+        </p:spPr>
+      </p:sp>
+      <p:sp>
+        <p:nvSpPr>
+          <p:cNvPr id="9" name="2025 Figure 10 safe-asset demand-frame">
+            <a:extLst xmlns:a="http://schemas.openxmlformats.org/drawingml/2006/main">
+              <a:ext uri="{FF2B5EF4-FFF2-40B4-BE49-F238E27FC236}">
+                <a16:creationId xmlns:a16="http://schemas.microsoft.com/office/drawing/2014/main" id="{98F7C92D-66A0-4F20-83BF-E349E5E80E9E}"/>
+              </a:ext>
+            </a:extLst>
+          </p:cNvPr>
+          <p:cNvSpPr>
+            <a:spLocks xmlns:a="http://schemas.openxmlformats.org/drawingml/2006/main" noGrp="1"/>
+          </p:cNvSpPr>
+          <p:nvPr/>
+        </p:nvSpPr>
+        <p:spPr>
+          <a:xfrm xmlns:a="http://schemas.openxmlformats.org/drawingml/2006/main">
+            <a:off x="6324600" y="1428750"/>
+            <a:ext cx="5410200" cy="3638550"/>
+          </a:xfrm>
+          <a:prstGeom xmlns:a="http://schemas.openxmlformats.org/drawingml/2006/main" prst="roundRect">
+            <a:avLst>
+              <a:gd name="adj" fmla="val 1047"/>
+            </a:avLst>
+          </a:prstGeom>
+          <a:solidFill xmlns:a="http://schemas.openxmlformats.org/drawingml/2006/main">
+            <a:srgbClr val="FFFFFF"/>
+          </a:solidFill>
+          <a:ln xmlns:a="http://schemas.openxmlformats.org/drawingml/2006/main" w="9525">
+            <a:solidFill>
+              <a:srgbClr val="D8E1E8"/>
+            </a:solidFill>
+            <a:prstDash val="solid"/>
+          </a:ln>
+        </p:spPr>
+      </p:sp>
+      <p:sp>
+        <p:nvSpPr>
+          <p:cNvPr id="11" name="assessment-band">
+            <a:extLst xmlns:a="http://schemas.openxmlformats.org/drawingml/2006/main">
+              <a:ext uri="{FF2B5EF4-FFF2-40B4-BE49-F238E27FC236}">
+                <a16:creationId xmlns:a16="http://schemas.microsoft.com/office/drawing/2014/main" id="{8E0201B9-6249-4F69-8DD3-3C91F0AFAC32}"/>
+              </a:ext>
+            </a:extLst>
+          </p:cNvPr>
+          <p:cNvSpPr>
+            <a:spLocks xmlns:a="http://schemas.openxmlformats.org/drawingml/2006/main" noGrp="1"/>
+          </p:cNvSpPr>
+          <p:nvPr/>
+        </p:nvSpPr>
+        <p:spPr>
+          <a:xfrm xmlns:a="http://schemas.openxmlformats.org/drawingml/2006/main">
+            <a:off x="457200" y="5219700"/>
+            <a:ext cx="11277600" cy="1219200"/>
+          </a:xfrm>
+          <a:prstGeom xmlns:a="http://schemas.openxmlformats.org/drawingml/2006/main" prst="roundRect">
+            <a:avLst>
+              <a:gd name="adj" fmla="val 3125"/>
+            </a:avLst>
+          </a:prstGeom>
+          <a:solidFill xmlns:a="http://schemas.openxmlformats.org/drawingml/2006/main">
+            <a:srgbClr val="F4F7FA"/>
+          </a:solidFill>
+          <a:ln xmlns:a="http://schemas.openxmlformats.org/drawingml/2006/main" w="0">
+            <a:noFill/>
+            <a:prstDash val="solid"/>
+          </a:ln>
+        </p:spPr>
+      </p:sp>
+      <p:sp>
+        <p:nvSpPr>
+          <p:cNvPr id="12" name="assessment-accent">
+            <a:extLst xmlns:a="http://schemas.openxmlformats.org/drawingml/2006/main">
+              <a:ext uri="{FF2B5EF4-FFF2-40B4-BE49-F238E27FC236}">
+                <a16:creationId xmlns:a16="http://schemas.microsoft.com/office/drawing/2014/main" id="{E6607933-8AC4-4796-94EB-F2FB6C0865F1}"/>
+              </a:ext>
+            </a:extLst>
+          </p:cNvPr>
+          <p:cNvSpPr>
+            <a:spLocks xmlns:a="http://schemas.openxmlformats.org/drawingml/2006/main" noGrp="1"/>
+          </p:cNvSpPr>
+          <p:nvPr/>
+        </p:nvSpPr>
+        <p:spPr>
+          <a:xfrm xmlns:a="http://schemas.openxmlformats.org/drawingml/2006/main">
+            <a:off x="457200" y="5219700"/>
+            <a:ext cx="76200" cy="1219200"/>
+          </a:xfrm>
+          <a:prstGeom xmlns:a="http://schemas.openxmlformats.org/drawingml/2006/main" prst="rect">
+            <a:avLst/>
+          </a:prstGeom>
+          <a:solidFill xmlns:a="http://schemas.openxmlformats.org/drawingml/2006/main">
+            <a:srgbClr val="2F855A"/>
+          </a:solidFill>
+          <a:ln xmlns:a="http://schemas.openxmlformats.org/drawingml/2006/main" w="0">
+            <a:noFill/>
+            <a:prstDash val="solid"/>
+          </a:ln>
+        </p:spPr>
+      </p:sp>
+      <p:sp>
+        <p:nvSpPr>
+          <p:cNvPr id="13" name="verdict">
+            <a:extLst xmlns:a="http://schemas.openxmlformats.org/drawingml/2006/main">
+              <a:ext uri="{FF2B5EF4-FFF2-40B4-BE49-F238E27FC236}">
+                <a16:creationId xmlns:a16="http://schemas.microsoft.com/office/drawing/2014/main" id="{DAEE4CAF-C158-4F1E-AF88-9B2A72776725}"/>
+              </a:ext>
+            </a:extLst>
+          </p:cNvPr>
+          <p:cNvSpPr>
+            <a:spLocks xmlns:a="http://schemas.openxmlformats.org/drawingml/2006/main" noGrp="1"/>
+          </p:cNvSpPr>
+          <p:nvPr/>
+        </p:nvSpPr>
+        <p:spPr>
+          <a:xfrm xmlns:a="http://schemas.openxmlformats.org/drawingml/2006/main">
+            <a:off x="685800" y="5362575"/>
+            <a:ext cx="3143250" cy="314325"/>
+          </a:xfrm>
+          <a:prstGeom xmlns:a="http://schemas.openxmlformats.org/drawingml/2006/main" prst="rect">
+            <a:avLst/>
+          </a:prstGeom>
+          <a:noFill xmlns:a="http://schemas.openxmlformats.org/drawingml/2006/main"/>
+          <a:ln xmlns:a="http://schemas.openxmlformats.org/drawingml/2006/main" w="0">
+            <a:noFill/>
+            <a:prstDash val="solid"/>
+          </a:ln>
+        </p:spPr>
+        <p:txBody>
+          <a:bodyPr xmlns:a="http://schemas.openxmlformats.org/drawingml/2006/main" anchor="t"/>
+          <a:lstStyle xmlns:a="http://schemas.openxmlformats.org/drawingml/2006/main"/>
+          <a:p xmlns:a="http://schemas.openxmlformats.org/drawingml/2006/main">
+            <a:pPr algn="l">
+              <a:buNone/>
+              <a:defRPr sz="1725" b="1">
+                <a:solidFill>
+                  <a:srgbClr val="2F855A"/>
+                </a:solidFill>
+              </a:defRPr>
+            </a:pPr>
+            <a:r>
+              <a:rPr sz="1725" b="1">
+                <a:solidFill>
+                  <a:srgbClr val="2F855A"/>
+                </a:solidFill>
+              </a:rPr>
+              <a:t>CLOSE PROXY</a:t>
+            </a:r>
+          </a:p>
+        </p:txBody>
+      </p:sp>
+      <p:sp>
+        <p:nvSpPr>
+          <p:cNvPr id="14" name="assessment">
+            <a:extLst xmlns:a="http://schemas.openxmlformats.org/drawingml/2006/main">
+              <a:ext uri="{FF2B5EF4-FFF2-40B4-BE49-F238E27FC236}">
+                <a16:creationId xmlns:a16="http://schemas.microsoft.com/office/drawing/2014/main" id="{F5E1C807-0687-4A75-8864-05548460D9A0}"/>
+              </a:ext>
+            </a:extLst>
+          </p:cNvPr>
+          <p:cNvSpPr>
+            <a:spLocks xmlns:a="http://schemas.openxmlformats.org/drawingml/2006/main" noGrp="1"/>
+          </p:cNvSpPr>
+          <p:nvPr/>
+        </p:nvSpPr>
+        <p:spPr>
+          <a:xfrm xmlns:a="http://schemas.openxmlformats.org/drawingml/2006/main">
+            <a:off x="3857625" y="5334000"/>
+            <a:ext cx="7620000" cy="457200"/>
+          </a:xfrm>
+          <a:prstGeom xmlns:a="http://schemas.openxmlformats.org/drawingml/2006/main" prst="rect">
+            <a:avLst/>
+          </a:prstGeom>
+          <a:noFill xmlns:a="http://schemas.openxmlformats.org/drawingml/2006/main"/>
+          <a:ln xmlns:a="http://schemas.openxmlformats.org/drawingml/2006/main" w="0">
+            <a:noFill/>
+            <a:prstDash val="solid"/>
+          </a:ln>
+        </p:spPr>
+        <p:txBody>
+          <a:bodyPr xmlns:a="http://schemas.openxmlformats.org/drawingml/2006/main" anchor="t"/>
+          <a:lstStyle xmlns:a="http://schemas.openxmlformats.org/drawingml/2006/main"/>
+          <a:p xmlns:a="http://schemas.openxmlformats.org/drawingml/2006/main">
+            <a:pPr algn="l">
+              <a:buNone/>
+              <a:defRPr sz="1350" b="0">
+                <a:solidFill>
+                  <a:srgbClr val="243B53"/>
+                </a:solidFill>
+              </a:defRPr>
+            </a:pPr>
+            <a:r>
+              <a:rPr sz="1350" b="0">
+                <a:solidFill>
+                  <a:srgbClr val="243B53"/>
+                </a:solidFill>
+              </a:rPr>
+              <a:t>2007: bottom 99% -38.88 pp proxy vs -38.76 paper; top 1% +12.03 vs +18.02.</a:t>
+            </a:r>
+          </a:p>
+        </p:txBody>
+      </p:sp>
+      <p:sp>
+        <p:nvSpPr>
+          <p:cNvPr id="15" name="difference">
+            <a:extLst xmlns:a="http://schemas.openxmlformats.org/drawingml/2006/main">
+              <a:ext uri="{FF2B5EF4-FFF2-40B4-BE49-F238E27FC236}">
+                <a16:creationId xmlns:a16="http://schemas.microsoft.com/office/drawing/2014/main" id="{9E94ECB7-8637-4F89-9ABB-1A8B2FEF54E1}"/>
+              </a:ext>
+            </a:extLst>
+          </p:cNvPr>
+          <p:cNvSpPr>
+            <a:spLocks xmlns:a="http://schemas.openxmlformats.org/drawingml/2006/main" noGrp="1"/>
+          </p:cNvSpPr>
+          <p:nvPr/>
+        </p:nvSpPr>
+        <p:spPr>
+          <a:xfrm xmlns:a="http://schemas.openxmlformats.org/drawingml/2006/main">
+            <a:off x="685800" y="5848350"/>
+            <a:ext cx="10763250" cy="400050"/>
+          </a:xfrm>
+          <a:prstGeom xmlns:a="http://schemas.openxmlformats.org/drawingml/2006/main" prst="rect">
+            <a:avLst/>
+          </a:prstGeom>
+          <a:noFill xmlns:a="http://schemas.openxmlformats.org/drawingml/2006/main"/>
+          <a:ln xmlns:a="http://schemas.openxmlformats.org/drawingml/2006/main" w="0">
+            <a:noFill/>
+            <a:prstDash val="solid"/>
+          </a:ln>
+        </p:spPr>
+        <p:txBody>
+          <a:bodyPr xmlns:a="http://schemas.openxmlformats.org/drawingml/2006/main" anchor="t"/>
+          <a:lstStyle xmlns:a="http://schemas.openxmlformats.org/drawingml/2006/main"/>
+          <a:p xmlns:a="http://schemas.openxmlformats.org/drawingml/2006/main">
+            <a:pPr algn="l">
+              <a:buNone/>
+              <a:defRPr sz="1200" b="0">
+                <a:solidFill>
+                  <a:srgbClr val="627D98"/>
+                </a:solidFill>
+              </a:defRPr>
+            </a:pPr>
+            <a:r>
+              <a:rPr sz="1200" b="0">
+                <a:solidFill>
+                  <a:srgbClr val="627D98"/>
+                </a:solidFill>
+              </a:rPr>
+              <a:t>Correlations: 0.993 / 0.995 (top 1% / bottom 99%). Missing matrices prevent a code-only interpretation.</a:t>
+            </a:r>
+          </a:p>
+        </p:txBody>
+      </p:sp>
+      <p:pic>
+        <p:nvPicPr>
+          <p:cNvPr id="32" name=""/>
+          <p:cNvPicPr>
+            <a:picLocks xmlns:a="http://schemas.openxmlformats.org/drawingml/2006/main" noChangeAspect="1"/>
+          </p:cNvPicPr>
+          <p:nvPr/>
+        </p:nvPicPr>
+        <p:blipFill>
+          <a:blip xmlns:r="http://schemas.openxmlformats.org/officeDocument/2006/relationships" xmlns:a="http://schemas.openxmlformats.org/drawingml/2006/main" r:embed="R3a9c50df4cec46a8"/>
+          <a:stretch xmlns:a="http://schemas.openxmlformats.org/drawingml/2006/main"/>
+        </p:blipFill>
+        <p:spPr>
+          <a:xfrm xmlns:a="http://schemas.openxmlformats.org/drawingml/2006/main">
+            <a:off x="632746" y="1552099"/>
+            <a:ext cx="5059204" cy="3372802"/>
+          </a:xfrm>
+          <a:prstGeom xmlns:a="http://schemas.openxmlformats.org/drawingml/2006/main" prst="rect">
+            <a:avLst/>
+          </a:prstGeom>
+        </p:spPr>
+      </p:pic>
+      <p:pic>
+        <p:nvPicPr>
+          <p:cNvPr id="33" name=""/>
+          <p:cNvPicPr>
+            <a:picLocks xmlns:a="http://schemas.openxmlformats.org/drawingml/2006/main" noChangeAspect="1"/>
+          </p:cNvPicPr>
+          <p:nvPr/>
+        </p:nvPicPr>
+        <p:blipFill>
+          <a:blip xmlns:r="http://schemas.openxmlformats.org/officeDocument/2006/relationships" xmlns:a="http://schemas.openxmlformats.org/drawingml/2006/main" r:embed="R032de42980c6416c"/>
+          <a:stretch xmlns:a="http://schemas.openxmlformats.org/drawingml/2006/main"/>
+        </p:blipFill>
+        <p:spPr>
+          <a:xfrm xmlns:a="http://schemas.openxmlformats.org/drawingml/2006/main">
+            <a:off x="6450393" y="1776603"/>
+            <a:ext cx="5158614" cy="2923699"/>
+          </a:xfrm>
+          <a:prstGeom xmlns:a="http://schemas.openxmlformats.org/drawingml/2006/main" prst="rect">
+            <a:avLst/>
+          </a:prstGeom>
+        </p:spPr>
+      </p:pic>
+    </p:spTree>
+    <p:extLst>
+      <p:ext uri="{BB962C8B-B14F-4D97-AF65-F5344CB8AC3E}">
+        <p14:creationId xmlns:p14="http://schemas.microsoft.com/office/powerpoint/2010/main" val="1065330000"/>
+      </p:ext>
+    </p:extLst>
+  </p:cSld>
+</p:sld>
+</file>
+
+<file path=ppt/slides/slide16.xml><?xml version="1.0" encoding="utf-8"?>
+<p:sld xmlns:p="http://schemas.openxmlformats.org/presentationml/2006/main">
+  <p:cSld>
+    <p:bg>
+      <p:bgPr>
+        <a:solidFill xmlns:a="http://schemas.openxmlformats.org/drawingml/2006/main">
+          <a:srgbClr val="FFFFFF"/>
+        </a:solidFill>
+      </p:bgPr>
+    </p:bg>
+    <p:spTree>
+      <p:nvGrpSpPr>
+        <p:cNvPr id="1" name=""/>
+        <p:cNvGrpSpPr/>
+        <p:nvPr/>
+      </p:nvGrpSpPr>
+      <p:grpSpPr>
+        <a:xfrm xmlns:a="http://schemas.openxmlformats.org/drawingml/2006/main"/>
+      </p:grpSpPr>
+      <p:sp>
+        <p:nvSpPr>
+          <p:cNvPr id="20" name="kicker">
+            <a:extLst xmlns:a="http://schemas.openxmlformats.org/drawingml/2006/main">
+              <a:ext uri="{FF2B5EF4-FFF2-40B4-BE49-F238E27FC236}">
+                <a16:creationId xmlns:a16="http://schemas.microsoft.com/office/drawing/2014/main" id="{4DBD74DF-ED28-4EE9-8535-9E366A67537D}"/>
+              </a:ext>
+            </a:extLst>
+          </p:cNvPr>
+          <p:cNvSpPr>
+            <a:spLocks xmlns:a="http://schemas.openxmlformats.org/drawingml/2006/main" noGrp="1"/>
+          </p:cNvSpPr>
+          <p:nvPr/>
+        </p:nvSpPr>
+        <p:spPr>
+          <a:xfrm xmlns:a="http://schemas.openxmlformats.org/drawingml/2006/main">
+            <a:off x="457200" y="228600"/>
+            <a:ext cx="8572500" cy="209550"/>
+          </a:xfrm>
+          <a:prstGeom xmlns:a="http://schemas.openxmlformats.org/drawingml/2006/main" prst="rect">
+            <a:avLst/>
+          </a:prstGeom>
+          <a:noFill xmlns:a="http://schemas.openxmlformats.org/drawingml/2006/main"/>
+          <a:ln xmlns:a="http://schemas.openxmlformats.org/drawingml/2006/main" w="0">
+            <a:noFill/>
+            <a:prstDash val="solid"/>
+          </a:ln>
+        </p:spPr>
+        <p:txBody>
+          <a:bodyPr xmlns:a="http://schemas.openxmlformats.org/drawingml/2006/main" anchor="t"/>
+          <a:lstStyle xmlns:a="http://schemas.openxmlformats.org/drawingml/2006/main"/>
+          <a:p xmlns:a="http://schemas.openxmlformats.org/drawingml/2006/main">
+            <a:pPr algn="l">
+              <a:buNone/>
+              <a:defRPr sz="1050" b="1">
+                <a:solidFill>
+                  <a:srgbClr val="C65D16"/>
+                </a:solidFill>
+              </a:defRPr>
+            </a:pPr>
+            <a:r>
+              <a:rPr sz="1050" b="1">
+                <a:solidFill>
+                  <a:srgbClr val="C65D16"/>
+                </a:solidFill>
+              </a:rPr>
+              <a:t>REPLICATION SYNTHESIS</a:t>
+            </a:r>
+          </a:p>
+        </p:txBody>
+      </p:sp>
+      <p:sp>
+        <p:nvSpPr>
+          <p:cNvPr id="2" name="title">
+            <a:extLst xmlns:a="http://schemas.openxmlformats.org/drawingml/2006/main">
+              <a:ext uri="{FF2B5EF4-FFF2-40B4-BE49-F238E27FC236}">
+                <a16:creationId xmlns:a16="http://schemas.microsoft.com/office/drawing/2014/main" id="{25994307-319F-4EAA-8D7C-9E832F74B960}"/>
+              </a:ext>
+            </a:extLst>
+          </p:cNvPr>
+          <p:cNvSpPr>
+            <a:spLocks xmlns:a="http://schemas.openxmlformats.org/drawingml/2006/main" noGrp="1"/>
+          </p:cNvSpPr>
+          <p:nvPr/>
+        </p:nvSpPr>
+        <p:spPr>
+          <a:xfrm xmlns:a="http://schemas.openxmlformats.org/drawingml/2006/main">
+            <a:off x="457200" y="457200"/>
+            <a:ext cx="10858500" cy="495300"/>
+          </a:xfrm>
+          <a:prstGeom xmlns:a="http://schemas.openxmlformats.org/drawingml/2006/main" prst="rect">
+            <a:avLst/>
+          </a:prstGeom>
+          <a:noFill xmlns:a="http://schemas.openxmlformats.org/drawingml/2006/main"/>
+          <a:ln xmlns:a="http://schemas.openxmlformats.org/drawingml/2006/main" w="0">
+            <a:noFill/>
+            <a:prstDash val="solid"/>
+          </a:ln>
+        </p:spPr>
+        <p:txBody>
+          <a:bodyPr xmlns:a="http://schemas.openxmlformats.org/drawingml/2006/main" anchor="t"/>
+          <a:lstStyle xmlns:a="http://schemas.openxmlformats.org/drawingml/2006/main"/>
+          <a:p xmlns:a="http://schemas.openxmlformats.org/drawingml/2006/main">
+            <a:pPr algn="l">
+              <a:buNone/>
+              <a:defRPr sz="2700" b="1">
+                <a:solidFill>
+                  <a:srgbClr val="102A43"/>
+                </a:solidFill>
+              </a:defRPr>
+            </a:pPr>
+            <a:r>
+              <a:rPr sz="2700" b="1">
+                <a:solidFill>
+                  <a:srgbClr val="102A43"/>
+                </a:solidFill>
+              </a:rPr>
+              <a:t>Figures 1, 5, and 6 reconstruct; Figure 8 remains a proxy</a:t>
+            </a:r>
+          </a:p>
+        </p:txBody>
+      </p:sp>
+      <p:sp>
+        <p:nvSpPr>
+          <p:cNvPr id="3" name="header-rule">
+            <a:extLst xmlns:a="http://schemas.openxmlformats.org/drawingml/2006/main">
+              <a:ext uri="{FF2B5EF4-FFF2-40B4-BE49-F238E27FC236}">
+                <a16:creationId xmlns:a16="http://schemas.microsoft.com/office/drawing/2014/main" id="{9304C898-8A92-4A39-A7EB-64A100354E4A}"/>
+              </a:ext>
+            </a:extLst>
+          </p:cNvPr>
+          <p:cNvSpPr>
+            <a:spLocks xmlns:a="http://schemas.openxmlformats.org/drawingml/2006/main" noGrp="1"/>
+          </p:cNvSpPr>
+          <p:nvPr/>
+        </p:nvSpPr>
+        <p:spPr>
+          <a:xfrm xmlns:a="http://schemas.openxmlformats.org/drawingml/2006/main">
+            <a:off x="457200" y="981075"/>
+            <a:ext cx="11277600" cy="19050"/>
+          </a:xfrm>
+          <a:prstGeom xmlns:a="http://schemas.openxmlformats.org/drawingml/2006/main" prst="rect">
+            <a:avLst/>
+          </a:prstGeom>
+          <a:solidFill xmlns:a="http://schemas.openxmlformats.org/drawingml/2006/main">
+            <a:srgbClr val="102A43"/>
+          </a:solidFill>
+          <a:ln xmlns:a="http://schemas.openxmlformats.org/drawingml/2006/main" w="0">
+            <a:noFill/>
+            <a:prstDash val="solid"/>
+          </a:ln>
+        </p:spPr>
+      </p:sp>
+      <p:sp>
+        <p:nvSpPr>
+          <p:cNvPr id="4" name="slide-number">
+            <a:extLst xmlns:a="http://schemas.openxmlformats.org/drawingml/2006/main">
+              <a:ext uri="{FF2B5EF4-FFF2-40B4-BE49-F238E27FC236}">
+                <a16:creationId xmlns:a16="http://schemas.microsoft.com/office/drawing/2014/main" id="{E4772364-3993-46C7-BB6A-7696849F37B9}"/>
+              </a:ext>
+            </a:extLst>
+          </p:cNvPr>
+          <p:cNvSpPr>
+            <a:spLocks xmlns:a="http://schemas.openxmlformats.org/drawingml/2006/main" noGrp="1"/>
+          </p:cNvSpPr>
+          <p:nvPr/>
+        </p:nvSpPr>
+        <p:spPr>
+          <a:xfrm xmlns:a="http://schemas.openxmlformats.org/drawingml/2006/main">
+            <a:off x="11334750" y="266700"/>
+            <a:ext cx="400050" cy="228600"/>
+          </a:xfrm>
+          <a:prstGeom xmlns:a="http://schemas.openxmlformats.org/drawingml/2006/main" prst="rect">
+            <a:avLst/>
+          </a:prstGeom>
+          <a:noFill xmlns:a="http://schemas.openxmlformats.org/drawingml/2006/main"/>
+          <a:ln xmlns:a="http://schemas.openxmlformats.org/drawingml/2006/main" w="0">
+            <a:noFill/>
+            <a:prstDash val="solid"/>
+          </a:ln>
+        </p:spPr>
+        <p:txBody>
+          <a:bodyPr xmlns:a="http://schemas.openxmlformats.org/drawingml/2006/main" anchor="t"/>
+          <a:lstStyle xmlns:a="http://schemas.openxmlformats.org/drawingml/2006/main"/>
+          <a:p xmlns:a="http://schemas.openxmlformats.org/drawingml/2006/main">
+            <a:pPr algn="r">
+              <a:buNone/>
+              <a:defRPr sz="1050" b="1">
+                <a:solidFill>
+                  <a:srgbClr val="627D98"/>
+                </a:solidFill>
+              </a:defRPr>
+            </a:pPr>
+            <a:r>
+              <a:rPr sz="1050" b="1">
+                <a:solidFill>
+                  <a:srgbClr val="627D98"/>
+                </a:solidFill>
+              </a:rPr>
+              <a:t>16</a:t>
+            </a:r>
+          </a:p>
+        </p:txBody>
+      </p:sp>
+      <p:sp>
+        <p:nvSpPr>
+          <p:cNvPr id="5" name="question">
+            <a:extLst xmlns:a="http://schemas.openxmlformats.org/drawingml/2006/main">
+              <a:ext uri="{FF2B5EF4-FFF2-40B4-BE49-F238E27FC236}">
+                <a16:creationId xmlns:a16="http://schemas.microsoft.com/office/drawing/2014/main" id="{1C4CBB66-390B-40CA-9A94-F3B655FADD50}"/>
+              </a:ext>
+            </a:extLst>
+          </p:cNvPr>
+          <p:cNvSpPr>
+            <a:spLocks xmlns:a="http://schemas.openxmlformats.org/drawingml/2006/main" noGrp="1"/>
+          </p:cNvSpPr>
+          <p:nvPr/>
+        </p:nvSpPr>
+        <p:spPr>
+          <a:xfrm xmlns:a="http://schemas.openxmlformats.org/drawingml/2006/main">
+            <a:off x="533400" y="1333500"/>
+            <a:ext cx="2095500" cy="323850"/>
+          </a:xfrm>
+          <a:prstGeom xmlns:a="http://schemas.openxmlformats.org/drawingml/2006/main" prst="rect">
+            <a:avLst/>
+          </a:prstGeom>
+          <a:noFill xmlns:a="http://schemas.openxmlformats.org/drawingml/2006/main"/>
+          <a:ln xmlns:a="http://schemas.openxmlformats.org/drawingml/2006/main" w="0">
+            <a:noFill/>
+            <a:prstDash val="solid"/>
+          </a:ln>
+        </p:spPr>
+        <p:txBody>
+          <a:bodyPr xmlns:a="http://schemas.openxmlformats.org/drawingml/2006/main" anchor="t"/>
+          <a:lstStyle xmlns:a="http://schemas.openxmlformats.org/drawingml/2006/main"/>
+          <a:p xmlns:a="http://schemas.openxmlformats.org/drawingml/2006/main">
+            <a:pPr algn="l">
+              <a:buNone/>
+              <a:defRPr sz="1650" b="1">
+                <a:solidFill>
+                  <a:srgbClr val="102A43"/>
+                </a:solidFill>
+              </a:defRPr>
+            </a:pPr>
+            <a:r>
+              <a:rPr sz="1650" b="1">
+                <a:solidFill>
+                  <a:srgbClr val="102A43"/>
+                </a:solidFill>
+              </a:rPr>
+              <a:t>Conclusion</a:t>
+            </a:r>
+          </a:p>
+        </p:txBody>
+      </p:sp>
+      <p:sp>
+        <p:nvSpPr>
+          <p:cNvPr id="6" name="question-body">
+            <a:extLst xmlns:a="http://schemas.openxmlformats.org/drawingml/2006/main">
+              <a:ext uri="{FF2B5EF4-FFF2-40B4-BE49-F238E27FC236}">
+                <a16:creationId xmlns:a16="http://schemas.microsoft.com/office/drawing/2014/main" id="{C7924291-5CE5-45A7-9502-25780E8749E1}"/>
+              </a:ext>
+            </a:extLst>
+          </p:cNvPr>
+          <p:cNvSpPr>
+            <a:spLocks xmlns:a="http://schemas.openxmlformats.org/drawingml/2006/main" noGrp="1"/>
+          </p:cNvSpPr>
+          <p:nvPr/>
+        </p:nvSpPr>
+        <p:spPr>
+          <a:xfrm xmlns:a="http://schemas.openxmlformats.org/drawingml/2006/main">
+            <a:off x="533400" y="1733550"/>
+            <a:ext cx="4381500" cy="1123950"/>
+          </a:xfrm>
+          <a:prstGeom xmlns:a="http://schemas.openxmlformats.org/drawingml/2006/main" prst="rect">
+            <a:avLst/>
+          </a:prstGeom>
+          <a:noFill xmlns:a="http://schemas.openxmlformats.org/drawingml/2006/main"/>
+          <a:ln xmlns:a="http://schemas.openxmlformats.org/drawingml/2006/main" w="0">
+            <a:noFill/>
+            <a:prstDash val="solid"/>
+          </a:ln>
+        </p:spPr>
+        <p:txBody>
+          <a:bodyPr xmlns:a="http://schemas.openxmlformats.org/drawingml/2006/main" anchor="t"/>
+          <a:lstStyle xmlns:a="http://schemas.openxmlformats.org/drawingml/2006/main"/>
+          <a:p xmlns:a="http://schemas.openxmlformats.org/drawingml/2006/main">
+            <a:pPr algn="l">
+              <a:buNone/>
+              <a:defRPr sz="1875" b="0">
+                <a:solidFill>
+                  <a:srgbClr val="243B53"/>
+                </a:solidFill>
+              </a:defRPr>
+            </a:pPr>
+            <a:r>
+              <a:rPr sz="1875" b="0">
+                <a:solidFill>
+                  <a:srgbClr val="243B53"/>
+                </a:solidFill>
+              </a:rPr>
+              <a:t>What did the 2021 kit let us test?</a:t>
+            </a:r>
+          </a:p>
+        </p:txBody>
+      </p:sp>
+      <p:sp>
+        <p:nvSpPr>
+          <p:cNvPr id="7" name="divider">
+            <a:extLst xmlns:a="http://schemas.openxmlformats.org/drawingml/2006/main">
+              <a:ext uri="{FF2B5EF4-FFF2-40B4-BE49-F238E27FC236}">
+                <a16:creationId xmlns:a16="http://schemas.microsoft.com/office/drawing/2014/main" id="{F04E65CB-1300-417C-A552-521BE00891D3}"/>
+              </a:ext>
+            </a:extLst>
+          </p:cNvPr>
+          <p:cNvSpPr>
+            <a:spLocks xmlns:a="http://schemas.openxmlformats.org/drawingml/2006/main" noGrp="1"/>
+          </p:cNvSpPr>
+          <p:nvPr/>
+        </p:nvSpPr>
+        <p:spPr>
+          <a:xfrm xmlns:a="http://schemas.openxmlformats.org/drawingml/2006/main">
+            <a:off x="5391150" y="1285875"/>
+            <a:ext cx="19050" cy="4381500"/>
+          </a:xfrm>
+          <a:prstGeom xmlns:a="http://schemas.openxmlformats.org/drawingml/2006/main" prst="rect">
+            <a:avLst/>
+          </a:prstGeom>
+          <a:solidFill xmlns:a="http://schemas.openxmlformats.org/drawingml/2006/main">
+            <a:srgbClr val="D8E1E8"/>
+          </a:solidFill>
+          <a:ln xmlns:a="http://schemas.openxmlformats.org/drawingml/2006/main" w="0">
+            <a:noFill/>
+            <a:prstDash val="solid"/>
+          </a:ln>
+        </p:spPr>
+      </p:sp>
+      <p:sp>
+        <p:nvSpPr>
+          <p:cNvPr id="8" name="Strong precursor-bar">
+            <a:extLst xmlns:a="http://schemas.openxmlformats.org/drawingml/2006/main">
+              <a:ext uri="{FF2B5EF4-FFF2-40B4-BE49-F238E27FC236}">
+                <a16:creationId xmlns:a16="http://schemas.microsoft.com/office/drawing/2014/main" id="{80A9BBD5-0978-4A47-9DE6-A7D2756C4BC7}"/>
+              </a:ext>
+            </a:extLst>
+          </p:cNvPr>
+          <p:cNvSpPr>
+            <a:spLocks xmlns:a="http://schemas.openxmlformats.org/drawingml/2006/main" noGrp="1"/>
+          </p:cNvSpPr>
+          <p:nvPr/>
+        </p:nvSpPr>
+        <p:spPr>
+          <a:xfrm xmlns:a="http://schemas.openxmlformats.org/drawingml/2006/main">
+            <a:off x="5905500" y="1333500"/>
+            <a:ext cx="76200" cy="952500"/>
+          </a:xfrm>
+          <a:prstGeom xmlns:a="http://schemas.openxmlformats.org/drawingml/2006/main" prst="rect">
+            <a:avLst/>
+          </a:prstGeom>
+          <a:solidFill xmlns:a="http://schemas.openxmlformats.org/drawingml/2006/main">
+            <a:srgbClr val="C65D16"/>
+          </a:solidFill>
+          <a:ln xmlns:a="http://schemas.openxmlformats.org/drawingml/2006/main" w="0">
+            <a:noFill/>
+            <a:prstDash val="solid"/>
+          </a:ln>
+        </p:spPr>
+      </p:sp>
+      <p:sp>
+        <p:nvSpPr>
+          <p:cNvPr id="9" name="Strong precursor-label">
+            <a:extLst xmlns:a="http://schemas.openxmlformats.org/drawingml/2006/main">
+              <a:ext uri="{FF2B5EF4-FFF2-40B4-BE49-F238E27FC236}">
+                <a16:creationId xmlns:a16="http://schemas.microsoft.com/office/drawing/2014/main" id="{51CC7C6F-9EBD-42A3-9CD8-DD0C6EE988A5}"/>
+              </a:ext>
+            </a:extLst>
+          </p:cNvPr>
+          <p:cNvSpPr>
+            <a:spLocks xmlns:a="http://schemas.openxmlformats.org/drawingml/2006/main" noGrp="1"/>
+          </p:cNvSpPr>
+          <p:nvPr/>
+        </p:nvSpPr>
+        <p:spPr>
+          <a:xfrm xmlns:a="http://schemas.openxmlformats.org/drawingml/2006/main">
+            <a:off x="6191250" y="1371600"/>
+            <a:ext cx="2476500" cy="285750"/>
+          </a:xfrm>
+          <a:prstGeom xmlns:a="http://schemas.openxmlformats.org/drawingml/2006/main" prst="rect">
+            <a:avLst/>
+          </a:prstGeom>
+          <a:noFill xmlns:a="http://schemas.openxmlformats.org/drawingml/2006/main"/>
+          <a:ln xmlns:a="http://schemas.openxmlformats.org/drawingml/2006/main" w="0">
+            <a:noFill/>
+            <a:prstDash val="solid"/>
+          </a:ln>
+        </p:spPr>
+        <p:txBody>
+          <a:bodyPr xmlns:a="http://schemas.openxmlformats.org/drawingml/2006/main" anchor="t"/>
+          <a:lstStyle xmlns:a="http://schemas.openxmlformats.org/drawingml/2006/main"/>
+          <a:p xmlns:a="http://schemas.openxmlformats.org/drawingml/2006/main">
+            <a:pPr algn="l">
+              <a:buNone/>
+              <a:defRPr sz="1725" b="1">
+                <a:solidFill>
+                  <a:srgbClr val="2F855A"/>
+                </a:solidFill>
+              </a:defRPr>
+            </a:pPr>
+            <a:r>
+              <a:rPr sz="1725" b="1">
+                <a:solidFill>
+                  <a:srgbClr val="C65D16"/>
+                </a:solidFill>
+              </a:rPr>
+              <a:t>Figure 1</a:t>
+            </a:r>
+          </a:p>
+        </p:txBody>
+      </p:sp>
+      <p:sp>
+        <p:nvSpPr>
+          <p:cNvPr id="10" name="Strong precursor-body">
+            <a:extLst xmlns:a="http://schemas.openxmlformats.org/drawingml/2006/main">
+              <a:ext uri="{FF2B5EF4-FFF2-40B4-BE49-F238E27FC236}">
+                <a16:creationId xmlns:a16="http://schemas.microsoft.com/office/drawing/2014/main" id="{244FF233-0930-4770-ADF3-1B1A9250D6B7}"/>
+              </a:ext>
+            </a:extLst>
+          </p:cNvPr>
+          <p:cNvSpPr>
+            <a:spLocks xmlns:a="http://schemas.openxmlformats.org/drawingml/2006/main" noGrp="1"/>
+          </p:cNvSpPr>
+          <p:nvPr/>
+        </p:nvSpPr>
+        <p:spPr>
+          <a:xfrm xmlns:a="http://schemas.openxmlformats.org/drawingml/2006/main">
+            <a:off x="6191250" y="1704975"/>
+            <a:ext cx="5048250" cy="552450"/>
+          </a:xfrm>
+          <a:prstGeom xmlns:a="http://schemas.openxmlformats.org/drawingml/2006/main" prst="rect">
+            <a:avLst/>
+          </a:prstGeom>
+          <a:noFill xmlns:a="http://schemas.openxmlformats.org/drawingml/2006/main"/>
+          <a:ln xmlns:a="http://schemas.openxmlformats.org/drawingml/2006/main" w="0">
+            <a:noFill/>
+            <a:prstDash val="solid"/>
+          </a:ln>
+        </p:spPr>
+        <p:txBody>
+          <a:bodyPr xmlns:a="http://schemas.openxmlformats.org/drawingml/2006/main" anchor="t"/>
+          <a:lstStyle xmlns:a="http://schemas.openxmlformats.org/drawingml/2006/main"/>
+          <a:p xmlns:a="http://schemas.openxmlformats.org/drawingml/2006/main">
+            <a:pPr algn="l">
+              <a:buNone/>
+              <a:defRPr sz="1350" b="0">
+                <a:solidFill>
+                  <a:srgbClr val="243B53"/>
+                </a:solidFill>
+              </a:defRPr>
+            </a:pPr>
+            <a:r>
+              <a:rPr sz="1350" b="0">
+                <a:solidFill>
+                  <a:srgbClr val="243B53"/>
+                </a:solidFill>
+              </a:rPr>
+              <a:t>Close stock reconstruction; share denominator remains version-specific.</a:t>
+            </a:r>
+          </a:p>
+        </p:txBody>
+      </p:sp>
+      <p:sp>
+        <p:nvSpPr>
+          <p:cNvPr id="11" name="Partial match-bar">
+            <a:extLst xmlns:a="http://schemas.openxmlformats.org/drawingml/2006/main">
+              <a:ext uri="{FF2B5EF4-FFF2-40B4-BE49-F238E27FC236}">
+                <a16:creationId xmlns:a16="http://schemas.microsoft.com/office/drawing/2014/main" id="{F0181655-D030-45C0-A3E0-D81445F8830B}"/>
+              </a:ext>
+            </a:extLst>
+          </p:cNvPr>
+          <p:cNvSpPr>
+            <a:spLocks xmlns:a="http://schemas.openxmlformats.org/drawingml/2006/main" noGrp="1"/>
+          </p:cNvSpPr>
+          <p:nvPr/>
+        </p:nvSpPr>
+        <p:spPr>
+          <a:xfrm xmlns:a="http://schemas.openxmlformats.org/drawingml/2006/main">
+            <a:off x="5905500" y="2609850"/>
+            <a:ext cx="76200" cy="952500"/>
+          </a:xfrm>
+          <a:prstGeom xmlns:a="http://schemas.openxmlformats.org/drawingml/2006/main" prst="rect">
+            <a:avLst/>
+          </a:prstGeom>
+          <a:solidFill xmlns:a="http://schemas.openxmlformats.org/drawingml/2006/main">
+            <a:srgbClr val="627D98"/>
+          </a:solidFill>
+          <a:ln xmlns:a="http://schemas.openxmlformats.org/drawingml/2006/main" w="0">
+            <a:noFill/>
+            <a:prstDash val="solid"/>
+          </a:ln>
+        </p:spPr>
+      </p:sp>
+      <p:sp>
+        <p:nvSpPr>
+          <p:cNvPr id="12" name="Partial match-label">
+            <a:extLst xmlns:a="http://schemas.openxmlformats.org/drawingml/2006/main">
+              <a:ext uri="{FF2B5EF4-FFF2-40B4-BE49-F238E27FC236}">
+                <a16:creationId xmlns:a16="http://schemas.microsoft.com/office/drawing/2014/main" id="{217D0269-3366-4106-A614-BFB2DD0B2ECF}"/>
+              </a:ext>
+            </a:extLst>
+          </p:cNvPr>
+          <p:cNvSpPr>
+            <a:spLocks xmlns:a="http://schemas.openxmlformats.org/drawingml/2006/main" noGrp="1"/>
+          </p:cNvSpPr>
+          <p:nvPr/>
+        </p:nvSpPr>
+        <p:spPr>
+          <a:xfrm xmlns:a="http://schemas.openxmlformats.org/drawingml/2006/main">
+            <a:off x="6191250" y="2647950"/>
+            <a:ext cx="2476500" cy="285750"/>
+          </a:xfrm>
+          <a:prstGeom xmlns:a="http://schemas.openxmlformats.org/drawingml/2006/main" prst="rect">
+            <a:avLst/>
+          </a:prstGeom>
+          <a:noFill xmlns:a="http://schemas.openxmlformats.org/drawingml/2006/main"/>
+          <a:ln xmlns:a="http://schemas.openxmlformats.org/drawingml/2006/main" w="0">
+            <a:noFill/>
+            <a:prstDash val="solid"/>
+          </a:ln>
+        </p:spPr>
+        <p:txBody>
+          <a:bodyPr xmlns:a="http://schemas.openxmlformats.org/drawingml/2006/main" anchor="t"/>
+          <a:lstStyle xmlns:a="http://schemas.openxmlformats.org/drawingml/2006/main"/>
+          <a:p xmlns:a="http://schemas.openxmlformats.org/drawingml/2006/main">
+            <a:pPr algn="l">
+              <a:buNone/>
+              <a:defRPr sz="1725" b="1">
+                <a:solidFill>
+                  <a:srgbClr val="B7791F"/>
+                </a:solidFill>
+              </a:defRPr>
+            </a:pPr>
+            <a:r>
+              <a:rPr sz="1725" b="1">
+                <a:solidFill>
+                  <a:srgbClr val="627D98"/>
+                </a:solidFill>
+              </a:rPr>
+              <a:t>Figures 5–6</a:t>
+            </a:r>
+          </a:p>
+        </p:txBody>
+      </p:sp>
+      <p:sp>
+        <p:nvSpPr>
+          <p:cNvPr id="13" name="Partial match-body">
+            <a:extLst xmlns:a="http://schemas.openxmlformats.org/drawingml/2006/main">
+              <a:ext uri="{FF2B5EF4-FFF2-40B4-BE49-F238E27FC236}">
+                <a16:creationId xmlns:a16="http://schemas.microsoft.com/office/drawing/2014/main" id="{00ABC748-B2B5-4893-8CE6-FDE63773F6C0}"/>
+              </a:ext>
+            </a:extLst>
+          </p:cNvPr>
+          <p:cNvSpPr>
+            <a:spLocks xmlns:a="http://schemas.openxmlformats.org/drawingml/2006/main" noGrp="1"/>
+          </p:cNvSpPr>
+          <p:nvPr/>
+        </p:nvSpPr>
+        <p:spPr>
+          <a:xfrm xmlns:a="http://schemas.openxmlformats.org/drawingml/2006/main">
+            <a:off x="6191250" y="2981325"/>
+            <a:ext cx="5048250" cy="552450"/>
+          </a:xfrm>
+          <a:prstGeom xmlns:a="http://schemas.openxmlformats.org/drawingml/2006/main" prst="rect">
+            <a:avLst/>
+          </a:prstGeom>
+          <a:noFill xmlns:a="http://schemas.openxmlformats.org/drawingml/2006/main"/>
+          <a:ln xmlns:a="http://schemas.openxmlformats.org/drawingml/2006/main" w="0">
+            <a:noFill/>
+            <a:prstDash val="solid"/>
+          </a:ln>
+        </p:spPr>
+        <p:txBody>
+          <a:bodyPr xmlns:a="http://schemas.openxmlformats.org/drawingml/2006/main" anchor="t"/>
+          <a:lstStyle xmlns:a="http://schemas.openxmlformats.org/drawingml/2006/main"/>
+          <a:p xmlns:a="http://schemas.openxmlformats.org/drawingml/2006/main">
+            <a:pPr algn="l">
+              <a:buNone/>
+              <a:defRPr sz="1350" b="0">
+                <a:solidFill>
+                  <a:srgbClr val="243B53"/>
+                </a:solidFill>
+              </a:defRPr>
+            </a:pPr>
+            <a:r>
+              <a:rPr sz="1350" b="0">
+                <a:solidFill>
+                  <a:srgbClr val="243B53"/>
+                </a:solidFill>
+              </a:rPr>
+              <a:t>High-fidelity saving-flow and saving-rate reconstructions through 2016.</a:t>
+            </a:r>
+          </a:p>
+        </p:txBody>
+      </p:sp>
+      <p:sp>
+        <p:nvSpPr>
+          <p:cNvPr id="14" name="Context only-bar">
+            <a:extLst xmlns:a="http://schemas.openxmlformats.org/drawingml/2006/main">
+              <a:ext uri="{FF2B5EF4-FFF2-40B4-BE49-F238E27FC236}">
+                <a16:creationId xmlns:a16="http://schemas.microsoft.com/office/drawing/2014/main" id="{A567A865-2022-41CE-BB30-AB58E2C2A04A}"/>
+              </a:ext>
+            </a:extLst>
+          </p:cNvPr>
+          <p:cNvSpPr>
+            <a:spLocks xmlns:a="http://schemas.openxmlformats.org/drawingml/2006/main" noGrp="1"/>
+          </p:cNvSpPr>
+          <p:nvPr/>
+        </p:nvSpPr>
+        <p:spPr>
+          <a:xfrm xmlns:a="http://schemas.openxmlformats.org/drawingml/2006/main">
+            <a:off x="5905500" y="3886200"/>
+            <a:ext cx="76200" cy="952500"/>
+          </a:xfrm>
+          <a:prstGeom xmlns:a="http://schemas.openxmlformats.org/drawingml/2006/main" prst="rect">
+            <a:avLst/>
+          </a:prstGeom>
+          <a:solidFill xmlns:a="http://schemas.openxmlformats.org/drawingml/2006/main">
+            <a:srgbClr val="2E5B88"/>
+          </a:solidFill>
+          <a:ln xmlns:a="http://schemas.openxmlformats.org/drawingml/2006/main" w="0">
+            <a:noFill/>
+            <a:prstDash val="solid"/>
+          </a:ln>
+        </p:spPr>
+      </p:sp>
+      <p:sp>
+        <p:nvSpPr>
+          <p:cNvPr id="15" name="Context only-label">
+            <a:extLst xmlns:a="http://schemas.openxmlformats.org/drawingml/2006/main">
+              <a:ext uri="{FF2B5EF4-FFF2-40B4-BE49-F238E27FC236}">
+                <a16:creationId xmlns:a16="http://schemas.microsoft.com/office/drawing/2014/main" id="{58F96603-D508-40F6-A485-776B0AF5C4BD}"/>
+              </a:ext>
+            </a:extLst>
+          </p:cNvPr>
+          <p:cNvSpPr>
+            <a:spLocks xmlns:a="http://schemas.openxmlformats.org/drawingml/2006/main" noGrp="1"/>
+          </p:cNvSpPr>
+          <p:nvPr/>
+        </p:nvSpPr>
+        <p:spPr>
+          <a:xfrm xmlns:a="http://schemas.openxmlformats.org/drawingml/2006/main">
+            <a:off x="6191250" y="3924300"/>
+            <a:ext cx="2476500" cy="285750"/>
+          </a:xfrm>
+          <a:prstGeom xmlns:a="http://schemas.openxmlformats.org/drawingml/2006/main" prst="rect">
+            <a:avLst/>
+          </a:prstGeom>
+          <a:noFill xmlns:a="http://schemas.openxmlformats.org/drawingml/2006/main"/>
+          <a:ln xmlns:a="http://schemas.openxmlformats.org/drawingml/2006/main" w="0">
+            <a:noFill/>
+            <a:prstDash val="solid"/>
+          </a:ln>
+        </p:spPr>
+        <p:txBody>
+          <a:bodyPr xmlns:a="http://schemas.openxmlformats.org/drawingml/2006/main" anchor="t"/>
+          <a:lstStyle xmlns:a="http://schemas.openxmlformats.org/drawingml/2006/main"/>
+          <a:p xmlns:a="http://schemas.openxmlformats.org/drawingml/2006/main">
+            <a:pPr algn="l">
+              <a:buNone/>
+              <a:defRPr sz="1725" b="1">
+                <a:solidFill>
+                  <a:srgbClr val="B83232"/>
+                </a:solidFill>
+              </a:defRPr>
+            </a:pPr>
+            <a:r>
+              <a:rPr sz="1725" b="1">
+                <a:solidFill>
+                  <a:srgbClr val="2E5B88"/>
+                </a:solidFill>
+              </a:rPr>
+              <a:t>Figure 8</a:t>
+            </a:r>
+          </a:p>
+        </p:txBody>
+      </p:sp>
+      <p:sp>
+        <p:nvSpPr>
+          <p:cNvPr id="16" name="Context only-body">
+            <a:extLst xmlns:a="http://schemas.openxmlformats.org/drawingml/2006/main">
+              <a:ext uri="{FF2B5EF4-FFF2-40B4-BE49-F238E27FC236}">
+                <a16:creationId xmlns:a16="http://schemas.microsoft.com/office/drawing/2014/main" id="{005F9EA7-5FC9-4084-B230-06E7E891E6B0}"/>
+              </a:ext>
+            </a:extLst>
+          </p:cNvPr>
+          <p:cNvSpPr>
+            <a:spLocks xmlns:a="http://schemas.openxmlformats.org/drawingml/2006/main" noGrp="1"/>
+          </p:cNvSpPr>
+          <p:nvPr/>
+        </p:nvSpPr>
+        <p:spPr>
+          <a:xfrm xmlns:a="http://schemas.openxmlformats.org/drawingml/2006/main">
+            <a:off x="6191250" y="4257675"/>
+            <a:ext cx="5048250" cy="552450"/>
+          </a:xfrm>
+          <a:prstGeom xmlns:a="http://schemas.openxmlformats.org/drawingml/2006/main" prst="rect">
+            <a:avLst/>
+          </a:prstGeom>
+          <a:noFill xmlns:a="http://schemas.openxmlformats.org/drawingml/2006/main"/>
+          <a:ln xmlns:a="http://schemas.openxmlformats.org/drawingml/2006/main" w="0">
+            <a:noFill/>
+            <a:prstDash val="solid"/>
+          </a:ln>
+        </p:spPr>
+        <p:txBody>
+          <a:bodyPr xmlns:a="http://schemas.openxmlformats.org/drawingml/2006/main" anchor="t"/>
+          <a:lstStyle xmlns:a="http://schemas.openxmlformats.org/drawingml/2006/main"/>
+          <a:p xmlns:a="http://schemas.openxmlformats.org/drawingml/2006/main">
+            <a:pPr algn="l">
+              <a:buNone/>
+              <a:defRPr sz="1350" b="0">
+                <a:solidFill>
+                  <a:srgbClr val="243B53"/>
+                </a:solidFill>
+              </a:defRPr>
+            </a:pPr>
+            <a:r>
+              <a:rPr sz="1350" b="0">
+                <a:solidFill>
+                  <a:srgbClr val="243B53"/>
+                </a:solidFill>
+              </a:rPr>
+              <a:t>Direction and bottom-99 level match; revised matrices are unavailable.</a:t>
+            </a:r>
+          </a:p>
+        </p:txBody>
+      </p:sp>
+      <p:sp>
+        <p:nvSpPr>
+          <p:cNvPr id="17" name="boundary">
+            <a:extLst xmlns:a="http://schemas.openxmlformats.org/drawingml/2006/main">
+              <a:ext uri="{FF2B5EF4-FFF2-40B4-BE49-F238E27FC236}">
+                <a16:creationId xmlns:a16="http://schemas.microsoft.com/office/drawing/2014/main" id="{79FA2934-1CA8-49CA-B94B-8B94B201C7B7}"/>
+              </a:ext>
+            </a:extLst>
+          </p:cNvPr>
+          <p:cNvSpPr>
+            <a:spLocks xmlns:a="http://schemas.openxmlformats.org/drawingml/2006/main" noGrp="1"/>
+          </p:cNvSpPr>
+          <p:nvPr/>
+        </p:nvSpPr>
+        <p:spPr>
+          <a:xfrm xmlns:a="http://schemas.openxmlformats.org/drawingml/2006/main">
+            <a:off x="533400" y="3238500"/>
+            <a:ext cx="4381500" cy="1809750"/>
+          </a:xfrm>
+          <a:prstGeom xmlns:a="http://schemas.openxmlformats.org/drawingml/2006/main" prst="roundRect">
+            <a:avLst>
+              <a:gd name="adj" fmla="val 2105"/>
+            </a:avLst>
+          </a:prstGeom>
+          <a:solidFill xmlns:a="http://schemas.openxmlformats.org/drawingml/2006/main">
+            <a:srgbClr val="F4F7FA"/>
+          </a:solidFill>
+          <a:ln xmlns:a="http://schemas.openxmlformats.org/drawingml/2006/main" w="0">
+            <a:noFill/>
+            <a:prstDash val="solid"/>
+          </a:ln>
+        </p:spPr>
+      </p:sp>
+      <p:sp>
+        <p:nvSpPr>
+          <p:cNvPr id="18" name="boundary-title">
+            <a:extLst xmlns:a="http://schemas.openxmlformats.org/drawingml/2006/main">
+              <a:ext uri="{FF2B5EF4-FFF2-40B4-BE49-F238E27FC236}">
+                <a16:creationId xmlns:a16="http://schemas.microsoft.com/office/drawing/2014/main" id="{90F1D0FA-121D-4208-9F34-9DE0662DF16B}"/>
+              </a:ext>
+            </a:extLst>
+          </p:cNvPr>
+          <p:cNvSpPr>
+            <a:spLocks xmlns:a="http://schemas.openxmlformats.org/drawingml/2006/main" noGrp="1"/>
+          </p:cNvSpPr>
+          <p:nvPr/>
+        </p:nvSpPr>
+        <p:spPr>
+          <a:xfrm xmlns:a="http://schemas.openxmlformats.org/drawingml/2006/main">
+            <a:off x="742950" y="3448050"/>
+            <a:ext cx="1905000" cy="285750"/>
+          </a:xfrm>
+          <a:prstGeom xmlns:a="http://schemas.openxmlformats.org/drawingml/2006/main" prst="rect">
+            <a:avLst/>
+          </a:prstGeom>
+          <a:noFill xmlns:a="http://schemas.openxmlformats.org/drawingml/2006/main"/>
+          <a:ln xmlns:a="http://schemas.openxmlformats.org/drawingml/2006/main" w="0">
+            <a:noFill/>
+            <a:prstDash val="solid"/>
+          </a:ln>
+        </p:spPr>
+        <p:txBody>
+          <a:bodyPr xmlns:a="http://schemas.openxmlformats.org/drawingml/2006/main" anchor="t"/>
+          <a:lstStyle xmlns:a="http://schemas.openxmlformats.org/drawingml/2006/main"/>
+          <a:p xmlns:a="http://schemas.openxmlformats.org/drawingml/2006/main">
+            <a:pPr algn="l">
+              <a:buNone/>
+              <a:defRPr sz="1575" b="1">
+                <a:solidFill>
+                  <a:srgbClr val="B83232"/>
+                </a:solidFill>
+              </a:defRPr>
+            </a:pPr>
+            <a:r>
+              <a:rPr sz="1575" b="1">
+                <a:solidFill>
+                  <a:srgbClr val="B83232"/>
+                </a:solidFill>
+              </a:rPr>
+              <a:t>Main lesson</a:t>
+            </a:r>
+          </a:p>
+        </p:txBody>
+      </p:sp>
+      <p:sp>
+        <p:nvSpPr>
+          <p:cNvPr id="19" name="boundary-body">
+            <a:extLst xmlns:a="http://schemas.openxmlformats.org/drawingml/2006/main">
+              <a:ext uri="{FF2B5EF4-FFF2-40B4-BE49-F238E27FC236}">
+                <a16:creationId xmlns:a16="http://schemas.microsoft.com/office/drawing/2014/main" id="{DF98F5D6-9D18-45C9-8820-2EA73D0D0CC3}"/>
+              </a:ext>
+            </a:extLst>
+          </p:cNvPr>
+          <p:cNvSpPr>
+            <a:spLocks xmlns:a="http://schemas.openxmlformats.org/drawingml/2006/main" noGrp="1"/>
+          </p:cNvSpPr>
+          <p:nvPr/>
+        </p:nvSpPr>
+        <p:spPr>
+          <a:xfrm xmlns:a="http://schemas.openxmlformats.org/drawingml/2006/main">
+            <a:off x="742950" y="3857625"/>
+            <a:ext cx="3905250" cy="1066800"/>
+          </a:xfrm>
+          <a:prstGeom xmlns:a="http://schemas.openxmlformats.org/drawingml/2006/main" prst="rect">
+            <a:avLst/>
+          </a:prstGeom>
+          <a:noFill xmlns:a="http://schemas.openxmlformats.org/drawingml/2006/main"/>
+          <a:ln xmlns:a="http://schemas.openxmlformats.org/drawingml/2006/main" w="0">
+            <a:noFill/>
+            <a:prstDash val="solid"/>
+          </a:ln>
+        </p:spPr>
+        <p:txBody>
+          <a:bodyPr xmlns:a="http://schemas.openxmlformats.org/drawingml/2006/main" anchor="t"/>
+          <a:lstStyle xmlns:a="http://schemas.openxmlformats.org/drawingml/2006/main"/>
+          <a:p xmlns:a="http://schemas.openxmlformats.org/drawingml/2006/main">
+            <a:pPr algn="l">
+              <a:buNone/>
+              <a:defRPr sz="1350" b="0">
+                <a:solidFill>
+                  <a:srgbClr val="243B53"/>
+                </a:solidFill>
+              </a:defRPr>
+            </a:pPr>
+            <a:r>
+              <a:rPr sz="1350" b="0">
+                <a:solidFill>
+                  <a:srgbClr val="243B53"/>
+                </a:solidFill>
+              </a:rPr>
+              <a:t>The 2021 inputs reproduce the paper's core patterns and support a new Figure 6 mechanism diagnostic. Figure 8 alone remains method-bounded.</a:t>
             </a:r>
           </a:p>
         </p:txBody>
@@ -5021,7 +8246,7 @@
                   <a:srgbClr val="102A43"/>
                 </a:solidFill>
               </a:rPr>
-              <a:t>One label cannot mean the same thing across all three figures</a:t>
+              <a:t>One label cannot mean the same thing across all four figures</a:t>
             </a:r>
           </a:p>
         </p:txBody>
@@ -5205,7 +8430,7 @@
                   <a:srgbClr val="243B53"/>
                 </a:solidFill>
               </a:rPr>
-              <a:t>Figures 1, 5, and 8</a:t>
+              <a:t>Figures 1, 5, 6, and 8</a:t>
             </a:r>
           </a:p>
           <a:p xmlns:a="http://schemas.openxmlformats.org/drawingml/2006/main">
@@ -5653,7 +8878,7 @@
                   <a:srgbClr val="243B53"/>
                 </a:solidFill>
               </a:rPr>
-              <a:t>Figure 1 reconstruction; Figure 5 reconstruction; Figure 8 bounded proxy.</a:t>
+              <a:t>Figures 1, 5, and 6: reconstructions. Figure 8: bounded proxy.</a:t>
             </a:r>
           </a:p>
         </p:txBody>
@@ -8397,7 +11622,7 @@
           <p:nvPr/>
         </p:nvPicPr>
         <p:blipFill>
-          <a:blip xmlns:r="http://schemas.openxmlformats.org/officeDocument/2006/relationships" xmlns:a="http://schemas.openxmlformats.org/drawingml/2006/main" r:embed="R1c1ef89d19034b12"/>
+          <a:blip xmlns:r="http://schemas.openxmlformats.org/officeDocument/2006/relationships" xmlns:a="http://schemas.openxmlformats.org/drawingml/2006/main" r:embed="R6aa12b65cdca4e52"/>
           <a:stretch xmlns:a="http://schemas.openxmlformats.org/drawingml/2006/main"/>
         </p:blipFill>
         <p:spPr>
@@ -8419,7 +11644,7 @@
           <p:nvPr/>
         </p:nvPicPr>
         <p:blipFill>
-          <a:blip xmlns:r="http://schemas.openxmlformats.org/officeDocument/2006/relationships" xmlns:a="http://schemas.openxmlformats.org/drawingml/2006/main" r:embed="Rec2e4d8bb1dc4df9"/>
+          <a:blip xmlns:r="http://schemas.openxmlformats.org/officeDocument/2006/relationships" xmlns:a="http://schemas.openxmlformats.org/drawingml/2006/main" r:embed="Rdea2508236734d7e"/>
           <a:stretch xmlns:a="http://schemas.openxmlformats.org/drawingml/2006/main"/>
         </p:blipFill>
         <p:spPr>
@@ -8791,7 +12016,7 @@
           <p:nvPr/>
         </p:nvPicPr>
         <p:blipFill>
-          <a:blip xmlns:r="http://schemas.openxmlformats.org/officeDocument/2006/relationships" xmlns:a="http://schemas.openxmlformats.org/drawingml/2006/main" r:embed="R5aaeb37cc0364663"/>
+          <a:blip xmlns:r="http://schemas.openxmlformats.org/officeDocument/2006/relationships" xmlns:a="http://schemas.openxmlformats.org/drawingml/2006/main" r:embed="Raf6c778a46924bbb"/>
           <a:stretch xmlns:a="http://schemas.openxmlformats.org/drawingml/2006/main"/>
         </p:blipFill>
         <p:spPr>
@@ -8848,7 +12073,7 @@
           <p:nvPr/>
         </p:nvPicPr>
         <p:blipFill>
-          <a:blip xmlns:r="http://schemas.openxmlformats.org/officeDocument/2006/relationships" xmlns:a="http://schemas.openxmlformats.org/drawingml/2006/main" r:embed="R0a223ed2f2664f05"/>
+          <a:blip xmlns:r="http://schemas.openxmlformats.org/officeDocument/2006/relationships" xmlns:a="http://schemas.openxmlformats.org/drawingml/2006/main" r:embed="Rad59a0640ae5410e"/>
           <a:stretch xmlns:a="http://schemas.openxmlformats.org/drawingml/2006/main"/>
         </p:blipFill>
         <p:spPr>
@@ -9437,7 +12662,7 @@
           <p:nvPr/>
         </p:nvPicPr>
         <p:blipFill>
-          <a:blip xmlns:r="http://schemas.openxmlformats.org/officeDocument/2006/relationships" xmlns:a="http://schemas.openxmlformats.org/drawingml/2006/main" r:embed="R2a56410e63a04ad9"/>
+          <a:blip xmlns:r="http://schemas.openxmlformats.org/officeDocument/2006/relationships" xmlns:a="http://schemas.openxmlformats.org/drawingml/2006/main" r:embed="Rdad12fba94434c25"/>
           <a:stretch xmlns:a="http://schemas.openxmlformats.org/drawingml/2006/main"/>
         </p:blipFill>
         <p:spPr>
@@ -9494,7 +12719,7 @@
           <p:nvPr/>
         </p:nvPicPr>
         <p:blipFill>
-          <a:blip xmlns:r="http://schemas.openxmlformats.org/officeDocument/2006/relationships" xmlns:a="http://schemas.openxmlformats.org/drawingml/2006/main" r:embed="R4972689358404001"/>
+          <a:blip xmlns:r="http://schemas.openxmlformats.org/officeDocument/2006/relationships" xmlns:a="http://schemas.openxmlformats.org/drawingml/2006/main" r:embed="Rf5fc36de7a4447d3"/>
           <a:stretch xmlns:a="http://schemas.openxmlformats.org/drawingml/2006/main"/>
         </p:blipFill>
         <p:spPr>
@@ -11089,7 +14314,7 @@
           <p:nvPr/>
         </p:nvPicPr>
         <p:blipFill>
-          <a:blip xmlns:r="http://schemas.openxmlformats.org/officeDocument/2006/relationships" xmlns:a="http://schemas.openxmlformats.org/drawingml/2006/main" r:embed="R68aee280b05a411d"/>
+          <a:blip xmlns:r="http://schemas.openxmlformats.org/officeDocument/2006/relationships" xmlns:a="http://schemas.openxmlformats.org/drawingml/2006/main" r:embed="R3e40c3c5f99843e1"/>
           <a:stretch xmlns:a="http://schemas.openxmlformats.org/drawingml/2006/main"/>
         </p:blipFill>
         <p:spPr>
@@ -12828,7 +16053,7 @@
           <p:nvPr/>
         </p:nvPicPr>
         <p:blipFill>
-          <a:blip xmlns:r="http://schemas.openxmlformats.org/officeDocument/2006/relationships" xmlns:a="http://schemas.openxmlformats.org/drawingml/2006/main" r:embed="R1ef496f441d74c23"/>
+          <a:blip xmlns:r="http://schemas.openxmlformats.org/officeDocument/2006/relationships" xmlns:a="http://schemas.openxmlformats.org/drawingml/2006/main" r:embed="Ra3b190a9b3c94faa"/>
           <a:stretch xmlns:a="http://schemas.openxmlformats.org/drawingml/2006/main"/>
         </p:blipFill>
         <p:spPr>
@@ -12850,7 +16075,7 @@
           <p:nvPr/>
         </p:nvPicPr>
         <p:blipFill>
-          <a:blip xmlns:r="http://schemas.openxmlformats.org/officeDocument/2006/relationships" xmlns:a="http://schemas.openxmlformats.org/drawingml/2006/main" r:embed="R6615eded92a64422"/>
+          <a:blip xmlns:r="http://schemas.openxmlformats.org/officeDocument/2006/relationships" xmlns:a="http://schemas.openxmlformats.org/drawingml/2006/main" r:embed="Rd6d7e32a55d9495f"/>
           <a:stretch xmlns:a="http://schemas.openxmlformats.org/drawingml/2006/main"/>
         </p:blipFill>
         <p:spPr>

</xml_diff>

<commit_message>
Audit Figure 6 paper-curve digitization
Extract and trace the paper's embedded Figure 6 raster with explicit axis calibration, exact-color sampling, and endpoint-marker handling. Add the pixel overlay, audit outputs, tests, documentation, and the audited comparison-deck slide.\n\nValidation: 26 tests passed; the 17-slide deck passed visual, template-fidelity, and archive checks. Paper curves remain approximate visual benchmarks, not empirical inputs.\n\nAI assistance: Codex implemented and documented the raster audit and presentation QA under researcher review.
</commit_message>
<xml_diff>
--- a/Presentation/4_figure_comparison/presentation.pptx
+++ b/Presentation/4_figure_comparison/presentation.pptx
@@ -2,28 +2,29 @@
 <file path=ppt/presentation.xml><?xml version="1.0" encoding="utf-8"?>
 <p:presentation xmlns:p="http://schemas.openxmlformats.org/presentationml/2006/main">
   <p:sldMasterIdLst>
-    <p:sldMasterId xmlns:r="http://schemas.openxmlformats.org/officeDocument/2006/relationships" id="2147483648" r:id="R1838919981e348df"/>
+    <p:sldMasterId xmlns:r="http://schemas.openxmlformats.org/officeDocument/2006/relationships" id="2147483648" r:id="R7754b5659fe94028"/>
   </p:sldMasterIdLst>
   <p:notesMasterIdLst>
-    <p:notesMasterId xmlns:r="http://schemas.openxmlformats.org/officeDocument/2006/relationships" r:id="R605570555d5b462e"/>
+    <p:notesMasterId xmlns:r="http://schemas.openxmlformats.org/officeDocument/2006/relationships" r:id="R5d2be0ef7bb7422a"/>
   </p:notesMasterIdLst>
   <p:sldIdLst>
-    <p:sldId xmlns:r="http://schemas.openxmlformats.org/officeDocument/2006/relationships" id="256" r:id="R84da1362116a4b82"/>
-    <p:sldId xmlns:r="http://schemas.openxmlformats.org/officeDocument/2006/relationships" id="257" r:id="Rcadedfa889564248"/>
-    <p:sldId xmlns:r="http://schemas.openxmlformats.org/officeDocument/2006/relationships" id="258" r:id="R9eb3ad82648f4ae4"/>
-    <p:sldId xmlns:r="http://schemas.openxmlformats.org/officeDocument/2006/relationships" id="259" r:id="R62dfc5cca4974225"/>
-    <p:sldId xmlns:r="http://schemas.openxmlformats.org/officeDocument/2006/relationships" id="260" r:id="R28ee73c8ddf34195"/>
-    <p:sldId xmlns:r="http://schemas.openxmlformats.org/officeDocument/2006/relationships" id="261" r:id="R23235f2fdf5944d3"/>
-    <p:sldId xmlns:r="http://schemas.openxmlformats.org/officeDocument/2006/relationships" id="262" r:id="R4264838c9bf541fd"/>
-    <p:sldId xmlns:r="http://schemas.openxmlformats.org/officeDocument/2006/relationships" id="263" r:id="Rec05dabc391c41e5"/>
-    <p:sldId xmlns:r="http://schemas.openxmlformats.org/officeDocument/2006/relationships" id="264" r:id="Rc0191ebf4b0d4776"/>
-    <p:sldId xmlns:r="http://schemas.openxmlformats.org/officeDocument/2006/relationships" id="265" r:id="R057506c52c764860"/>
-    <p:sldId xmlns:r="http://schemas.openxmlformats.org/officeDocument/2006/relationships" id="266" r:id="Rfb9f3df32da049c9"/>
-    <p:sldId xmlns:r="http://schemas.openxmlformats.org/officeDocument/2006/relationships" id="267" r:id="Raf2da36407f04012"/>
-    <p:sldId xmlns:r="http://schemas.openxmlformats.org/officeDocument/2006/relationships" id="268" r:id="Rab1f9779c11e4a04"/>
-    <p:sldId xmlns:r="http://schemas.openxmlformats.org/officeDocument/2006/relationships" id="269" r:id="R8e5cc8f4e278455b"/>
-    <p:sldId xmlns:r="http://schemas.openxmlformats.org/officeDocument/2006/relationships" id="270" r:id="R3c67d6e8237a4c28"/>
-    <p:sldId xmlns:r="http://schemas.openxmlformats.org/officeDocument/2006/relationships" id="271" r:id="Rc78f4ef058d54d18"/>
+    <p:sldId xmlns:r="http://schemas.openxmlformats.org/officeDocument/2006/relationships" id="256" r:id="Rdc4ba6c466ab4e93"/>
+    <p:sldId xmlns:r="http://schemas.openxmlformats.org/officeDocument/2006/relationships" id="257" r:id="Rb7c9300ae47d4086"/>
+    <p:sldId xmlns:r="http://schemas.openxmlformats.org/officeDocument/2006/relationships" id="258" r:id="R9b7f8c9e134a4143"/>
+    <p:sldId xmlns:r="http://schemas.openxmlformats.org/officeDocument/2006/relationships" id="259" r:id="R5bf7b3f6c79d4790"/>
+    <p:sldId xmlns:r="http://schemas.openxmlformats.org/officeDocument/2006/relationships" id="260" r:id="R833e3b743b6848f2"/>
+    <p:sldId xmlns:r="http://schemas.openxmlformats.org/officeDocument/2006/relationships" id="261" r:id="R941bd215d9ce4f7b"/>
+    <p:sldId xmlns:r="http://schemas.openxmlformats.org/officeDocument/2006/relationships" id="262" r:id="R32f46ed513a74bd8"/>
+    <p:sldId xmlns:r="http://schemas.openxmlformats.org/officeDocument/2006/relationships" id="263" r:id="Rf3954c43ab7145f8"/>
+    <p:sldId xmlns:r="http://schemas.openxmlformats.org/officeDocument/2006/relationships" id="264" r:id="R7662e0075fde4b5d"/>
+    <p:sldId xmlns:r="http://schemas.openxmlformats.org/officeDocument/2006/relationships" id="265" r:id="Rebd344961c384d72"/>
+    <p:sldId xmlns:r="http://schemas.openxmlformats.org/officeDocument/2006/relationships" id="266" r:id="Rbb833f42d056455e"/>
+    <p:sldId xmlns:r="http://schemas.openxmlformats.org/officeDocument/2006/relationships" id="267" r:id="R69643c3880e14f9c"/>
+    <p:sldId xmlns:r="http://schemas.openxmlformats.org/officeDocument/2006/relationships" id="268" r:id="Rb7fbd363fd48413b"/>
+    <p:sldId xmlns:r="http://schemas.openxmlformats.org/officeDocument/2006/relationships" id="269" r:id="R53eae6ede676446a"/>
+    <p:sldId xmlns:r="http://schemas.openxmlformats.org/officeDocument/2006/relationships" id="270" r:id="Rc5ede7fd4d8b466b"/>
+    <p:sldId xmlns:r="http://schemas.openxmlformats.org/officeDocument/2006/relationships" id="271" r:id="Re5280e21748e4a8f"/>
+    <p:sldId xmlns:r="http://schemas.openxmlformats.org/officeDocument/2006/relationships" id="272" r:id="Rca3f9368614443ee"/>
   </p:sldIdLst>
   <p:sldSz cx="12192000" cy="6858000"/>
   <p:notesSz cx="6858000" cy="9144000"/>
@@ -662,6 +663,11 @@
           </a:p>
           <a:p xmlns:a="http://schemas.openxmlformats.org/drawingml/2006/main">
             <a:r>
+              <a:t>- Data/processed/figure6_digitization_audit.csv</a:t>
+            </a:r>
+          </a:p>
+          <a:p xmlns:a="http://schemas.openxmlformats.org/drawingml/2006/main">
+            <a:r>
               <a:t>- docs/project/tasks/figure6-replication.md</a:t>
             </a:r>
           </a:p>
@@ -737,27 +743,32 @@
           </a:p>
           <a:p xmlns:a="http://schemas.openxmlformats.org/drawingml/2006/main">
             <a:r>
-              <a:t>- Results_Proposal/figures/figure6_authors_data_percentiles.png</a:t>
-            </a:r>
-          </a:p>
-          <a:p xmlns:a="http://schemas.openxmlformats.org/drawingml/2006/main">
-            <a:r>
-              <a:t>- Results_Proposal/figures/figure6_authors_data_wealth_levels.png</a:t>
-            </a:r>
-          </a:p>
-          <a:p xmlns:a="http://schemas.openxmlformats.org/drawingml/2006/main">
-            <a:r>
-              <a:t>- Data/processed/figure6_authors_data.csv</a:t>
-            </a:r>
-          </a:p>
-          <a:p xmlns:a="http://schemas.openxmlformats.org/drawingml/2006/main">
-            <a:r>
-              <a:t>- docs/project/personal-considerations-saving-inequality.md</a:t>
-            </a:r>
-          </a:p>
-          <a:p xmlns:a="http://schemas.openxmlformats.org/drawingml/2006/main">
-            <a:r>
-              <a:t>- docs/data/figure6-data.md</a:t>
+              <a:t>- MSS_SGR_July242025.pdf, Figure 6, physical PDF page 24; original embedded raster</a:t>
+            </a:r>
+          </a:p>
+          <a:p xmlns:a="http://schemas.openxmlformats.org/drawingml/2006/main">
+            <a:r>
+              <a:t>- Results_Proposal/figures/figure6_digitization_overlay_slide.png</a:t>
+            </a:r>
+          </a:p>
+          <a:p xmlns:a="http://schemas.openxmlformats.org/drawingml/2006/main">
+            <a:r>
+              <a:t>- Data/processed/figure6_digitization_audit.csv</a:t>
+            </a:r>
+          </a:p>
+          <a:p xmlns:a="http://schemas.openxmlformats.org/drawingml/2006/main">
+            <a:r>
+              <a:t>- Code/unveiling/paper_benchmarks.py</a:t>
+            </a:r>
+          </a:p>
+          <a:p xmlns:a="http://schemas.openxmlformats.org/drawingml/2006/main">
+            <a:r>
+              <a:t>- Code/scripts/build_figure6_authors_data.py</a:t>
+            </a:r>
+          </a:p>
+          <a:p xmlns:a="http://schemas.openxmlformats.org/drawingml/2006/main">
+            <a:r>
+              <a:t>- docs/data/figure6-data.md, Paper-curve digitization</a:t>
             </a:r>
           </a:p>
         </p:txBody>
@@ -832,22 +843,22 @@
           </a:p>
           <a:p xmlns:a="http://schemas.openxmlformats.org/drawingml/2006/main">
             <a:r>
-              <a:t>- Data/processed/figure6_authors_rolling5.csv</a:t>
-            </a:r>
-          </a:p>
-          <a:p xmlns:a="http://schemas.openxmlformats.org/drawingml/2006/main">
-            <a:r>
-              <a:t>- Results_Proposal/figures/figure6_rolling5_heatmap.png</a:t>
-            </a:r>
-          </a:p>
-          <a:p xmlns:a="http://schemas.openxmlformats.org/drawingml/2006/main">
-            <a:r>
-              <a:t>- Results_Proposal/figures/figure6_rolling5_selected_percentiles.png</a:t>
-            </a:r>
-          </a:p>
-          <a:p xmlns:a="http://schemas.openxmlformats.org/drawingml/2006/main">
-            <a:r>
-              <a:t>- Code/scripts/build_figure6_authors_data.py</a:t>
+              <a:t>- Results_Proposal/figures/figure6_authors_data_percentiles.png</a:t>
+            </a:r>
+          </a:p>
+          <a:p xmlns:a="http://schemas.openxmlformats.org/drawingml/2006/main">
+            <a:r>
+              <a:t>- Results_Proposal/figures/figure6_authors_data_wealth_levels.png</a:t>
+            </a:r>
+          </a:p>
+          <a:p xmlns:a="http://schemas.openxmlformats.org/drawingml/2006/main">
+            <a:r>
+              <a:t>- Data/processed/figure6_authors_data.csv</a:t>
+            </a:r>
+          </a:p>
+          <a:p xmlns:a="http://schemas.openxmlformats.org/drawingml/2006/main">
+            <a:r>
+              <a:t>- docs/project/personal-considerations-saving-inequality.md</a:t>
             </a:r>
           </a:p>
           <a:p xmlns:a="http://schemas.openxmlformats.org/drawingml/2006/main">
@@ -927,22 +938,27 @@
           </a:p>
           <a:p xmlns:a="http://schemas.openxmlformats.org/drawingml/2006/main">
             <a:r>
-              <a:t>- MSS_SGR_July242025.pdf, Sections 4.1-4.2 and Figure 8, physical PDF page 29</a:t>
-            </a:r>
-          </a:p>
-          <a:p xmlns:a="http://schemas.openxmlformats.org/drawingml/2006/main">
-            <a:r>
-              <a:t>- MSS2021Febreplicationkit/code/build_fa_unveiling_data.do</a:t>
-            </a:r>
-          </a:p>
-          <a:p xmlns:a="http://schemas.openxmlformats.org/drawingml/2006/main">
-            <a:r>
-              <a:t>- docs/data/figure8-data.md</a:t>
-            </a:r>
-          </a:p>
-          <a:p xmlns:a="http://schemas.openxmlformats.org/drawingml/2006/main">
-            <a:r>
-              <a:t>- Code/unveiling/figure8_authors.py</a:t>
+              <a:t>- Data/processed/figure6_authors_rolling5.csv</a:t>
+            </a:r>
+          </a:p>
+          <a:p xmlns:a="http://schemas.openxmlformats.org/drawingml/2006/main">
+            <a:r>
+              <a:t>- Results_Proposal/figures/figure6_rolling5_heatmap.png</a:t>
+            </a:r>
+          </a:p>
+          <a:p xmlns:a="http://schemas.openxmlformats.org/drawingml/2006/main">
+            <a:r>
+              <a:t>- Results_Proposal/figures/figure6_rolling5_selected_percentiles.png</a:t>
+            </a:r>
+          </a:p>
+          <a:p xmlns:a="http://schemas.openxmlformats.org/drawingml/2006/main">
+            <a:r>
+              <a:t>- Code/scripts/build_figure6_authors_data.py</a:t>
+            </a:r>
+          </a:p>
+          <a:p xmlns:a="http://schemas.openxmlformats.org/drawingml/2006/main">
+            <a:r>
+              <a:t>- docs/data/figure6-data.md</a:t>
             </a:r>
           </a:p>
         </p:txBody>
@@ -1017,22 +1033,22 @@
           </a:p>
           <a:p xmlns:a="http://schemas.openxmlformats.org/drawingml/2006/main">
             <a:r>
-              <a:t>- MSS_SGR_July242025.pdf, Figure 8, physical PDF page 29; embedded chart extracted without caption</a:t>
-            </a:r>
-          </a:p>
-          <a:p xmlns:a="http://schemas.openxmlformats.org/drawingml/2006/main">
-            <a:r>
-              <a:t>- Results_Proposal/figures/figure8_authors_proxy.png</a:t>
-            </a:r>
-          </a:p>
-          <a:p xmlns:a="http://schemas.openxmlformats.org/drawingml/2006/main">
-            <a:r>
-              <a:t>- Data/processed/figure8_authors_proxy_comparison.csv</a:t>
-            </a:r>
-          </a:p>
-          <a:p xmlns:a="http://schemas.openxmlformats.org/drawingml/2006/main">
-            <a:r>
-              <a:t>- docs/project/tasks/figure8-replication.md, Verification and result</a:t>
+              <a:t>- MSS_SGR_July242025.pdf, Sections 4.1-4.2 and Figure 8, physical PDF page 29</a:t>
+            </a:r>
+          </a:p>
+          <a:p xmlns:a="http://schemas.openxmlformats.org/drawingml/2006/main">
+            <a:r>
+              <a:t>- MSS2021Febreplicationkit/code/build_fa_unveiling_data.do</a:t>
+            </a:r>
+          </a:p>
+          <a:p xmlns:a="http://schemas.openxmlformats.org/drawingml/2006/main">
+            <a:r>
+              <a:t>- docs/data/figure8-data.md</a:t>
+            </a:r>
+          </a:p>
+          <a:p xmlns:a="http://schemas.openxmlformats.org/drawingml/2006/main">
+            <a:r>
+              <a:t>- Code/unveiling/figure8_authors.py</a:t>
             </a:r>
           </a:p>
         </p:txBody>
@@ -1063,6 +1079,96 @@
 </file>
 
 <file path=ppt/notesSlides/notesSlide16.xml><?xml version="1.0" encoding="utf-8"?>
+<p:notes xmlns:p="http://schemas.openxmlformats.org/presentationml/2006/main">
+  <p:cSld>
+    <p:spTree>
+      <p:nvGrpSpPr>
+        <p:cNvPr id="1" name=""/>
+        <p:cNvGrpSpPr/>
+        <p:nvPr/>
+      </p:nvGrpSpPr>
+      <p:grpSpPr>
+        <a:xfrm xmlns:a="http://schemas.openxmlformats.org/drawingml/2006/main"/>
+      </p:grpSpPr>
+      <p:sp>
+        <p:nvSpPr>
+          <p:cNvPr id="2" name="Slide Image Placeholder 1"/>
+          <p:cNvSpPr>
+            <a:spLocks xmlns:a="http://schemas.openxmlformats.org/drawingml/2006/main" noGrp="1"/>
+          </p:cNvSpPr>
+          <p:nvPr>
+            <p:ph type="sldImg" idx="0"/>
+          </p:nvPr>
+        </p:nvSpPr>
+        <p:spPr/>
+      </p:sp>
+      <p:sp>
+        <p:nvSpPr>
+          <p:cNvPr id="3" name="Notes Placeholder 2"/>
+          <p:cNvSpPr>
+            <a:spLocks xmlns:a="http://schemas.openxmlformats.org/drawingml/2006/main" noGrp="1"/>
+          </p:cNvSpPr>
+          <p:nvPr>
+            <p:ph type="body" idx="1"/>
+          </p:nvPr>
+        </p:nvSpPr>
+        <p:spPr/>
+        <p:txBody>
+          <a:bodyPr xmlns:a="http://schemas.openxmlformats.org/drawingml/2006/main"/>
+          <a:lstStyle xmlns:a="http://schemas.openxmlformats.org/drawingml/2006/main"/>
+          <a:p xmlns:a="http://schemas.openxmlformats.org/drawingml/2006/main">
+            <a:r>
+              <a:t>[Sources]</a:t>
+            </a:r>
+          </a:p>
+          <a:p xmlns:a="http://schemas.openxmlformats.org/drawingml/2006/main">
+            <a:r>
+              <a:t>- MSS_SGR_July242025.pdf, Figure 8, physical PDF page 29; embedded chart extracted without caption</a:t>
+            </a:r>
+          </a:p>
+          <a:p xmlns:a="http://schemas.openxmlformats.org/drawingml/2006/main">
+            <a:r>
+              <a:t>- Results_Proposal/figures/figure8_authors_proxy.png</a:t>
+            </a:r>
+          </a:p>
+          <a:p xmlns:a="http://schemas.openxmlformats.org/drawingml/2006/main">
+            <a:r>
+              <a:t>- Data/processed/figure8_authors_proxy_comparison.csv</a:t>
+            </a:r>
+          </a:p>
+          <a:p xmlns:a="http://schemas.openxmlformats.org/drawingml/2006/main">
+            <a:r>
+              <a:t>- docs/project/tasks/figure8-replication.md, Verification and result</a:t>
+            </a:r>
+          </a:p>
+        </p:txBody>
+      </p:sp>
+      <p:sp>
+        <p:nvSpPr>
+          <p:cNvPr id="4" name="Slide Number Placeholder 3"/>
+          <p:cNvSpPr>
+            <a:spLocks xmlns:a="http://schemas.openxmlformats.org/drawingml/2006/main" noGrp="1"/>
+          </p:cNvSpPr>
+          <p:nvPr>
+            <p:ph type="sldNum" idx="5"/>
+          </p:nvPr>
+        </p:nvSpPr>
+        <p:spPr/>
+        <p:txBody>
+          <a:bodyPr xmlns:a="http://schemas.openxmlformats.org/drawingml/2006/main"/>
+          <a:lstStyle xmlns:a="http://schemas.openxmlformats.org/drawingml/2006/main"/>
+          <a:p xmlns:a="http://schemas.openxmlformats.org/drawingml/2006/main"/>
+        </p:txBody>
+      </p:sp>
+    </p:spTree>
+  </p:cSld>
+  <p:clrMapOvr>
+    <a:masterClrMapping xmlns:a="http://schemas.openxmlformats.org/drawingml/2006/main"/>
+  </p:clrMapOvr>
+</p:notes>
+</file>
+
+<file path=ppt/notesSlides/notesSlide17.xml><?xml version="1.0" encoding="utf-8"?>
 <p:notes xmlns:p="http://schemas.openxmlformats.org/presentationml/2006/main">
   <p:cSld>
     <p:spTree>
@@ -1915,7 +2021,7 @@
   </p:cSld>
   <p:clrMap bg1="lt1" tx1="dk1" bg2="lt2" tx2="dk2" accent1="accent1" accent2="accent2" accent3="accent3" accent4="accent4" accent5="accent5" accent6="accent6" hlink="hlink" folHlink="folHlink"/>
   <p:sldLayoutIdLst>
-    <p:sldLayoutId xmlns:r="http://schemas.openxmlformats.org/officeDocument/2006/relationships" id="2147483649" r:id="R9cabc6dfa9f443f0"/>
+    <p:sldLayoutId xmlns:r="http://schemas.openxmlformats.org/officeDocument/2006/relationships" id="2147483649" r:id="Reed8852cf2014fcc"/>
   </p:sldLayoutIdLst>
   <p:txStyles>
     <p:titleStyle>
@@ -4304,7 +4410,7 @@
                   <a:srgbClr val="243B53"/>
                 </a:solidFill>
               </a:rPr>
-              <a:t>Correlations: 0.991 / 0.972; MAE: 1.46 / 1.20 pp.</a:t>
+              <a:t>Correlations: 0.991 / 0.969; MAE: 1.46 / 1.22 pp.</a:t>
             </a:r>
           </a:p>
         </p:txBody>
@@ -4369,7 +4475,7 @@
           <p:nvPr/>
         </p:nvPicPr>
         <p:blipFill>
-          <a:blip xmlns:r="http://schemas.openxmlformats.org/officeDocument/2006/relationships" xmlns:a="http://schemas.openxmlformats.org/drawingml/2006/main" r:embed="R0f0005083477437e"/>
+          <a:blip xmlns:r="http://schemas.openxmlformats.org/officeDocument/2006/relationships" xmlns:a="http://schemas.openxmlformats.org/drawingml/2006/main" r:embed="Rf008d5e6a4b74503"/>
           <a:stretch xmlns:a="http://schemas.openxmlformats.org/drawingml/2006/main"/>
         </p:blipFill>
         <p:spPr>
@@ -4391,7 +4497,7 @@
           <p:nvPr/>
         </p:nvPicPr>
         <p:blipFill>
-          <a:blip xmlns:r="http://schemas.openxmlformats.org/officeDocument/2006/relationships" xmlns:a="http://schemas.openxmlformats.org/drawingml/2006/main" r:embed="R1e207e051435401b"/>
+          <a:blip xmlns:r="http://schemas.openxmlformats.org/officeDocument/2006/relationships" xmlns:a="http://schemas.openxmlformats.org/drawingml/2006/main" r:embed="Ra5902b3c204b41b9"/>
           <a:stretch xmlns:a="http://schemas.openxmlformats.org/drawingml/2006/main"/>
         </p:blipFill>
         <p:spPr>
@@ -4435,10 +4541,10 @@
       </p:grpSpPr>
       <p:sp>
         <p:nvSpPr>
-          <p:cNvPr id="16" name="kicker">
-            <a:extLst xmlns:a="http://schemas.openxmlformats.org/drawingml/2006/main">
-              <a:ext uri="{FF2B5EF4-FFF2-40B4-BE49-F238E27FC236}">
-                <a16:creationId xmlns:a16="http://schemas.microsoft.com/office/drawing/2014/main" id="{AA955CD9-B4EF-4E20-A3FC-1D7B4F59A354}"/>
+          <p:cNvPr id="36" name="kicker">
+            <a:extLst xmlns:a="http://schemas.openxmlformats.org/drawingml/2006/main">
+              <a:ext uri="{FF2B5EF4-FFF2-40B4-BE49-F238E27FC236}">
+                <a16:creationId xmlns:a16="http://schemas.microsoft.com/office/drawing/2014/main" id="{EAB68E1F-5F14-41BF-B5B2-0B83C02C7208}"/>
               </a:ext>
             </a:extLst>
           </p:cNvPr>
@@ -4479,7 +4585,7 @@
                   <a:srgbClr val="C65D16"/>
                 </a:solidFill>
               </a:rPr>
-              <a:t>FIGURE 6 MECHANISM VIEW</a:t>
+              <a:t>DIGITIZATION AUDIT</a:t>
             </a:r>
           </a:p>
         </p:txBody>
@@ -4489,7 +4595,7 @@
           <p:cNvPr id="2" name="title">
             <a:extLst xmlns:a="http://schemas.openxmlformats.org/drawingml/2006/main">
               <a:ext uri="{FF2B5EF4-FFF2-40B4-BE49-F238E27FC236}">
-                <a16:creationId xmlns:a16="http://schemas.microsoft.com/office/drawing/2014/main" id="{BE8A36E9-77A3-4197-AAEB-944D96A22E35}"/>
+                <a16:creationId xmlns:a16="http://schemas.microsoft.com/office/drawing/2014/main" id="{36B9ACAC-E63B-4F9A-A769-27A011FD5716}"/>
               </a:ext>
             </a:extLst>
           </p:cNvPr>
@@ -4530,7 +4636,7 @@
                   <a:srgbClr val="102A43"/>
                 </a:solidFill>
               </a:rPr>
-              <a:t>Rising wealth alone does not explain the saving-rate shift</a:t>
+              <a:t>Recovered centerlines match the paper pixels</a:t>
             </a:r>
           </a:p>
         </p:txBody>
@@ -4540,7 +4646,7 @@
           <p:cNvPr id="3" name="header-rule">
             <a:extLst xmlns:a="http://schemas.openxmlformats.org/drawingml/2006/main">
               <a:ext uri="{FF2B5EF4-FFF2-40B4-BE49-F238E27FC236}">
-                <a16:creationId xmlns:a16="http://schemas.microsoft.com/office/drawing/2014/main" id="{514C6BB1-D2D7-4502-B63E-CB46F5220FD9}"/>
+                <a16:creationId xmlns:a16="http://schemas.microsoft.com/office/drawing/2014/main" id="{2E310BCA-30B4-4B4B-9F0D-082B1D7DE1B4}"/>
               </a:ext>
             </a:extLst>
           </p:cNvPr>
@@ -4571,7 +4677,7 @@
           <p:cNvPr id="4" name="slide-number">
             <a:extLst xmlns:a="http://schemas.openxmlformats.org/drawingml/2006/main">
               <a:ext uri="{FF2B5EF4-FFF2-40B4-BE49-F238E27FC236}">
-                <a16:creationId xmlns:a16="http://schemas.microsoft.com/office/drawing/2014/main" id="{1846DD66-DAE1-4F4D-9638-E1108AC93C86}"/>
+                <a16:creationId xmlns:a16="http://schemas.microsoft.com/office/drawing/2014/main" id="{0230AEA7-5E87-4D82-B1C4-A09E0F2B1521}"/>
               </a:ext>
             </a:extLst>
           </p:cNvPr>
@@ -4622,7 +4728,7 @@
           <p:cNvPr id="5" name="left-label">
             <a:extLst xmlns:a="http://schemas.openxmlformats.org/drawingml/2006/main">
               <a:ext uri="{FF2B5EF4-FFF2-40B4-BE49-F238E27FC236}">
-                <a16:creationId xmlns:a16="http://schemas.microsoft.com/office/drawing/2014/main" id="{AC7EBFD9-49FB-40B3-B7BA-0564A41A3ADA}"/>
+                <a16:creationId xmlns:a16="http://schemas.microsoft.com/office/drawing/2014/main" id="{433D43E3-23C7-49D8-9C90-19B44AAA1828}"/>
               </a:ext>
             </a:extLst>
           </p:cNvPr>
@@ -4634,7 +4740,7 @@
         <p:spPr>
           <a:xfrm xmlns:a="http://schemas.openxmlformats.org/drawingml/2006/main">
             <a:off x="457200" y="1123950"/>
-            <a:ext cx="5334000" cy="266700"/>
+            <a:ext cx="4953000" cy="266700"/>
           </a:xfrm>
           <a:prstGeom xmlns:a="http://schemas.openxmlformats.org/drawingml/2006/main" prst="rect">
             <a:avLst/>
@@ -4663,7 +4769,7 @@
                   <a:srgbClr val="2E5B88"/>
                 </a:solidFill>
               </a:rPr>
-              <a:t>Same rates · wealth percentile</a:t>
+              <a:t>Calibration and trace</a:t>
             </a:r>
           </a:p>
         </p:txBody>
@@ -4673,19 +4779,19 @@
           <p:cNvPr id="6" name="right-label">
             <a:extLst xmlns:a="http://schemas.openxmlformats.org/drawingml/2006/main">
               <a:ext uri="{FF2B5EF4-FFF2-40B4-BE49-F238E27FC236}">
-                <a16:creationId xmlns:a16="http://schemas.microsoft.com/office/drawing/2014/main" id="{D7EBD11C-5C33-487B-AFE7-65F7CD7D2108}"/>
-              </a:ext>
-            </a:extLst>
-          </p:cNvPr>
-          <p:cNvSpPr>
-            <a:spLocks xmlns:a="http://schemas.openxmlformats.org/drawingml/2006/main" noGrp="1"/>
-          </p:cNvSpPr>
-          <p:nvPr/>
-        </p:nvSpPr>
-        <p:spPr>
-          <a:xfrm xmlns:a="http://schemas.openxmlformats.org/drawingml/2006/main">
-            <a:off x="6324600" y="1123950"/>
-            <a:ext cx="5410200" cy="266700"/>
+                <a16:creationId xmlns:a16="http://schemas.microsoft.com/office/drawing/2014/main" id="{EBA5073A-538F-4458-851D-23CDE872ED3E}"/>
+              </a:ext>
+            </a:extLst>
+          </p:cNvPr>
+          <p:cNvSpPr>
+            <a:spLocks xmlns:a="http://schemas.openxmlformats.org/drawingml/2006/main" noGrp="1"/>
+          </p:cNvSpPr>
+          <p:nvPr/>
+        </p:nvSpPr>
+        <p:spPr>
+          <a:xfrm xmlns:a="http://schemas.openxmlformats.org/drawingml/2006/main">
+            <a:off x="6667500" y="1123950"/>
+            <a:ext cx="5067300" cy="266700"/>
           </a:xfrm>
           <a:prstGeom xmlns:a="http://schemas.openxmlformats.org/drawingml/2006/main" prst="rect">
             <a:avLst/>
@@ -4714,17 +4820,17 @@
                   <a:srgbClr val="C65D16"/>
                 </a:solidFill>
               </a:rPr>
-              <a:t>Same rates · mean real wealth per adult</a:t>
-            </a:r>
-          </a:p>
-        </p:txBody>
-      </p:sp>
-      <p:sp>
-        <p:nvSpPr>
-          <p:cNvPr id="7" name="Regenerated 2021 safe-asset demand figure-frame">
-            <a:extLst xmlns:a="http://schemas.openxmlformats.org/drawingml/2006/main">
-              <a:ext uri="{FF2B5EF4-FFF2-40B4-BE49-F238E27FC236}">
-                <a16:creationId xmlns:a16="http://schemas.microsoft.com/office/drawing/2014/main" id="{1442A94D-98B9-4DC6-8E97-11AE6BD7202F}"/>
+              <a:t>Original raster + recovered centerlines</a:t>
+            </a:r>
+          </a:p>
+        </p:txBody>
+      </p:sp>
+      <p:sp>
+        <p:nvSpPr>
+          <p:cNvPr id="7" name="table-frame">
+            <a:extLst xmlns:a="http://schemas.openxmlformats.org/drawingml/2006/main">
+              <a:ext uri="{FF2B5EF4-FFF2-40B4-BE49-F238E27FC236}">
+                <a16:creationId xmlns:a16="http://schemas.microsoft.com/office/drawing/2014/main" id="{DF9B9604-BE23-46D2-9562-D6BCA821EB64}"/>
               </a:ext>
             </a:extLst>
           </p:cNvPr>
@@ -4756,10 +4862,981 @@
       </p:sp>
       <p:sp>
         <p:nvSpPr>
-          <p:cNvPr id="9" name="2025 Figure 10 safe-asset demand-frame">
-            <a:extLst xmlns:a="http://schemas.openxmlformats.org/drawingml/2006/main">
-              <a:ext uri="{FF2B5EF4-FFF2-40B4-BE49-F238E27FC236}">
-                <a16:creationId xmlns:a16="http://schemas.microsoft.com/office/drawing/2014/main" id="{98F7C92D-66A0-4F20-83BF-E349E5E80E9E}"/>
+          <p:cNvPr id="8" name="table-title">
+            <a:extLst xmlns:a="http://schemas.openxmlformats.org/drawingml/2006/main">
+              <a:ext uri="{FF2B5EF4-FFF2-40B4-BE49-F238E27FC236}">
+                <a16:creationId xmlns:a16="http://schemas.microsoft.com/office/drawing/2014/main" id="{081084E9-D741-43A8-900E-CF85F270B44A}"/>
+              </a:ext>
+            </a:extLst>
+          </p:cNvPr>
+          <p:cNvSpPr>
+            <a:spLocks xmlns:a="http://schemas.openxmlformats.org/drawingml/2006/main" noGrp="1"/>
+          </p:cNvSpPr>
+          <p:nvPr/>
+        </p:nvSpPr>
+        <p:spPr>
+          <a:xfrm xmlns:a="http://schemas.openxmlformats.org/drawingml/2006/main">
+            <a:off x="714375" y="1666875"/>
+            <a:ext cx="4857750" cy="552450"/>
+          </a:xfrm>
+          <a:prstGeom xmlns:a="http://schemas.openxmlformats.org/drawingml/2006/main" prst="rect">
+            <a:avLst/>
+          </a:prstGeom>
+          <a:noFill xmlns:a="http://schemas.openxmlformats.org/drawingml/2006/main"/>
+          <a:ln xmlns:a="http://schemas.openxmlformats.org/drawingml/2006/main" w="0">
+            <a:noFill/>
+            <a:prstDash val="solid"/>
+          </a:ln>
+        </p:spPr>
+        <p:txBody>
+          <a:bodyPr xmlns:a="http://schemas.openxmlformats.org/drawingml/2006/main" anchor="t"/>
+          <a:lstStyle xmlns:a="http://schemas.openxmlformats.org/drawingml/2006/main"/>
+          <a:p xmlns:a="http://schemas.openxmlformats.org/drawingml/2006/main">
+            <a:pPr algn="ctr">
+              <a:buNone/>
+              <a:defRPr sz="1500" b="1">
+                <a:solidFill>
+                  <a:srgbClr val="102A43"/>
+                </a:solidFill>
+              </a:defRPr>
+            </a:pPr>
+            <a:r>
+              <a:rPr sz="1500" b="1">
+                <a:solidFill>
+                  <a:srgbClr val="102A43"/>
+                </a:solidFill>
+              </a:rPr>
+              <a:t>No hand-clicking or screenshot interpolation</a:t>
+            </a:r>
+          </a:p>
+        </p:txBody>
+      </p:sp>
+      <p:sp>
+        <p:nvSpPr>
+          <p:cNvPr id="9" name="cell-0-0">
+            <a:extLst xmlns:a="http://schemas.openxmlformats.org/drawingml/2006/main">
+              <a:ext uri="{FF2B5EF4-FFF2-40B4-BE49-F238E27FC236}">
+                <a16:creationId xmlns:a16="http://schemas.microsoft.com/office/drawing/2014/main" id="{578615A5-537D-460B-8322-D66557A3B8F7}"/>
+              </a:ext>
+            </a:extLst>
+          </p:cNvPr>
+          <p:cNvSpPr>
+            <a:spLocks xmlns:a="http://schemas.openxmlformats.org/drawingml/2006/main" noGrp="1"/>
+          </p:cNvSpPr>
+          <p:nvPr/>
+        </p:nvSpPr>
+        <p:spPr>
+          <a:xfrm xmlns:a="http://schemas.openxmlformats.org/drawingml/2006/main">
+            <a:off x="952500" y="2476500"/>
+            <a:ext cx="1381125" cy="323850"/>
+          </a:xfrm>
+          <a:prstGeom xmlns:a="http://schemas.openxmlformats.org/drawingml/2006/main" prst="rect">
+            <a:avLst/>
+          </a:prstGeom>
+          <a:noFill xmlns:a="http://schemas.openxmlformats.org/drawingml/2006/main"/>
+          <a:ln xmlns:a="http://schemas.openxmlformats.org/drawingml/2006/main" w="0">
+            <a:noFill/>
+            <a:prstDash val="solid"/>
+          </a:ln>
+        </p:spPr>
+        <p:txBody>
+          <a:bodyPr xmlns:a="http://schemas.openxmlformats.org/drawingml/2006/main" anchor="t"/>
+          <a:lstStyle xmlns:a="http://schemas.openxmlformats.org/drawingml/2006/main"/>
+          <a:p xmlns:a="http://schemas.openxmlformats.org/drawingml/2006/main">
+            <a:pPr algn="l">
+              <a:buNone/>
+              <a:defRPr sz="1275" b="1">
+                <a:solidFill>
+                  <a:srgbClr val="102A43"/>
+                </a:solidFill>
+              </a:defRPr>
+            </a:pPr>
+            <a:r>
+              <a:rPr sz="1275" b="1">
+                <a:solidFill>
+                  <a:srgbClr val="102A43"/>
+                </a:solidFill>
+              </a:rPr>
+              <a:t>Object</a:t>
+            </a:r>
+          </a:p>
+        </p:txBody>
+      </p:sp>
+      <p:sp>
+        <p:nvSpPr>
+          <p:cNvPr id="10" name="cell-0-1">
+            <a:extLst xmlns:a="http://schemas.openxmlformats.org/drawingml/2006/main">
+              <a:ext uri="{FF2B5EF4-FFF2-40B4-BE49-F238E27FC236}">
+                <a16:creationId xmlns:a16="http://schemas.microsoft.com/office/drawing/2014/main" id="{185BC6AA-6653-4B7B-BC03-67E44DB69B70}"/>
+              </a:ext>
+            </a:extLst>
+          </p:cNvPr>
+          <p:cNvSpPr>
+            <a:spLocks xmlns:a="http://schemas.openxmlformats.org/drawingml/2006/main" noGrp="1"/>
+          </p:cNvSpPr>
+          <p:nvPr/>
+        </p:nvSpPr>
+        <p:spPr>
+          <a:xfrm xmlns:a="http://schemas.openxmlformats.org/drawingml/2006/main">
+            <a:off x="2333625" y="2476500"/>
+            <a:ext cx="1619250" cy="323850"/>
+          </a:xfrm>
+          <a:prstGeom xmlns:a="http://schemas.openxmlformats.org/drawingml/2006/main" prst="rect">
+            <a:avLst/>
+          </a:prstGeom>
+          <a:noFill xmlns:a="http://schemas.openxmlformats.org/drawingml/2006/main"/>
+          <a:ln xmlns:a="http://schemas.openxmlformats.org/drawingml/2006/main" w="0">
+            <a:noFill/>
+            <a:prstDash val="solid"/>
+          </a:ln>
+        </p:spPr>
+        <p:txBody>
+          <a:bodyPr xmlns:a="http://schemas.openxmlformats.org/drawingml/2006/main" anchor="t"/>
+          <a:lstStyle xmlns:a="http://schemas.openxmlformats.org/drawingml/2006/main"/>
+          <a:p xmlns:a="http://schemas.openxmlformats.org/drawingml/2006/main">
+            <a:pPr algn="r">
+              <a:buNone/>
+              <a:defRPr sz="1275" b="1">
+                <a:solidFill>
+                  <a:srgbClr val="102A43"/>
+                </a:solidFill>
+              </a:defRPr>
+            </a:pPr>
+            <a:r>
+              <a:rPr sz="1275" b="1">
+                <a:solidFill>
+                  <a:srgbClr val="102A43"/>
+                </a:solidFill>
+              </a:rPr>
+              <a:t>Audit</a:t>
+            </a:r>
+          </a:p>
+        </p:txBody>
+      </p:sp>
+      <p:sp>
+        <p:nvSpPr>
+          <p:cNvPr id="11" name="cell-0-2">
+            <a:extLst xmlns:a="http://schemas.openxmlformats.org/drawingml/2006/main">
+              <a:ext uri="{FF2B5EF4-FFF2-40B4-BE49-F238E27FC236}">
+                <a16:creationId xmlns:a16="http://schemas.microsoft.com/office/drawing/2014/main" id="{828C9540-C458-4921-8D7B-F2F3FBABBC2A}"/>
+              </a:ext>
+            </a:extLst>
+          </p:cNvPr>
+          <p:cNvSpPr>
+            <a:spLocks xmlns:a="http://schemas.openxmlformats.org/drawingml/2006/main" noGrp="1"/>
+          </p:cNvSpPr>
+          <p:nvPr/>
+        </p:nvSpPr>
+        <p:spPr>
+          <a:xfrm xmlns:a="http://schemas.openxmlformats.org/drawingml/2006/main">
+            <a:off x="3952875" y="2476500"/>
+            <a:ext cx="1381125" cy="323850"/>
+          </a:xfrm>
+          <a:prstGeom xmlns:a="http://schemas.openxmlformats.org/drawingml/2006/main" prst="rect">
+            <a:avLst/>
+          </a:prstGeom>
+          <a:noFill xmlns:a="http://schemas.openxmlformats.org/drawingml/2006/main"/>
+          <a:ln xmlns:a="http://schemas.openxmlformats.org/drawingml/2006/main" w="0">
+            <a:noFill/>
+            <a:prstDash val="solid"/>
+          </a:ln>
+        </p:spPr>
+        <p:txBody>
+          <a:bodyPr xmlns:a="http://schemas.openxmlformats.org/drawingml/2006/main" anchor="t"/>
+          <a:lstStyle xmlns:a="http://schemas.openxmlformats.org/drawingml/2006/main"/>
+          <a:p xmlns:a="http://schemas.openxmlformats.org/drawingml/2006/main">
+            <a:pPr algn="r">
+              <a:buNone/>
+              <a:defRPr sz="1275" b="1">
+                <a:solidFill>
+                  <a:srgbClr val="102A43"/>
+                </a:solidFill>
+              </a:defRPr>
+            </a:pPr>
+            <a:r>
+              <a:rPr sz="1275" b="1">
+                <a:solidFill>
+                  <a:srgbClr val="102A43"/>
+                </a:solidFill>
+              </a:rPr>
+              <a:t>Result</a:t>
+            </a:r>
+          </a:p>
+        </p:txBody>
+      </p:sp>
+      <p:sp>
+        <p:nvSpPr>
+          <p:cNvPr id="12" name="row-line-0">
+            <a:extLst xmlns:a="http://schemas.openxmlformats.org/drawingml/2006/main">
+              <a:ext uri="{FF2B5EF4-FFF2-40B4-BE49-F238E27FC236}">
+                <a16:creationId xmlns:a16="http://schemas.microsoft.com/office/drawing/2014/main" id="{D69F3A4E-8E5A-44AE-AB89-D12450A3E760}"/>
+              </a:ext>
+            </a:extLst>
+          </p:cNvPr>
+          <p:cNvSpPr>
+            <a:spLocks xmlns:a="http://schemas.openxmlformats.org/drawingml/2006/main" noGrp="1"/>
+          </p:cNvSpPr>
+          <p:nvPr/>
+        </p:nvSpPr>
+        <p:spPr>
+          <a:xfrm xmlns:a="http://schemas.openxmlformats.org/drawingml/2006/main">
+            <a:off x="876300" y="2790825"/>
+            <a:ext cx="4476750" cy="9525"/>
+          </a:xfrm>
+          <a:prstGeom xmlns:a="http://schemas.openxmlformats.org/drawingml/2006/main" prst="rect">
+            <a:avLst/>
+          </a:prstGeom>
+          <a:solidFill xmlns:a="http://schemas.openxmlformats.org/drawingml/2006/main">
+            <a:srgbClr val="102A43"/>
+          </a:solidFill>
+          <a:ln xmlns:a="http://schemas.openxmlformats.org/drawingml/2006/main" w="0">
+            <a:noFill/>
+            <a:prstDash val="solid"/>
+          </a:ln>
+        </p:spPr>
+      </p:sp>
+      <p:sp>
+        <p:nvSpPr>
+          <p:cNvPr id="13" name="cell-1-0">
+            <a:extLst xmlns:a="http://schemas.openxmlformats.org/drawingml/2006/main">
+              <a:ext uri="{FF2B5EF4-FFF2-40B4-BE49-F238E27FC236}">
+                <a16:creationId xmlns:a16="http://schemas.microsoft.com/office/drawing/2014/main" id="{375EAF70-F87B-4459-AB19-10E3F57ADEC5}"/>
+              </a:ext>
+            </a:extLst>
+          </p:cNvPr>
+          <p:cNvSpPr>
+            <a:spLocks xmlns:a="http://schemas.openxmlformats.org/drawingml/2006/main" noGrp="1"/>
+          </p:cNvSpPr>
+          <p:nvPr/>
+        </p:nvSpPr>
+        <p:spPr>
+          <a:xfrm xmlns:a="http://schemas.openxmlformats.org/drawingml/2006/main">
+            <a:off x="952500" y="2933700"/>
+            <a:ext cx="1381125" cy="323850"/>
+          </a:xfrm>
+          <a:prstGeom xmlns:a="http://schemas.openxmlformats.org/drawingml/2006/main" prst="rect">
+            <a:avLst/>
+          </a:prstGeom>
+          <a:noFill xmlns:a="http://schemas.openxmlformats.org/drawingml/2006/main"/>
+          <a:ln xmlns:a="http://schemas.openxmlformats.org/drawingml/2006/main" w="0">
+            <a:noFill/>
+            <a:prstDash val="solid"/>
+          </a:ln>
+        </p:spPr>
+        <p:txBody>
+          <a:bodyPr xmlns:a="http://schemas.openxmlformats.org/drawingml/2006/main" anchor="t"/>
+          <a:lstStyle xmlns:a="http://schemas.openxmlformats.org/drawingml/2006/main"/>
+          <a:p xmlns:a="http://schemas.openxmlformats.org/drawingml/2006/main">
+            <a:pPr algn="l">
+              <a:buNone/>
+              <a:defRPr sz="1425" b="0">
+                <a:solidFill>
+                  <a:srgbClr val="243B53"/>
+                </a:solidFill>
+              </a:defRPr>
+            </a:pPr>
+            <a:r>
+              <a:rPr sz="1425" b="0">
+                <a:solidFill>
+                  <a:srgbClr val="243B53"/>
+                </a:solidFill>
+              </a:rPr>
+              <a:t>Source</a:t>
+            </a:r>
+          </a:p>
+        </p:txBody>
+      </p:sp>
+      <p:sp>
+        <p:nvSpPr>
+          <p:cNvPr id="14" name="cell-1-1">
+            <a:extLst xmlns:a="http://schemas.openxmlformats.org/drawingml/2006/main">
+              <a:ext uri="{FF2B5EF4-FFF2-40B4-BE49-F238E27FC236}">
+                <a16:creationId xmlns:a16="http://schemas.microsoft.com/office/drawing/2014/main" id="{DB8CB67E-0F32-4F5D-8B84-368704233C5C}"/>
+              </a:ext>
+            </a:extLst>
+          </p:cNvPr>
+          <p:cNvSpPr>
+            <a:spLocks xmlns:a="http://schemas.openxmlformats.org/drawingml/2006/main" noGrp="1"/>
+          </p:cNvSpPr>
+          <p:nvPr/>
+        </p:nvSpPr>
+        <p:spPr>
+          <a:xfrm xmlns:a="http://schemas.openxmlformats.org/drawingml/2006/main">
+            <a:off x="2333625" y="2933700"/>
+            <a:ext cx="1619250" cy="323850"/>
+          </a:xfrm>
+          <a:prstGeom xmlns:a="http://schemas.openxmlformats.org/drawingml/2006/main" prst="rect">
+            <a:avLst/>
+          </a:prstGeom>
+          <a:noFill xmlns:a="http://schemas.openxmlformats.org/drawingml/2006/main"/>
+          <a:ln xmlns:a="http://schemas.openxmlformats.org/drawingml/2006/main" w="0">
+            <a:noFill/>
+            <a:prstDash val="solid"/>
+          </a:ln>
+        </p:spPr>
+        <p:txBody>
+          <a:bodyPr xmlns:a="http://schemas.openxmlformats.org/drawingml/2006/main" anchor="t"/>
+          <a:lstStyle xmlns:a="http://schemas.openxmlformats.org/drawingml/2006/main"/>
+          <a:p xmlns:a="http://schemas.openxmlformats.org/drawingml/2006/main">
+            <a:pPr algn="r">
+              <a:buNone/>
+              <a:defRPr sz="1425" b="0">
+                <a:solidFill>
+                  <a:srgbClr val="243B53"/>
+                </a:solidFill>
+              </a:defRPr>
+            </a:pPr>
+            <a:r>
+              <a:rPr sz="1425" b="0">
+                <a:solidFill>
+                  <a:srgbClr val="243B53"/>
+                </a:solidFill>
+              </a:rPr>
+              <a:t>1047×698</a:t>
+            </a:r>
+          </a:p>
+        </p:txBody>
+      </p:sp>
+      <p:sp>
+        <p:nvSpPr>
+          <p:cNvPr id="15" name="cell-1-2">
+            <a:extLst xmlns:a="http://schemas.openxmlformats.org/drawingml/2006/main">
+              <a:ext uri="{FF2B5EF4-FFF2-40B4-BE49-F238E27FC236}">
+                <a16:creationId xmlns:a16="http://schemas.microsoft.com/office/drawing/2014/main" id="{A588232C-CDA7-48B1-B9EA-9DEFFC3AC34E}"/>
+              </a:ext>
+            </a:extLst>
+          </p:cNvPr>
+          <p:cNvSpPr>
+            <a:spLocks xmlns:a="http://schemas.openxmlformats.org/drawingml/2006/main" noGrp="1"/>
+          </p:cNvSpPr>
+          <p:nvPr/>
+        </p:nvSpPr>
+        <p:spPr>
+          <a:xfrm xmlns:a="http://schemas.openxmlformats.org/drawingml/2006/main">
+            <a:off x="3952875" y="2933700"/>
+            <a:ext cx="1381125" cy="323850"/>
+          </a:xfrm>
+          <a:prstGeom xmlns:a="http://schemas.openxmlformats.org/drawingml/2006/main" prst="rect">
+            <a:avLst/>
+          </a:prstGeom>
+          <a:noFill xmlns:a="http://schemas.openxmlformats.org/drawingml/2006/main"/>
+          <a:ln xmlns:a="http://schemas.openxmlformats.org/drawingml/2006/main" w="0">
+            <a:noFill/>
+            <a:prstDash val="solid"/>
+          </a:ln>
+        </p:spPr>
+        <p:txBody>
+          <a:bodyPr xmlns:a="http://schemas.openxmlformats.org/drawingml/2006/main" anchor="t"/>
+          <a:lstStyle xmlns:a="http://schemas.openxmlformats.org/drawingml/2006/main"/>
+          <a:p xmlns:a="http://schemas.openxmlformats.org/drawingml/2006/main">
+            <a:pPr algn="r">
+              <a:buNone/>
+              <a:defRPr sz="1425" b="0">
+                <a:solidFill>
+                  <a:srgbClr val="243B53"/>
+                </a:solidFill>
+              </a:defRPr>
+            </a:pPr>
+            <a:r>
+              <a:rPr sz="1425" b="0">
+                <a:solidFill>
+                  <a:srgbClr val="243B53"/>
+                </a:solidFill>
+              </a:rPr>
+              <a:t>Embedded</a:t>
+            </a:r>
+          </a:p>
+        </p:txBody>
+      </p:sp>
+      <p:sp>
+        <p:nvSpPr>
+          <p:cNvPr id="16" name="row-line-1">
+            <a:extLst xmlns:a="http://schemas.openxmlformats.org/drawingml/2006/main">
+              <a:ext uri="{FF2B5EF4-FFF2-40B4-BE49-F238E27FC236}">
+                <a16:creationId xmlns:a16="http://schemas.microsoft.com/office/drawing/2014/main" id="{5DC11FF2-CA06-4350-9B7E-DAE541383948}"/>
+              </a:ext>
+            </a:extLst>
+          </p:cNvPr>
+          <p:cNvSpPr>
+            <a:spLocks xmlns:a="http://schemas.openxmlformats.org/drawingml/2006/main" noGrp="1"/>
+          </p:cNvSpPr>
+          <p:nvPr/>
+        </p:nvSpPr>
+        <p:spPr>
+          <a:xfrm xmlns:a="http://schemas.openxmlformats.org/drawingml/2006/main">
+            <a:off x="876300" y="3248025"/>
+            <a:ext cx="4476750" cy="9525"/>
+          </a:xfrm>
+          <a:prstGeom xmlns:a="http://schemas.openxmlformats.org/drawingml/2006/main" prst="rect">
+            <a:avLst/>
+          </a:prstGeom>
+          <a:solidFill xmlns:a="http://schemas.openxmlformats.org/drawingml/2006/main">
+            <a:srgbClr val="D8E1E8"/>
+          </a:solidFill>
+          <a:ln xmlns:a="http://schemas.openxmlformats.org/drawingml/2006/main" w="0">
+            <a:noFill/>
+            <a:prstDash val="solid"/>
+          </a:ln>
+        </p:spPr>
+      </p:sp>
+      <p:sp>
+        <p:nvSpPr>
+          <p:cNvPr id="17" name="cell-2-0">
+            <a:extLst xmlns:a="http://schemas.openxmlformats.org/drawingml/2006/main">
+              <a:ext uri="{FF2B5EF4-FFF2-40B4-BE49-F238E27FC236}">
+                <a16:creationId xmlns:a16="http://schemas.microsoft.com/office/drawing/2014/main" id="{BB249022-439E-4DFD-8870-B63B95063C4A}"/>
+              </a:ext>
+            </a:extLst>
+          </p:cNvPr>
+          <p:cNvSpPr>
+            <a:spLocks xmlns:a="http://schemas.openxmlformats.org/drawingml/2006/main" noGrp="1"/>
+          </p:cNvSpPr>
+          <p:nvPr/>
+        </p:nvSpPr>
+        <p:spPr>
+          <a:xfrm xmlns:a="http://schemas.openxmlformats.org/drawingml/2006/main">
+            <a:off x="952500" y="3390900"/>
+            <a:ext cx="1381125" cy="323850"/>
+          </a:xfrm>
+          <a:prstGeom xmlns:a="http://schemas.openxmlformats.org/drawingml/2006/main" prst="rect">
+            <a:avLst/>
+          </a:prstGeom>
+          <a:noFill xmlns:a="http://schemas.openxmlformats.org/drawingml/2006/main"/>
+          <a:ln xmlns:a="http://schemas.openxmlformats.org/drawingml/2006/main" w="0">
+            <a:noFill/>
+            <a:prstDash val="solid"/>
+          </a:ln>
+        </p:spPr>
+        <p:txBody>
+          <a:bodyPr xmlns:a="http://schemas.openxmlformats.org/drawingml/2006/main" anchor="t"/>
+          <a:lstStyle xmlns:a="http://schemas.openxmlformats.org/drawingml/2006/main"/>
+          <a:p xmlns:a="http://schemas.openxmlformats.org/drawingml/2006/main">
+            <a:pPr algn="l">
+              <a:buNone/>
+              <a:defRPr sz="1425" b="0">
+                <a:solidFill>
+                  <a:srgbClr val="243B53"/>
+                </a:solidFill>
+              </a:defRPr>
+            </a:pPr>
+            <a:r>
+              <a:rPr sz="1425" b="0">
+                <a:solidFill>
+                  <a:srgbClr val="243B53"/>
+                </a:solidFill>
+              </a:rPr>
+              <a:t>Grid</a:t>
+            </a:r>
+          </a:p>
+        </p:txBody>
+      </p:sp>
+      <p:sp>
+        <p:nvSpPr>
+          <p:cNvPr id="18" name="cell-2-1">
+            <a:extLst xmlns:a="http://schemas.openxmlformats.org/drawingml/2006/main">
+              <a:ext uri="{FF2B5EF4-FFF2-40B4-BE49-F238E27FC236}">
+                <a16:creationId xmlns:a16="http://schemas.microsoft.com/office/drawing/2014/main" id="{87840E93-4394-4955-914E-BD1A8634115D}"/>
+              </a:ext>
+            </a:extLst>
+          </p:cNvPr>
+          <p:cNvSpPr>
+            <a:spLocks xmlns:a="http://schemas.openxmlformats.org/drawingml/2006/main" noGrp="1"/>
+          </p:cNvSpPr>
+          <p:nvPr/>
+        </p:nvSpPr>
+        <p:spPr>
+          <a:xfrm xmlns:a="http://schemas.openxmlformats.org/drawingml/2006/main">
+            <a:off x="2333625" y="3390900"/>
+            <a:ext cx="1619250" cy="323850"/>
+          </a:xfrm>
+          <a:prstGeom xmlns:a="http://schemas.openxmlformats.org/drawingml/2006/main" prst="rect">
+            <a:avLst/>
+          </a:prstGeom>
+          <a:noFill xmlns:a="http://schemas.openxmlformats.org/drawingml/2006/main"/>
+          <a:ln xmlns:a="http://schemas.openxmlformats.org/drawingml/2006/main" w="0">
+            <a:noFill/>
+            <a:prstDash val="solid"/>
+          </a:ln>
+        </p:spPr>
+        <p:txBody>
+          <a:bodyPr xmlns:a="http://schemas.openxmlformats.org/drawingml/2006/main" anchor="t"/>
+          <a:lstStyle xmlns:a="http://schemas.openxmlformats.org/drawingml/2006/main"/>
+          <a:p xmlns:a="http://schemas.openxmlformats.org/drawingml/2006/main">
+            <a:pPr algn="r">
+              <a:buNone/>
+              <a:defRPr sz="1425" b="0">
+                <a:solidFill>
+                  <a:srgbClr val="243B53"/>
+                </a:solidFill>
+              </a:defRPr>
+            </a:pPr>
+            <a:r>
+              <a:rPr sz="1425" b="0">
+                <a:solidFill>
+                  <a:srgbClr val="243B53"/>
+                </a:solidFill>
+              </a:rPr>
+              <a:t>61 × 2</a:t>
+            </a:r>
+          </a:p>
+        </p:txBody>
+      </p:sp>
+      <p:sp>
+        <p:nvSpPr>
+          <p:cNvPr id="19" name="cell-2-2">
+            <a:extLst xmlns:a="http://schemas.openxmlformats.org/drawingml/2006/main">
+              <a:ext uri="{FF2B5EF4-FFF2-40B4-BE49-F238E27FC236}">
+                <a16:creationId xmlns:a16="http://schemas.microsoft.com/office/drawing/2014/main" id="{6AE24D16-27CB-4592-8B92-E7B21942B9E3}"/>
+              </a:ext>
+            </a:extLst>
+          </p:cNvPr>
+          <p:cNvSpPr>
+            <a:spLocks xmlns:a="http://schemas.openxmlformats.org/drawingml/2006/main" noGrp="1"/>
+          </p:cNvSpPr>
+          <p:nvPr/>
+        </p:nvSpPr>
+        <p:spPr>
+          <a:xfrm xmlns:a="http://schemas.openxmlformats.org/drawingml/2006/main">
+            <a:off x="3952875" y="3390900"/>
+            <a:ext cx="1381125" cy="323850"/>
+          </a:xfrm>
+          <a:prstGeom xmlns:a="http://schemas.openxmlformats.org/drawingml/2006/main" prst="rect">
+            <a:avLst/>
+          </a:prstGeom>
+          <a:noFill xmlns:a="http://schemas.openxmlformats.org/drawingml/2006/main"/>
+          <a:ln xmlns:a="http://schemas.openxmlformats.org/drawingml/2006/main" w="0">
+            <a:noFill/>
+            <a:prstDash val="solid"/>
+          </a:ln>
+        </p:spPr>
+        <p:txBody>
+          <a:bodyPr xmlns:a="http://schemas.openxmlformats.org/drawingml/2006/main" anchor="t"/>
+          <a:lstStyle xmlns:a="http://schemas.openxmlformats.org/drawingml/2006/main"/>
+          <a:p xmlns:a="http://schemas.openxmlformats.org/drawingml/2006/main">
+            <a:pPr algn="r">
+              <a:buNone/>
+              <a:defRPr sz="1425" b="0">
+                <a:solidFill>
+                  <a:srgbClr val="243B53"/>
+                </a:solidFill>
+              </a:defRPr>
+            </a:pPr>
+            <a:r>
+              <a:rPr sz="1425" b="0">
+                <a:solidFill>
+                  <a:srgbClr val="243B53"/>
+                </a:solidFill>
+              </a:rPr>
+              <a:t>122 samples</a:t>
+            </a:r>
+          </a:p>
+        </p:txBody>
+      </p:sp>
+      <p:sp>
+        <p:nvSpPr>
+          <p:cNvPr id="20" name="row-line-2">
+            <a:extLst xmlns:a="http://schemas.openxmlformats.org/drawingml/2006/main">
+              <a:ext uri="{FF2B5EF4-FFF2-40B4-BE49-F238E27FC236}">
+                <a16:creationId xmlns:a16="http://schemas.microsoft.com/office/drawing/2014/main" id="{58202A1E-47E9-4450-9AAF-4809157C4107}"/>
+              </a:ext>
+            </a:extLst>
+          </p:cNvPr>
+          <p:cNvSpPr>
+            <a:spLocks xmlns:a="http://schemas.openxmlformats.org/drawingml/2006/main" noGrp="1"/>
+          </p:cNvSpPr>
+          <p:nvPr/>
+        </p:nvSpPr>
+        <p:spPr>
+          <a:xfrm xmlns:a="http://schemas.openxmlformats.org/drawingml/2006/main">
+            <a:off x="876300" y="3705225"/>
+            <a:ext cx="4476750" cy="9525"/>
+          </a:xfrm>
+          <a:prstGeom xmlns:a="http://schemas.openxmlformats.org/drawingml/2006/main" prst="rect">
+            <a:avLst/>
+          </a:prstGeom>
+          <a:solidFill xmlns:a="http://schemas.openxmlformats.org/drawingml/2006/main">
+            <a:srgbClr val="D8E1E8"/>
+          </a:solidFill>
+          <a:ln xmlns:a="http://schemas.openxmlformats.org/drawingml/2006/main" w="0">
+            <a:noFill/>
+            <a:prstDash val="solid"/>
+          </a:ln>
+        </p:spPr>
+      </p:sp>
+      <p:sp>
+        <p:nvSpPr>
+          <p:cNvPr id="21" name="cell-3-0">
+            <a:extLst xmlns:a="http://schemas.openxmlformats.org/drawingml/2006/main">
+              <a:ext uri="{FF2B5EF4-FFF2-40B4-BE49-F238E27FC236}">
+                <a16:creationId xmlns:a16="http://schemas.microsoft.com/office/drawing/2014/main" id="{5D5C5D74-A455-4E52-8A25-CDCBC8D788B6}"/>
+              </a:ext>
+            </a:extLst>
+          </p:cNvPr>
+          <p:cNvSpPr>
+            <a:spLocks xmlns:a="http://schemas.openxmlformats.org/drawingml/2006/main" noGrp="1"/>
+          </p:cNvSpPr>
+          <p:nvPr/>
+        </p:nvSpPr>
+        <p:spPr>
+          <a:xfrm xmlns:a="http://schemas.openxmlformats.org/drawingml/2006/main">
+            <a:off x="952500" y="3848100"/>
+            <a:ext cx="1381125" cy="323850"/>
+          </a:xfrm>
+          <a:prstGeom xmlns:a="http://schemas.openxmlformats.org/drawingml/2006/main" prst="rect">
+            <a:avLst/>
+          </a:prstGeom>
+          <a:noFill xmlns:a="http://schemas.openxmlformats.org/drawingml/2006/main"/>
+          <a:ln xmlns:a="http://schemas.openxmlformats.org/drawingml/2006/main" w="0">
+            <a:noFill/>
+            <a:prstDash val="solid"/>
+          </a:ln>
+        </p:spPr>
+        <p:txBody>
+          <a:bodyPr xmlns:a="http://schemas.openxmlformats.org/drawingml/2006/main" anchor="t"/>
+          <a:lstStyle xmlns:a="http://schemas.openxmlformats.org/drawingml/2006/main"/>
+          <a:p xmlns:a="http://schemas.openxmlformats.org/drawingml/2006/main">
+            <a:pPr algn="l">
+              <a:buNone/>
+              <a:defRPr sz="1425" b="0">
+                <a:solidFill>
+                  <a:srgbClr val="243B53"/>
+                </a:solidFill>
+              </a:defRPr>
+            </a:pPr>
+            <a:r>
+              <a:rPr sz="1425" b="0">
+                <a:solidFill>
+                  <a:srgbClr val="243B53"/>
+                </a:solidFill>
+              </a:rPr>
+              <a:t>Matches</a:t>
+            </a:r>
+          </a:p>
+        </p:txBody>
+      </p:sp>
+      <p:sp>
+        <p:nvSpPr>
+          <p:cNvPr id="22" name="cell-3-1">
+            <a:extLst xmlns:a="http://schemas.openxmlformats.org/drawingml/2006/main">
+              <a:ext uri="{FF2B5EF4-FFF2-40B4-BE49-F238E27FC236}">
+                <a16:creationId xmlns:a16="http://schemas.microsoft.com/office/drawing/2014/main" id="{73DF07FB-E70E-4854-A60E-F8243C8085AB}"/>
+              </a:ext>
+            </a:extLst>
+          </p:cNvPr>
+          <p:cNvSpPr>
+            <a:spLocks xmlns:a="http://schemas.openxmlformats.org/drawingml/2006/main" noGrp="1"/>
+          </p:cNvSpPr>
+          <p:nvPr/>
+        </p:nvSpPr>
+        <p:spPr>
+          <a:xfrm xmlns:a="http://schemas.openxmlformats.org/drawingml/2006/main">
+            <a:off x="2333625" y="3848100"/>
+            <a:ext cx="1619250" cy="323850"/>
+          </a:xfrm>
+          <a:prstGeom xmlns:a="http://schemas.openxmlformats.org/drawingml/2006/main" prst="rect">
+            <a:avLst/>
+          </a:prstGeom>
+          <a:noFill xmlns:a="http://schemas.openxmlformats.org/drawingml/2006/main"/>
+          <a:ln xmlns:a="http://schemas.openxmlformats.org/drawingml/2006/main" w="0">
+            <a:noFill/>
+            <a:prstDash val="solid"/>
+          </a:ln>
+        </p:spPr>
+        <p:txBody>
+          <a:bodyPr xmlns:a="http://schemas.openxmlformats.org/drawingml/2006/main" anchor="t"/>
+          <a:lstStyle xmlns:a="http://schemas.openxmlformats.org/drawingml/2006/main"/>
+          <a:p xmlns:a="http://schemas.openxmlformats.org/drawingml/2006/main">
+            <a:pPr algn="r">
+              <a:buNone/>
+              <a:defRPr sz="1425" b="0">
+                <a:solidFill>
+                  <a:srgbClr val="243B53"/>
+                </a:solidFill>
+              </a:defRPr>
+            </a:pPr>
+            <a:r>
+              <a:rPr sz="1425" b="0">
+                <a:solidFill>
+                  <a:srgbClr val="243B53"/>
+                </a:solidFill>
+              </a:rPr>
+              <a:t>122 / 122</a:t>
+            </a:r>
+          </a:p>
+        </p:txBody>
+      </p:sp>
+      <p:sp>
+        <p:nvSpPr>
+          <p:cNvPr id="23" name="cell-3-2">
+            <a:extLst xmlns:a="http://schemas.openxmlformats.org/drawingml/2006/main">
+              <a:ext uri="{FF2B5EF4-FFF2-40B4-BE49-F238E27FC236}">
+                <a16:creationId xmlns:a16="http://schemas.microsoft.com/office/drawing/2014/main" id="{3E8F525E-F811-4AC8-9E28-88298201D1E4}"/>
+              </a:ext>
+            </a:extLst>
+          </p:cNvPr>
+          <p:cNvSpPr>
+            <a:spLocks xmlns:a="http://schemas.openxmlformats.org/drawingml/2006/main" noGrp="1"/>
+          </p:cNvSpPr>
+          <p:nvPr/>
+        </p:nvSpPr>
+        <p:spPr>
+          <a:xfrm xmlns:a="http://schemas.openxmlformats.org/drawingml/2006/main">
+            <a:off x="3952875" y="3848100"/>
+            <a:ext cx="1381125" cy="323850"/>
+          </a:xfrm>
+          <a:prstGeom xmlns:a="http://schemas.openxmlformats.org/drawingml/2006/main" prst="rect">
+            <a:avLst/>
+          </a:prstGeom>
+          <a:noFill xmlns:a="http://schemas.openxmlformats.org/drawingml/2006/main"/>
+          <a:ln xmlns:a="http://schemas.openxmlformats.org/drawingml/2006/main" w="0">
+            <a:noFill/>
+            <a:prstDash val="solid"/>
+          </a:ln>
+        </p:spPr>
+        <p:txBody>
+          <a:bodyPr xmlns:a="http://schemas.openxmlformats.org/drawingml/2006/main" anchor="t"/>
+          <a:lstStyle xmlns:a="http://schemas.openxmlformats.org/drawingml/2006/main"/>
+          <a:p xmlns:a="http://schemas.openxmlformats.org/drawingml/2006/main">
+            <a:pPr algn="r">
+              <a:buNone/>
+              <a:defRPr sz="1425" b="0">
+                <a:solidFill>
+                  <a:srgbClr val="243B53"/>
+                </a:solidFill>
+              </a:defRPr>
+            </a:pPr>
+            <a:r>
+              <a:rPr sz="1425" b="0">
+                <a:solidFill>
+                  <a:srgbClr val="243B53"/>
+                </a:solidFill>
+              </a:rPr>
+              <a:t>0 filled</a:t>
+            </a:r>
+          </a:p>
+        </p:txBody>
+      </p:sp>
+      <p:sp>
+        <p:nvSpPr>
+          <p:cNvPr id="24" name="row-line-3">
+            <a:extLst xmlns:a="http://schemas.openxmlformats.org/drawingml/2006/main">
+              <a:ext uri="{FF2B5EF4-FFF2-40B4-BE49-F238E27FC236}">
+                <a16:creationId xmlns:a16="http://schemas.microsoft.com/office/drawing/2014/main" id="{818FEF36-9BF4-4EA1-976A-5EA965CA851D}"/>
+              </a:ext>
+            </a:extLst>
+          </p:cNvPr>
+          <p:cNvSpPr>
+            <a:spLocks xmlns:a="http://schemas.openxmlformats.org/drawingml/2006/main" noGrp="1"/>
+          </p:cNvSpPr>
+          <p:nvPr/>
+        </p:nvSpPr>
+        <p:spPr>
+          <a:xfrm xmlns:a="http://schemas.openxmlformats.org/drawingml/2006/main">
+            <a:off x="876300" y="4162425"/>
+            <a:ext cx="4476750" cy="9525"/>
+          </a:xfrm>
+          <a:prstGeom xmlns:a="http://schemas.openxmlformats.org/drawingml/2006/main" prst="rect">
+            <a:avLst/>
+          </a:prstGeom>
+          <a:solidFill xmlns:a="http://schemas.openxmlformats.org/drawingml/2006/main">
+            <a:srgbClr val="D8E1E8"/>
+          </a:solidFill>
+          <a:ln xmlns:a="http://schemas.openxmlformats.org/drawingml/2006/main" w="0">
+            <a:noFill/>
+            <a:prstDash val="solid"/>
+          </a:ln>
+        </p:spPr>
+      </p:sp>
+      <p:sp>
+        <p:nvSpPr>
+          <p:cNvPr id="25" name="cell-4-0">
+            <a:extLst xmlns:a="http://schemas.openxmlformats.org/drawingml/2006/main">
+              <a:ext uri="{FF2B5EF4-FFF2-40B4-BE49-F238E27FC236}">
+                <a16:creationId xmlns:a16="http://schemas.microsoft.com/office/drawing/2014/main" id="{72CD9AF7-AAEF-488F-8615-0686F1259BD2}"/>
+              </a:ext>
+            </a:extLst>
+          </p:cNvPr>
+          <p:cNvSpPr>
+            <a:spLocks xmlns:a="http://schemas.openxmlformats.org/drawingml/2006/main" noGrp="1"/>
+          </p:cNvSpPr>
+          <p:nvPr/>
+        </p:nvSpPr>
+        <p:spPr>
+          <a:xfrm xmlns:a="http://schemas.openxmlformats.org/drawingml/2006/main">
+            <a:off x="952500" y="4305300"/>
+            <a:ext cx="1381125" cy="323850"/>
+          </a:xfrm>
+          <a:prstGeom xmlns:a="http://schemas.openxmlformats.org/drawingml/2006/main" prst="rect">
+            <a:avLst/>
+          </a:prstGeom>
+          <a:noFill xmlns:a="http://schemas.openxmlformats.org/drawingml/2006/main"/>
+          <a:ln xmlns:a="http://schemas.openxmlformats.org/drawingml/2006/main" w="0">
+            <a:noFill/>
+            <a:prstDash val="solid"/>
+          </a:ln>
+        </p:spPr>
+        <p:txBody>
+          <a:bodyPr xmlns:a="http://schemas.openxmlformats.org/drawingml/2006/main" anchor="t"/>
+          <a:lstStyle xmlns:a="http://schemas.openxmlformats.org/drawingml/2006/main"/>
+          <a:p xmlns:a="http://schemas.openxmlformats.org/drawingml/2006/main">
+            <a:pPr algn="l">
+              <a:buNone/>
+              <a:defRPr sz="1425" b="0">
+                <a:solidFill>
+                  <a:srgbClr val="243B53"/>
+                </a:solidFill>
+              </a:defRPr>
+            </a:pPr>
+            <a:r>
+              <a:rPr sz="1425" b="0">
+                <a:solidFill>
+                  <a:srgbClr val="243B53"/>
+                </a:solidFill>
+              </a:rPr>
+              <a:t>Scale</a:t>
+            </a:r>
+          </a:p>
+        </p:txBody>
+      </p:sp>
+      <p:sp>
+        <p:nvSpPr>
+          <p:cNvPr id="26" name="cell-4-1">
+            <a:extLst xmlns:a="http://schemas.openxmlformats.org/drawingml/2006/main">
+              <a:ext uri="{FF2B5EF4-FFF2-40B4-BE49-F238E27FC236}">
+                <a16:creationId xmlns:a16="http://schemas.microsoft.com/office/drawing/2014/main" id="{8E997FD0-B881-427E-8EA9-E24A4D126C81}"/>
+              </a:ext>
+            </a:extLst>
+          </p:cNvPr>
+          <p:cNvSpPr>
+            <a:spLocks xmlns:a="http://schemas.openxmlformats.org/drawingml/2006/main" noGrp="1"/>
+          </p:cNvSpPr>
+          <p:nvPr/>
+        </p:nvSpPr>
+        <p:spPr>
+          <a:xfrm xmlns:a="http://schemas.openxmlformats.org/drawingml/2006/main">
+            <a:off x="2333625" y="4305300"/>
+            <a:ext cx="1619250" cy="323850"/>
+          </a:xfrm>
+          <a:prstGeom xmlns:a="http://schemas.openxmlformats.org/drawingml/2006/main" prst="rect">
+            <a:avLst/>
+          </a:prstGeom>
+          <a:noFill xmlns:a="http://schemas.openxmlformats.org/drawingml/2006/main"/>
+          <a:ln xmlns:a="http://schemas.openxmlformats.org/drawingml/2006/main" w="0">
+            <a:noFill/>
+            <a:prstDash val="solid"/>
+          </a:ln>
+        </p:spPr>
+        <p:txBody>
+          <a:bodyPr xmlns:a="http://schemas.openxmlformats.org/drawingml/2006/main" anchor="t"/>
+          <a:lstStyle xmlns:a="http://schemas.openxmlformats.org/drawingml/2006/main"/>
+          <a:p xmlns:a="http://schemas.openxmlformats.org/drawingml/2006/main">
+            <a:pPr algn="r">
+              <a:buNone/>
+              <a:defRPr sz="1425" b="0">
+                <a:solidFill>
+                  <a:srgbClr val="243B53"/>
+                </a:solidFill>
+              </a:defRPr>
+            </a:pPr>
+            <a:r>
+              <a:rPr sz="1425" b="0">
+                <a:solidFill>
+                  <a:srgbClr val="243B53"/>
+                </a:solidFill>
+              </a:rPr>
+              <a:t>1 pixel</a:t>
+            </a:r>
+          </a:p>
+        </p:txBody>
+      </p:sp>
+      <p:sp>
+        <p:nvSpPr>
+          <p:cNvPr id="27" name="cell-4-2">
+            <a:extLst xmlns:a="http://schemas.openxmlformats.org/drawingml/2006/main">
+              <a:ext uri="{FF2B5EF4-FFF2-40B4-BE49-F238E27FC236}">
+                <a16:creationId xmlns:a16="http://schemas.microsoft.com/office/drawing/2014/main" id="{6AE699B0-0AEF-4868-BF2E-0C8DAD10EDE4}"/>
+              </a:ext>
+            </a:extLst>
+          </p:cNvPr>
+          <p:cNvSpPr>
+            <a:spLocks xmlns:a="http://schemas.openxmlformats.org/drawingml/2006/main" noGrp="1"/>
+          </p:cNvSpPr>
+          <p:nvPr/>
+        </p:nvSpPr>
+        <p:spPr>
+          <a:xfrm xmlns:a="http://schemas.openxmlformats.org/drawingml/2006/main">
+            <a:off x="3952875" y="4305300"/>
+            <a:ext cx="1381125" cy="323850"/>
+          </a:xfrm>
+          <a:prstGeom xmlns:a="http://schemas.openxmlformats.org/drawingml/2006/main" prst="rect">
+            <a:avLst/>
+          </a:prstGeom>
+          <a:noFill xmlns:a="http://schemas.openxmlformats.org/drawingml/2006/main"/>
+          <a:ln xmlns:a="http://schemas.openxmlformats.org/drawingml/2006/main" w="0">
+            <a:noFill/>
+            <a:prstDash val="solid"/>
+          </a:ln>
+        </p:spPr>
+        <p:txBody>
+          <a:bodyPr xmlns:a="http://schemas.openxmlformats.org/drawingml/2006/main" anchor="t"/>
+          <a:lstStyle xmlns:a="http://schemas.openxmlformats.org/drawingml/2006/main"/>
+          <a:p xmlns:a="http://schemas.openxmlformats.org/drawingml/2006/main">
+            <a:pPr algn="r">
+              <a:buNone/>
+              <a:defRPr sz="1425" b="0">
+                <a:solidFill>
+                  <a:srgbClr val="243B53"/>
+                </a:solidFill>
+              </a:defRPr>
+            </a:pPr>
+            <a:r>
+              <a:rPr sz="1425" b="0">
+                <a:solidFill>
+                  <a:srgbClr val="243B53"/>
+                </a:solidFill>
+              </a:rPr>
+              <a:t>0.129 pp</a:t>
+            </a:r>
+          </a:p>
+        </p:txBody>
+      </p:sp>
+      <p:sp>
+        <p:nvSpPr>
+          <p:cNvPr id="28" name="row-line-4">
+            <a:extLst xmlns:a="http://schemas.openxmlformats.org/drawingml/2006/main">
+              <a:ext uri="{FF2B5EF4-FFF2-40B4-BE49-F238E27FC236}">
+                <a16:creationId xmlns:a16="http://schemas.microsoft.com/office/drawing/2014/main" id="{0704D39B-5682-4E58-8970-C924CACF602C}"/>
+              </a:ext>
+            </a:extLst>
+          </p:cNvPr>
+          <p:cNvSpPr>
+            <a:spLocks xmlns:a="http://schemas.openxmlformats.org/drawingml/2006/main" noGrp="1"/>
+          </p:cNvSpPr>
+          <p:nvPr/>
+        </p:nvSpPr>
+        <p:spPr>
+          <a:xfrm xmlns:a="http://schemas.openxmlformats.org/drawingml/2006/main">
+            <a:off x="876300" y="4619625"/>
+            <a:ext cx="4476750" cy="9525"/>
+          </a:xfrm>
+          <a:prstGeom xmlns:a="http://schemas.openxmlformats.org/drawingml/2006/main" prst="rect">
+            <a:avLst/>
+          </a:prstGeom>
+          <a:solidFill xmlns:a="http://schemas.openxmlformats.org/drawingml/2006/main">
+            <a:srgbClr val="D8E1E8"/>
+          </a:solidFill>
+          <a:ln xmlns:a="http://schemas.openxmlformats.org/drawingml/2006/main" w="0">
+            <a:noFill/>
+            <a:prstDash val="solid"/>
+          </a:ln>
+        </p:spPr>
+      </p:sp>
+      <p:sp>
+        <p:nvSpPr>
+          <p:cNvPr id="29" name="2025 Figure 9 debt-financing flows-frame">
+            <a:extLst xmlns:a="http://schemas.openxmlformats.org/drawingml/2006/main">
+              <a:ext uri="{FF2B5EF4-FFF2-40B4-BE49-F238E27FC236}">
+                <a16:creationId xmlns:a16="http://schemas.microsoft.com/office/drawing/2014/main" id="{219A4000-C6D6-4F3C-A70A-16384C12DE15}"/>
               </a:ext>
             </a:extLst>
           </p:cNvPr>
@@ -4791,10 +5868,10 @@
       </p:sp>
       <p:sp>
         <p:nvSpPr>
-          <p:cNvPr id="11" name="assessment-band">
-            <a:extLst xmlns:a="http://schemas.openxmlformats.org/drawingml/2006/main">
-              <a:ext uri="{FF2B5EF4-FFF2-40B4-BE49-F238E27FC236}">
-                <a16:creationId xmlns:a16="http://schemas.microsoft.com/office/drawing/2014/main" id="{8E0201B9-6249-4F69-8DD3-3C91F0AFAC32}"/>
+          <p:cNvPr id="31" name="assessment-band">
+            <a:extLst xmlns:a="http://schemas.openxmlformats.org/drawingml/2006/main">
+              <a:ext uri="{FF2B5EF4-FFF2-40B4-BE49-F238E27FC236}">
+                <a16:creationId xmlns:a16="http://schemas.microsoft.com/office/drawing/2014/main" id="{45164E07-14D9-410E-B5ED-A6A5995E50DF}"/>
               </a:ext>
             </a:extLst>
           </p:cNvPr>
@@ -4824,10 +5901,10 @@
       </p:sp>
       <p:sp>
         <p:nvSpPr>
-          <p:cNvPr id="12" name="assessment-accent">
-            <a:extLst xmlns:a="http://schemas.openxmlformats.org/drawingml/2006/main">
-              <a:ext uri="{FF2B5EF4-FFF2-40B4-BE49-F238E27FC236}">
-                <a16:creationId xmlns:a16="http://schemas.microsoft.com/office/drawing/2014/main" id="{E6607933-8AC4-4796-94EB-F2FB6C0865F1}"/>
+          <p:cNvPr id="32" name="assessment-accent">
+            <a:extLst xmlns:a="http://schemas.openxmlformats.org/drawingml/2006/main">
+              <a:ext uri="{FF2B5EF4-FFF2-40B4-BE49-F238E27FC236}">
+                <a16:creationId xmlns:a16="http://schemas.microsoft.com/office/drawing/2014/main" id="{B7340063-81CA-4574-9077-44EFF41E1D48}"/>
               </a:ext>
             </a:extLst>
           </p:cNvPr>
@@ -4845,7 +5922,7 @@
             <a:avLst/>
           </a:prstGeom>
           <a:solidFill xmlns:a="http://schemas.openxmlformats.org/drawingml/2006/main">
-            <a:srgbClr val="2F855A"/>
+            <a:srgbClr val="B7791F"/>
           </a:solidFill>
           <a:ln xmlns:a="http://schemas.openxmlformats.org/drawingml/2006/main" w="0">
             <a:noFill/>
@@ -4855,10 +5932,10 @@
       </p:sp>
       <p:sp>
         <p:nvSpPr>
-          <p:cNvPr id="13" name="verdict">
-            <a:extLst xmlns:a="http://schemas.openxmlformats.org/drawingml/2006/main">
-              <a:ext uri="{FF2B5EF4-FFF2-40B4-BE49-F238E27FC236}">
-                <a16:creationId xmlns:a16="http://schemas.microsoft.com/office/drawing/2014/main" id="{DAEE4CAF-C158-4F1E-AF88-9B2A72776725}"/>
+          <p:cNvPr id="33" name="verdict">
+            <a:extLst xmlns:a="http://schemas.openxmlformats.org/drawingml/2006/main">
+              <a:ext uri="{FF2B5EF4-FFF2-40B4-BE49-F238E27FC236}">
+                <a16:creationId xmlns:a16="http://schemas.microsoft.com/office/drawing/2014/main" id="{58150FBF-9B5D-4B58-BB9C-CF5537C997F7}"/>
               </a:ext>
             </a:extLst>
           </p:cNvPr>
@@ -4870,7 +5947,7 @@
         <p:spPr>
           <a:xfrm xmlns:a="http://schemas.openxmlformats.org/drawingml/2006/main">
             <a:off x="685800" y="5362575"/>
-            <a:ext cx="3143250" cy="314325"/>
+            <a:ext cx="2857500" cy="314325"/>
           </a:xfrm>
           <a:prstGeom xmlns:a="http://schemas.openxmlformats.org/drawingml/2006/main" prst="rect">
             <a:avLst/>
@@ -4889,39 +5966,39 @@
               <a:buNone/>
               <a:defRPr sz="1725" b="1">
                 <a:solidFill>
-                  <a:srgbClr val="2F855A"/>
+                  <a:srgbClr val="B7791F"/>
                 </a:solidFill>
               </a:defRPr>
             </a:pPr>
             <a:r>
               <a:rPr sz="1725" b="1">
                 <a:solidFill>
-                  <a:srgbClr val="2F855A"/>
-                </a:solidFill>
-              </a:rPr>
-              <a:t>NOT PURE COMPOSITION</a:t>
-            </a:r>
-          </a:p>
-        </p:txBody>
-      </p:sp>
-      <p:sp>
-        <p:nvSpPr>
-          <p:cNvPr id="14" name="assessment">
-            <a:extLst xmlns:a="http://schemas.openxmlformats.org/drawingml/2006/main">
-              <a:ext uri="{FF2B5EF4-FFF2-40B4-BE49-F238E27FC236}">
-                <a16:creationId xmlns:a16="http://schemas.microsoft.com/office/drawing/2014/main" id="{F5E1C807-0687-4A75-8864-05548460D9A0}"/>
-              </a:ext>
-            </a:extLst>
-          </p:cNvPr>
-          <p:cNvSpPr>
-            <a:spLocks xmlns:a="http://schemas.openxmlformats.org/drawingml/2006/main" noGrp="1"/>
-          </p:cNvSpPr>
-          <p:nvPr/>
-        </p:nvSpPr>
-        <p:spPr>
-          <a:xfrm xmlns:a="http://schemas.openxmlformats.org/drawingml/2006/main">
-            <a:off x="3857625" y="5334000"/>
-            <a:ext cx="7620000" cy="457200"/>
+                  <a:srgbClr val="B7791F"/>
+                </a:solidFill>
+              </a:rPr>
+              <a:t>PIXEL TRACE PASSES</a:t>
+            </a:r>
+          </a:p>
+        </p:txBody>
+      </p:sp>
+      <p:sp>
+        <p:nvSpPr>
+          <p:cNvPr id="34" name="assessment">
+            <a:extLst xmlns:a="http://schemas.openxmlformats.org/drawingml/2006/main">
+              <a:ext uri="{FF2B5EF4-FFF2-40B4-BE49-F238E27FC236}">
+                <a16:creationId xmlns:a16="http://schemas.microsoft.com/office/drawing/2014/main" id="{94677C1B-710E-4943-B335-D005A436F57B}"/>
+              </a:ext>
+            </a:extLst>
+          </p:cNvPr>
+          <p:cNvSpPr>
+            <a:spLocks xmlns:a="http://schemas.openxmlformats.org/drawingml/2006/main" noGrp="1"/>
+          </p:cNvSpPr>
+          <p:nvPr/>
+        </p:nvSpPr>
+        <p:spPr>
+          <a:xfrm xmlns:a="http://schemas.openxmlformats.org/drawingml/2006/main">
+            <a:off x="3381375" y="5314950"/>
+            <a:ext cx="8096250" cy="533400"/>
           </a:xfrm>
           <a:prstGeom xmlns:a="http://schemas.openxmlformats.org/drawingml/2006/main" prst="rect">
             <a:avLst/>
@@ -4950,29 +6027,29 @@
                   <a:srgbClr val="243B53"/>
                 </a:solidFill>
               </a:rPr>
-              <a:t>At similar mean wealth, post-1982 cohorts often save less.</a:t>
-            </a:r>
-          </a:p>
-        </p:txBody>
-      </p:sp>
-      <p:sp>
-        <p:nvSpPr>
-          <p:cNvPr id="15" name="difference">
-            <a:extLst xmlns:a="http://schemas.openxmlformats.org/drawingml/2006/main">
-              <a:ext uri="{FF2B5EF4-FFF2-40B4-BE49-F238E27FC236}">
-                <a16:creationId xmlns:a16="http://schemas.microsoft.com/office/drawing/2014/main" id="{9E94ECB7-8637-4F89-9ABB-1A8B2FEF54E1}"/>
-              </a:ext>
-            </a:extLst>
-          </p:cNvPr>
-          <p:cNvSpPr>
-            <a:spLocks xmlns:a="http://schemas.openxmlformats.org/drawingml/2006/main" noGrp="1"/>
-          </p:cNvSpPr>
-          <p:nvPr/>
-        </p:nvSpPr>
-        <p:spPr>
-          <a:xfrm xmlns:a="http://schemas.openxmlformats.org/drawingml/2006/main">
-            <a:off x="685800" y="5848350"/>
-            <a:ext cx="10763250" cy="400050"/>
+              <a:t>Solid recovered centerlines overlap the original dashed curves.</a:t>
+            </a:r>
+          </a:p>
+        </p:txBody>
+      </p:sp>
+      <p:sp>
+        <p:nvSpPr>
+          <p:cNvPr id="35" name="difference">
+            <a:extLst xmlns:a="http://schemas.openxmlformats.org/drawingml/2006/main">
+              <a:ext uri="{FF2B5EF4-FFF2-40B4-BE49-F238E27FC236}">
+                <a16:creationId xmlns:a16="http://schemas.microsoft.com/office/drawing/2014/main" id="{F73CA6A4-7682-4A38-9F63-F48562BF99F7}"/>
+              </a:ext>
+            </a:extLst>
+          </p:cNvPr>
+          <p:cNvSpPr>
+            <a:spLocks xmlns:a="http://schemas.openxmlformats.org/drawingml/2006/main" noGrp="1"/>
+          </p:cNvSpPr>
+          <p:nvPr/>
+        </p:nvSpPr>
+        <p:spPr>
+          <a:xfrm xmlns:a="http://schemas.openxmlformats.org/drawingml/2006/main">
+            <a:off x="685800" y="5915025"/>
+            <a:ext cx="10763250" cy="381000"/>
           </a:xfrm>
           <a:prstGeom xmlns:a="http://schemas.openxmlformats.org/drawingml/2006/main" prst="rect">
             <a:avLst/>
@@ -5001,49 +6078,27 @@
                   <a:srgbClr val="627D98"/>
                 </a:solidFill>
               </a:rPr>
-              <a:t>Near $300k mean wealth: pre p90 saves 31.5%; post p80 saves 7.4%. Cohort means are not fixed-dollar bins.</a:t>
+              <a:t>The overlay corrected the blue top-1 endpoint by ≈1.3 pp; post-period correlation / MAE are 0.969 / 1.22 pp.</a:t>
             </a:r>
           </a:p>
         </p:txBody>
       </p:sp>
       <p:pic>
         <p:nvPicPr>
-          <p:cNvPr id="32" name=""/>
+          <p:cNvPr id="72" name=""/>
           <p:cNvPicPr>
             <a:picLocks xmlns:a="http://schemas.openxmlformats.org/drawingml/2006/main" noChangeAspect="1"/>
           </p:cNvPicPr>
           <p:nvPr/>
         </p:nvPicPr>
         <p:blipFill>
-          <a:blip xmlns:r="http://schemas.openxmlformats.org/officeDocument/2006/relationships" xmlns:a="http://schemas.openxmlformats.org/drawingml/2006/main" r:embed="R5e0396f78d1a4d55"/>
+          <a:blip xmlns:r="http://schemas.openxmlformats.org/officeDocument/2006/relationships" xmlns:a="http://schemas.openxmlformats.org/drawingml/2006/main" r:embed="Rdbdf3d260c0d44e2"/>
           <a:stretch xmlns:a="http://schemas.openxmlformats.org/drawingml/2006/main"/>
         </p:blipFill>
         <p:spPr>
           <a:xfrm xmlns:a="http://schemas.openxmlformats.org/drawingml/2006/main" flipH="0" flipV="0">
-            <a:off x="632746" y="1552099"/>
-            <a:ext cx="5059204" cy="3372802"/>
-          </a:xfrm>
-          <a:prstGeom xmlns:a="http://schemas.openxmlformats.org/drawingml/2006/main" prst="rect">
-            <a:avLst/>
-          </a:prstGeom>
-        </p:spPr>
-      </p:pic>
-      <p:pic>
-        <p:nvPicPr>
-          <p:cNvPr id="33" name=""/>
-          <p:cNvPicPr>
-            <a:picLocks xmlns:a="http://schemas.openxmlformats.org/drawingml/2006/main" noChangeAspect="1"/>
-          </p:cNvPicPr>
-          <p:nvPr/>
-        </p:nvPicPr>
-        <p:blipFill>
-          <a:blip xmlns:r="http://schemas.openxmlformats.org/officeDocument/2006/relationships" xmlns:a="http://schemas.openxmlformats.org/drawingml/2006/main" r:embed="R0e563d3933f64e0c"/>
-          <a:stretch xmlns:a="http://schemas.openxmlformats.org/drawingml/2006/main"/>
-        </p:blipFill>
-        <p:spPr>
-          <a:xfrm xmlns:a="http://schemas.openxmlformats.org/drawingml/2006/main" flipH="0" flipV="0">
-            <a:off x="6450393" y="1776603"/>
-            <a:ext cx="5158614" cy="2923699"/>
+            <a:off x="6400800" y="1776685"/>
+            <a:ext cx="5257800" cy="2942680"/>
           </a:xfrm>
           <a:prstGeom xmlns:a="http://schemas.openxmlformats.org/drawingml/2006/main" prst="rect">
             <a:avLst/>
@@ -5053,7 +6108,7 @@
     </p:spTree>
     <p:extLst>
       <p:ext uri="{BB962C8B-B14F-4D97-AF65-F5344CB8AC3E}">
-        <p14:creationId xmlns:p14="http://schemas.microsoft.com/office/powerpoint/2010/main" val="1065330000"/>
+        <p14:creationId xmlns:p14="http://schemas.microsoft.com/office/powerpoint/2010/main" val="996002771"/>
       </p:ext>
     </p:extLst>
   </p:cSld>
@@ -5125,7 +6180,7 @@
                   <a:srgbClr val="C65D16"/>
                 </a:solidFill>
               </a:rPr>
-              <a:t>FIGURE 6 TIME EVOLUTION</a:t>
+              <a:t>FIGURE 6 MECHANISM VIEW</a:t>
             </a:r>
           </a:p>
         </p:txBody>
@@ -5176,7 +6231,7 @@
                   <a:srgbClr val="102A43"/>
                 </a:solidFill>
               </a:rPr>
-              <a:t>Upper-middle rates trend down; the top 1% remains volatile</a:t>
+              <a:t>Rising wealth alone does not explain the saving-rate shift</a:t>
             </a:r>
           </a:p>
         </p:txBody>
@@ -5309,7 +6364,7 @@
                   <a:srgbClr val="2E5B88"/>
                 </a:solidFill>
               </a:rPr>
-              <a:t>Full distribution · trailing five-year means</a:t>
+              <a:t>Same rates · wealth percentile</a:t>
             </a:r>
           </a:p>
         </p:txBody>
@@ -5360,7 +6415,7 @@
                   <a:srgbClr val="C65D16"/>
                 </a:solidFill>
               </a:rPr>
-              <a:t>Selected upper-tail percentiles</a:t>
+              <a:t>Same rates · mean real wealth per adult</a:t>
             </a:r>
           </a:p>
         </p:txBody>
@@ -5545,7 +6600,7 @@
                   <a:srgbClr val="2F855A"/>
                 </a:solidFill>
               </a:rPr>
-              <a:t>NOT A SINGLE BREAK</a:t>
+              <a:t>NOT PURE COMPOSITION</a:t>
             </a:r>
           </a:p>
         </p:txBody>
@@ -5596,7 +6651,7 @@
                   <a:srgbClr val="243B53"/>
                 </a:solidFill>
               </a:rPr>
-              <a:t>The 80th–90th percentiles decline persistently after the late 1980s.</a:t>
+              <a:t>At similar mean wealth, post-1982 cohorts often save less.</a:t>
             </a:r>
           </a:p>
         </p:txBody>
@@ -5647,7 +6702,7 @@
                   <a:srgbClr val="627D98"/>
                 </a:solidFill>
               </a:rPr>
-              <a:t>The top 1% oscillates sharply, including a 2008 five-year peak; this is not one smooth monotone trend.</a:t>
+              <a:t>Near $300k mean wealth: pre p90 saves 31.5%; post p80 saves 7.4%. Cohort means are not fixed-dollar bins.</a:t>
             </a:r>
           </a:p>
         </p:txBody>
@@ -5661,7 +6716,7 @@
           <p:nvPr/>
         </p:nvPicPr>
         <p:blipFill>
-          <a:blip xmlns:r="http://schemas.openxmlformats.org/officeDocument/2006/relationships" xmlns:a="http://schemas.openxmlformats.org/drawingml/2006/main" r:embed="Ree30bd9c5b574034"/>
+          <a:blip xmlns:r="http://schemas.openxmlformats.org/officeDocument/2006/relationships" xmlns:a="http://schemas.openxmlformats.org/drawingml/2006/main" r:embed="R186f75e2e8254654"/>
           <a:stretch xmlns:a="http://schemas.openxmlformats.org/drawingml/2006/main"/>
         </p:blipFill>
         <p:spPr>
@@ -5683,7 +6738,7 @@
           <p:nvPr/>
         </p:nvPicPr>
         <p:blipFill>
-          <a:blip xmlns:r="http://schemas.openxmlformats.org/officeDocument/2006/relationships" xmlns:a="http://schemas.openxmlformats.org/drawingml/2006/main" r:embed="R13be0ab094e54193"/>
+          <a:blip xmlns:r="http://schemas.openxmlformats.org/officeDocument/2006/relationships" xmlns:a="http://schemas.openxmlformats.org/drawingml/2006/main" r:embed="Rdf8da51c0cda4b64"/>
           <a:stretch xmlns:a="http://schemas.openxmlformats.org/drawingml/2006/main"/>
         </p:blipFill>
         <p:spPr>
@@ -5727,10 +6782,10 @@
       </p:grpSpPr>
       <p:sp>
         <p:nvSpPr>
-          <p:cNvPr id="20" name="kicker">
-            <a:extLst xmlns:a="http://schemas.openxmlformats.org/drawingml/2006/main">
-              <a:ext uri="{FF2B5EF4-FFF2-40B4-BE49-F238E27FC236}">
-                <a16:creationId xmlns:a16="http://schemas.microsoft.com/office/drawing/2014/main" id="{4DBD74DF-ED28-4EE9-8535-9E366A67537D}"/>
+          <p:cNvPr id="16" name="kicker">
+            <a:extLst xmlns:a="http://schemas.openxmlformats.org/drawingml/2006/main">
+              <a:ext uri="{FF2B5EF4-FFF2-40B4-BE49-F238E27FC236}">
+                <a16:creationId xmlns:a16="http://schemas.microsoft.com/office/drawing/2014/main" id="{AA955CD9-B4EF-4E20-A3FC-1D7B4F59A354}"/>
               </a:ext>
             </a:extLst>
           </p:cNvPr>
@@ -5771,7 +6826,7 @@
                   <a:srgbClr val="C65D16"/>
                 </a:solidFill>
               </a:rPr>
-              <a:t>FIGURE 8 FEASIBILITY</a:t>
+              <a:t>FIGURE 6 TIME EVOLUTION</a:t>
             </a:r>
           </a:p>
         </p:txBody>
@@ -5781,7 +6836,7 @@
           <p:cNvPr id="2" name="title">
             <a:extLst xmlns:a="http://schemas.openxmlformats.org/drawingml/2006/main">
               <a:ext uri="{FF2B5EF4-FFF2-40B4-BE49-F238E27FC236}">
-                <a16:creationId xmlns:a16="http://schemas.microsoft.com/office/drawing/2014/main" id="{25994307-319F-4EAA-8D7C-9E832F74B960}"/>
+                <a16:creationId xmlns:a16="http://schemas.microsoft.com/office/drawing/2014/main" id="{BE8A36E9-77A3-4197-AAEB-944D96A22E35}"/>
               </a:ext>
             </a:extLst>
           </p:cNvPr>
@@ -5822,7 +6877,7 @@
                   <a:srgbClr val="102A43"/>
                 </a:solidFill>
               </a:rPr>
-              <a:t>Figure 8 stops one step before the revised matrix solve</a:t>
+              <a:t>Upper-middle rates trend down; the top 1% remains volatile</a:t>
             </a:r>
           </a:p>
         </p:txBody>
@@ -5832,7 +6887,7 @@
           <p:cNvPr id="3" name="header-rule">
             <a:extLst xmlns:a="http://schemas.openxmlformats.org/drawingml/2006/main">
               <a:ext uri="{FF2B5EF4-FFF2-40B4-BE49-F238E27FC236}">
-                <a16:creationId xmlns:a16="http://schemas.microsoft.com/office/drawing/2014/main" id="{9304C898-8A92-4A39-A7EB-64A100354E4A}"/>
+                <a16:creationId xmlns:a16="http://schemas.microsoft.com/office/drawing/2014/main" id="{514C6BB1-D2D7-4502-B63E-CB46F5220FD9}"/>
               </a:ext>
             </a:extLst>
           </p:cNvPr>
@@ -5863,7 +6918,7 @@
           <p:cNvPr id="4" name="slide-number">
             <a:extLst xmlns:a="http://schemas.openxmlformats.org/drawingml/2006/main">
               <a:ext uri="{FF2B5EF4-FFF2-40B4-BE49-F238E27FC236}">
-                <a16:creationId xmlns:a16="http://schemas.microsoft.com/office/drawing/2014/main" id="{E4772364-3993-46C7-BB6A-7696849F37B9}"/>
+                <a16:creationId xmlns:a16="http://schemas.microsoft.com/office/drawing/2014/main" id="{1846DD66-DAE1-4F4D-9638-E1108AC93C86}"/>
               </a:ext>
             </a:extLst>
           </p:cNvPr>
@@ -5911,576 +6966,198 @@
       </p:sp>
       <p:sp>
         <p:nvSpPr>
-          <p:cNvPr id="5" name="question">
-            <a:extLst xmlns:a="http://schemas.openxmlformats.org/drawingml/2006/main">
-              <a:ext uri="{FF2B5EF4-FFF2-40B4-BE49-F238E27FC236}">
-                <a16:creationId xmlns:a16="http://schemas.microsoft.com/office/drawing/2014/main" id="{1C4CBB66-390B-40CA-9A94-F3B655FADD50}"/>
-              </a:ext>
-            </a:extLst>
-          </p:cNvPr>
-          <p:cNvSpPr>
-            <a:spLocks xmlns:a="http://schemas.openxmlformats.org/drawingml/2006/main" noGrp="1"/>
-          </p:cNvSpPr>
-          <p:nvPr/>
-        </p:nvSpPr>
-        <p:spPr>
-          <a:xfrm xmlns:a="http://schemas.openxmlformats.org/drawingml/2006/main">
-            <a:off x="533400" y="1333500"/>
-            <a:ext cx="2095500" cy="323850"/>
-          </a:xfrm>
-          <a:prstGeom xmlns:a="http://schemas.openxmlformats.org/drawingml/2006/main" prst="rect">
-            <a:avLst/>
-          </a:prstGeom>
-          <a:noFill xmlns:a="http://schemas.openxmlformats.org/drawingml/2006/main"/>
-          <a:ln xmlns:a="http://schemas.openxmlformats.org/drawingml/2006/main" w="0">
-            <a:noFill/>
-            <a:prstDash val="solid"/>
-          </a:ln>
-        </p:spPr>
-        <p:txBody>
-          <a:bodyPr xmlns:a="http://schemas.openxmlformats.org/drawingml/2006/main" anchor="t"/>
-          <a:lstStyle xmlns:a="http://schemas.openxmlformats.org/drawingml/2006/main"/>
-          <a:p xmlns:a="http://schemas.openxmlformats.org/drawingml/2006/main">
-            <a:pPr algn="l">
-              <a:buNone/>
-              <a:defRPr sz="1650" b="1">
-                <a:solidFill>
-                  <a:srgbClr val="102A43"/>
-                </a:solidFill>
-              </a:defRPr>
-            </a:pPr>
-            <a:r>
-              <a:rPr sz="1650" b="1">
-                <a:solidFill>
-                  <a:srgbClr val="102A43"/>
-                </a:solidFill>
-              </a:rPr>
-              <a:t>Target</a:t>
-            </a:r>
-          </a:p>
-        </p:txBody>
-      </p:sp>
-      <p:sp>
-        <p:nvSpPr>
-          <p:cNvPr id="6" name="question-body">
-            <a:extLst xmlns:a="http://schemas.openxmlformats.org/drawingml/2006/main">
-              <a:ext uri="{FF2B5EF4-FFF2-40B4-BE49-F238E27FC236}">
-                <a16:creationId xmlns:a16="http://schemas.microsoft.com/office/drawing/2014/main" id="{C7924291-5CE5-45A7-9502-25780E8749E1}"/>
-              </a:ext>
-            </a:extLst>
-          </p:cNvPr>
-          <p:cNvSpPr>
-            <a:spLocks xmlns:a="http://schemas.openxmlformats.org/drawingml/2006/main" noGrp="1"/>
-          </p:cNvSpPr>
-          <p:nvPr/>
-        </p:nvSpPr>
-        <p:spPr>
-          <a:xfrm xmlns:a="http://schemas.openxmlformats.org/drawingml/2006/main">
-            <a:off x="533400" y="1733550"/>
-            <a:ext cx="4381500" cy="1123950"/>
-          </a:xfrm>
-          <a:prstGeom xmlns:a="http://schemas.openxmlformats.org/drawingml/2006/main" prst="rect">
-            <a:avLst/>
-          </a:prstGeom>
-          <a:noFill xmlns:a="http://schemas.openxmlformats.org/drawingml/2006/main"/>
-          <a:ln xmlns:a="http://schemas.openxmlformats.org/drawingml/2006/main" w="0">
-            <a:noFill/>
-            <a:prstDash val="solid"/>
-          </a:ln>
-        </p:spPr>
-        <p:txBody>
-          <a:bodyPr xmlns:a="http://schemas.openxmlformats.org/drawingml/2006/main" anchor="t"/>
-          <a:lstStyle xmlns:a="http://schemas.openxmlformats.org/drawingml/2006/main"/>
-          <a:p xmlns:a="http://schemas.openxmlformats.org/drawingml/2006/main">
-            <a:pPr algn="l">
-              <a:buNone/>
-              <a:defRPr sz="1875" b="0">
-                <a:solidFill>
-                  <a:srgbClr val="243B53"/>
-                </a:solidFill>
-              </a:defRPr>
-            </a:pPr>
-            <a:r>
-              <a:rPr sz="1875" b="0">
-                <a:solidFill>
-                  <a:srgbClr val="243B53"/>
-                </a:solidFill>
-              </a:rPr>
-              <a:t>2025 Figure 8</a:t>
-            </a:r>
-          </a:p>
-          <a:p xmlns:a="http://schemas.openxmlformats.org/drawingml/2006/main">
-            <a:pPr algn="l">
-              <a:buNone/>
-              <a:defRPr sz="1875" b="0">
-                <a:solidFill>
-                  <a:srgbClr val="243B53"/>
-                </a:solidFill>
-              </a:defRPr>
-            </a:pPr>
-            <a:r>
-              <a:rPr sz="1875" b="0">
-                <a:solidFill>
-                  <a:srgbClr val="243B53"/>
-                </a:solidFill>
-              </a:rPr>
-              <a:t>Net household debt by wealth group</a:t>
-            </a:r>
-          </a:p>
-        </p:txBody>
-      </p:sp>
-      <p:sp>
-        <p:nvSpPr>
-          <p:cNvPr id="7" name="divider">
-            <a:extLst xmlns:a="http://schemas.openxmlformats.org/drawingml/2006/main">
-              <a:ext uri="{FF2B5EF4-FFF2-40B4-BE49-F238E27FC236}">
-                <a16:creationId xmlns:a16="http://schemas.microsoft.com/office/drawing/2014/main" id="{F04E65CB-1300-417C-A552-521BE00891D3}"/>
-              </a:ext>
-            </a:extLst>
-          </p:cNvPr>
-          <p:cNvSpPr>
-            <a:spLocks xmlns:a="http://schemas.openxmlformats.org/drawingml/2006/main" noGrp="1"/>
-          </p:cNvSpPr>
-          <p:nvPr/>
-        </p:nvSpPr>
-        <p:spPr>
-          <a:xfrm xmlns:a="http://schemas.openxmlformats.org/drawingml/2006/main">
-            <a:off x="5391150" y="1285875"/>
-            <a:ext cx="19050" cy="4381500"/>
-          </a:xfrm>
-          <a:prstGeom xmlns:a="http://schemas.openxmlformats.org/drawingml/2006/main" prst="rect">
-            <a:avLst/>
-          </a:prstGeom>
-          <a:solidFill xmlns:a="http://schemas.openxmlformats.org/drawingml/2006/main">
-            <a:srgbClr val="D8E1E8"/>
-          </a:solidFill>
-          <a:ln xmlns:a="http://schemas.openxmlformats.org/drawingml/2006/main" w="0">
-            <a:noFill/>
-            <a:prstDash val="solid"/>
-          </a:ln>
-        </p:spPr>
-      </p:sp>
-      <p:sp>
-        <p:nvSpPr>
-          <p:cNvPr id="8" name="Strong precursor-bar">
-            <a:extLst xmlns:a="http://schemas.openxmlformats.org/drawingml/2006/main">
-              <a:ext uri="{FF2B5EF4-FFF2-40B4-BE49-F238E27FC236}">
-                <a16:creationId xmlns:a16="http://schemas.microsoft.com/office/drawing/2014/main" id="{80A9BBD5-0978-4A47-9DE6-A7D2756C4BC7}"/>
-              </a:ext>
-            </a:extLst>
-          </p:cNvPr>
-          <p:cNvSpPr>
-            <a:spLocks xmlns:a="http://schemas.openxmlformats.org/drawingml/2006/main" noGrp="1"/>
-          </p:cNvSpPr>
-          <p:nvPr/>
-        </p:nvSpPr>
-        <p:spPr>
-          <a:xfrm xmlns:a="http://schemas.openxmlformats.org/drawingml/2006/main">
-            <a:off x="5905500" y="1333500"/>
-            <a:ext cx="76200" cy="952500"/>
-          </a:xfrm>
-          <a:prstGeom xmlns:a="http://schemas.openxmlformats.org/drawingml/2006/main" prst="rect">
-            <a:avLst/>
-          </a:prstGeom>
-          <a:solidFill xmlns:a="http://schemas.openxmlformats.org/drawingml/2006/main">
-            <a:srgbClr val="8A96A3"/>
-          </a:solidFill>
-          <a:ln xmlns:a="http://schemas.openxmlformats.org/drawingml/2006/main" w="0">
-            <a:noFill/>
-            <a:prstDash val="solid"/>
-          </a:ln>
-        </p:spPr>
-      </p:sp>
-      <p:sp>
-        <p:nvSpPr>
-          <p:cNvPr id="9" name="Strong precursor-label">
-            <a:extLst xmlns:a="http://schemas.openxmlformats.org/drawingml/2006/main">
-              <a:ext uri="{FF2B5EF4-FFF2-40B4-BE49-F238E27FC236}">
-                <a16:creationId xmlns:a16="http://schemas.microsoft.com/office/drawing/2014/main" id="{51CC7C6F-9EBD-42A3-9CD8-DD0C6EE988A5}"/>
-              </a:ext>
-            </a:extLst>
-          </p:cNvPr>
-          <p:cNvSpPr>
-            <a:spLocks xmlns:a="http://schemas.openxmlformats.org/drawingml/2006/main" noGrp="1"/>
-          </p:cNvSpPr>
-          <p:nvPr/>
-        </p:nvSpPr>
-        <p:spPr>
-          <a:xfrm xmlns:a="http://schemas.openxmlformats.org/drawingml/2006/main">
-            <a:off x="6191250" y="1371600"/>
-            <a:ext cx="2476500" cy="285750"/>
-          </a:xfrm>
-          <a:prstGeom xmlns:a="http://schemas.openxmlformats.org/drawingml/2006/main" prst="rect">
-            <a:avLst/>
-          </a:prstGeom>
-          <a:noFill xmlns:a="http://schemas.openxmlformats.org/drawingml/2006/main"/>
-          <a:ln xmlns:a="http://schemas.openxmlformats.org/drawingml/2006/main" w="0">
-            <a:noFill/>
-            <a:prstDash val="solid"/>
-          </a:ln>
-        </p:spPr>
-        <p:txBody>
-          <a:bodyPr xmlns:a="http://schemas.openxmlformats.org/drawingml/2006/main" anchor="t"/>
-          <a:lstStyle xmlns:a="http://schemas.openxmlformats.org/drawingml/2006/main"/>
-          <a:p xmlns:a="http://schemas.openxmlformats.org/drawingml/2006/main">
-            <a:pPr algn="l">
-              <a:buNone/>
-              <a:defRPr sz="1725" b="1">
-                <a:solidFill>
-                  <a:srgbClr val="2F855A"/>
-                </a:solidFill>
-              </a:defRPr>
-            </a:pPr>
-            <a:r>
-              <a:rPr sz="1725" b="1">
-                <a:solidFill>
-                  <a:srgbClr val="627D98"/>
-                </a:solidFill>
-              </a:rPr>
-              <a:t>1 · Missing upstream</a:t>
-            </a:r>
-          </a:p>
-        </p:txBody>
-      </p:sp>
-      <p:sp>
-        <p:nvSpPr>
-          <p:cNvPr id="10" name="Strong precursor-body">
-            <a:extLst xmlns:a="http://schemas.openxmlformats.org/drawingml/2006/main">
-              <a:ext uri="{FF2B5EF4-FFF2-40B4-BE49-F238E27FC236}">
-                <a16:creationId xmlns:a16="http://schemas.microsoft.com/office/drawing/2014/main" id="{244FF233-0930-4770-ADF3-1B1A9250D6B7}"/>
-              </a:ext>
-            </a:extLst>
-          </p:cNvPr>
-          <p:cNvSpPr>
-            <a:spLocks xmlns:a="http://schemas.openxmlformats.org/drawingml/2006/main" noGrp="1"/>
-          </p:cNvSpPr>
-          <p:nvPr/>
-        </p:nvSpPr>
-        <p:spPr>
-          <a:xfrm xmlns:a="http://schemas.openxmlformats.org/drawingml/2006/main">
-            <a:off x="6191250" y="1704975"/>
-            <a:ext cx="5048250" cy="552450"/>
-          </a:xfrm>
-          <a:prstGeom xmlns:a="http://schemas.openxmlformats.org/drawingml/2006/main" prst="rect">
-            <a:avLst/>
-          </a:prstGeom>
-          <a:noFill xmlns:a="http://schemas.openxmlformats.org/drawingml/2006/main"/>
-          <a:ln xmlns:a="http://schemas.openxmlformats.org/drawingml/2006/main" w="0">
-            <a:noFill/>
-            <a:prstDash val="solid"/>
-          </a:ln>
-        </p:spPr>
-        <p:txBody>
-          <a:bodyPr xmlns:a="http://schemas.openxmlformats.org/drawingml/2006/main" anchor="t"/>
-          <a:lstStyle xmlns:a="http://schemas.openxmlformats.org/drawingml/2006/main"/>
-          <a:p xmlns:a="http://schemas.openxmlformats.org/drawingml/2006/main">
-            <a:pPr algn="l">
-              <a:buNone/>
-              <a:defRPr sz="1350" b="0">
-                <a:solidFill>
-                  <a:srgbClr val="243B53"/>
-                </a:solidFill>
-              </a:defRPr>
-            </a:pPr>
-            <a:r>
-              <a:rPr sz="1350" b="0">
-                <a:solidFill>
-                  <a:srgbClr val="243B53"/>
-                </a:solidFill>
-              </a:rPr>
-              <a:t>Completed 2025 instrument × sector matrices and augmented household columns.</a:t>
-            </a:r>
-          </a:p>
-        </p:txBody>
-      </p:sp>
-      <p:sp>
-        <p:nvSpPr>
-          <p:cNvPr id="11" name="Partial match-bar">
-            <a:extLst xmlns:a="http://schemas.openxmlformats.org/drawingml/2006/main">
-              <a:ext uri="{FF2B5EF4-FFF2-40B4-BE49-F238E27FC236}">
-                <a16:creationId xmlns:a16="http://schemas.microsoft.com/office/drawing/2014/main" id="{F0181655-D030-45C0-A3E0-D81445F8830B}"/>
-              </a:ext>
-            </a:extLst>
-          </p:cNvPr>
-          <p:cNvSpPr>
-            <a:spLocks xmlns:a="http://schemas.openxmlformats.org/drawingml/2006/main" noGrp="1"/>
-          </p:cNvSpPr>
-          <p:nvPr/>
-        </p:nvSpPr>
-        <p:spPr>
-          <a:xfrm xmlns:a="http://schemas.openxmlformats.org/drawingml/2006/main">
-            <a:off x="5905500" y="2609850"/>
-            <a:ext cx="76200" cy="952500"/>
-          </a:xfrm>
-          <a:prstGeom xmlns:a="http://schemas.openxmlformats.org/drawingml/2006/main" prst="rect">
-            <a:avLst/>
-          </a:prstGeom>
-          <a:solidFill xmlns:a="http://schemas.openxmlformats.org/drawingml/2006/main">
-            <a:srgbClr val="2E5B88"/>
-          </a:solidFill>
-          <a:ln xmlns:a="http://schemas.openxmlformats.org/drawingml/2006/main" w="0">
-            <a:noFill/>
-            <a:prstDash val="solid"/>
-          </a:ln>
-        </p:spPr>
-      </p:sp>
-      <p:sp>
-        <p:nvSpPr>
-          <p:cNvPr id="12" name="Partial match-label">
-            <a:extLst xmlns:a="http://schemas.openxmlformats.org/drawingml/2006/main">
-              <a:ext uri="{FF2B5EF4-FFF2-40B4-BE49-F238E27FC236}">
-                <a16:creationId xmlns:a16="http://schemas.microsoft.com/office/drawing/2014/main" id="{217D0269-3366-4106-A614-BFB2DD0B2ECF}"/>
-              </a:ext>
-            </a:extLst>
-          </p:cNvPr>
-          <p:cNvSpPr>
-            <a:spLocks xmlns:a="http://schemas.openxmlformats.org/drawingml/2006/main" noGrp="1"/>
-          </p:cNvSpPr>
-          <p:nvPr/>
-        </p:nvSpPr>
-        <p:spPr>
-          <a:xfrm xmlns:a="http://schemas.openxmlformats.org/drawingml/2006/main">
-            <a:off x="6191250" y="2647950"/>
-            <a:ext cx="2476500" cy="285750"/>
-          </a:xfrm>
-          <a:prstGeom xmlns:a="http://schemas.openxmlformats.org/drawingml/2006/main" prst="rect">
-            <a:avLst/>
-          </a:prstGeom>
-          <a:noFill xmlns:a="http://schemas.openxmlformats.org/drawingml/2006/main"/>
-          <a:ln xmlns:a="http://schemas.openxmlformats.org/drawingml/2006/main" w="0">
-            <a:noFill/>
-            <a:prstDash val="solid"/>
-          </a:ln>
-        </p:spPr>
-        <p:txBody>
-          <a:bodyPr xmlns:a="http://schemas.openxmlformats.org/drawingml/2006/main" anchor="t"/>
-          <a:lstStyle xmlns:a="http://schemas.openxmlformats.org/drawingml/2006/main"/>
-          <a:p xmlns:a="http://schemas.openxmlformats.org/drawingml/2006/main">
-            <a:pPr algn="l">
-              <a:buNone/>
-              <a:defRPr sz="1725" b="1">
-                <a:solidFill>
-                  <a:srgbClr val="B7791F"/>
-                </a:solidFill>
-              </a:defRPr>
-            </a:pPr>
-            <a:r>
-              <a:rPr sz="1725" b="1">
+          <p:cNvPr id="5" name="left-label">
+            <a:extLst xmlns:a="http://schemas.openxmlformats.org/drawingml/2006/main">
+              <a:ext uri="{FF2B5EF4-FFF2-40B4-BE49-F238E27FC236}">
+                <a16:creationId xmlns:a16="http://schemas.microsoft.com/office/drawing/2014/main" id="{AC7EBFD9-49FB-40B3-B7BA-0564A41A3ADA}"/>
+              </a:ext>
+            </a:extLst>
+          </p:cNvPr>
+          <p:cNvSpPr>
+            <a:spLocks xmlns:a="http://schemas.openxmlformats.org/drawingml/2006/main" noGrp="1"/>
+          </p:cNvSpPr>
+          <p:nvPr/>
+        </p:nvSpPr>
+        <p:spPr>
+          <a:xfrm xmlns:a="http://schemas.openxmlformats.org/drawingml/2006/main">
+            <a:off x="457200" y="1123950"/>
+            <a:ext cx="5334000" cy="266700"/>
+          </a:xfrm>
+          <a:prstGeom xmlns:a="http://schemas.openxmlformats.org/drawingml/2006/main" prst="rect">
+            <a:avLst/>
+          </a:prstGeom>
+          <a:noFill xmlns:a="http://schemas.openxmlformats.org/drawingml/2006/main"/>
+          <a:ln xmlns:a="http://schemas.openxmlformats.org/drawingml/2006/main" w="0">
+            <a:noFill/>
+            <a:prstDash val="solid"/>
+          </a:ln>
+        </p:spPr>
+        <p:txBody>
+          <a:bodyPr xmlns:a="http://schemas.openxmlformats.org/drawingml/2006/main" anchor="t"/>
+          <a:lstStyle xmlns:a="http://schemas.openxmlformats.org/drawingml/2006/main"/>
+          <a:p xmlns:a="http://schemas.openxmlformats.org/drawingml/2006/main">
+            <a:pPr algn="l">
+              <a:buNone/>
+              <a:defRPr sz="1350" b="1">
                 <a:solidFill>
                   <a:srgbClr val="2E5B88"/>
                 </a:solidFill>
-              </a:rPr>
-              <a:t>2 · Old-kit output</a:t>
-            </a:r>
-          </a:p>
-        </p:txBody>
-      </p:sp>
-      <p:sp>
-        <p:nvSpPr>
-          <p:cNvPr id="13" name="Partial match-body">
-            <a:extLst xmlns:a="http://schemas.openxmlformats.org/drawingml/2006/main">
-              <a:ext uri="{FF2B5EF4-FFF2-40B4-BE49-F238E27FC236}">
-                <a16:creationId xmlns:a16="http://schemas.microsoft.com/office/drawing/2014/main" id="{00ABC748-B2B5-4893-8CE6-FDE63773F6C0}"/>
-              </a:ext>
-            </a:extLst>
-          </p:cNvPr>
-          <p:cNvSpPr>
-            <a:spLocks xmlns:a="http://schemas.openxmlformats.org/drawingml/2006/main" noGrp="1"/>
-          </p:cNvSpPr>
-          <p:nvPr/>
-        </p:nvSpPr>
-        <p:spPr>
-          <a:xfrm xmlns:a="http://schemas.openxmlformats.org/drawingml/2006/main">
-            <a:off x="6191250" y="2981325"/>
-            <a:ext cx="5048250" cy="552450"/>
-          </a:xfrm>
-          <a:prstGeom xmlns:a="http://schemas.openxmlformats.org/drawingml/2006/main" prst="rect">
-            <a:avLst/>
-          </a:prstGeom>
-          <a:noFill xmlns:a="http://schemas.openxmlformats.org/drawingml/2006/main"/>
-          <a:ln xmlns:a="http://schemas.openxmlformats.org/drawingml/2006/main" w="0">
-            <a:noFill/>
-            <a:prstDash val="solid"/>
-          </a:ln>
-        </p:spPr>
-        <p:txBody>
-          <a:bodyPr xmlns:a="http://schemas.openxmlformats.org/drawingml/2006/main" anchor="t"/>
-          <a:lstStyle xmlns:a="http://schemas.openxmlformats.org/drawingml/2006/main"/>
-          <a:p xmlns:a="http://schemas.openxmlformats.org/drawingml/2006/main">
-            <a:pPr algn="l">
-              <a:buNone/>
-              <a:defRPr sz="1350" b="0">
-                <a:solidFill>
-                  <a:srgbClr val="243B53"/>
-                </a:solidFill>
-              </a:defRPr>
-            </a:pPr>
-            <a:r>
-              <a:rPr sz="1350" b="0">
-                <a:solidFill>
-                  <a:srgbClr val="243B53"/>
-                </a:solidFill>
-              </a:rPr>
-              <a:t>Fine debt assets after seven rounds + fine liabilities.</a:t>
-            </a:r>
-          </a:p>
-        </p:txBody>
-      </p:sp>
-      <p:sp>
-        <p:nvSpPr>
-          <p:cNvPr id="14" name="Context only-bar">
-            <a:extLst xmlns:a="http://schemas.openxmlformats.org/drawingml/2006/main">
-              <a:ext uri="{FF2B5EF4-FFF2-40B4-BE49-F238E27FC236}">
-                <a16:creationId xmlns:a16="http://schemas.microsoft.com/office/drawing/2014/main" id="{A567A865-2022-41CE-BB30-AB58E2C2A04A}"/>
-              </a:ext>
-            </a:extLst>
-          </p:cNvPr>
-          <p:cNvSpPr>
-            <a:spLocks xmlns:a="http://schemas.openxmlformats.org/drawingml/2006/main" noGrp="1"/>
-          </p:cNvSpPr>
-          <p:nvPr/>
-        </p:nvSpPr>
-        <p:spPr>
-          <a:xfrm xmlns:a="http://schemas.openxmlformats.org/drawingml/2006/main">
-            <a:off x="5905500" y="3886200"/>
-            <a:ext cx="76200" cy="952500"/>
-          </a:xfrm>
-          <a:prstGeom xmlns:a="http://schemas.openxmlformats.org/drawingml/2006/main" prst="rect">
-            <a:avLst/>
-          </a:prstGeom>
-          <a:solidFill xmlns:a="http://schemas.openxmlformats.org/drawingml/2006/main">
-            <a:srgbClr val="C65D16"/>
-          </a:solidFill>
-          <a:ln xmlns:a="http://schemas.openxmlformats.org/drawingml/2006/main" w="0">
-            <a:noFill/>
-            <a:prstDash val="solid"/>
-          </a:ln>
-        </p:spPr>
-      </p:sp>
-      <p:sp>
-        <p:nvSpPr>
-          <p:cNvPr id="15" name="Context only-label">
-            <a:extLst xmlns:a="http://schemas.openxmlformats.org/drawingml/2006/main">
-              <a:ext uri="{FF2B5EF4-FFF2-40B4-BE49-F238E27FC236}">
-                <a16:creationId xmlns:a16="http://schemas.microsoft.com/office/drawing/2014/main" id="{58F96603-D508-40F6-A485-776B0AF5C4BD}"/>
-              </a:ext>
-            </a:extLst>
-          </p:cNvPr>
-          <p:cNvSpPr>
-            <a:spLocks xmlns:a="http://schemas.openxmlformats.org/drawingml/2006/main" noGrp="1"/>
-          </p:cNvSpPr>
-          <p:nvPr/>
-        </p:nvSpPr>
-        <p:spPr>
-          <a:xfrm xmlns:a="http://schemas.openxmlformats.org/drawingml/2006/main">
-            <a:off x="6191250" y="3924300"/>
-            <a:ext cx="2476500" cy="285750"/>
-          </a:xfrm>
-          <a:prstGeom xmlns:a="http://schemas.openxmlformats.org/drawingml/2006/main" prst="rect">
-            <a:avLst/>
-          </a:prstGeom>
-          <a:noFill xmlns:a="http://schemas.openxmlformats.org/drawingml/2006/main"/>
-          <a:ln xmlns:a="http://schemas.openxmlformats.org/drawingml/2006/main" w="0">
-            <a:noFill/>
-            <a:prstDash val="solid"/>
-          </a:ln>
-        </p:spPr>
-        <p:txBody>
-          <a:bodyPr xmlns:a="http://schemas.openxmlformats.org/drawingml/2006/main" anchor="t"/>
-          <a:lstStyle xmlns:a="http://schemas.openxmlformats.org/drawingml/2006/main"/>
-          <a:p xmlns:a="http://schemas.openxmlformats.org/drawingml/2006/main">
-            <a:pPr algn="l">
-              <a:buNone/>
-              <a:defRPr sz="1725" b="1">
-                <a:solidFill>
-                  <a:srgbClr val="B83232"/>
-                </a:solidFill>
-              </a:defRPr>
-            </a:pPr>
-            <a:r>
-              <a:rPr sz="1725" b="1">
+              </a:defRPr>
+            </a:pPr>
+            <a:r>
+              <a:rPr sz="1350" b="1">
+                <a:solidFill>
+                  <a:srgbClr val="2E5B88"/>
+                </a:solidFill>
+              </a:rPr>
+              <a:t>Full distribution · trailing five-year means</a:t>
+            </a:r>
+          </a:p>
+        </p:txBody>
+      </p:sp>
+      <p:sp>
+        <p:nvSpPr>
+          <p:cNvPr id="6" name="right-label">
+            <a:extLst xmlns:a="http://schemas.openxmlformats.org/drawingml/2006/main">
+              <a:ext uri="{FF2B5EF4-FFF2-40B4-BE49-F238E27FC236}">
+                <a16:creationId xmlns:a16="http://schemas.microsoft.com/office/drawing/2014/main" id="{D7EBD11C-5C33-487B-AFE7-65F7CD7D2108}"/>
+              </a:ext>
+            </a:extLst>
+          </p:cNvPr>
+          <p:cNvSpPr>
+            <a:spLocks xmlns:a="http://schemas.openxmlformats.org/drawingml/2006/main" noGrp="1"/>
+          </p:cNvSpPr>
+          <p:nvPr/>
+        </p:nvSpPr>
+        <p:spPr>
+          <a:xfrm xmlns:a="http://schemas.openxmlformats.org/drawingml/2006/main">
+            <a:off x="6324600" y="1123950"/>
+            <a:ext cx="5410200" cy="266700"/>
+          </a:xfrm>
+          <a:prstGeom xmlns:a="http://schemas.openxmlformats.org/drawingml/2006/main" prst="rect">
+            <a:avLst/>
+          </a:prstGeom>
+          <a:noFill xmlns:a="http://schemas.openxmlformats.org/drawingml/2006/main"/>
+          <a:ln xmlns:a="http://schemas.openxmlformats.org/drawingml/2006/main" w="0">
+            <a:noFill/>
+            <a:prstDash val="solid"/>
+          </a:ln>
+        </p:spPr>
+        <p:txBody>
+          <a:bodyPr xmlns:a="http://schemas.openxmlformats.org/drawingml/2006/main" anchor="t"/>
+          <a:lstStyle xmlns:a="http://schemas.openxmlformats.org/drawingml/2006/main"/>
+          <a:p xmlns:a="http://schemas.openxmlformats.org/drawingml/2006/main">
+            <a:pPr algn="l">
+              <a:buNone/>
+              <a:defRPr sz="1350" b="1">
                 <a:solidFill>
                   <a:srgbClr val="C65D16"/>
                 </a:solidFill>
-              </a:rPr>
-              <a:t>3 · Applied faithfully</a:t>
-            </a:r>
-          </a:p>
-        </p:txBody>
-      </p:sp>
-      <p:sp>
-        <p:nvSpPr>
-          <p:cNvPr id="16" name="Context only-body">
-            <a:extLst xmlns:a="http://schemas.openxmlformats.org/drawingml/2006/main">
-              <a:ext uri="{FF2B5EF4-FFF2-40B4-BE49-F238E27FC236}">
-                <a16:creationId xmlns:a16="http://schemas.microsoft.com/office/drawing/2014/main" id="{005F9EA7-5FC9-4084-B230-06E7E891E6B0}"/>
-              </a:ext>
-            </a:extLst>
-          </p:cNvPr>
-          <p:cNvSpPr>
-            <a:spLocks xmlns:a="http://schemas.openxmlformats.org/drawingml/2006/main" noGrp="1"/>
-          </p:cNvSpPr>
-          <p:nvPr/>
-        </p:nvSpPr>
-        <p:spPr>
-          <a:xfrm xmlns:a="http://schemas.openxmlformats.org/drawingml/2006/main">
-            <a:off x="6191250" y="4257675"/>
-            <a:ext cx="5048250" cy="552450"/>
-          </a:xfrm>
-          <a:prstGeom xmlns:a="http://schemas.openxmlformats.org/drawingml/2006/main" prst="rect">
-            <a:avLst/>
-          </a:prstGeom>
-          <a:noFill xmlns:a="http://schemas.openxmlformats.org/drawingml/2006/main"/>
-          <a:ln xmlns:a="http://schemas.openxmlformats.org/drawingml/2006/main" w="0">
-            <a:noFill/>
-            <a:prstDash val="solid"/>
-          </a:ln>
-        </p:spPr>
-        <p:txBody>
-          <a:bodyPr xmlns:a="http://schemas.openxmlformats.org/drawingml/2006/main" anchor="t"/>
-          <a:lstStyle xmlns:a="http://schemas.openxmlformats.org/drawingml/2006/main"/>
-          <a:p xmlns:a="http://schemas.openxmlformats.org/drawingml/2006/main">
-            <a:pPr algn="l">
-              <a:buNone/>
-              <a:defRPr sz="1350" b="0">
-                <a:solidFill>
-                  <a:srgbClr val="243B53"/>
-                </a:solidFill>
-              </a:defRPr>
-            </a:pPr>
-            <a:r>
-              <a:rPr sz="1350" b="0">
-                <a:solidFill>
-                  <a:srgbClr val="243B53"/>
-                </a:solidFill>
-              </a:rPr>
-              <a:t>Net debt = debt assets − liabilities; divide by NI; subtract 1982.</a:t>
-            </a:r>
-          </a:p>
-        </p:txBody>
-      </p:sp>
-      <p:sp>
-        <p:nvSpPr>
-          <p:cNvPr id="17" name="boundary">
-            <a:extLst xmlns:a="http://schemas.openxmlformats.org/drawingml/2006/main">
-              <a:ext uri="{FF2B5EF4-FFF2-40B4-BE49-F238E27FC236}">
-                <a16:creationId xmlns:a16="http://schemas.microsoft.com/office/drawing/2014/main" id="{79FA2934-1CA8-49CA-B94B-8B94B201C7B7}"/>
-              </a:ext>
-            </a:extLst>
-          </p:cNvPr>
-          <p:cNvSpPr>
-            <a:spLocks xmlns:a="http://schemas.openxmlformats.org/drawingml/2006/main" noGrp="1"/>
-          </p:cNvSpPr>
-          <p:nvPr/>
-        </p:nvSpPr>
-        <p:spPr>
-          <a:xfrm xmlns:a="http://schemas.openxmlformats.org/drawingml/2006/main">
-            <a:off x="533400" y="3238500"/>
-            <a:ext cx="4381500" cy="1809750"/>
+              </a:defRPr>
+            </a:pPr>
+            <a:r>
+              <a:rPr sz="1350" b="1">
+                <a:solidFill>
+                  <a:srgbClr val="C65D16"/>
+                </a:solidFill>
+              </a:rPr>
+              <a:t>Selected upper-tail percentiles</a:t>
+            </a:r>
+          </a:p>
+        </p:txBody>
+      </p:sp>
+      <p:sp>
+        <p:nvSpPr>
+          <p:cNvPr id="7" name="Regenerated 2021 safe-asset demand figure-frame">
+            <a:extLst xmlns:a="http://schemas.openxmlformats.org/drawingml/2006/main">
+              <a:ext uri="{FF2B5EF4-FFF2-40B4-BE49-F238E27FC236}">
+                <a16:creationId xmlns:a16="http://schemas.microsoft.com/office/drawing/2014/main" id="{1442A94D-98B9-4DC6-8E97-11AE6BD7202F}"/>
+              </a:ext>
+            </a:extLst>
+          </p:cNvPr>
+          <p:cNvSpPr>
+            <a:spLocks xmlns:a="http://schemas.openxmlformats.org/drawingml/2006/main" noGrp="1"/>
+          </p:cNvSpPr>
+          <p:nvPr/>
+        </p:nvSpPr>
+        <p:spPr>
+          <a:xfrm xmlns:a="http://schemas.openxmlformats.org/drawingml/2006/main">
+            <a:off x="457200" y="1428750"/>
+            <a:ext cx="5410200" cy="3638550"/>
           </a:xfrm>
           <a:prstGeom xmlns:a="http://schemas.openxmlformats.org/drawingml/2006/main" prst="roundRect">
             <a:avLst>
-              <a:gd name="adj" fmla="val 2105"/>
+              <a:gd name="adj" fmla="val 1047"/>
+            </a:avLst>
+          </a:prstGeom>
+          <a:solidFill xmlns:a="http://schemas.openxmlformats.org/drawingml/2006/main">
+            <a:srgbClr val="FFFFFF"/>
+          </a:solidFill>
+          <a:ln xmlns:a="http://schemas.openxmlformats.org/drawingml/2006/main" w="9525">
+            <a:solidFill>
+              <a:srgbClr val="D8E1E8"/>
+            </a:solidFill>
+            <a:prstDash val="solid"/>
+          </a:ln>
+        </p:spPr>
+      </p:sp>
+      <p:sp>
+        <p:nvSpPr>
+          <p:cNvPr id="9" name="2025 Figure 10 safe-asset demand-frame">
+            <a:extLst xmlns:a="http://schemas.openxmlformats.org/drawingml/2006/main">
+              <a:ext uri="{FF2B5EF4-FFF2-40B4-BE49-F238E27FC236}">
+                <a16:creationId xmlns:a16="http://schemas.microsoft.com/office/drawing/2014/main" id="{98F7C92D-66A0-4F20-83BF-E349E5E80E9E}"/>
+              </a:ext>
+            </a:extLst>
+          </p:cNvPr>
+          <p:cNvSpPr>
+            <a:spLocks xmlns:a="http://schemas.openxmlformats.org/drawingml/2006/main" noGrp="1"/>
+          </p:cNvSpPr>
+          <p:nvPr/>
+        </p:nvSpPr>
+        <p:spPr>
+          <a:xfrm xmlns:a="http://schemas.openxmlformats.org/drawingml/2006/main">
+            <a:off x="6324600" y="1428750"/>
+            <a:ext cx="5410200" cy="3638550"/>
+          </a:xfrm>
+          <a:prstGeom xmlns:a="http://schemas.openxmlformats.org/drawingml/2006/main" prst="roundRect">
+            <a:avLst>
+              <a:gd name="adj" fmla="val 1047"/>
+            </a:avLst>
+          </a:prstGeom>
+          <a:solidFill xmlns:a="http://schemas.openxmlformats.org/drawingml/2006/main">
+            <a:srgbClr val="FFFFFF"/>
+          </a:solidFill>
+          <a:ln xmlns:a="http://schemas.openxmlformats.org/drawingml/2006/main" w="9525">
+            <a:solidFill>
+              <a:srgbClr val="D8E1E8"/>
+            </a:solidFill>
+            <a:prstDash val="solid"/>
+          </a:ln>
+        </p:spPr>
+      </p:sp>
+      <p:sp>
+        <p:nvSpPr>
+          <p:cNvPr id="11" name="assessment-band">
+            <a:extLst xmlns:a="http://schemas.openxmlformats.org/drawingml/2006/main">
+              <a:ext uri="{FF2B5EF4-FFF2-40B4-BE49-F238E27FC236}">
+                <a16:creationId xmlns:a16="http://schemas.microsoft.com/office/drawing/2014/main" id="{8E0201B9-6249-4F69-8DD3-3C91F0AFAC32}"/>
+              </a:ext>
+            </a:extLst>
+          </p:cNvPr>
+          <p:cNvSpPr>
+            <a:spLocks xmlns:a="http://schemas.openxmlformats.org/drawingml/2006/main" noGrp="1"/>
+          </p:cNvSpPr>
+          <p:nvPr/>
+        </p:nvSpPr>
+        <p:spPr>
+          <a:xfrm xmlns:a="http://schemas.openxmlformats.org/drawingml/2006/main">
+            <a:off x="457200" y="5219700"/>
+            <a:ext cx="11277600" cy="1219200"/>
+          </a:xfrm>
+          <a:prstGeom xmlns:a="http://schemas.openxmlformats.org/drawingml/2006/main" prst="roundRect">
+            <a:avLst>
+              <a:gd name="adj" fmla="val 3125"/>
             </a:avLst>
           </a:prstGeom>
           <a:solidFill xmlns:a="http://schemas.openxmlformats.org/drawingml/2006/main">
@@ -6494,73 +7171,104 @@
       </p:sp>
       <p:sp>
         <p:nvSpPr>
-          <p:cNvPr id="18" name="boundary-title">
-            <a:extLst xmlns:a="http://schemas.openxmlformats.org/drawingml/2006/main">
-              <a:ext uri="{FF2B5EF4-FFF2-40B4-BE49-F238E27FC236}">
-                <a16:creationId xmlns:a16="http://schemas.microsoft.com/office/drawing/2014/main" id="{90F1D0FA-121D-4208-9F34-9DE0662DF16B}"/>
-              </a:ext>
-            </a:extLst>
-          </p:cNvPr>
-          <p:cNvSpPr>
-            <a:spLocks xmlns:a="http://schemas.openxmlformats.org/drawingml/2006/main" noGrp="1"/>
-          </p:cNvSpPr>
-          <p:nvPr/>
-        </p:nvSpPr>
-        <p:spPr>
-          <a:xfrm xmlns:a="http://schemas.openxmlformats.org/drawingml/2006/main">
-            <a:off x="742950" y="3448050"/>
-            <a:ext cx="1905000" cy="285750"/>
-          </a:xfrm>
-          <a:prstGeom xmlns:a="http://schemas.openxmlformats.org/drawingml/2006/main" prst="rect">
-            <a:avLst/>
-          </a:prstGeom>
-          <a:noFill xmlns:a="http://schemas.openxmlformats.org/drawingml/2006/main"/>
-          <a:ln xmlns:a="http://schemas.openxmlformats.org/drawingml/2006/main" w="0">
-            <a:noFill/>
-            <a:prstDash val="solid"/>
-          </a:ln>
-        </p:spPr>
-        <p:txBody>
-          <a:bodyPr xmlns:a="http://schemas.openxmlformats.org/drawingml/2006/main" anchor="t"/>
-          <a:lstStyle xmlns:a="http://schemas.openxmlformats.org/drawingml/2006/main"/>
-          <a:p xmlns:a="http://schemas.openxmlformats.org/drawingml/2006/main">
-            <a:pPr algn="l">
-              <a:buNone/>
-              <a:defRPr sz="1575" b="1">
-                <a:solidFill>
-                  <a:srgbClr val="B83232"/>
-                </a:solidFill>
-              </a:defRPr>
-            </a:pPr>
-            <a:r>
-              <a:rPr sz="1575" b="1">
-                <a:solidFill>
-                  <a:srgbClr val="B83232"/>
-                </a:solidFill>
-              </a:rPr>
-              <a:t>Classification</a:t>
-            </a:r>
-          </a:p>
-        </p:txBody>
-      </p:sp>
-      <p:sp>
-        <p:nvSpPr>
-          <p:cNvPr id="19" name="boundary-body">
-            <a:extLst xmlns:a="http://schemas.openxmlformats.org/drawingml/2006/main">
-              <a:ext uri="{FF2B5EF4-FFF2-40B4-BE49-F238E27FC236}">
-                <a16:creationId xmlns:a16="http://schemas.microsoft.com/office/drawing/2014/main" id="{DF98F5D6-9D18-45C9-8820-2EA73D0D0CC3}"/>
-              </a:ext>
-            </a:extLst>
-          </p:cNvPr>
-          <p:cNvSpPr>
-            <a:spLocks xmlns:a="http://schemas.openxmlformats.org/drawingml/2006/main" noGrp="1"/>
-          </p:cNvSpPr>
-          <p:nvPr/>
-        </p:nvSpPr>
-        <p:spPr>
-          <a:xfrm xmlns:a="http://schemas.openxmlformats.org/drawingml/2006/main">
-            <a:off x="742950" y="3857625"/>
-            <a:ext cx="3905250" cy="1066800"/>
+          <p:cNvPr id="12" name="assessment-accent">
+            <a:extLst xmlns:a="http://schemas.openxmlformats.org/drawingml/2006/main">
+              <a:ext uri="{FF2B5EF4-FFF2-40B4-BE49-F238E27FC236}">
+                <a16:creationId xmlns:a16="http://schemas.microsoft.com/office/drawing/2014/main" id="{E6607933-8AC4-4796-94EB-F2FB6C0865F1}"/>
+              </a:ext>
+            </a:extLst>
+          </p:cNvPr>
+          <p:cNvSpPr>
+            <a:spLocks xmlns:a="http://schemas.openxmlformats.org/drawingml/2006/main" noGrp="1"/>
+          </p:cNvSpPr>
+          <p:nvPr/>
+        </p:nvSpPr>
+        <p:spPr>
+          <a:xfrm xmlns:a="http://schemas.openxmlformats.org/drawingml/2006/main">
+            <a:off x="457200" y="5219700"/>
+            <a:ext cx="76200" cy="1219200"/>
+          </a:xfrm>
+          <a:prstGeom xmlns:a="http://schemas.openxmlformats.org/drawingml/2006/main" prst="rect">
+            <a:avLst/>
+          </a:prstGeom>
+          <a:solidFill xmlns:a="http://schemas.openxmlformats.org/drawingml/2006/main">
+            <a:srgbClr val="2F855A"/>
+          </a:solidFill>
+          <a:ln xmlns:a="http://schemas.openxmlformats.org/drawingml/2006/main" w="0">
+            <a:noFill/>
+            <a:prstDash val="solid"/>
+          </a:ln>
+        </p:spPr>
+      </p:sp>
+      <p:sp>
+        <p:nvSpPr>
+          <p:cNvPr id="13" name="verdict">
+            <a:extLst xmlns:a="http://schemas.openxmlformats.org/drawingml/2006/main">
+              <a:ext uri="{FF2B5EF4-FFF2-40B4-BE49-F238E27FC236}">
+                <a16:creationId xmlns:a16="http://schemas.microsoft.com/office/drawing/2014/main" id="{DAEE4CAF-C158-4F1E-AF88-9B2A72776725}"/>
+              </a:ext>
+            </a:extLst>
+          </p:cNvPr>
+          <p:cNvSpPr>
+            <a:spLocks xmlns:a="http://schemas.openxmlformats.org/drawingml/2006/main" noGrp="1"/>
+          </p:cNvSpPr>
+          <p:nvPr/>
+        </p:nvSpPr>
+        <p:spPr>
+          <a:xfrm xmlns:a="http://schemas.openxmlformats.org/drawingml/2006/main">
+            <a:off x="685800" y="5362575"/>
+            <a:ext cx="3143250" cy="314325"/>
+          </a:xfrm>
+          <a:prstGeom xmlns:a="http://schemas.openxmlformats.org/drawingml/2006/main" prst="rect">
+            <a:avLst/>
+          </a:prstGeom>
+          <a:noFill xmlns:a="http://schemas.openxmlformats.org/drawingml/2006/main"/>
+          <a:ln xmlns:a="http://schemas.openxmlformats.org/drawingml/2006/main" w="0">
+            <a:noFill/>
+            <a:prstDash val="solid"/>
+          </a:ln>
+        </p:spPr>
+        <p:txBody>
+          <a:bodyPr xmlns:a="http://schemas.openxmlformats.org/drawingml/2006/main" anchor="t"/>
+          <a:lstStyle xmlns:a="http://schemas.openxmlformats.org/drawingml/2006/main"/>
+          <a:p xmlns:a="http://schemas.openxmlformats.org/drawingml/2006/main">
+            <a:pPr algn="l">
+              <a:buNone/>
+              <a:defRPr sz="1725" b="1">
+                <a:solidFill>
+                  <a:srgbClr val="2F855A"/>
+                </a:solidFill>
+              </a:defRPr>
+            </a:pPr>
+            <a:r>
+              <a:rPr sz="1725" b="1">
+                <a:solidFill>
+                  <a:srgbClr val="2F855A"/>
+                </a:solidFill>
+              </a:rPr>
+              <a:t>NOT A SINGLE BREAK</a:t>
+            </a:r>
+          </a:p>
+        </p:txBody>
+      </p:sp>
+      <p:sp>
+        <p:nvSpPr>
+          <p:cNvPr id="14" name="assessment">
+            <a:extLst xmlns:a="http://schemas.openxmlformats.org/drawingml/2006/main">
+              <a:ext uri="{FF2B5EF4-FFF2-40B4-BE49-F238E27FC236}">
+                <a16:creationId xmlns:a16="http://schemas.microsoft.com/office/drawing/2014/main" id="{F5E1C807-0687-4A75-8864-05548460D9A0}"/>
+              </a:ext>
+            </a:extLst>
+          </p:cNvPr>
+          <p:cNvSpPr>
+            <a:spLocks xmlns:a="http://schemas.openxmlformats.org/drawingml/2006/main" noGrp="1"/>
+          </p:cNvSpPr>
+          <p:nvPr/>
+        </p:nvSpPr>
+        <p:spPr>
+          <a:xfrm xmlns:a="http://schemas.openxmlformats.org/drawingml/2006/main">
+            <a:off x="3857625" y="5334000"/>
+            <a:ext cx="7620000" cy="457200"/>
           </a:xfrm>
           <a:prstGeom xmlns:a="http://schemas.openxmlformats.org/drawingml/2006/main" prst="rect">
             <a:avLst/>
@@ -6589,15 +7297,110 @@
                   <a:srgbClr val="243B53"/>
                 </a:solidFill>
               </a:rPr>
-              <a:t>Proxy: group, sign, scale, and base are revised; unveiled asset stocks still come from the older method.</a:t>
-            </a:r>
-          </a:p>
-        </p:txBody>
-      </p:sp>
+              <a:t>The 80th–90th percentiles decline persistently after the late 1980s.</a:t>
+            </a:r>
+          </a:p>
+        </p:txBody>
+      </p:sp>
+      <p:sp>
+        <p:nvSpPr>
+          <p:cNvPr id="15" name="difference">
+            <a:extLst xmlns:a="http://schemas.openxmlformats.org/drawingml/2006/main">
+              <a:ext uri="{FF2B5EF4-FFF2-40B4-BE49-F238E27FC236}">
+                <a16:creationId xmlns:a16="http://schemas.microsoft.com/office/drawing/2014/main" id="{9E94ECB7-8637-4F89-9ABB-1A8B2FEF54E1}"/>
+              </a:ext>
+            </a:extLst>
+          </p:cNvPr>
+          <p:cNvSpPr>
+            <a:spLocks xmlns:a="http://schemas.openxmlformats.org/drawingml/2006/main" noGrp="1"/>
+          </p:cNvSpPr>
+          <p:nvPr/>
+        </p:nvSpPr>
+        <p:spPr>
+          <a:xfrm xmlns:a="http://schemas.openxmlformats.org/drawingml/2006/main">
+            <a:off x="685800" y="5848350"/>
+            <a:ext cx="10763250" cy="400050"/>
+          </a:xfrm>
+          <a:prstGeom xmlns:a="http://schemas.openxmlformats.org/drawingml/2006/main" prst="rect">
+            <a:avLst/>
+          </a:prstGeom>
+          <a:noFill xmlns:a="http://schemas.openxmlformats.org/drawingml/2006/main"/>
+          <a:ln xmlns:a="http://schemas.openxmlformats.org/drawingml/2006/main" w="0">
+            <a:noFill/>
+            <a:prstDash val="solid"/>
+          </a:ln>
+        </p:spPr>
+        <p:txBody>
+          <a:bodyPr xmlns:a="http://schemas.openxmlformats.org/drawingml/2006/main" anchor="t"/>
+          <a:lstStyle xmlns:a="http://schemas.openxmlformats.org/drawingml/2006/main"/>
+          <a:p xmlns:a="http://schemas.openxmlformats.org/drawingml/2006/main">
+            <a:pPr algn="l">
+              <a:buNone/>
+              <a:defRPr sz="1200" b="0">
+                <a:solidFill>
+                  <a:srgbClr val="627D98"/>
+                </a:solidFill>
+              </a:defRPr>
+            </a:pPr>
+            <a:r>
+              <a:rPr sz="1200" b="0">
+                <a:solidFill>
+                  <a:srgbClr val="627D98"/>
+                </a:solidFill>
+              </a:rPr>
+              <a:t>The top 1% oscillates sharply, including a 2008 five-year peak; this is not one smooth monotone trend.</a:t>
+            </a:r>
+          </a:p>
+        </p:txBody>
+      </p:sp>
+      <p:pic>
+        <p:nvPicPr>
+          <p:cNvPr id="32" name=""/>
+          <p:cNvPicPr>
+            <a:picLocks xmlns:a="http://schemas.openxmlformats.org/drawingml/2006/main" noChangeAspect="1"/>
+          </p:cNvPicPr>
+          <p:nvPr/>
+        </p:nvPicPr>
+        <p:blipFill>
+          <a:blip xmlns:r="http://schemas.openxmlformats.org/officeDocument/2006/relationships" xmlns:a="http://schemas.openxmlformats.org/drawingml/2006/main" r:embed="Racc47952e25f4bfb"/>
+          <a:stretch xmlns:a="http://schemas.openxmlformats.org/drawingml/2006/main"/>
+        </p:blipFill>
+        <p:spPr>
+          <a:xfrm xmlns:a="http://schemas.openxmlformats.org/drawingml/2006/main" flipH="0" flipV="0">
+            <a:off x="632746" y="1552099"/>
+            <a:ext cx="5059204" cy="3372802"/>
+          </a:xfrm>
+          <a:prstGeom xmlns:a="http://schemas.openxmlformats.org/drawingml/2006/main" prst="rect">
+            <a:avLst/>
+          </a:prstGeom>
+        </p:spPr>
+      </p:pic>
+      <p:pic>
+        <p:nvPicPr>
+          <p:cNvPr id="33" name=""/>
+          <p:cNvPicPr>
+            <a:picLocks xmlns:a="http://schemas.openxmlformats.org/drawingml/2006/main" noChangeAspect="1"/>
+          </p:cNvPicPr>
+          <p:nvPr/>
+        </p:nvPicPr>
+        <p:blipFill>
+          <a:blip xmlns:r="http://schemas.openxmlformats.org/officeDocument/2006/relationships" xmlns:a="http://schemas.openxmlformats.org/drawingml/2006/main" r:embed="R02cfb27218314478"/>
+          <a:stretch xmlns:a="http://schemas.openxmlformats.org/drawingml/2006/main"/>
+        </p:blipFill>
+        <p:spPr>
+          <a:xfrm xmlns:a="http://schemas.openxmlformats.org/drawingml/2006/main" flipH="0" flipV="0">
+            <a:off x="6450393" y="1776603"/>
+            <a:ext cx="5158614" cy="2923699"/>
+          </a:xfrm>
+          <a:prstGeom xmlns:a="http://schemas.openxmlformats.org/drawingml/2006/main" prst="rect">
+            <a:avLst/>
+          </a:prstGeom>
+        </p:spPr>
+      </p:pic>
     </p:spTree>
     <p:extLst>
       <p:ext uri="{BB962C8B-B14F-4D97-AF65-F5344CB8AC3E}">
-        <p14:creationId xmlns:p14="http://schemas.microsoft.com/office/powerpoint/2010/main" val="221189521"/>
+        <p14:creationId xmlns:p14="http://schemas.microsoft.com/office/powerpoint/2010/main" val="1065330000"/>
       </p:ext>
     </p:extLst>
   </p:cSld>
@@ -6625,10 +7428,10 @@
       </p:grpSpPr>
       <p:sp>
         <p:nvSpPr>
-          <p:cNvPr id="16" name="kicker">
-            <a:extLst xmlns:a="http://schemas.openxmlformats.org/drawingml/2006/main">
-              <a:ext uri="{FF2B5EF4-FFF2-40B4-BE49-F238E27FC236}">
-                <a16:creationId xmlns:a16="http://schemas.microsoft.com/office/drawing/2014/main" id="{AA955CD9-B4EF-4E20-A3FC-1D7B4F59A354}"/>
+          <p:cNvPr id="20" name="kicker">
+            <a:extLst xmlns:a="http://schemas.openxmlformats.org/drawingml/2006/main">
+              <a:ext uri="{FF2B5EF4-FFF2-40B4-BE49-F238E27FC236}">
+                <a16:creationId xmlns:a16="http://schemas.microsoft.com/office/drawing/2014/main" id="{4DBD74DF-ED28-4EE9-8535-9E366A67537D}"/>
               </a:ext>
             </a:extLst>
           </p:cNvPr>
@@ -6669,7 +7472,7 @@
                   <a:srgbClr val="C65D16"/>
                 </a:solidFill>
               </a:rPr>
-              <a:t>FIGURE 8 PRIMARY COMPARISON</a:t>
+              <a:t>FIGURE 8 FEASIBILITY</a:t>
             </a:r>
           </a:p>
         </p:txBody>
@@ -6679,7 +7482,7 @@
           <p:cNvPr id="2" name="title">
             <a:extLst xmlns:a="http://schemas.openxmlformats.org/drawingml/2006/main">
               <a:ext uri="{FF2B5EF4-FFF2-40B4-BE49-F238E27FC236}">
-                <a16:creationId xmlns:a16="http://schemas.microsoft.com/office/drawing/2014/main" id="{BE8A36E9-77A3-4197-AAEB-944D96A22E35}"/>
+                <a16:creationId xmlns:a16="http://schemas.microsoft.com/office/drawing/2014/main" id="{25994307-319F-4EAA-8D7C-9E832F74B960}"/>
               </a:ext>
             </a:extLst>
           </p:cNvPr>
@@ -6720,7 +7523,7 @@
                   <a:srgbClr val="102A43"/>
                 </a:solidFill>
               </a:rPr>
-              <a:t>The proxy reproduces borrowing, but understates top-1 lending</a:t>
+              <a:t>Figure 8 stops one step before the revised matrix solve</a:t>
             </a:r>
           </a:p>
         </p:txBody>
@@ -6730,7 +7533,7 @@
           <p:cNvPr id="3" name="header-rule">
             <a:extLst xmlns:a="http://schemas.openxmlformats.org/drawingml/2006/main">
               <a:ext uri="{FF2B5EF4-FFF2-40B4-BE49-F238E27FC236}">
-                <a16:creationId xmlns:a16="http://schemas.microsoft.com/office/drawing/2014/main" id="{514C6BB1-D2D7-4502-B63E-CB46F5220FD9}"/>
+                <a16:creationId xmlns:a16="http://schemas.microsoft.com/office/drawing/2014/main" id="{9304C898-8A92-4A39-A7EB-64A100354E4A}"/>
               </a:ext>
             </a:extLst>
           </p:cNvPr>
@@ -6761,7 +7564,7 @@
           <p:cNvPr id="4" name="slide-number">
             <a:extLst xmlns:a="http://schemas.openxmlformats.org/drawingml/2006/main">
               <a:ext uri="{FF2B5EF4-FFF2-40B4-BE49-F238E27FC236}">
-                <a16:creationId xmlns:a16="http://schemas.microsoft.com/office/drawing/2014/main" id="{1846DD66-DAE1-4F4D-9638-E1108AC93C86}"/>
+                <a16:creationId xmlns:a16="http://schemas.microsoft.com/office/drawing/2014/main" id="{E4772364-3993-46C7-BB6A-7696849F37B9}"/>
               </a:ext>
             </a:extLst>
           </p:cNvPr>
@@ -6809,198 +7612,576 @@
       </p:sp>
       <p:sp>
         <p:nvSpPr>
-          <p:cNvPr id="5" name="left-label">
-            <a:extLst xmlns:a="http://schemas.openxmlformats.org/drawingml/2006/main">
-              <a:ext uri="{FF2B5EF4-FFF2-40B4-BE49-F238E27FC236}">
-                <a16:creationId xmlns:a16="http://schemas.microsoft.com/office/drawing/2014/main" id="{AC7EBFD9-49FB-40B3-B7BA-0564A41A3ADA}"/>
-              </a:ext>
-            </a:extLst>
-          </p:cNvPr>
-          <p:cNvSpPr>
-            <a:spLocks xmlns:a="http://schemas.openxmlformats.org/drawingml/2006/main" noGrp="1"/>
-          </p:cNvSpPr>
-          <p:nvPr/>
-        </p:nvSpPr>
-        <p:spPr>
-          <a:xfrm xmlns:a="http://schemas.openxmlformats.org/drawingml/2006/main">
-            <a:off x="457200" y="1123950"/>
-            <a:ext cx="5334000" cy="266700"/>
-          </a:xfrm>
-          <a:prstGeom xmlns:a="http://schemas.openxmlformats.org/drawingml/2006/main" prst="rect">
-            <a:avLst/>
-          </a:prstGeom>
-          <a:noFill xmlns:a="http://schemas.openxmlformats.org/drawingml/2006/main"/>
-          <a:ln xmlns:a="http://schemas.openxmlformats.org/drawingml/2006/main" w="0">
-            <a:noFill/>
-            <a:prstDash val="solid"/>
-          </a:ln>
-        </p:spPr>
-        <p:txBody>
-          <a:bodyPr xmlns:a="http://schemas.openxmlformats.org/drawingml/2006/main" anchor="t"/>
-          <a:lstStyle xmlns:a="http://schemas.openxmlformats.org/drawingml/2006/main"/>
-          <a:p xmlns:a="http://schemas.openxmlformats.org/drawingml/2006/main">
-            <a:pPr algn="l">
-              <a:buNone/>
-              <a:defRPr sz="1350" b="1">
+          <p:cNvPr id="5" name="question">
+            <a:extLst xmlns:a="http://schemas.openxmlformats.org/drawingml/2006/main">
+              <a:ext uri="{FF2B5EF4-FFF2-40B4-BE49-F238E27FC236}">
+                <a16:creationId xmlns:a16="http://schemas.microsoft.com/office/drawing/2014/main" id="{1C4CBB66-390B-40CA-9A94-F3B655FADD50}"/>
+              </a:ext>
+            </a:extLst>
+          </p:cNvPr>
+          <p:cNvSpPr>
+            <a:spLocks xmlns:a="http://schemas.openxmlformats.org/drawingml/2006/main" noGrp="1"/>
+          </p:cNvSpPr>
+          <p:nvPr/>
+        </p:nvSpPr>
+        <p:spPr>
+          <a:xfrm xmlns:a="http://schemas.openxmlformats.org/drawingml/2006/main">
+            <a:off x="533400" y="1333500"/>
+            <a:ext cx="2095500" cy="323850"/>
+          </a:xfrm>
+          <a:prstGeom xmlns:a="http://schemas.openxmlformats.org/drawingml/2006/main" prst="rect">
+            <a:avLst/>
+          </a:prstGeom>
+          <a:noFill xmlns:a="http://schemas.openxmlformats.org/drawingml/2006/main"/>
+          <a:ln xmlns:a="http://schemas.openxmlformats.org/drawingml/2006/main" w="0">
+            <a:noFill/>
+            <a:prstDash val="solid"/>
+          </a:ln>
+        </p:spPr>
+        <p:txBody>
+          <a:bodyPr xmlns:a="http://schemas.openxmlformats.org/drawingml/2006/main" anchor="t"/>
+          <a:lstStyle xmlns:a="http://schemas.openxmlformats.org/drawingml/2006/main"/>
+          <a:p xmlns:a="http://schemas.openxmlformats.org/drawingml/2006/main">
+            <a:pPr algn="l">
+              <a:buNone/>
+              <a:defRPr sz="1650" b="1">
+                <a:solidFill>
+                  <a:srgbClr val="102A43"/>
+                </a:solidFill>
+              </a:defRPr>
+            </a:pPr>
+            <a:r>
+              <a:rPr sz="1650" b="1">
+                <a:solidFill>
+                  <a:srgbClr val="102A43"/>
+                </a:solidFill>
+              </a:rPr>
+              <a:t>Target</a:t>
+            </a:r>
+          </a:p>
+        </p:txBody>
+      </p:sp>
+      <p:sp>
+        <p:nvSpPr>
+          <p:cNvPr id="6" name="question-body">
+            <a:extLst xmlns:a="http://schemas.openxmlformats.org/drawingml/2006/main">
+              <a:ext uri="{FF2B5EF4-FFF2-40B4-BE49-F238E27FC236}">
+                <a16:creationId xmlns:a16="http://schemas.microsoft.com/office/drawing/2014/main" id="{C7924291-5CE5-45A7-9502-25780E8749E1}"/>
+              </a:ext>
+            </a:extLst>
+          </p:cNvPr>
+          <p:cNvSpPr>
+            <a:spLocks xmlns:a="http://schemas.openxmlformats.org/drawingml/2006/main" noGrp="1"/>
+          </p:cNvSpPr>
+          <p:nvPr/>
+        </p:nvSpPr>
+        <p:spPr>
+          <a:xfrm xmlns:a="http://schemas.openxmlformats.org/drawingml/2006/main">
+            <a:off x="533400" y="1733550"/>
+            <a:ext cx="4381500" cy="1123950"/>
+          </a:xfrm>
+          <a:prstGeom xmlns:a="http://schemas.openxmlformats.org/drawingml/2006/main" prst="rect">
+            <a:avLst/>
+          </a:prstGeom>
+          <a:noFill xmlns:a="http://schemas.openxmlformats.org/drawingml/2006/main"/>
+          <a:ln xmlns:a="http://schemas.openxmlformats.org/drawingml/2006/main" w="0">
+            <a:noFill/>
+            <a:prstDash val="solid"/>
+          </a:ln>
+        </p:spPr>
+        <p:txBody>
+          <a:bodyPr xmlns:a="http://schemas.openxmlformats.org/drawingml/2006/main" anchor="t"/>
+          <a:lstStyle xmlns:a="http://schemas.openxmlformats.org/drawingml/2006/main"/>
+          <a:p xmlns:a="http://schemas.openxmlformats.org/drawingml/2006/main">
+            <a:pPr algn="l">
+              <a:buNone/>
+              <a:defRPr sz="1875" b="0">
+                <a:solidFill>
+                  <a:srgbClr val="243B53"/>
+                </a:solidFill>
+              </a:defRPr>
+            </a:pPr>
+            <a:r>
+              <a:rPr sz="1875" b="0">
+                <a:solidFill>
+                  <a:srgbClr val="243B53"/>
+                </a:solidFill>
+              </a:rPr>
+              <a:t>2025 Figure 8</a:t>
+            </a:r>
+          </a:p>
+          <a:p xmlns:a="http://schemas.openxmlformats.org/drawingml/2006/main">
+            <a:pPr algn="l">
+              <a:buNone/>
+              <a:defRPr sz="1875" b="0">
+                <a:solidFill>
+                  <a:srgbClr val="243B53"/>
+                </a:solidFill>
+              </a:defRPr>
+            </a:pPr>
+            <a:r>
+              <a:rPr sz="1875" b="0">
+                <a:solidFill>
+                  <a:srgbClr val="243B53"/>
+                </a:solidFill>
+              </a:rPr>
+              <a:t>Net household debt by wealth group</a:t>
+            </a:r>
+          </a:p>
+        </p:txBody>
+      </p:sp>
+      <p:sp>
+        <p:nvSpPr>
+          <p:cNvPr id="7" name="divider">
+            <a:extLst xmlns:a="http://schemas.openxmlformats.org/drawingml/2006/main">
+              <a:ext uri="{FF2B5EF4-FFF2-40B4-BE49-F238E27FC236}">
+                <a16:creationId xmlns:a16="http://schemas.microsoft.com/office/drawing/2014/main" id="{F04E65CB-1300-417C-A552-521BE00891D3}"/>
+              </a:ext>
+            </a:extLst>
+          </p:cNvPr>
+          <p:cNvSpPr>
+            <a:spLocks xmlns:a="http://schemas.openxmlformats.org/drawingml/2006/main" noGrp="1"/>
+          </p:cNvSpPr>
+          <p:nvPr/>
+        </p:nvSpPr>
+        <p:spPr>
+          <a:xfrm xmlns:a="http://schemas.openxmlformats.org/drawingml/2006/main">
+            <a:off x="5391150" y="1285875"/>
+            <a:ext cx="19050" cy="4381500"/>
+          </a:xfrm>
+          <a:prstGeom xmlns:a="http://schemas.openxmlformats.org/drawingml/2006/main" prst="rect">
+            <a:avLst/>
+          </a:prstGeom>
+          <a:solidFill xmlns:a="http://schemas.openxmlformats.org/drawingml/2006/main">
+            <a:srgbClr val="D8E1E8"/>
+          </a:solidFill>
+          <a:ln xmlns:a="http://schemas.openxmlformats.org/drawingml/2006/main" w="0">
+            <a:noFill/>
+            <a:prstDash val="solid"/>
+          </a:ln>
+        </p:spPr>
+      </p:sp>
+      <p:sp>
+        <p:nvSpPr>
+          <p:cNvPr id="8" name="Strong precursor-bar">
+            <a:extLst xmlns:a="http://schemas.openxmlformats.org/drawingml/2006/main">
+              <a:ext uri="{FF2B5EF4-FFF2-40B4-BE49-F238E27FC236}">
+                <a16:creationId xmlns:a16="http://schemas.microsoft.com/office/drawing/2014/main" id="{80A9BBD5-0978-4A47-9DE6-A7D2756C4BC7}"/>
+              </a:ext>
+            </a:extLst>
+          </p:cNvPr>
+          <p:cNvSpPr>
+            <a:spLocks xmlns:a="http://schemas.openxmlformats.org/drawingml/2006/main" noGrp="1"/>
+          </p:cNvSpPr>
+          <p:nvPr/>
+        </p:nvSpPr>
+        <p:spPr>
+          <a:xfrm xmlns:a="http://schemas.openxmlformats.org/drawingml/2006/main">
+            <a:off x="5905500" y="1333500"/>
+            <a:ext cx="76200" cy="952500"/>
+          </a:xfrm>
+          <a:prstGeom xmlns:a="http://schemas.openxmlformats.org/drawingml/2006/main" prst="rect">
+            <a:avLst/>
+          </a:prstGeom>
+          <a:solidFill xmlns:a="http://schemas.openxmlformats.org/drawingml/2006/main">
+            <a:srgbClr val="8A96A3"/>
+          </a:solidFill>
+          <a:ln xmlns:a="http://schemas.openxmlformats.org/drawingml/2006/main" w="0">
+            <a:noFill/>
+            <a:prstDash val="solid"/>
+          </a:ln>
+        </p:spPr>
+      </p:sp>
+      <p:sp>
+        <p:nvSpPr>
+          <p:cNvPr id="9" name="Strong precursor-label">
+            <a:extLst xmlns:a="http://schemas.openxmlformats.org/drawingml/2006/main">
+              <a:ext uri="{FF2B5EF4-FFF2-40B4-BE49-F238E27FC236}">
+                <a16:creationId xmlns:a16="http://schemas.microsoft.com/office/drawing/2014/main" id="{51CC7C6F-9EBD-42A3-9CD8-DD0C6EE988A5}"/>
+              </a:ext>
+            </a:extLst>
+          </p:cNvPr>
+          <p:cNvSpPr>
+            <a:spLocks xmlns:a="http://schemas.openxmlformats.org/drawingml/2006/main" noGrp="1"/>
+          </p:cNvSpPr>
+          <p:nvPr/>
+        </p:nvSpPr>
+        <p:spPr>
+          <a:xfrm xmlns:a="http://schemas.openxmlformats.org/drawingml/2006/main">
+            <a:off x="6191250" y="1371600"/>
+            <a:ext cx="2476500" cy="285750"/>
+          </a:xfrm>
+          <a:prstGeom xmlns:a="http://schemas.openxmlformats.org/drawingml/2006/main" prst="rect">
+            <a:avLst/>
+          </a:prstGeom>
+          <a:noFill xmlns:a="http://schemas.openxmlformats.org/drawingml/2006/main"/>
+          <a:ln xmlns:a="http://schemas.openxmlformats.org/drawingml/2006/main" w="0">
+            <a:noFill/>
+            <a:prstDash val="solid"/>
+          </a:ln>
+        </p:spPr>
+        <p:txBody>
+          <a:bodyPr xmlns:a="http://schemas.openxmlformats.org/drawingml/2006/main" anchor="t"/>
+          <a:lstStyle xmlns:a="http://schemas.openxmlformats.org/drawingml/2006/main"/>
+          <a:p xmlns:a="http://schemas.openxmlformats.org/drawingml/2006/main">
+            <a:pPr algn="l">
+              <a:buNone/>
+              <a:defRPr sz="1725" b="1">
+                <a:solidFill>
+                  <a:srgbClr val="2F855A"/>
+                </a:solidFill>
+              </a:defRPr>
+            </a:pPr>
+            <a:r>
+              <a:rPr sz="1725" b="1">
+                <a:solidFill>
+                  <a:srgbClr val="627D98"/>
+                </a:solidFill>
+              </a:rPr>
+              <a:t>1 · Missing upstream</a:t>
+            </a:r>
+          </a:p>
+        </p:txBody>
+      </p:sp>
+      <p:sp>
+        <p:nvSpPr>
+          <p:cNvPr id="10" name="Strong precursor-body">
+            <a:extLst xmlns:a="http://schemas.openxmlformats.org/drawingml/2006/main">
+              <a:ext uri="{FF2B5EF4-FFF2-40B4-BE49-F238E27FC236}">
+                <a16:creationId xmlns:a16="http://schemas.microsoft.com/office/drawing/2014/main" id="{244FF233-0930-4770-ADF3-1B1A9250D6B7}"/>
+              </a:ext>
+            </a:extLst>
+          </p:cNvPr>
+          <p:cNvSpPr>
+            <a:spLocks xmlns:a="http://schemas.openxmlformats.org/drawingml/2006/main" noGrp="1"/>
+          </p:cNvSpPr>
+          <p:nvPr/>
+        </p:nvSpPr>
+        <p:spPr>
+          <a:xfrm xmlns:a="http://schemas.openxmlformats.org/drawingml/2006/main">
+            <a:off x="6191250" y="1704975"/>
+            <a:ext cx="5048250" cy="552450"/>
+          </a:xfrm>
+          <a:prstGeom xmlns:a="http://schemas.openxmlformats.org/drawingml/2006/main" prst="rect">
+            <a:avLst/>
+          </a:prstGeom>
+          <a:noFill xmlns:a="http://schemas.openxmlformats.org/drawingml/2006/main"/>
+          <a:ln xmlns:a="http://schemas.openxmlformats.org/drawingml/2006/main" w="0">
+            <a:noFill/>
+            <a:prstDash val="solid"/>
+          </a:ln>
+        </p:spPr>
+        <p:txBody>
+          <a:bodyPr xmlns:a="http://schemas.openxmlformats.org/drawingml/2006/main" anchor="t"/>
+          <a:lstStyle xmlns:a="http://schemas.openxmlformats.org/drawingml/2006/main"/>
+          <a:p xmlns:a="http://schemas.openxmlformats.org/drawingml/2006/main">
+            <a:pPr algn="l">
+              <a:buNone/>
+              <a:defRPr sz="1350" b="0">
+                <a:solidFill>
+                  <a:srgbClr val="243B53"/>
+                </a:solidFill>
+              </a:defRPr>
+            </a:pPr>
+            <a:r>
+              <a:rPr sz="1350" b="0">
+                <a:solidFill>
+                  <a:srgbClr val="243B53"/>
+                </a:solidFill>
+              </a:rPr>
+              <a:t>Completed 2025 instrument × sector matrices and augmented household columns.</a:t>
+            </a:r>
+          </a:p>
+        </p:txBody>
+      </p:sp>
+      <p:sp>
+        <p:nvSpPr>
+          <p:cNvPr id="11" name="Partial match-bar">
+            <a:extLst xmlns:a="http://schemas.openxmlformats.org/drawingml/2006/main">
+              <a:ext uri="{FF2B5EF4-FFF2-40B4-BE49-F238E27FC236}">
+                <a16:creationId xmlns:a16="http://schemas.microsoft.com/office/drawing/2014/main" id="{F0181655-D030-45C0-A3E0-D81445F8830B}"/>
+              </a:ext>
+            </a:extLst>
+          </p:cNvPr>
+          <p:cNvSpPr>
+            <a:spLocks xmlns:a="http://schemas.openxmlformats.org/drawingml/2006/main" noGrp="1"/>
+          </p:cNvSpPr>
+          <p:nvPr/>
+        </p:nvSpPr>
+        <p:spPr>
+          <a:xfrm xmlns:a="http://schemas.openxmlformats.org/drawingml/2006/main">
+            <a:off x="5905500" y="2609850"/>
+            <a:ext cx="76200" cy="952500"/>
+          </a:xfrm>
+          <a:prstGeom xmlns:a="http://schemas.openxmlformats.org/drawingml/2006/main" prst="rect">
+            <a:avLst/>
+          </a:prstGeom>
+          <a:solidFill xmlns:a="http://schemas.openxmlformats.org/drawingml/2006/main">
+            <a:srgbClr val="2E5B88"/>
+          </a:solidFill>
+          <a:ln xmlns:a="http://schemas.openxmlformats.org/drawingml/2006/main" w="0">
+            <a:noFill/>
+            <a:prstDash val="solid"/>
+          </a:ln>
+        </p:spPr>
+      </p:sp>
+      <p:sp>
+        <p:nvSpPr>
+          <p:cNvPr id="12" name="Partial match-label">
+            <a:extLst xmlns:a="http://schemas.openxmlformats.org/drawingml/2006/main">
+              <a:ext uri="{FF2B5EF4-FFF2-40B4-BE49-F238E27FC236}">
+                <a16:creationId xmlns:a16="http://schemas.microsoft.com/office/drawing/2014/main" id="{217D0269-3366-4106-A614-BFB2DD0B2ECF}"/>
+              </a:ext>
+            </a:extLst>
+          </p:cNvPr>
+          <p:cNvSpPr>
+            <a:spLocks xmlns:a="http://schemas.openxmlformats.org/drawingml/2006/main" noGrp="1"/>
+          </p:cNvSpPr>
+          <p:nvPr/>
+        </p:nvSpPr>
+        <p:spPr>
+          <a:xfrm xmlns:a="http://schemas.openxmlformats.org/drawingml/2006/main">
+            <a:off x="6191250" y="2647950"/>
+            <a:ext cx="2476500" cy="285750"/>
+          </a:xfrm>
+          <a:prstGeom xmlns:a="http://schemas.openxmlformats.org/drawingml/2006/main" prst="rect">
+            <a:avLst/>
+          </a:prstGeom>
+          <a:noFill xmlns:a="http://schemas.openxmlformats.org/drawingml/2006/main"/>
+          <a:ln xmlns:a="http://schemas.openxmlformats.org/drawingml/2006/main" w="0">
+            <a:noFill/>
+            <a:prstDash val="solid"/>
+          </a:ln>
+        </p:spPr>
+        <p:txBody>
+          <a:bodyPr xmlns:a="http://schemas.openxmlformats.org/drawingml/2006/main" anchor="t"/>
+          <a:lstStyle xmlns:a="http://schemas.openxmlformats.org/drawingml/2006/main"/>
+          <a:p xmlns:a="http://schemas.openxmlformats.org/drawingml/2006/main">
+            <a:pPr algn="l">
+              <a:buNone/>
+              <a:defRPr sz="1725" b="1">
+                <a:solidFill>
+                  <a:srgbClr val="B7791F"/>
+                </a:solidFill>
+              </a:defRPr>
+            </a:pPr>
+            <a:r>
+              <a:rPr sz="1725" b="1">
                 <a:solidFill>
                   <a:srgbClr val="2E5B88"/>
                 </a:solidFill>
-              </a:defRPr>
-            </a:pPr>
-            <a:r>
-              <a:rPr sz="1350" b="1">
-                <a:solidFill>
-                  <a:srgbClr val="2E5B88"/>
-                </a:solidFill>
-              </a:rPr>
-              <a:t>2025 paper · ratio axis (0.10 = 10 pp)</a:t>
-            </a:r>
-          </a:p>
-        </p:txBody>
-      </p:sp>
-      <p:sp>
-        <p:nvSpPr>
-          <p:cNvPr id="6" name="right-label">
-            <a:extLst xmlns:a="http://schemas.openxmlformats.org/drawingml/2006/main">
-              <a:ext uri="{FF2B5EF4-FFF2-40B4-BE49-F238E27FC236}">
-                <a16:creationId xmlns:a16="http://schemas.microsoft.com/office/drawing/2014/main" id="{D7EBD11C-5C33-487B-AFE7-65F7CD7D2108}"/>
-              </a:ext>
-            </a:extLst>
-          </p:cNvPr>
-          <p:cNvSpPr>
-            <a:spLocks xmlns:a="http://schemas.openxmlformats.org/drawingml/2006/main" noGrp="1"/>
-          </p:cNvSpPr>
-          <p:nvPr/>
-        </p:nvSpPr>
-        <p:spPr>
-          <a:xfrm xmlns:a="http://schemas.openxmlformats.org/drawingml/2006/main">
-            <a:off x="6324600" y="1123950"/>
-            <a:ext cx="5410200" cy="266700"/>
-          </a:xfrm>
-          <a:prstGeom xmlns:a="http://schemas.openxmlformats.org/drawingml/2006/main" prst="rect">
-            <a:avLst/>
-          </a:prstGeom>
-          <a:noFill xmlns:a="http://schemas.openxmlformats.org/drawingml/2006/main"/>
-          <a:ln xmlns:a="http://schemas.openxmlformats.org/drawingml/2006/main" w="0">
-            <a:noFill/>
-            <a:prstDash val="solid"/>
-          </a:ln>
-        </p:spPr>
-        <p:txBody>
-          <a:bodyPr xmlns:a="http://schemas.openxmlformats.org/drawingml/2006/main" anchor="t"/>
-          <a:lstStyle xmlns:a="http://schemas.openxmlformats.org/drawingml/2006/main"/>
-          <a:p xmlns:a="http://schemas.openxmlformats.org/drawingml/2006/main">
-            <a:pPr algn="l">
-              <a:buNone/>
-              <a:defRPr sz="1350" b="1">
+              </a:rPr>
+              <a:t>2 · Old-kit output</a:t>
+            </a:r>
+          </a:p>
+        </p:txBody>
+      </p:sp>
+      <p:sp>
+        <p:nvSpPr>
+          <p:cNvPr id="13" name="Partial match-body">
+            <a:extLst xmlns:a="http://schemas.openxmlformats.org/drawingml/2006/main">
+              <a:ext uri="{FF2B5EF4-FFF2-40B4-BE49-F238E27FC236}">
+                <a16:creationId xmlns:a16="http://schemas.microsoft.com/office/drawing/2014/main" id="{00ABC748-B2B5-4893-8CE6-FDE63773F6C0}"/>
+              </a:ext>
+            </a:extLst>
+          </p:cNvPr>
+          <p:cNvSpPr>
+            <a:spLocks xmlns:a="http://schemas.openxmlformats.org/drawingml/2006/main" noGrp="1"/>
+          </p:cNvSpPr>
+          <p:nvPr/>
+        </p:nvSpPr>
+        <p:spPr>
+          <a:xfrm xmlns:a="http://schemas.openxmlformats.org/drawingml/2006/main">
+            <a:off x="6191250" y="2981325"/>
+            <a:ext cx="5048250" cy="552450"/>
+          </a:xfrm>
+          <a:prstGeom xmlns:a="http://schemas.openxmlformats.org/drawingml/2006/main" prst="rect">
+            <a:avLst/>
+          </a:prstGeom>
+          <a:noFill xmlns:a="http://schemas.openxmlformats.org/drawingml/2006/main"/>
+          <a:ln xmlns:a="http://schemas.openxmlformats.org/drawingml/2006/main" w="0">
+            <a:noFill/>
+            <a:prstDash val="solid"/>
+          </a:ln>
+        </p:spPr>
+        <p:txBody>
+          <a:bodyPr xmlns:a="http://schemas.openxmlformats.org/drawingml/2006/main" anchor="t"/>
+          <a:lstStyle xmlns:a="http://schemas.openxmlformats.org/drawingml/2006/main"/>
+          <a:p xmlns:a="http://schemas.openxmlformats.org/drawingml/2006/main">
+            <a:pPr algn="l">
+              <a:buNone/>
+              <a:defRPr sz="1350" b="0">
+                <a:solidFill>
+                  <a:srgbClr val="243B53"/>
+                </a:solidFill>
+              </a:defRPr>
+            </a:pPr>
+            <a:r>
+              <a:rPr sz="1350" b="0">
+                <a:solidFill>
+                  <a:srgbClr val="243B53"/>
+                </a:solidFill>
+              </a:rPr>
+              <a:t>Fine debt assets after seven rounds + fine liabilities.</a:t>
+            </a:r>
+          </a:p>
+        </p:txBody>
+      </p:sp>
+      <p:sp>
+        <p:nvSpPr>
+          <p:cNvPr id="14" name="Context only-bar">
+            <a:extLst xmlns:a="http://schemas.openxmlformats.org/drawingml/2006/main">
+              <a:ext uri="{FF2B5EF4-FFF2-40B4-BE49-F238E27FC236}">
+                <a16:creationId xmlns:a16="http://schemas.microsoft.com/office/drawing/2014/main" id="{A567A865-2022-41CE-BB30-AB58E2C2A04A}"/>
+              </a:ext>
+            </a:extLst>
+          </p:cNvPr>
+          <p:cNvSpPr>
+            <a:spLocks xmlns:a="http://schemas.openxmlformats.org/drawingml/2006/main" noGrp="1"/>
+          </p:cNvSpPr>
+          <p:nvPr/>
+        </p:nvSpPr>
+        <p:spPr>
+          <a:xfrm xmlns:a="http://schemas.openxmlformats.org/drawingml/2006/main">
+            <a:off x="5905500" y="3886200"/>
+            <a:ext cx="76200" cy="952500"/>
+          </a:xfrm>
+          <a:prstGeom xmlns:a="http://schemas.openxmlformats.org/drawingml/2006/main" prst="rect">
+            <a:avLst/>
+          </a:prstGeom>
+          <a:solidFill xmlns:a="http://schemas.openxmlformats.org/drawingml/2006/main">
+            <a:srgbClr val="C65D16"/>
+          </a:solidFill>
+          <a:ln xmlns:a="http://schemas.openxmlformats.org/drawingml/2006/main" w="0">
+            <a:noFill/>
+            <a:prstDash val="solid"/>
+          </a:ln>
+        </p:spPr>
+      </p:sp>
+      <p:sp>
+        <p:nvSpPr>
+          <p:cNvPr id="15" name="Context only-label">
+            <a:extLst xmlns:a="http://schemas.openxmlformats.org/drawingml/2006/main">
+              <a:ext uri="{FF2B5EF4-FFF2-40B4-BE49-F238E27FC236}">
+                <a16:creationId xmlns:a16="http://schemas.microsoft.com/office/drawing/2014/main" id="{58F96603-D508-40F6-A485-776B0AF5C4BD}"/>
+              </a:ext>
+            </a:extLst>
+          </p:cNvPr>
+          <p:cNvSpPr>
+            <a:spLocks xmlns:a="http://schemas.openxmlformats.org/drawingml/2006/main" noGrp="1"/>
+          </p:cNvSpPr>
+          <p:nvPr/>
+        </p:nvSpPr>
+        <p:spPr>
+          <a:xfrm xmlns:a="http://schemas.openxmlformats.org/drawingml/2006/main">
+            <a:off x="6191250" y="3924300"/>
+            <a:ext cx="2476500" cy="285750"/>
+          </a:xfrm>
+          <a:prstGeom xmlns:a="http://schemas.openxmlformats.org/drawingml/2006/main" prst="rect">
+            <a:avLst/>
+          </a:prstGeom>
+          <a:noFill xmlns:a="http://schemas.openxmlformats.org/drawingml/2006/main"/>
+          <a:ln xmlns:a="http://schemas.openxmlformats.org/drawingml/2006/main" w="0">
+            <a:noFill/>
+            <a:prstDash val="solid"/>
+          </a:ln>
+        </p:spPr>
+        <p:txBody>
+          <a:bodyPr xmlns:a="http://schemas.openxmlformats.org/drawingml/2006/main" anchor="t"/>
+          <a:lstStyle xmlns:a="http://schemas.openxmlformats.org/drawingml/2006/main"/>
+          <a:p xmlns:a="http://schemas.openxmlformats.org/drawingml/2006/main">
+            <a:pPr algn="l">
+              <a:buNone/>
+              <a:defRPr sz="1725" b="1">
+                <a:solidFill>
+                  <a:srgbClr val="B83232"/>
+                </a:solidFill>
+              </a:defRPr>
+            </a:pPr>
+            <a:r>
+              <a:rPr sz="1725" b="1">
                 <a:solidFill>
                   <a:srgbClr val="C65D16"/>
                 </a:solidFill>
-              </a:defRPr>
-            </a:pPr>
-            <a:r>
-              <a:rPr sz="1350" b="1">
-                <a:solidFill>
-                  <a:srgbClr val="C65D16"/>
-                </a:solidFill>
-              </a:rPr>
-              <a:t>Our proxy · percentage-point axis</a:t>
-            </a:r>
-          </a:p>
-        </p:txBody>
-      </p:sp>
-      <p:sp>
-        <p:nvSpPr>
-          <p:cNvPr id="7" name="Regenerated 2021 safe-asset demand figure-frame">
-            <a:extLst xmlns:a="http://schemas.openxmlformats.org/drawingml/2006/main">
-              <a:ext uri="{FF2B5EF4-FFF2-40B4-BE49-F238E27FC236}">
-                <a16:creationId xmlns:a16="http://schemas.microsoft.com/office/drawing/2014/main" id="{1442A94D-98B9-4DC6-8E97-11AE6BD7202F}"/>
-              </a:ext>
-            </a:extLst>
-          </p:cNvPr>
-          <p:cNvSpPr>
-            <a:spLocks xmlns:a="http://schemas.openxmlformats.org/drawingml/2006/main" noGrp="1"/>
-          </p:cNvSpPr>
-          <p:nvPr/>
-        </p:nvSpPr>
-        <p:spPr>
-          <a:xfrm xmlns:a="http://schemas.openxmlformats.org/drawingml/2006/main">
-            <a:off x="457200" y="1428750"/>
-            <a:ext cx="5410200" cy="3638550"/>
+              </a:rPr>
+              <a:t>3 · Applied faithfully</a:t>
+            </a:r>
+          </a:p>
+        </p:txBody>
+      </p:sp>
+      <p:sp>
+        <p:nvSpPr>
+          <p:cNvPr id="16" name="Context only-body">
+            <a:extLst xmlns:a="http://schemas.openxmlformats.org/drawingml/2006/main">
+              <a:ext uri="{FF2B5EF4-FFF2-40B4-BE49-F238E27FC236}">
+                <a16:creationId xmlns:a16="http://schemas.microsoft.com/office/drawing/2014/main" id="{005F9EA7-5FC9-4084-B230-06E7E891E6B0}"/>
+              </a:ext>
+            </a:extLst>
+          </p:cNvPr>
+          <p:cNvSpPr>
+            <a:spLocks xmlns:a="http://schemas.openxmlformats.org/drawingml/2006/main" noGrp="1"/>
+          </p:cNvSpPr>
+          <p:nvPr/>
+        </p:nvSpPr>
+        <p:spPr>
+          <a:xfrm xmlns:a="http://schemas.openxmlformats.org/drawingml/2006/main">
+            <a:off x="6191250" y="4257675"/>
+            <a:ext cx="5048250" cy="552450"/>
+          </a:xfrm>
+          <a:prstGeom xmlns:a="http://schemas.openxmlformats.org/drawingml/2006/main" prst="rect">
+            <a:avLst/>
+          </a:prstGeom>
+          <a:noFill xmlns:a="http://schemas.openxmlformats.org/drawingml/2006/main"/>
+          <a:ln xmlns:a="http://schemas.openxmlformats.org/drawingml/2006/main" w="0">
+            <a:noFill/>
+            <a:prstDash val="solid"/>
+          </a:ln>
+        </p:spPr>
+        <p:txBody>
+          <a:bodyPr xmlns:a="http://schemas.openxmlformats.org/drawingml/2006/main" anchor="t"/>
+          <a:lstStyle xmlns:a="http://schemas.openxmlformats.org/drawingml/2006/main"/>
+          <a:p xmlns:a="http://schemas.openxmlformats.org/drawingml/2006/main">
+            <a:pPr algn="l">
+              <a:buNone/>
+              <a:defRPr sz="1350" b="0">
+                <a:solidFill>
+                  <a:srgbClr val="243B53"/>
+                </a:solidFill>
+              </a:defRPr>
+            </a:pPr>
+            <a:r>
+              <a:rPr sz="1350" b="0">
+                <a:solidFill>
+                  <a:srgbClr val="243B53"/>
+                </a:solidFill>
+              </a:rPr>
+              <a:t>Net debt = debt assets − liabilities; divide by NI; subtract 1982.</a:t>
+            </a:r>
+          </a:p>
+        </p:txBody>
+      </p:sp>
+      <p:sp>
+        <p:nvSpPr>
+          <p:cNvPr id="17" name="boundary">
+            <a:extLst xmlns:a="http://schemas.openxmlformats.org/drawingml/2006/main">
+              <a:ext uri="{FF2B5EF4-FFF2-40B4-BE49-F238E27FC236}">
+                <a16:creationId xmlns:a16="http://schemas.microsoft.com/office/drawing/2014/main" id="{79FA2934-1CA8-49CA-B94B-8B94B201C7B7}"/>
+              </a:ext>
+            </a:extLst>
+          </p:cNvPr>
+          <p:cNvSpPr>
+            <a:spLocks xmlns:a="http://schemas.openxmlformats.org/drawingml/2006/main" noGrp="1"/>
+          </p:cNvSpPr>
+          <p:nvPr/>
+        </p:nvSpPr>
+        <p:spPr>
+          <a:xfrm xmlns:a="http://schemas.openxmlformats.org/drawingml/2006/main">
+            <a:off x="533400" y="3238500"/>
+            <a:ext cx="4381500" cy="1809750"/>
           </a:xfrm>
           <a:prstGeom xmlns:a="http://schemas.openxmlformats.org/drawingml/2006/main" prst="roundRect">
             <a:avLst>
-              <a:gd name="adj" fmla="val 1047"/>
-            </a:avLst>
-          </a:prstGeom>
-          <a:solidFill xmlns:a="http://schemas.openxmlformats.org/drawingml/2006/main">
-            <a:srgbClr val="FFFFFF"/>
-          </a:solidFill>
-          <a:ln xmlns:a="http://schemas.openxmlformats.org/drawingml/2006/main" w="9525">
-            <a:solidFill>
-              <a:srgbClr val="D8E1E8"/>
-            </a:solidFill>
-            <a:prstDash val="solid"/>
-          </a:ln>
-        </p:spPr>
-      </p:sp>
-      <p:sp>
-        <p:nvSpPr>
-          <p:cNvPr id="9" name="2025 Figure 10 safe-asset demand-frame">
-            <a:extLst xmlns:a="http://schemas.openxmlformats.org/drawingml/2006/main">
-              <a:ext uri="{FF2B5EF4-FFF2-40B4-BE49-F238E27FC236}">
-                <a16:creationId xmlns:a16="http://schemas.microsoft.com/office/drawing/2014/main" id="{98F7C92D-66A0-4F20-83BF-E349E5E80E9E}"/>
-              </a:ext>
-            </a:extLst>
-          </p:cNvPr>
-          <p:cNvSpPr>
-            <a:spLocks xmlns:a="http://schemas.openxmlformats.org/drawingml/2006/main" noGrp="1"/>
-          </p:cNvSpPr>
-          <p:nvPr/>
-        </p:nvSpPr>
-        <p:spPr>
-          <a:xfrm xmlns:a="http://schemas.openxmlformats.org/drawingml/2006/main">
-            <a:off x="6324600" y="1428750"/>
-            <a:ext cx="5410200" cy="3638550"/>
-          </a:xfrm>
-          <a:prstGeom xmlns:a="http://schemas.openxmlformats.org/drawingml/2006/main" prst="roundRect">
-            <a:avLst>
-              <a:gd name="adj" fmla="val 1047"/>
-            </a:avLst>
-          </a:prstGeom>
-          <a:solidFill xmlns:a="http://schemas.openxmlformats.org/drawingml/2006/main">
-            <a:srgbClr val="FFFFFF"/>
-          </a:solidFill>
-          <a:ln xmlns:a="http://schemas.openxmlformats.org/drawingml/2006/main" w="9525">
-            <a:solidFill>
-              <a:srgbClr val="D8E1E8"/>
-            </a:solidFill>
-            <a:prstDash val="solid"/>
-          </a:ln>
-        </p:spPr>
-      </p:sp>
-      <p:sp>
-        <p:nvSpPr>
-          <p:cNvPr id="11" name="assessment-band">
-            <a:extLst xmlns:a="http://schemas.openxmlformats.org/drawingml/2006/main">
-              <a:ext uri="{FF2B5EF4-FFF2-40B4-BE49-F238E27FC236}">
-                <a16:creationId xmlns:a16="http://schemas.microsoft.com/office/drawing/2014/main" id="{8E0201B9-6249-4F69-8DD3-3C91F0AFAC32}"/>
-              </a:ext>
-            </a:extLst>
-          </p:cNvPr>
-          <p:cNvSpPr>
-            <a:spLocks xmlns:a="http://schemas.openxmlformats.org/drawingml/2006/main" noGrp="1"/>
-          </p:cNvSpPr>
-          <p:nvPr/>
-        </p:nvSpPr>
-        <p:spPr>
-          <a:xfrm xmlns:a="http://schemas.openxmlformats.org/drawingml/2006/main">
-            <a:off x="457200" y="5219700"/>
-            <a:ext cx="11277600" cy="1219200"/>
-          </a:xfrm>
-          <a:prstGeom xmlns:a="http://schemas.openxmlformats.org/drawingml/2006/main" prst="roundRect">
-            <a:avLst>
-              <a:gd name="adj" fmla="val 3125"/>
+              <a:gd name="adj" fmla="val 2105"/>
             </a:avLst>
           </a:prstGeom>
           <a:solidFill xmlns:a="http://schemas.openxmlformats.org/drawingml/2006/main">
@@ -7014,104 +8195,73 @@
       </p:sp>
       <p:sp>
         <p:nvSpPr>
-          <p:cNvPr id="12" name="assessment-accent">
-            <a:extLst xmlns:a="http://schemas.openxmlformats.org/drawingml/2006/main">
-              <a:ext uri="{FF2B5EF4-FFF2-40B4-BE49-F238E27FC236}">
-                <a16:creationId xmlns:a16="http://schemas.microsoft.com/office/drawing/2014/main" id="{E6607933-8AC4-4796-94EB-F2FB6C0865F1}"/>
-              </a:ext>
-            </a:extLst>
-          </p:cNvPr>
-          <p:cNvSpPr>
-            <a:spLocks xmlns:a="http://schemas.openxmlformats.org/drawingml/2006/main" noGrp="1"/>
-          </p:cNvSpPr>
-          <p:nvPr/>
-        </p:nvSpPr>
-        <p:spPr>
-          <a:xfrm xmlns:a="http://schemas.openxmlformats.org/drawingml/2006/main">
-            <a:off x="457200" y="5219700"/>
-            <a:ext cx="76200" cy="1219200"/>
-          </a:xfrm>
-          <a:prstGeom xmlns:a="http://schemas.openxmlformats.org/drawingml/2006/main" prst="rect">
-            <a:avLst/>
-          </a:prstGeom>
-          <a:solidFill xmlns:a="http://schemas.openxmlformats.org/drawingml/2006/main">
-            <a:srgbClr val="2F855A"/>
-          </a:solidFill>
-          <a:ln xmlns:a="http://schemas.openxmlformats.org/drawingml/2006/main" w="0">
-            <a:noFill/>
-            <a:prstDash val="solid"/>
-          </a:ln>
-        </p:spPr>
-      </p:sp>
-      <p:sp>
-        <p:nvSpPr>
-          <p:cNvPr id="13" name="verdict">
-            <a:extLst xmlns:a="http://schemas.openxmlformats.org/drawingml/2006/main">
-              <a:ext uri="{FF2B5EF4-FFF2-40B4-BE49-F238E27FC236}">
-                <a16:creationId xmlns:a16="http://schemas.microsoft.com/office/drawing/2014/main" id="{DAEE4CAF-C158-4F1E-AF88-9B2A72776725}"/>
-              </a:ext>
-            </a:extLst>
-          </p:cNvPr>
-          <p:cNvSpPr>
-            <a:spLocks xmlns:a="http://schemas.openxmlformats.org/drawingml/2006/main" noGrp="1"/>
-          </p:cNvSpPr>
-          <p:nvPr/>
-        </p:nvSpPr>
-        <p:spPr>
-          <a:xfrm xmlns:a="http://schemas.openxmlformats.org/drawingml/2006/main">
-            <a:off x="685800" y="5362575"/>
-            <a:ext cx="3143250" cy="314325"/>
-          </a:xfrm>
-          <a:prstGeom xmlns:a="http://schemas.openxmlformats.org/drawingml/2006/main" prst="rect">
-            <a:avLst/>
-          </a:prstGeom>
-          <a:noFill xmlns:a="http://schemas.openxmlformats.org/drawingml/2006/main"/>
-          <a:ln xmlns:a="http://schemas.openxmlformats.org/drawingml/2006/main" w="0">
-            <a:noFill/>
-            <a:prstDash val="solid"/>
-          </a:ln>
-        </p:spPr>
-        <p:txBody>
-          <a:bodyPr xmlns:a="http://schemas.openxmlformats.org/drawingml/2006/main" anchor="t"/>
-          <a:lstStyle xmlns:a="http://schemas.openxmlformats.org/drawingml/2006/main"/>
-          <a:p xmlns:a="http://schemas.openxmlformats.org/drawingml/2006/main">
-            <a:pPr algn="l">
-              <a:buNone/>
-              <a:defRPr sz="1725" b="1">
-                <a:solidFill>
-                  <a:srgbClr val="2F855A"/>
-                </a:solidFill>
-              </a:defRPr>
-            </a:pPr>
-            <a:r>
-              <a:rPr sz="1725" b="1">
-                <a:solidFill>
-                  <a:srgbClr val="2F855A"/>
-                </a:solidFill>
-              </a:rPr>
-              <a:t>CLOSE PROXY</a:t>
-            </a:r>
-          </a:p>
-        </p:txBody>
-      </p:sp>
-      <p:sp>
-        <p:nvSpPr>
-          <p:cNvPr id="14" name="assessment">
-            <a:extLst xmlns:a="http://schemas.openxmlformats.org/drawingml/2006/main">
-              <a:ext uri="{FF2B5EF4-FFF2-40B4-BE49-F238E27FC236}">
-                <a16:creationId xmlns:a16="http://schemas.microsoft.com/office/drawing/2014/main" id="{F5E1C807-0687-4A75-8864-05548460D9A0}"/>
-              </a:ext>
-            </a:extLst>
-          </p:cNvPr>
-          <p:cNvSpPr>
-            <a:spLocks xmlns:a="http://schemas.openxmlformats.org/drawingml/2006/main" noGrp="1"/>
-          </p:cNvSpPr>
-          <p:nvPr/>
-        </p:nvSpPr>
-        <p:spPr>
-          <a:xfrm xmlns:a="http://schemas.openxmlformats.org/drawingml/2006/main">
-            <a:off x="3857625" y="5334000"/>
-            <a:ext cx="7620000" cy="457200"/>
+          <p:cNvPr id="18" name="boundary-title">
+            <a:extLst xmlns:a="http://schemas.openxmlformats.org/drawingml/2006/main">
+              <a:ext uri="{FF2B5EF4-FFF2-40B4-BE49-F238E27FC236}">
+                <a16:creationId xmlns:a16="http://schemas.microsoft.com/office/drawing/2014/main" id="{90F1D0FA-121D-4208-9F34-9DE0662DF16B}"/>
+              </a:ext>
+            </a:extLst>
+          </p:cNvPr>
+          <p:cNvSpPr>
+            <a:spLocks xmlns:a="http://schemas.openxmlformats.org/drawingml/2006/main" noGrp="1"/>
+          </p:cNvSpPr>
+          <p:nvPr/>
+        </p:nvSpPr>
+        <p:spPr>
+          <a:xfrm xmlns:a="http://schemas.openxmlformats.org/drawingml/2006/main">
+            <a:off x="742950" y="3448050"/>
+            <a:ext cx="1905000" cy="285750"/>
+          </a:xfrm>
+          <a:prstGeom xmlns:a="http://schemas.openxmlformats.org/drawingml/2006/main" prst="rect">
+            <a:avLst/>
+          </a:prstGeom>
+          <a:noFill xmlns:a="http://schemas.openxmlformats.org/drawingml/2006/main"/>
+          <a:ln xmlns:a="http://schemas.openxmlformats.org/drawingml/2006/main" w="0">
+            <a:noFill/>
+            <a:prstDash val="solid"/>
+          </a:ln>
+        </p:spPr>
+        <p:txBody>
+          <a:bodyPr xmlns:a="http://schemas.openxmlformats.org/drawingml/2006/main" anchor="t"/>
+          <a:lstStyle xmlns:a="http://schemas.openxmlformats.org/drawingml/2006/main"/>
+          <a:p xmlns:a="http://schemas.openxmlformats.org/drawingml/2006/main">
+            <a:pPr algn="l">
+              <a:buNone/>
+              <a:defRPr sz="1575" b="1">
+                <a:solidFill>
+                  <a:srgbClr val="B83232"/>
+                </a:solidFill>
+              </a:defRPr>
+            </a:pPr>
+            <a:r>
+              <a:rPr sz="1575" b="1">
+                <a:solidFill>
+                  <a:srgbClr val="B83232"/>
+                </a:solidFill>
+              </a:rPr>
+              <a:t>Classification</a:t>
+            </a:r>
+          </a:p>
+        </p:txBody>
+      </p:sp>
+      <p:sp>
+        <p:nvSpPr>
+          <p:cNvPr id="19" name="boundary-body">
+            <a:extLst xmlns:a="http://schemas.openxmlformats.org/drawingml/2006/main">
+              <a:ext uri="{FF2B5EF4-FFF2-40B4-BE49-F238E27FC236}">
+                <a16:creationId xmlns:a16="http://schemas.microsoft.com/office/drawing/2014/main" id="{DF98F5D6-9D18-45C9-8820-2EA73D0D0CC3}"/>
+              </a:ext>
+            </a:extLst>
+          </p:cNvPr>
+          <p:cNvSpPr>
+            <a:spLocks xmlns:a="http://schemas.openxmlformats.org/drawingml/2006/main" noGrp="1"/>
+          </p:cNvSpPr>
+          <p:nvPr/>
+        </p:nvSpPr>
+        <p:spPr>
+          <a:xfrm xmlns:a="http://schemas.openxmlformats.org/drawingml/2006/main">
+            <a:off x="742950" y="3857625"/>
+            <a:ext cx="3905250" cy="1066800"/>
           </a:xfrm>
           <a:prstGeom xmlns:a="http://schemas.openxmlformats.org/drawingml/2006/main" prst="rect">
             <a:avLst/>
@@ -7140,110 +8290,15 @@
                   <a:srgbClr val="243B53"/>
                 </a:solidFill>
               </a:rPr>
-              <a:t>2007: bottom 99% -38.88 pp proxy vs -38.76 paper; top 1% +12.03 vs +18.02.</a:t>
-            </a:r>
-          </a:p>
-        </p:txBody>
-      </p:sp>
-      <p:sp>
-        <p:nvSpPr>
-          <p:cNvPr id="15" name="difference">
-            <a:extLst xmlns:a="http://schemas.openxmlformats.org/drawingml/2006/main">
-              <a:ext uri="{FF2B5EF4-FFF2-40B4-BE49-F238E27FC236}">
-                <a16:creationId xmlns:a16="http://schemas.microsoft.com/office/drawing/2014/main" id="{9E94ECB7-8637-4F89-9ABB-1A8B2FEF54E1}"/>
-              </a:ext>
-            </a:extLst>
-          </p:cNvPr>
-          <p:cNvSpPr>
-            <a:spLocks xmlns:a="http://schemas.openxmlformats.org/drawingml/2006/main" noGrp="1"/>
-          </p:cNvSpPr>
-          <p:nvPr/>
-        </p:nvSpPr>
-        <p:spPr>
-          <a:xfrm xmlns:a="http://schemas.openxmlformats.org/drawingml/2006/main">
-            <a:off x="685800" y="5848350"/>
-            <a:ext cx="10763250" cy="400050"/>
-          </a:xfrm>
-          <a:prstGeom xmlns:a="http://schemas.openxmlformats.org/drawingml/2006/main" prst="rect">
-            <a:avLst/>
-          </a:prstGeom>
-          <a:noFill xmlns:a="http://schemas.openxmlformats.org/drawingml/2006/main"/>
-          <a:ln xmlns:a="http://schemas.openxmlformats.org/drawingml/2006/main" w="0">
-            <a:noFill/>
-            <a:prstDash val="solid"/>
-          </a:ln>
-        </p:spPr>
-        <p:txBody>
-          <a:bodyPr xmlns:a="http://schemas.openxmlformats.org/drawingml/2006/main" anchor="t"/>
-          <a:lstStyle xmlns:a="http://schemas.openxmlformats.org/drawingml/2006/main"/>
-          <a:p xmlns:a="http://schemas.openxmlformats.org/drawingml/2006/main">
-            <a:pPr algn="l">
-              <a:buNone/>
-              <a:defRPr sz="1200" b="0">
-                <a:solidFill>
-                  <a:srgbClr val="627D98"/>
-                </a:solidFill>
-              </a:defRPr>
-            </a:pPr>
-            <a:r>
-              <a:rPr sz="1200" b="0">
-                <a:solidFill>
-                  <a:srgbClr val="627D98"/>
-                </a:solidFill>
-              </a:rPr>
-              <a:t>Correlations: 0.993 / 0.995 (top 1% / bottom 99%). Missing matrices prevent a code-only interpretation.</a:t>
-            </a:r>
-          </a:p>
-        </p:txBody>
-      </p:sp>
-      <p:pic>
-        <p:nvPicPr>
-          <p:cNvPr id="32" name=""/>
-          <p:cNvPicPr>
-            <a:picLocks xmlns:a="http://schemas.openxmlformats.org/drawingml/2006/main" noChangeAspect="1"/>
-          </p:cNvPicPr>
-          <p:nvPr/>
-        </p:nvPicPr>
-        <p:blipFill>
-          <a:blip xmlns:r="http://schemas.openxmlformats.org/officeDocument/2006/relationships" xmlns:a="http://schemas.openxmlformats.org/drawingml/2006/main" r:embed="R3a9c50df4cec46a8"/>
-          <a:stretch xmlns:a="http://schemas.openxmlformats.org/drawingml/2006/main"/>
-        </p:blipFill>
-        <p:spPr>
-          <a:xfrm xmlns:a="http://schemas.openxmlformats.org/drawingml/2006/main">
-            <a:off x="632746" y="1552099"/>
-            <a:ext cx="5059204" cy="3372802"/>
-          </a:xfrm>
-          <a:prstGeom xmlns:a="http://schemas.openxmlformats.org/drawingml/2006/main" prst="rect">
-            <a:avLst/>
-          </a:prstGeom>
-        </p:spPr>
-      </p:pic>
-      <p:pic>
-        <p:nvPicPr>
-          <p:cNvPr id="33" name=""/>
-          <p:cNvPicPr>
-            <a:picLocks xmlns:a="http://schemas.openxmlformats.org/drawingml/2006/main" noChangeAspect="1"/>
-          </p:cNvPicPr>
-          <p:nvPr/>
-        </p:nvPicPr>
-        <p:blipFill>
-          <a:blip xmlns:r="http://schemas.openxmlformats.org/officeDocument/2006/relationships" xmlns:a="http://schemas.openxmlformats.org/drawingml/2006/main" r:embed="R032de42980c6416c"/>
-          <a:stretch xmlns:a="http://schemas.openxmlformats.org/drawingml/2006/main"/>
-        </p:blipFill>
-        <p:spPr>
-          <a:xfrm xmlns:a="http://schemas.openxmlformats.org/drawingml/2006/main">
-            <a:off x="6450393" y="1776603"/>
-            <a:ext cx="5158614" cy="2923699"/>
-          </a:xfrm>
-          <a:prstGeom xmlns:a="http://schemas.openxmlformats.org/drawingml/2006/main" prst="rect">
-            <a:avLst/>
-          </a:prstGeom>
-        </p:spPr>
-      </p:pic>
+              <a:t>Proxy: group, sign, scale, and base are revised; unveiled asset stocks still come from the older method.</a:t>
+            </a:r>
+          </a:p>
+        </p:txBody>
+      </p:sp>
     </p:spTree>
     <p:extLst>
       <p:ext uri="{BB962C8B-B14F-4D97-AF65-F5344CB8AC3E}">
-        <p14:creationId xmlns:p14="http://schemas.microsoft.com/office/powerpoint/2010/main" val="1065330000"/>
+        <p14:creationId xmlns:p14="http://schemas.microsoft.com/office/powerpoint/2010/main" val="221189521"/>
       </p:ext>
     </p:extLst>
   </p:cSld>
@@ -7271,10 +8326,10 @@
       </p:grpSpPr>
       <p:sp>
         <p:nvSpPr>
-          <p:cNvPr id="20" name="kicker">
-            <a:extLst xmlns:a="http://schemas.openxmlformats.org/drawingml/2006/main">
-              <a:ext uri="{FF2B5EF4-FFF2-40B4-BE49-F238E27FC236}">
-                <a16:creationId xmlns:a16="http://schemas.microsoft.com/office/drawing/2014/main" id="{4DBD74DF-ED28-4EE9-8535-9E366A67537D}"/>
+          <p:cNvPr id="16" name="kicker">
+            <a:extLst xmlns:a="http://schemas.openxmlformats.org/drawingml/2006/main">
+              <a:ext uri="{FF2B5EF4-FFF2-40B4-BE49-F238E27FC236}">
+                <a16:creationId xmlns:a16="http://schemas.microsoft.com/office/drawing/2014/main" id="{AA955CD9-B4EF-4E20-A3FC-1D7B4F59A354}"/>
               </a:ext>
             </a:extLst>
           </p:cNvPr>
@@ -7315,7 +8370,7 @@
                   <a:srgbClr val="C65D16"/>
                 </a:solidFill>
               </a:rPr>
-              <a:t>REPLICATION SYNTHESIS</a:t>
+              <a:t>FIGURE 8 PRIMARY COMPARISON</a:t>
             </a:r>
           </a:p>
         </p:txBody>
@@ -7325,7 +8380,7 @@
           <p:cNvPr id="2" name="title">
             <a:extLst xmlns:a="http://schemas.openxmlformats.org/drawingml/2006/main">
               <a:ext uri="{FF2B5EF4-FFF2-40B4-BE49-F238E27FC236}">
-                <a16:creationId xmlns:a16="http://schemas.microsoft.com/office/drawing/2014/main" id="{25994307-319F-4EAA-8D7C-9E832F74B960}"/>
+                <a16:creationId xmlns:a16="http://schemas.microsoft.com/office/drawing/2014/main" id="{BE8A36E9-77A3-4197-AAEB-944D96A22E35}"/>
               </a:ext>
             </a:extLst>
           </p:cNvPr>
@@ -7366,7 +8421,7 @@
                   <a:srgbClr val="102A43"/>
                 </a:solidFill>
               </a:rPr>
-              <a:t>Figures 1, 5, and 6 reconstruct; Figure 8 remains a proxy</a:t>
+              <a:t>The proxy reproduces borrowing, but understates top-1 lending</a:t>
             </a:r>
           </a:p>
         </p:txBody>
@@ -7376,7 +8431,7 @@
           <p:cNvPr id="3" name="header-rule">
             <a:extLst xmlns:a="http://schemas.openxmlformats.org/drawingml/2006/main">
               <a:ext uri="{FF2B5EF4-FFF2-40B4-BE49-F238E27FC236}">
-                <a16:creationId xmlns:a16="http://schemas.microsoft.com/office/drawing/2014/main" id="{9304C898-8A92-4A39-A7EB-64A100354E4A}"/>
+                <a16:creationId xmlns:a16="http://schemas.microsoft.com/office/drawing/2014/main" id="{514C6BB1-D2D7-4502-B63E-CB46F5220FD9}"/>
               </a:ext>
             </a:extLst>
           </p:cNvPr>
@@ -7407,7 +8462,7 @@
           <p:cNvPr id="4" name="slide-number">
             <a:extLst xmlns:a="http://schemas.openxmlformats.org/drawingml/2006/main">
               <a:ext uri="{FF2B5EF4-FFF2-40B4-BE49-F238E27FC236}">
-                <a16:creationId xmlns:a16="http://schemas.microsoft.com/office/drawing/2014/main" id="{E4772364-3993-46C7-BB6A-7696849F37B9}"/>
+                <a16:creationId xmlns:a16="http://schemas.microsoft.com/office/drawing/2014/main" id="{1846DD66-DAE1-4F4D-9638-E1108AC93C86}"/>
               </a:ext>
             </a:extLst>
           </p:cNvPr>
@@ -7449,6 +8504,652 @@
                 </a:solidFill>
               </a:rPr>
               <a:t>16</a:t>
+            </a:r>
+          </a:p>
+        </p:txBody>
+      </p:sp>
+      <p:sp>
+        <p:nvSpPr>
+          <p:cNvPr id="5" name="left-label">
+            <a:extLst xmlns:a="http://schemas.openxmlformats.org/drawingml/2006/main">
+              <a:ext uri="{FF2B5EF4-FFF2-40B4-BE49-F238E27FC236}">
+                <a16:creationId xmlns:a16="http://schemas.microsoft.com/office/drawing/2014/main" id="{AC7EBFD9-49FB-40B3-B7BA-0564A41A3ADA}"/>
+              </a:ext>
+            </a:extLst>
+          </p:cNvPr>
+          <p:cNvSpPr>
+            <a:spLocks xmlns:a="http://schemas.openxmlformats.org/drawingml/2006/main" noGrp="1"/>
+          </p:cNvSpPr>
+          <p:nvPr/>
+        </p:nvSpPr>
+        <p:spPr>
+          <a:xfrm xmlns:a="http://schemas.openxmlformats.org/drawingml/2006/main">
+            <a:off x="457200" y="1123950"/>
+            <a:ext cx="5334000" cy="266700"/>
+          </a:xfrm>
+          <a:prstGeom xmlns:a="http://schemas.openxmlformats.org/drawingml/2006/main" prst="rect">
+            <a:avLst/>
+          </a:prstGeom>
+          <a:noFill xmlns:a="http://schemas.openxmlformats.org/drawingml/2006/main"/>
+          <a:ln xmlns:a="http://schemas.openxmlformats.org/drawingml/2006/main" w="0">
+            <a:noFill/>
+            <a:prstDash val="solid"/>
+          </a:ln>
+        </p:spPr>
+        <p:txBody>
+          <a:bodyPr xmlns:a="http://schemas.openxmlformats.org/drawingml/2006/main" anchor="t"/>
+          <a:lstStyle xmlns:a="http://schemas.openxmlformats.org/drawingml/2006/main"/>
+          <a:p xmlns:a="http://schemas.openxmlformats.org/drawingml/2006/main">
+            <a:pPr algn="l">
+              <a:buNone/>
+              <a:defRPr sz="1350" b="1">
+                <a:solidFill>
+                  <a:srgbClr val="2E5B88"/>
+                </a:solidFill>
+              </a:defRPr>
+            </a:pPr>
+            <a:r>
+              <a:rPr sz="1350" b="1">
+                <a:solidFill>
+                  <a:srgbClr val="2E5B88"/>
+                </a:solidFill>
+              </a:rPr>
+              <a:t>2025 paper · ratio axis (0.10 = 10 pp)</a:t>
+            </a:r>
+          </a:p>
+        </p:txBody>
+      </p:sp>
+      <p:sp>
+        <p:nvSpPr>
+          <p:cNvPr id="6" name="right-label">
+            <a:extLst xmlns:a="http://schemas.openxmlformats.org/drawingml/2006/main">
+              <a:ext uri="{FF2B5EF4-FFF2-40B4-BE49-F238E27FC236}">
+                <a16:creationId xmlns:a16="http://schemas.microsoft.com/office/drawing/2014/main" id="{D7EBD11C-5C33-487B-AFE7-65F7CD7D2108}"/>
+              </a:ext>
+            </a:extLst>
+          </p:cNvPr>
+          <p:cNvSpPr>
+            <a:spLocks xmlns:a="http://schemas.openxmlformats.org/drawingml/2006/main" noGrp="1"/>
+          </p:cNvSpPr>
+          <p:nvPr/>
+        </p:nvSpPr>
+        <p:spPr>
+          <a:xfrm xmlns:a="http://schemas.openxmlformats.org/drawingml/2006/main">
+            <a:off x="6324600" y="1123950"/>
+            <a:ext cx="5410200" cy="266700"/>
+          </a:xfrm>
+          <a:prstGeom xmlns:a="http://schemas.openxmlformats.org/drawingml/2006/main" prst="rect">
+            <a:avLst/>
+          </a:prstGeom>
+          <a:noFill xmlns:a="http://schemas.openxmlformats.org/drawingml/2006/main"/>
+          <a:ln xmlns:a="http://schemas.openxmlformats.org/drawingml/2006/main" w="0">
+            <a:noFill/>
+            <a:prstDash val="solid"/>
+          </a:ln>
+        </p:spPr>
+        <p:txBody>
+          <a:bodyPr xmlns:a="http://schemas.openxmlformats.org/drawingml/2006/main" anchor="t"/>
+          <a:lstStyle xmlns:a="http://schemas.openxmlformats.org/drawingml/2006/main"/>
+          <a:p xmlns:a="http://schemas.openxmlformats.org/drawingml/2006/main">
+            <a:pPr algn="l">
+              <a:buNone/>
+              <a:defRPr sz="1350" b="1">
+                <a:solidFill>
+                  <a:srgbClr val="C65D16"/>
+                </a:solidFill>
+              </a:defRPr>
+            </a:pPr>
+            <a:r>
+              <a:rPr sz="1350" b="1">
+                <a:solidFill>
+                  <a:srgbClr val="C65D16"/>
+                </a:solidFill>
+              </a:rPr>
+              <a:t>Our proxy · percentage-point axis</a:t>
+            </a:r>
+          </a:p>
+        </p:txBody>
+      </p:sp>
+      <p:sp>
+        <p:nvSpPr>
+          <p:cNvPr id="7" name="Regenerated 2021 safe-asset demand figure-frame">
+            <a:extLst xmlns:a="http://schemas.openxmlformats.org/drawingml/2006/main">
+              <a:ext uri="{FF2B5EF4-FFF2-40B4-BE49-F238E27FC236}">
+                <a16:creationId xmlns:a16="http://schemas.microsoft.com/office/drawing/2014/main" id="{1442A94D-98B9-4DC6-8E97-11AE6BD7202F}"/>
+              </a:ext>
+            </a:extLst>
+          </p:cNvPr>
+          <p:cNvSpPr>
+            <a:spLocks xmlns:a="http://schemas.openxmlformats.org/drawingml/2006/main" noGrp="1"/>
+          </p:cNvSpPr>
+          <p:nvPr/>
+        </p:nvSpPr>
+        <p:spPr>
+          <a:xfrm xmlns:a="http://schemas.openxmlformats.org/drawingml/2006/main">
+            <a:off x="457200" y="1428750"/>
+            <a:ext cx="5410200" cy="3638550"/>
+          </a:xfrm>
+          <a:prstGeom xmlns:a="http://schemas.openxmlformats.org/drawingml/2006/main" prst="roundRect">
+            <a:avLst>
+              <a:gd name="adj" fmla="val 1047"/>
+            </a:avLst>
+          </a:prstGeom>
+          <a:solidFill xmlns:a="http://schemas.openxmlformats.org/drawingml/2006/main">
+            <a:srgbClr val="FFFFFF"/>
+          </a:solidFill>
+          <a:ln xmlns:a="http://schemas.openxmlformats.org/drawingml/2006/main" w="9525">
+            <a:solidFill>
+              <a:srgbClr val="D8E1E8"/>
+            </a:solidFill>
+            <a:prstDash val="solid"/>
+          </a:ln>
+        </p:spPr>
+      </p:sp>
+      <p:sp>
+        <p:nvSpPr>
+          <p:cNvPr id="9" name="2025 Figure 10 safe-asset demand-frame">
+            <a:extLst xmlns:a="http://schemas.openxmlformats.org/drawingml/2006/main">
+              <a:ext uri="{FF2B5EF4-FFF2-40B4-BE49-F238E27FC236}">
+                <a16:creationId xmlns:a16="http://schemas.microsoft.com/office/drawing/2014/main" id="{98F7C92D-66A0-4F20-83BF-E349E5E80E9E}"/>
+              </a:ext>
+            </a:extLst>
+          </p:cNvPr>
+          <p:cNvSpPr>
+            <a:spLocks xmlns:a="http://schemas.openxmlformats.org/drawingml/2006/main" noGrp="1"/>
+          </p:cNvSpPr>
+          <p:nvPr/>
+        </p:nvSpPr>
+        <p:spPr>
+          <a:xfrm xmlns:a="http://schemas.openxmlformats.org/drawingml/2006/main">
+            <a:off x="6324600" y="1428750"/>
+            <a:ext cx="5410200" cy="3638550"/>
+          </a:xfrm>
+          <a:prstGeom xmlns:a="http://schemas.openxmlformats.org/drawingml/2006/main" prst="roundRect">
+            <a:avLst>
+              <a:gd name="adj" fmla="val 1047"/>
+            </a:avLst>
+          </a:prstGeom>
+          <a:solidFill xmlns:a="http://schemas.openxmlformats.org/drawingml/2006/main">
+            <a:srgbClr val="FFFFFF"/>
+          </a:solidFill>
+          <a:ln xmlns:a="http://schemas.openxmlformats.org/drawingml/2006/main" w="9525">
+            <a:solidFill>
+              <a:srgbClr val="D8E1E8"/>
+            </a:solidFill>
+            <a:prstDash val="solid"/>
+          </a:ln>
+        </p:spPr>
+      </p:sp>
+      <p:sp>
+        <p:nvSpPr>
+          <p:cNvPr id="11" name="assessment-band">
+            <a:extLst xmlns:a="http://schemas.openxmlformats.org/drawingml/2006/main">
+              <a:ext uri="{FF2B5EF4-FFF2-40B4-BE49-F238E27FC236}">
+                <a16:creationId xmlns:a16="http://schemas.microsoft.com/office/drawing/2014/main" id="{8E0201B9-6249-4F69-8DD3-3C91F0AFAC32}"/>
+              </a:ext>
+            </a:extLst>
+          </p:cNvPr>
+          <p:cNvSpPr>
+            <a:spLocks xmlns:a="http://schemas.openxmlformats.org/drawingml/2006/main" noGrp="1"/>
+          </p:cNvSpPr>
+          <p:nvPr/>
+        </p:nvSpPr>
+        <p:spPr>
+          <a:xfrm xmlns:a="http://schemas.openxmlformats.org/drawingml/2006/main">
+            <a:off x="457200" y="5219700"/>
+            <a:ext cx="11277600" cy="1219200"/>
+          </a:xfrm>
+          <a:prstGeom xmlns:a="http://schemas.openxmlformats.org/drawingml/2006/main" prst="roundRect">
+            <a:avLst>
+              <a:gd name="adj" fmla="val 3125"/>
+            </a:avLst>
+          </a:prstGeom>
+          <a:solidFill xmlns:a="http://schemas.openxmlformats.org/drawingml/2006/main">
+            <a:srgbClr val="F4F7FA"/>
+          </a:solidFill>
+          <a:ln xmlns:a="http://schemas.openxmlformats.org/drawingml/2006/main" w="0">
+            <a:noFill/>
+            <a:prstDash val="solid"/>
+          </a:ln>
+        </p:spPr>
+      </p:sp>
+      <p:sp>
+        <p:nvSpPr>
+          <p:cNvPr id="12" name="assessment-accent">
+            <a:extLst xmlns:a="http://schemas.openxmlformats.org/drawingml/2006/main">
+              <a:ext uri="{FF2B5EF4-FFF2-40B4-BE49-F238E27FC236}">
+                <a16:creationId xmlns:a16="http://schemas.microsoft.com/office/drawing/2014/main" id="{E6607933-8AC4-4796-94EB-F2FB6C0865F1}"/>
+              </a:ext>
+            </a:extLst>
+          </p:cNvPr>
+          <p:cNvSpPr>
+            <a:spLocks xmlns:a="http://schemas.openxmlformats.org/drawingml/2006/main" noGrp="1"/>
+          </p:cNvSpPr>
+          <p:nvPr/>
+        </p:nvSpPr>
+        <p:spPr>
+          <a:xfrm xmlns:a="http://schemas.openxmlformats.org/drawingml/2006/main">
+            <a:off x="457200" y="5219700"/>
+            <a:ext cx="76200" cy="1219200"/>
+          </a:xfrm>
+          <a:prstGeom xmlns:a="http://schemas.openxmlformats.org/drawingml/2006/main" prst="rect">
+            <a:avLst/>
+          </a:prstGeom>
+          <a:solidFill xmlns:a="http://schemas.openxmlformats.org/drawingml/2006/main">
+            <a:srgbClr val="2F855A"/>
+          </a:solidFill>
+          <a:ln xmlns:a="http://schemas.openxmlformats.org/drawingml/2006/main" w="0">
+            <a:noFill/>
+            <a:prstDash val="solid"/>
+          </a:ln>
+        </p:spPr>
+      </p:sp>
+      <p:sp>
+        <p:nvSpPr>
+          <p:cNvPr id="13" name="verdict">
+            <a:extLst xmlns:a="http://schemas.openxmlformats.org/drawingml/2006/main">
+              <a:ext uri="{FF2B5EF4-FFF2-40B4-BE49-F238E27FC236}">
+                <a16:creationId xmlns:a16="http://schemas.microsoft.com/office/drawing/2014/main" id="{DAEE4CAF-C158-4F1E-AF88-9B2A72776725}"/>
+              </a:ext>
+            </a:extLst>
+          </p:cNvPr>
+          <p:cNvSpPr>
+            <a:spLocks xmlns:a="http://schemas.openxmlformats.org/drawingml/2006/main" noGrp="1"/>
+          </p:cNvSpPr>
+          <p:nvPr/>
+        </p:nvSpPr>
+        <p:spPr>
+          <a:xfrm xmlns:a="http://schemas.openxmlformats.org/drawingml/2006/main">
+            <a:off x="685800" y="5362575"/>
+            <a:ext cx="3143250" cy="314325"/>
+          </a:xfrm>
+          <a:prstGeom xmlns:a="http://schemas.openxmlformats.org/drawingml/2006/main" prst="rect">
+            <a:avLst/>
+          </a:prstGeom>
+          <a:noFill xmlns:a="http://schemas.openxmlformats.org/drawingml/2006/main"/>
+          <a:ln xmlns:a="http://schemas.openxmlformats.org/drawingml/2006/main" w="0">
+            <a:noFill/>
+            <a:prstDash val="solid"/>
+          </a:ln>
+        </p:spPr>
+        <p:txBody>
+          <a:bodyPr xmlns:a="http://schemas.openxmlformats.org/drawingml/2006/main" anchor="t"/>
+          <a:lstStyle xmlns:a="http://schemas.openxmlformats.org/drawingml/2006/main"/>
+          <a:p xmlns:a="http://schemas.openxmlformats.org/drawingml/2006/main">
+            <a:pPr algn="l">
+              <a:buNone/>
+              <a:defRPr sz="1725" b="1">
+                <a:solidFill>
+                  <a:srgbClr val="2F855A"/>
+                </a:solidFill>
+              </a:defRPr>
+            </a:pPr>
+            <a:r>
+              <a:rPr sz="1725" b="1">
+                <a:solidFill>
+                  <a:srgbClr val="2F855A"/>
+                </a:solidFill>
+              </a:rPr>
+              <a:t>CLOSE PROXY</a:t>
+            </a:r>
+          </a:p>
+        </p:txBody>
+      </p:sp>
+      <p:sp>
+        <p:nvSpPr>
+          <p:cNvPr id="14" name="assessment">
+            <a:extLst xmlns:a="http://schemas.openxmlformats.org/drawingml/2006/main">
+              <a:ext uri="{FF2B5EF4-FFF2-40B4-BE49-F238E27FC236}">
+                <a16:creationId xmlns:a16="http://schemas.microsoft.com/office/drawing/2014/main" id="{F5E1C807-0687-4A75-8864-05548460D9A0}"/>
+              </a:ext>
+            </a:extLst>
+          </p:cNvPr>
+          <p:cNvSpPr>
+            <a:spLocks xmlns:a="http://schemas.openxmlformats.org/drawingml/2006/main" noGrp="1"/>
+          </p:cNvSpPr>
+          <p:nvPr/>
+        </p:nvSpPr>
+        <p:spPr>
+          <a:xfrm xmlns:a="http://schemas.openxmlformats.org/drawingml/2006/main">
+            <a:off x="3857625" y="5334000"/>
+            <a:ext cx="7620000" cy="457200"/>
+          </a:xfrm>
+          <a:prstGeom xmlns:a="http://schemas.openxmlformats.org/drawingml/2006/main" prst="rect">
+            <a:avLst/>
+          </a:prstGeom>
+          <a:noFill xmlns:a="http://schemas.openxmlformats.org/drawingml/2006/main"/>
+          <a:ln xmlns:a="http://schemas.openxmlformats.org/drawingml/2006/main" w="0">
+            <a:noFill/>
+            <a:prstDash val="solid"/>
+          </a:ln>
+        </p:spPr>
+        <p:txBody>
+          <a:bodyPr xmlns:a="http://schemas.openxmlformats.org/drawingml/2006/main" anchor="t"/>
+          <a:lstStyle xmlns:a="http://schemas.openxmlformats.org/drawingml/2006/main"/>
+          <a:p xmlns:a="http://schemas.openxmlformats.org/drawingml/2006/main">
+            <a:pPr algn="l">
+              <a:buNone/>
+              <a:defRPr sz="1350" b="0">
+                <a:solidFill>
+                  <a:srgbClr val="243B53"/>
+                </a:solidFill>
+              </a:defRPr>
+            </a:pPr>
+            <a:r>
+              <a:rPr sz="1350" b="0">
+                <a:solidFill>
+                  <a:srgbClr val="243B53"/>
+                </a:solidFill>
+              </a:rPr>
+              <a:t>2007: bottom 99% -38.88 pp proxy vs -38.76 paper; top 1% +12.03 vs +18.02.</a:t>
+            </a:r>
+          </a:p>
+        </p:txBody>
+      </p:sp>
+      <p:sp>
+        <p:nvSpPr>
+          <p:cNvPr id="15" name="difference">
+            <a:extLst xmlns:a="http://schemas.openxmlformats.org/drawingml/2006/main">
+              <a:ext uri="{FF2B5EF4-FFF2-40B4-BE49-F238E27FC236}">
+                <a16:creationId xmlns:a16="http://schemas.microsoft.com/office/drawing/2014/main" id="{9E94ECB7-8637-4F89-9ABB-1A8B2FEF54E1}"/>
+              </a:ext>
+            </a:extLst>
+          </p:cNvPr>
+          <p:cNvSpPr>
+            <a:spLocks xmlns:a="http://schemas.openxmlformats.org/drawingml/2006/main" noGrp="1"/>
+          </p:cNvSpPr>
+          <p:nvPr/>
+        </p:nvSpPr>
+        <p:spPr>
+          <a:xfrm xmlns:a="http://schemas.openxmlformats.org/drawingml/2006/main">
+            <a:off x="685800" y="5848350"/>
+            <a:ext cx="10763250" cy="400050"/>
+          </a:xfrm>
+          <a:prstGeom xmlns:a="http://schemas.openxmlformats.org/drawingml/2006/main" prst="rect">
+            <a:avLst/>
+          </a:prstGeom>
+          <a:noFill xmlns:a="http://schemas.openxmlformats.org/drawingml/2006/main"/>
+          <a:ln xmlns:a="http://schemas.openxmlformats.org/drawingml/2006/main" w="0">
+            <a:noFill/>
+            <a:prstDash val="solid"/>
+          </a:ln>
+        </p:spPr>
+        <p:txBody>
+          <a:bodyPr xmlns:a="http://schemas.openxmlformats.org/drawingml/2006/main" anchor="t"/>
+          <a:lstStyle xmlns:a="http://schemas.openxmlformats.org/drawingml/2006/main"/>
+          <a:p xmlns:a="http://schemas.openxmlformats.org/drawingml/2006/main">
+            <a:pPr algn="l">
+              <a:buNone/>
+              <a:defRPr sz="1200" b="0">
+                <a:solidFill>
+                  <a:srgbClr val="627D98"/>
+                </a:solidFill>
+              </a:defRPr>
+            </a:pPr>
+            <a:r>
+              <a:rPr sz="1200" b="0">
+                <a:solidFill>
+                  <a:srgbClr val="627D98"/>
+                </a:solidFill>
+              </a:rPr>
+              <a:t>Correlations: 0.993 / 0.995 (top 1% / bottom 99%). Missing matrices prevent a code-only interpretation.</a:t>
+            </a:r>
+          </a:p>
+        </p:txBody>
+      </p:sp>
+      <p:pic>
+        <p:nvPicPr>
+          <p:cNvPr id="32" name=""/>
+          <p:cNvPicPr>
+            <a:picLocks xmlns:a="http://schemas.openxmlformats.org/drawingml/2006/main" noChangeAspect="1"/>
+          </p:cNvPicPr>
+          <p:nvPr/>
+        </p:nvPicPr>
+        <p:blipFill>
+          <a:blip xmlns:r="http://schemas.openxmlformats.org/officeDocument/2006/relationships" xmlns:a="http://schemas.openxmlformats.org/drawingml/2006/main" r:embed="R27c94668cce14583"/>
+          <a:stretch xmlns:a="http://schemas.openxmlformats.org/drawingml/2006/main"/>
+        </p:blipFill>
+        <p:spPr>
+          <a:xfrm xmlns:a="http://schemas.openxmlformats.org/drawingml/2006/main">
+            <a:off x="632746" y="1552099"/>
+            <a:ext cx="5059204" cy="3372802"/>
+          </a:xfrm>
+          <a:prstGeom xmlns:a="http://schemas.openxmlformats.org/drawingml/2006/main" prst="rect">
+            <a:avLst/>
+          </a:prstGeom>
+        </p:spPr>
+      </p:pic>
+      <p:pic>
+        <p:nvPicPr>
+          <p:cNvPr id="33" name=""/>
+          <p:cNvPicPr>
+            <a:picLocks xmlns:a="http://schemas.openxmlformats.org/drawingml/2006/main" noChangeAspect="1"/>
+          </p:cNvPicPr>
+          <p:nvPr/>
+        </p:nvPicPr>
+        <p:blipFill>
+          <a:blip xmlns:r="http://schemas.openxmlformats.org/officeDocument/2006/relationships" xmlns:a="http://schemas.openxmlformats.org/drawingml/2006/main" r:embed="Rc4779c4d0cb944e8"/>
+          <a:stretch xmlns:a="http://schemas.openxmlformats.org/drawingml/2006/main"/>
+        </p:blipFill>
+        <p:spPr>
+          <a:xfrm xmlns:a="http://schemas.openxmlformats.org/drawingml/2006/main">
+            <a:off x="6450393" y="1776603"/>
+            <a:ext cx="5158614" cy="2923699"/>
+          </a:xfrm>
+          <a:prstGeom xmlns:a="http://schemas.openxmlformats.org/drawingml/2006/main" prst="rect">
+            <a:avLst/>
+          </a:prstGeom>
+        </p:spPr>
+      </p:pic>
+    </p:spTree>
+    <p:extLst>
+      <p:ext uri="{BB962C8B-B14F-4D97-AF65-F5344CB8AC3E}">
+        <p14:creationId xmlns:p14="http://schemas.microsoft.com/office/powerpoint/2010/main" val="1065330000"/>
+      </p:ext>
+    </p:extLst>
+  </p:cSld>
+</p:sld>
+</file>
+
+<file path=ppt/slides/slide17.xml><?xml version="1.0" encoding="utf-8"?>
+<p:sld xmlns:p="http://schemas.openxmlformats.org/presentationml/2006/main">
+  <p:cSld>
+    <p:bg>
+      <p:bgPr>
+        <a:solidFill xmlns:a="http://schemas.openxmlformats.org/drawingml/2006/main">
+          <a:srgbClr val="FFFFFF"/>
+        </a:solidFill>
+      </p:bgPr>
+    </p:bg>
+    <p:spTree>
+      <p:nvGrpSpPr>
+        <p:cNvPr id="1" name=""/>
+        <p:cNvGrpSpPr/>
+        <p:nvPr/>
+      </p:nvGrpSpPr>
+      <p:grpSpPr>
+        <a:xfrm xmlns:a="http://schemas.openxmlformats.org/drawingml/2006/main"/>
+      </p:grpSpPr>
+      <p:sp>
+        <p:nvSpPr>
+          <p:cNvPr id="20" name="kicker">
+            <a:extLst xmlns:a="http://schemas.openxmlformats.org/drawingml/2006/main">
+              <a:ext uri="{FF2B5EF4-FFF2-40B4-BE49-F238E27FC236}">
+                <a16:creationId xmlns:a16="http://schemas.microsoft.com/office/drawing/2014/main" id="{4DBD74DF-ED28-4EE9-8535-9E366A67537D}"/>
+              </a:ext>
+            </a:extLst>
+          </p:cNvPr>
+          <p:cNvSpPr>
+            <a:spLocks xmlns:a="http://schemas.openxmlformats.org/drawingml/2006/main" noGrp="1"/>
+          </p:cNvSpPr>
+          <p:nvPr/>
+        </p:nvSpPr>
+        <p:spPr>
+          <a:xfrm xmlns:a="http://schemas.openxmlformats.org/drawingml/2006/main">
+            <a:off x="457200" y="228600"/>
+            <a:ext cx="8572500" cy="209550"/>
+          </a:xfrm>
+          <a:prstGeom xmlns:a="http://schemas.openxmlformats.org/drawingml/2006/main" prst="rect">
+            <a:avLst/>
+          </a:prstGeom>
+          <a:noFill xmlns:a="http://schemas.openxmlformats.org/drawingml/2006/main"/>
+          <a:ln xmlns:a="http://schemas.openxmlformats.org/drawingml/2006/main" w="0">
+            <a:noFill/>
+            <a:prstDash val="solid"/>
+          </a:ln>
+        </p:spPr>
+        <p:txBody>
+          <a:bodyPr xmlns:a="http://schemas.openxmlformats.org/drawingml/2006/main" anchor="t"/>
+          <a:lstStyle xmlns:a="http://schemas.openxmlformats.org/drawingml/2006/main"/>
+          <a:p xmlns:a="http://schemas.openxmlformats.org/drawingml/2006/main">
+            <a:pPr algn="l">
+              <a:buNone/>
+              <a:defRPr sz="1050" b="1">
+                <a:solidFill>
+                  <a:srgbClr val="C65D16"/>
+                </a:solidFill>
+              </a:defRPr>
+            </a:pPr>
+            <a:r>
+              <a:rPr sz="1050" b="1">
+                <a:solidFill>
+                  <a:srgbClr val="C65D16"/>
+                </a:solidFill>
+              </a:rPr>
+              <a:t>REPLICATION SYNTHESIS</a:t>
+            </a:r>
+          </a:p>
+        </p:txBody>
+      </p:sp>
+      <p:sp>
+        <p:nvSpPr>
+          <p:cNvPr id="2" name="title">
+            <a:extLst xmlns:a="http://schemas.openxmlformats.org/drawingml/2006/main">
+              <a:ext uri="{FF2B5EF4-FFF2-40B4-BE49-F238E27FC236}">
+                <a16:creationId xmlns:a16="http://schemas.microsoft.com/office/drawing/2014/main" id="{25994307-319F-4EAA-8D7C-9E832F74B960}"/>
+              </a:ext>
+            </a:extLst>
+          </p:cNvPr>
+          <p:cNvSpPr>
+            <a:spLocks xmlns:a="http://schemas.openxmlformats.org/drawingml/2006/main" noGrp="1"/>
+          </p:cNvSpPr>
+          <p:nvPr/>
+        </p:nvSpPr>
+        <p:spPr>
+          <a:xfrm xmlns:a="http://schemas.openxmlformats.org/drawingml/2006/main">
+            <a:off x="457200" y="457200"/>
+            <a:ext cx="10858500" cy="495300"/>
+          </a:xfrm>
+          <a:prstGeom xmlns:a="http://schemas.openxmlformats.org/drawingml/2006/main" prst="rect">
+            <a:avLst/>
+          </a:prstGeom>
+          <a:noFill xmlns:a="http://schemas.openxmlformats.org/drawingml/2006/main"/>
+          <a:ln xmlns:a="http://schemas.openxmlformats.org/drawingml/2006/main" w="0">
+            <a:noFill/>
+            <a:prstDash val="solid"/>
+          </a:ln>
+        </p:spPr>
+        <p:txBody>
+          <a:bodyPr xmlns:a="http://schemas.openxmlformats.org/drawingml/2006/main" anchor="t"/>
+          <a:lstStyle xmlns:a="http://schemas.openxmlformats.org/drawingml/2006/main"/>
+          <a:p xmlns:a="http://schemas.openxmlformats.org/drawingml/2006/main">
+            <a:pPr algn="l">
+              <a:buNone/>
+              <a:defRPr sz="2700" b="1">
+                <a:solidFill>
+                  <a:srgbClr val="102A43"/>
+                </a:solidFill>
+              </a:defRPr>
+            </a:pPr>
+            <a:r>
+              <a:rPr sz="2700" b="1">
+                <a:solidFill>
+                  <a:srgbClr val="102A43"/>
+                </a:solidFill>
+              </a:rPr>
+              <a:t>Figures 1, 5, and 6 reconstruct; Figure 8 remains a proxy</a:t>
+            </a:r>
+          </a:p>
+        </p:txBody>
+      </p:sp>
+      <p:sp>
+        <p:nvSpPr>
+          <p:cNvPr id="3" name="header-rule">
+            <a:extLst xmlns:a="http://schemas.openxmlformats.org/drawingml/2006/main">
+              <a:ext uri="{FF2B5EF4-FFF2-40B4-BE49-F238E27FC236}">
+                <a16:creationId xmlns:a16="http://schemas.microsoft.com/office/drawing/2014/main" id="{9304C898-8A92-4A39-A7EB-64A100354E4A}"/>
+              </a:ext>
+            </a:extLst>
+          </p:cNvPr>
+          <p:cNvSpPr>
+            <a:spLocks xmlns:a="http://schemas.openxmlformats.org/drawingml/2006/main" noGrp="1"/>
+          </p:cNvSpPr>
+          <p:nvPr/>
+        </p:nvSpPr>
+        <p:spPr>
+          <a:xfrm xmlns:a="http://schemas.openxmlformats.org/drawingml/2006/main">
+            <a:off x="457200" y="981075"/>
+            <a:ext cx="11277600" cy="19050"/>
+          </a:xfrm>
+          <a:prstGeom xmlns:a="http://schemas.openxmlformats.org/drawingml/2006/main" prst="rect">
+            <a:avLst/>
+          </a:prstGeom>
+          <a:solidFill xmlns:a="http://schemas.openxmlformats.org/drawingml/2006/main">
+            <a:srgbClr val="102A43"/>
+          </a:solidFill>
+          <a:ln xmlns:a="http://schemas.openxmlformats.org/drawingml/2006/main" w="0">
+            <a:noFill/>
+            <a:prstDash val="solid"/>
+          </a:ln>
+        </p:spPr>
+      </p:sp>
+      <p:sp>
+        <p:nvSpPr>
+          <p:cNvPr id="4" name="slide-number">
+            <a:extLst xmlns:a="http://schemas.openxmlformats.org/drawingml/2006/main">
+              <a:ext uri="{FF2B5EF4-FFF2-40B4-BE49-F238E27FC236}">
+                <a16:creationId xmlns:a16="http://schemas.microsoft.com/office/drawing/2014/main" id="{E4772364-3993-46C7-BB6A-7696849F37B9}"/>
+              </a:ext>
+            </a:extLst>
+          </p:cNvPr>
+          <p:cNvSpPr>
+            <a:spLocks xmlns:a="http://schemas.openxmlformats.org/drawingml/2006/main" noGrp="1"/>
+          </p:cNvSpPr>
+          <p:nvPr/>
+        </p:nvSpPr>
+        <p:spPr>
+          <a:xfrm xmlns:a="http://schemas.openxmlformats.org/drawingml/2006/main">
+            <a:off x="11334750" y="266700"/>
+            <a:ext cx="400050" cy="228600"/>
+          </a:xfrm>
+          <a:prstGeom xmlns:a="http://schemas.openxmlformats.org/drawingml/2006/main" prst="rect">
+            <a:avLst/>
+          </a:prstGeom>
+          <a:noFill xmlns:a="http://schemas.openxmlformats.org/drawingml/2006/main"/>
+          <a:ln xmlns:a="http://schemas.openxmlformats.org/drawingml/2006/main" w="0">
+            <a:noFill/>
+            <a:prstDash val="solid"/>
+          </a:ln>
+        </p:spPr>
+        <p:txBody>
+          <a:bodyPr xmlns:a="http://schemas.openxmlformats.org/drawingml/2006/main" anchor="t"/>
+          <a:lstStyle xmlns:a="http://schemas.openxmlformats.org/drawingml/2006/main"/>
+          <a:p xmlns:a="http://schemas.openxmlformats.org/drawingml/2006/main">
+            <a:pPr algn="r">
+              <a:buNone/>
+              <a:defRPr sz="1050" b="1">
+                <a:solidFill>
+                  <a:srgbClr val="627D98"/>
+                </a:solidFill>
+              </a:defRPr>
+            </a:pPr>
+            <a:r>
+              <a:rPr sz="1050" b="1">
+                <a:solidFill>
+                  <a:srgbClr val="627D98"/>
+                </a:solidFill>
+              </a:rPr>
+              <a:t>17</a:t>
             </a:r>
           </a:p>
         </p:txBody>
@@ -11622,7 +13323,7 @@
           <p:nvPr/>
         </p:nvPicPr>
         <p:blipFill>
-          <a:blip xmlns:r="http://schemas.openxmlformats.org/officeDocument/2006/relationships" xmlns:a="http://schemas.openxmlformats.org/drawingml/2006/main" r:embed="R6aa12b65cdca4e52"/>
+          <a:blip xmlns:r="http://schemas.openxmlformats.org/officeDocument/2006/relationships" xmlns:a="http://schemas.openxmlformats.org/drawingml/2006/main" r:embed="R94ab6fb04a0641b8"/>
           <a:stretch xmlns:a="http://schemas.openxmlformats.org/drawingml/2006/main"/>
         </p:blipFill>
         <p:spPr>
@@ -11644,7 +13345,7 @@
           <p:nvPr/>
         </p:nvPicPr>
         <p:blipFill>
-          <a:blip xmlns:r="http://schemas.openxmlformats.org/officeDocument/2006/relationships" xmlns:a="http://schemas.openxmlformats.org/drawingml/2006/main" r:embed="Rdea2508236734d7e"/>
+          <a:blip xmlns:r="http://schemas.openxmlformats.org/officeDocument/2006/relationships" xmlns:a="http://schemas.openxmlformats.org/drawingml/2006/main" r:embed="Rf02d881174ef4358"/>
           <a:stretch xmlns:a="http://schemas.openxmlformats.org/drawingml/2006/main"/>
         </p:blipFill>
         <p:spPr>
@@ -12016,7 +13717,7 @@
           <p:nvPr/>
         </p:nvPicPr>
         <p:blipFill>
-          <a:blip xmlns:r="http://schemas.openxmlformats.org/officeDocument/2006/relationships" xmlns:a="http://schemas.openxmlformats.org/drawingml/2006/main" r:embed="Raf6c778a46924bbb"/>
+          <a:blip xmlns:r="http://schemas.openxmlformats.org/officeDocument/2006/relationships" xmlns:a="http://schemas.openxmlformats.org/drawingml/2006/main" r:embed="R9534cdb9fd8c4022"/>
           <a:stretch xmlns:a="http://schemas.openxmlformats.org/drawingml/2006/main"/>
         </p:blipFill>
         <p:spPr>
@@ -12073,7 +13774,7 @@
           <p:nvPr/>
         </p:nvPicPr>
         <p:blipFill>
-          <a:blip xmlns:r="http://schemas.openxmlformats.org/officeDocument/2006/relationships" xmlns:a="http://schemas.openxmlformats.org/drawingml/2006/main" r:embed="Rad59a0640ae5410e"/>
+          <a:blip xmlns:r="http://schemas.openxmlformats.org/officeDocument/2006/relationships" xmlns:a="http://schemas.openxmlformats.org/drawingml/2006/main" r:embed="Rda9f34b59f424a0d"/>
           <a:stretch xmlns:a="http://schemas.openxmlformats.org/drawingml/2006/main"/>
         </p:blipFill>
         <p:spPr>
@@ -12662,7 +14363,7 @@
           <p:nvPr/>
         </p:nvPicPr>
         <p:blipFill>
-          <a:blip xmlns:r="http://schemas.openxmlformats.org/officeDocument/2006/relationships" xmlns:a="http://schemas.openxmlformats.org/drawingml/2006/main" r:embed="Rdad12fba94434c25"/>
+          <a:blip xmlns:r="http://schemas.openxmlformats.org/officeDocument/2006/relationships" xmlns:a="http://schemas.openxmlformats.org/drawingml/2006/main" r:embed="Rc6e7e966de924570"/>
           <a:stretch xmlns:a="http://schemas.openxmlformats.org/drawingml/2006/main"/>
         </p:blipFill>
         <p:spPr>
@@ -12719,7 +14420,7 @@
           <p:nvPr/>
         </p:nvPicPr>
         <p:blipFill>
-          <a:blip xmlns:r="http://schemas.openxmlformats.org/officeDocument/2006/relationships" xmlns:a="http://schemas.openxmlformats.org/drawingml/2006/main" r:embed="Rf5fc36de7a4447d3"/>
+          <a:blip xmlns:r="http://schemas.openxmlformats.org/officeDocument/2006/relationships" xmlns:a="http://schemas.openxmlformats.org/drawingml/2006/main" r:embed="Ra257a84fd6094087"/>
           <a:stretch xmlns:a="http://schemas.openxmlformats.org/drawingml/2006/main"/>
         </p:blipFill>
         <p:spPr>
@@ -14314,7 +16015,7 @@
           <p:nvPr/>
         </p:nvPicPr>
         <p:blipFill>
-          <a:blip xmlns:r="http://schemas.openxmlformats.org/officeDocument/2006/relationships" xmlns:a="http://schemas.openxmlformats.org/drawingml/2006/main" r:embed="R3e40c3c5f99843e1"/>
+          <a:blip xmlns:r="http://schemas.openxmlformats.org/officeDocument/2006/relationships" xmlns:a="http://schemas.openxmlformats.org/drawingml/2006/main" r:embed="Rb2b8710490e148b6"/>
           <a:stretch xmlns:a="http://schemas.openxmlformats.org/drawingml/2006/main"/>
         </p:blipFill>
         <p:spPr>
@@ -16053,7 +17754,7 @@
           <p:nvPr/>
         </p:nvPicPr>
         <p:blipFill>
-          <a:blip xmlns:r="http://schemas.openxmlformats.org/officeDocument/2006/relationships" xmlns:a="http://schemas.openxmlformats.org/drawingml/2006/main" r:embed="Ra3b190a9b3c94faa"/>
+          <a:blip xmlns:r="http://schemas.openxmlformats.org/officeDocument/2006/relationships" xmlns:a="http://schemas.openxmlformats.org/drawingml/2006/main" r:embed="Rfddfd1b3b70944d0"/>
           <a:stretch xmlns:a="http://schemas.openxmlformats.org/drawingml/2006/main"/>
         </p:blipFill>
         <p:spPr>
@@ -16075,7 +17776,7 @@
           <p:nvPr/>
         </p:nvPicPr>
         <p:blipFill>
-          <a:blip xmlns:r="http://schemas.openxmlformats.org/officeDocument/2006/relationships" xmlns:a="http://schemas.openxmlformats.org/drawingml/2006/main" r:embed="Rd6d7e32a55d9495f"/>
+          <a:blip xmlns:r="http://schemas.openxmlformats.org/officeDocument/2006/relationships" xmlns:a="http://schemas.openxmlformats.org/drawingml/2006/main" r:embed="R050fff38d4c54ab3"/>
           <a:stretch xmlns:a="http://schemas.openxmlformats.org/drawingml/2006/main"/>
         </p:blipFill>
         <p:spPr>

</xml_diff>